<commit_message>
Fill Helvetia deck with 8th-grade Swiss history content, speaker notes and text fade-ins
Co-Authored-By: Claude Opus 5.5 <noreply@anthropic.com>
Claude-Session: https://claude.ai/code/session_01ETjVcpBAzS2WJAYjtqxef9
</commit_message>
<xml_diff>
--- a/presentation/Helvetia.pptx
+++ b/presentation/Helvetia.pptx
@@ -507,7 +507,7 @@
           <a:p>
             <a:r>
               <a:rPr lang="en-US" dirty="0"/>
-              <a:t>Титульный слайд. Переход: затемнение через чёрное. Замените название, подзаголовок и автора.</a:t>
+              <a:t>Здравствуйте! Тема моего проекта — «Швейцария до XVIII века». Сегодня Швейцарию знают по часам, сыру, банкам и тому, что она не участвует в войнах. Но как маленькая горная страна без моря и без короля смогла стать независимой среди больших империй? Официальное название страны по-латыни — Confoederatio Helvetica, то есть Гельветическая конфедерация: в древности здесь жило кельтское племя гельветов. Я расскажу, как появился швейцарский союз, на чём держалась его сила и как к 1648 году его независимость признала вся Европа.</a:t>
             </a:r>
             <a:endParaRPr lang="en-US" dirty="0"/>
           </a:p>
@@ -595,7 +595,7 @@
           <a:p>
             <a:r>
               <a:rPr lang="en-US" dirty="0"/>
-              <a:t>Переход: «Занавес» (Curtains). Картина слева — плейсхолдер; правый клик → Изменить рисунок, чтобы поставить свою.</a:t>
+              <a:t>В конце XIII века горные долины у Фирвальдштетского озера — Ури, Швиц и Унтервальден — пытались подчинить австрийские Габсбурги. Через эти земли шла важная торговая дорога через перевал Сен-Готард из Германии в Италию. В начале августа 1291 года жители трёх долин заключили «Вечный союз»: они пообещали помогать друг другу против любого врага и не признавать чужих судей. Поэтому 1 августа сегодня — национальный праздник Швейцарии. С этим временем связана легенда о Вильгельме Телле — стрелке, которого жестокий наместник Гесслер заставил сбить стрелой яблоко с головы собственного сына. Телль справился, а потом отомстил наместнику. Историки считают Телля легендарным героем, но он стал символом борьбы швейцарцев за свободу. А само название страны произошло от кантона Швиц.</a:t>
             </a:r>
             <a:endParaRPr lang="en-US" dirty="0"/>
           </a:p>
@@ -683,7 +683,7 @@
           <a:p>
             <a:r>
               <a:rPr lang="en-US" dirty="0"/>
-              <a:t>Переход: «Трансформация» (Morph) — картина плавно перетекает из рамы в широкий баннер, заголовок и герб переезжают.</a:t>
+              <a:t>Почему союз выжил? Я выделяю три причины. Первая — свобода общин. В кантонах не было короля: важные вопросы решало ландсгемайнде — собрание всех свободных мужчин кантона под открытым небом, где голосовали поднятием руки. Такие собрания до сих пор проходят в кантонах Гларус и Аппенцелль-Иннерроден. Вторая — сильная армия. Швейцарская пехота с длинными пиками и алебардами научилась побеждать рыцарскую конницу. Швейцарцев охотно нанимали короли и папы, а с 1506 года папу римского охраняет Швейцарская гвардия — она служит в Ватикане и сегодня. Третья — вера и ремесло. В XVI веке в Цюрихе Реформацию начал Ульрих Цвингли, а Женева при Жане Кальвине стала «протестантским Римом». Кальвинисты ценили труд и бережливость, а строгие законы против роскоши заставили женевских ювелиров перейти к изготовлению часов — так началась слава швейцарских часов.</a:t>
             </a:r>
             <a:endParaRPr lang="en-US" dirty="0"/>
           </a:p>
@@ -771,7 +771,7 @@
           <a:p>
             <a:r>
               <a:rPr lang="en-US" dirty="0"/>
-              <a:t>Переход: Morph — картина раскрывается на весь экран и уходит в сумрак, заголовок поднимается вверх.</a:t>
+              <a:t>Пройдём по главным датам. 1291 год — «Вечный союз» трёх лесных кантонов. 1315 год — битва при Моргартене: крестьяне-ополченцы устроили засаду в горном проходе, сбрасывали на рыцарей герцога Леопольда Австрийского камни и брёвна и разгромили их. Это первая большая победа конфедератов. 1476 год — победы при Грансоне и Муртене над герцогом Бургундии Карлом Смелым, одним из самых богатых правителей Европы; в 1477 году он погиб в битве при Нанси. После этого швейцарскую пехоту стали считать лучшей в Европе. 1515 год — поражение при Мариньяно от французского короля Франциска I. Швейцарцы поняли, что большие завоевательные войны им не по силам, и постепенно перешли к политике нейтралитета. И наконец, 1648 год: по Вестфальскому миру, завершившему Тридцатилетнюю войну, независимость Швейцарии от Священной Римской империи признали официально. На деле империи она не подчинялась уже с 1499 года — после Швабской войны.</a:t>
             </a:r>
             <a:endParaRPr lang="en-US" dirty="0"/>
           </a:p>
@@ -859,7 +859,7 @@
           <a:p>
             <a:r>
               <a:rPr lang="en-US" dirty="0"/>
-              <a:t>Переход: «Престиж» (Prestige). Число можно заменить на любую ключевую метрику.</a:t>
+              <a:t>К 1513 году союз вырос до тринадцати кантонов: Ури, Швиц, Унтервальден, Люцерн, Цюрих, Гларус, Цуг, Берн, Фрибур, Золотурн, Базель, Шаффхаузен и Аппенцелль. Союз тринадцати кантонов просуществовал почти триста лет — до 1798 года. У каждого кантона были свои законы и своё правительство, а общие дела обсуждали послы кантонов на общем собрании — сейме, по-немецки Tagsatzung. Итальянский мыслитель Никколо Макиавелли в книге «Государь» (1513) писал: «Швейцарцы превосходно вооружены и пользуются полной свободой». Эти слова хорошо объясняют, почему соседям было так трудно покорить Швейцарию.</a:t>
             </a:r>
             <a:endParaRPr lang="en-US" dirty="0"/>
           </a:p>
@@ -947,7 +947,7 @@
           <a:p>
             <a:r>
               <a:rPr lang="en-US" dirty="0"/>
-              <a:t>Переход: Morph — герб вырастает в центр, рамка возвращается. Замените контакты.</a:t>
+              <a:t>Подведём итог. Швейцария до XVIII века — это союз небольших горных общин, которые объединились, чтобы защищать свою свободу. Её силу составляли самоуправление, отличная пехота, а затем — трудолюбие и ремесло, которые укрепила Реформация. Пройдя путь от «Вечного союза» 1291 года до признания независимости в 1648 году, Швейцария показала, что маленькая страна может отстоять себя рядом с великими державами. Спасибо за внимание! Готов(а) ответить на ваши вопросы.</a:t>
             </a:r>
             <a:endParaRPr lang="en-US" dirty="0"/>
           </a:p>
@@ -1450,7 +1450,7 @@
                 <a:ea typeface="Bookman Old Style" pitchFamily="34" charset="-122"/>
                 <a:cs typeface="Bookman Old Style" pitchFamily="34" charset="-120"/>
               </a:rPr>
-              <a:t>CONFOEDERATIO  HELVETICA  ·  ANNO  MDCXLVIII</a:t>
+              <a:t>CONFOEDERATIO  HELVETICA  ·  MCCXCI — MDCXLVIII</a:t>
             </a:r>
             <a:endParaRPr lang="en-US" sz="1300" dirty="0"/>
           </a:p>
@@ -1481,7 +1481,7 @@
               <a:buNone/>
             </a:pPr>
             <a:r>
-              <a:rPr lang="en-US" sz="5400" b="1" dirty="0">
+              <a:rPr lang="en-US" sz="5200" b="1" dirty="0">
                 <a:solidFill>
                   <a:srgbClr val="F1E6CF"/>
                 </a:solidFill>
@@ -1489,9 +1489,9 @@
                 <a:ea typeface="Bookman Old Style" pitchFamily="34" charset="-122"/>
                 <a:cs typeface="Bookman Old Style" pitchFamily="34" charset="-120"/>
               </a:rPr>
-              <a:t>Название презентации</a:t>
+              <a:t>Швейцария до XVIII века</a:t>
             </a:r>
-            <a:endParaRPr lang="en-US" sz="5400" dirty="0"/>
+            <a:endParaRPr lang="en-US" sz="5200" dirty="0"/>
           </a:p>
         </p:txBody>
       </p:sp>
@@ -1503,8 +1503,8 @@
         </p:nvSpPr>
         <p:spPr>
           <a:xfrm>
-            <a:off x="1371600" y="3840480"/>
-            <a:ext cx="9448495" cy="548640"/>
+            <a:off x="1828800" y="3840480"/>
+            <a:ext cx="8534095" cy="822960"/>
           </a:xfrm>
           <a:prstGeom prst="rect">
             <a:avLst/>
@@ -1513,14 +1513,14 @@
           <a:ln/>
         </p:spPr>
         <p:txBody>
-          <a:bodyPr wrap="square" lIns="0" tIns="0" rIns="0" bIns="0" rtlCol="0" anchor="ctr"/>
+          <a:bodyPr wrap="square" lIns="0" tIns="0" rIns="0" bIns="0" rtlCol="0" anchor="t"/>
           <a:lstStyle/>
           <a:p>
             <a:pPr algn="ctr" indent="0" marL="0">
               <a:buNone/>
             </a:pPr>
             <a:r>
-              <a:rPr lang="en-US" sz="2200" i="1" dirty="0">
+              <a:rPr lang="en-US" sz="2100" i="1" dirty="0">
                 <a:solidFill>
                   <a:srgbClr val="E2D2B0"/>
                 </a:solidFill>
@@ -1528,9 +1528,9 @@
                 <a:ea typeface="Cambria" pitchFamily="34" charset="-122"/>
                 <a:cs typeface="Cambria" pitchFamily="34" charset="-120"/>
               </a:rPr>
-              <a:t>Подзаголовок — одна строка о сути выступления</a:t>
+              <a:t>Как горные общины создали союз, который не смогла покорить ни одна империя</a:t>
             </a:r>
-            <a:endParaRPr lang="en-US" sz="2200" dirty="0"/>
+            <a:endParaRPr lang="en-US" sz="2100" dirty="0"/>
           </a:p>
         </p:txBody>
       </p:sp>
@@ -1567,7 +1567,7 @@
                 <a:ea typeface="Cambria" pitchFamily="34" charset="-122"/>
                 <a:cs typeface="Cambria" pitchFamily="34" charset="-120"/>
               </a:rPr>
-              <a:t>Имя Фамилия  ·  Город  ·  2026</a:t>
+              <a:t>Проект по истории  ·  8 класс  ·  Фамилия Имя</a:t>
             </a:r>
             <a:endParaRPr lang="en-US" sz="1400" dirty="0"/>
           </a:p>
@@ -1590,6 +1590,140 @@
       </p:transition>
     </mc:Fallback>
   </mc:AlternateContent>
+  <p:timing>
+    <p:tnLst>
+      <p:par>
+        <p:cTn id="1" dur="indefinite" restart="never" nodeType="tmRoot">
+          <p:childTnLst>
+            <p:seq concurrent="1" nextAc="seek">
+              <p:cTn id="2" dur="indefinite" nodeType="mainSeq">
+                <p:childTnLst>
+                  <p:par>
+                    <p:cTn id="3" fill="hold">
+                      <p:stCondLst>
+                        <p:cond delay="indefinite"/>
+                        <p:cond evt="onBegin" delay="0">
+                          <p:tn val="2"/>
+                        </p:cond>
+                      </p:stCondLst>
+                      <p:childTnLst>
+                        <p:par>
+                          <p:cTn id="4" fill="hold">
+                            <p:stCondLst>
+                              <p:cond delay="900"/>
+                            </p:stCondLst>
+                            <p:childTnLst>
+                              <p:par>
+                                <p:cTn id="5" presetID="10" presetClass="entr" presetSubtype="0" fill="hold" grpId="0" nodeType="withEffect">
+                                  <p:stCondLst>
+                                    <p:cond delay="0"/>
+                                  </p:stCondLst>
+                                  <p:childTnLst>
+                                    <p:set>
+                                      <p:cBhvr>
+                                        <p:cTn id="6" dur="1" fill="hold">
+                                          <p:stCondLst>
+                                            <p:cond delay="0"/>
+                                          </p:stCondLst>
+                                        </p:cTn>
+                                        <p:tgtEl>
+                                          <p:spTgt spid="8"/>
+                                        </p:tgtEl>
+                                        <p:attrNameLst>
+                                          <p:attrName>style.visibility</p:attrName>
+                                        </p:attrNameLst>
+                                      </p:cBhvr>
+                                      <p:to>
+                                        <p:strVal val="visible"/>
+                                      </p:to>
+                                    </p:set>
+                                    <p:animEffect transition="in" filter="fade">
+                                      <p:cBhvr>
+                                        <p:cTn id="7" dur="900"/>
+                                        <p:tgtEl>
+                                          <p:spTgt spid="8"/>
+                                        </p:tgtEl>
+                                      </p:cBhvr>
+                                    </p:animEffect>
+                                  </p:childTnLst>
+                                </p:cTn>
+                              </p:par>
+                            </p:childTnLst>
+                          </p:cTn>
+                        </p:par>
+                        <p:par>
+                          <p:cTn id="8" fill="hold">
+                            <p:stCondLst>
+                              <p:cond delay="1080"/>
+                            </p:stCondLst>
+                            <p:childTnLst>
+                              <p:par>
+                                <p:cTn id="9" presetID="10" presetClass="entr" presetSubtype="0" fill="hold" grpId="0" nodeType="withEffect">
+                                  <p:stCondLst>
+                                    <p:cond delay="0"/>
+                                  </p:stCondLst>
+                                  <p:childTnLst>
+                                    <p:set>
+                                      <p:cBhvr>
+                                        <p:cTn id="10" dur="1" fill="hold">
+                                          <p:stCondLst>
+                                            <p:cond delay="0"/>
+                                          </p:stCondLst>
+                                        </p:cTn>
+                                        <p:tgtEl>
+                                          <p:spTgt spid="9"/>
+                                        </p:tgtEl>
+                                        <p:attrNameLst>
+                                          <p:attrName>style.visibility</p:attrName>
+                                        </p:attrNameLst>
+                                      </p:cBhvr>
+                                      <p:to>
+                                        <p:strVal val="visible"/>
+                                      </p:to>
+                                    </p:set>
+                                    <p:animEffect transition="in" filter="fade">
+                                      <p:cBhvr>
+                                        <p:cTn id="11" dur="900"/>
+                                        <p:tgtEl>
+                                          <p:spTgt spid="9"/>
+                                        </p:tgtEl>
+                                      </p:cBhvr>
+                                    </p:animEffect>
+                                  </p:childTnLst>
+                                </p:cTn>
+                              </p:par>
+                            </p:childTnLst>
+                          </p:cTn>
+                        </p:par>
+                      </p:childTnLst>
+                    </p:cTn>
+                  </p:par>
+                </p:childTnLst>
+              </p:cTn>
+              <p:prevCondLst>
+                <p:cond evt="onPrev" delay="0">
+                  <p:tgtEl>
+                    <p:sldTgt/>
+                  </p:tgtEl>
+                </p:cond>
+              </p:prevCondLst>
+              <p:nextCondLst>
+                <p:cond evt="onNext" delay="0">
+                  <p:tgtEl>
+                    <p:sldTgt/>
+                  </p:tgtEl>
+                </p:cond>
+              </p:nextCondLst>
+            </p:seq>
+          </p:childTnLst>
+        </p:cTn>
+      </p:par>
+    </p:tnLst>
+    <p:bldLst>
+      <p:bldP spid="8" grpId="0"/>
+      <p:bldP spid="9" grpId="0"/>
+    </p:bldLst>
+  </p:timing>
 </p:sld>
 </file>
 
@@ -1711,8 +1845,8 @@
         </p:nvSpPr>
         <p:spPr>
           <a:xfrm>
-            <a:off x="6537960" y="914400"/>
-            <a:ext cx="4572000" cy="320040"/>
+            <a:off x="6537960" y="868680"/>
+            <a:ext cx="4114800" cy="320040"/>
           </a:xfrm>
           <a:prstGeom prst="rect">
             <a:avLst/>
@@ -1736,7 +1870,7 @@
                 <a:ea typeface="Bookman Old Style" pitchFamily="34" charset="-122"/>
                 <a:cs typeface="Bookman Old Style" pitchFamily="34" charset="-120"/>
               </a:rPr>
-              <a:t>CAPUT  I</a:t>
+              <a:t>CAPUT  I  ·  1291</a:t>
             </a:r>
             <a:endParaRPr lang="en-US" sz="1300" dirty="0"/>
           </a:p>
@@ -1750,8 +1884,8 @@
         </p:nvSpPr>
         <p:spPr>
           <a:xfrm>
-            <a:off x="6537960" y="1280160"/>
-            <a:ext cx="4937760" cy="822960"/>
+            <a:off x="6537960" y="1234440"/>
+            <a:ext cx="4983480" cy="822960"/>
           </a:xfrm>
           <a:prstGeom prst="rect">
             <a:avLst/>
@@ -1767,7 +1901,7 @@
               <a:buNone/>
             </a:pPr>
             <a:r>
-              <a:rPr lang="en-US" sz="4000" b="1" dirty="0">
+              <a:rPr lang="en-US" sz="3200" b="1" dirty="0">
                 <a:solidFill>
                   <a:srgbClr val="2A1E16"/>
                 </a:solidFill>
@@ -1775,9 +1909,9 @@
                 <a:ea typeface="Bookman Old Style" pitchFamily="34" charset="-122"/>
                 <a:cs typeface="Bookman Old Style" pitchFamily="34" charset="-120"/>
               </a:rPr>
-              <a:t>Введение</a:t>
+              <a:t>Как всё началось</a:t>
             </a:r>
-            <a:endParaRPr lang="en-US" sz="4000" dirty="0"/>
+            <a:endParaRPr lang="en-US" sz="3200" dirty="0"/>
           </a:p>
         </p:txBody>
       </p:sp>
@@ -1789,7 +1923,7 @@
         </p:nvSpPr>
         <p:spPr>
           <a:xfrm>
-            <a:off x="6537960" y="2331720"/>
+            <a:off x="6537960" y="2286000"/>
             <a:ext cx="868680" cy="960120"/>
           </a:xfrm>
           <a:prstGeom prst="rect">
@@ -1828,8 +1962,8 @@
         </p:nvSpPr>
         <p:spPr>
           <a:xfrm>
-            <a:off x="7452360" y="2377440"/>
-            <a:ext cx="4069080" cy="1005840"/>
+            <a:off x="7452360" y="2331720"/>
+            <a:ext cx="4069080" cy="1097280"/>
           </a:xfrm>
           <a:prstGeom prst="rect">
             <a:avLst/>
@@ -1848,7 +1982,7 @@
               <a:buNone/>
             </a:pPr>
             <a:r>
-              <a:rPr lang="en-US" sz="1600" dirty="0">
+              <a:rPr lang="en-US" sz="1500" dirty="0">
                 <a:solidFill>
                   <a:srgbClr val="2A1E16"/>
                 </a:solidFill>
@@ -1856,9 +1990,9 @@
                 <a:ea typeface="Cambria" pitchFamily="34" charset="-122"/>
                 <a:cs typeface="Cambria" pitchFamily="34" charset="-120"/>
               </a:rPr>
-              <a:t>ступительный абзац. Расскажите, о чём пойдёт речь и почему это важно слушателю именно сейчас.</a:t>
+              <a:t>1291 году три горные долины — Ури, Швиц и Унтервальден — заключили «Вечный союз» против власти Габсбургов.</a:t>
             </a:r>
-            <a:endParaRPr lang="en-US" sz="1600" dirty="0"/>
+            <a:endParaRPr lang="en-US" sz="1500" dirty="0"/>
           </a:p>
         </p:txBody>
       </p:sp>
@@ -1871,7 +2005,7 @@
         <p:spPr>
           <a:xfrm>
             <a:off x="6537960" y="3520440"/>
-            <a:ext cx="4983480" cy="1005840"/>
+            <a:ext cx="4983480" cy="1188720"/>
           </a:xfrm>
           <a:prstGeom prst="rect">
             <a:avLst/>
@@ -1890,7 +2024,7 @@
               <a:buNone/>
             </a:pPr>
             <a:r>
-              <a:rPr lang="en-US" sz="1600" dirty="0">
+              <a:rPr lang="en-US" sz="1500" dirty="0">
                 <a:solidFill>
                   <a:srgbClr val="2A1E16"/>
                 </a:solidFill>
@@ -1898,9 +2032,9 @@
                 <a:ea typeface="Cambria" pitchFamily="34" charset="-122"/>
                 <a:cs typeface="Cambria" pitchFamily="34" charset="-120"/>
               </a:rPr>
-              <a:t>Второй абзац раскрывает контекст: откуда возникла тема, кого она касается и какой вопрос мы ставим перед собой.</a:t>
+              <a:t>Через их земли шла дорога через перевал Сен-Готард из Германии в Италию. Название страны дал кантон Швиц, а 1 августа — её национальный праздник.</a:t>
             </a:r>
-            <a:endParaRPr lang="en-US" sz="1600" dirty="0"/>
+            <a:endParaRPr lang="en-US" sz="1500" dirty="0"/>
           </a:p>
         </p:txBody>
       </p:sp>
@@ -1912,8 +2046,8 @@
         </p:nvSpPr>
         <p:spPr>
           <a:xfrm>
-            <a:off x="6537960" y="4892040"/>
-            <a:ext cx="4983480" cy="731520"/>
+            <a:off x="6537960" y="4846320"/>
+            <a:ext cx="4983480" cy="868680"/>
           </a:xfrm>
           <a:prstGeom prst="rect">
             <a:avLst/>
@@ -1929,7 +2063,7 @@
               <a:buNone/>
             </a:pPr>
             <a:r>
-              <a:rPr lang="en-US" sz="1700" i="1" dirty="0">
+              <a:rPr lang="en-US" sz="1600" i="1" dirty="0">
                 <a:solidFill>
                   <a:srgbClr val="7A1C1A"/>
                 </a:solidFill>
@@ -1937,15 +2071,15 @@
                 <a:ea typeface="Cambria" pitchFamily="34" charset="-122"/>
                 <a:cs typeface="Cambria" pitchFamily="34" charset="-120"/>
               </a:rPr>
-              <a:t>«Цитата или ключевая мысль, выделенная курсивом»</a:t>
+              <a:t>Легенда о Вильгельме Телле, сбившем стрелой яблоко с головы сына, стала символом свободы швейцарцев.</a:t>
             </a:r>
-            <a:endParaRPr lang="en-US" sz="1700" dirty="0"/>
-          </a:p>
-        </p:txBody>
-      </p:sp>
-      <p:sp>
-        <p:nvSpPr>
-          <p:cNvPr id="11" name="Text 7"/>
+            <a:endParaRPr lang="en-US" sz="1600" dirty="0"/>
+          </a:p>
+        </p:txBody>
+      </p:sp>
+      <p:sp>
+        <p:nvSpPr>
+          <p:cNvPr id="11" name="pageNum"/>
           <p:cNvSpPr txBox="1"/>
           <p:nvPr/>
         </p:nvSpPr>
@@ -1976,7 +2110,46 @@
                 <a:ea typeface="Cambria" pitchFamily="34" charset="-122"/>
                 <a:cs typeface="Cambria" pitchFamily="34" charset="-120"/>
               </a:rPr>
-              <a:t>Женевское озеро, ок. 1444</a:t>
+              <a:t>Фирвальдштетское озеро — колыбель союза (иллюстрация)</a:t>
+            </a:r>
+            <a:endParaRPr lang="en-US" sz="1000" dirty="0"/>
+          </a:p>
+        </p:txBody>
+      </p:sp>
+      <p:sp>
+        <p:nvSpPr>
+          <p:cNvPr id="12" name="pageNum"/>
+          <p:cNvSpPr txBox="1"/>
+          <p:nvPr/>
+        </p:nvSpPr>
+        <p:spPr>
+          <a:xfrm>
+            <a:off x="10332720" y="6263640"/>
+            <a:ext cx="1097280" cy="274320"/>
+          </a:xfrm>
+          <a:prstGeom prst="rect">
+            <a:avLst/>
+          </a:prstGeom>
+          <a:noFill/>
+          <a:ln/>
+        </p:spPr>
+        <p:txBody>
+          <a:bodyPr wrap="square" lIns="0" tIns="0" rIns="0" bIns="0" rtlCol="0" anchor="ctr"/>
+          <a:lstStyle/>
+          <a:p>
+            <a:pPr algn="r" indent="0" marL="0">
+              <a:buNone/>
+            </a:pPr>
+            <a:r>
+              <a:rPr lang="en-US" sz="1000" spc="300" kern="0" dirty="0">
+                <a:solidFill>
+                  <a:srgbClr val="6B5640"/>
+                </a:solidFill>
+                <a:latin typeface="Bookman Old Style" pitchFamily="34" charset="0"/>
+                <a:ea typeface="Bookman Old Style" pitchFamily="34" charset="-122"/>
+                <a:cs typeface="Bookman Old Style" pitchFamily="34" charset="-120"/>
+              </a:rPr>
+              <a:t>II  ·  VI</a:t>
             </a:r>
             <a:endParaRPr lang="en-US" sz="1000" dirty="0"/>
           </a:p>
@@ -1999,6 +2172,230 @@
       </p:transition>
     </mc:Fallback>
   </mc:AlternateContent>
+  <p:timing>
+    <p:tnLst>
+      <p:par>
+        <p:cTn id="1" dur="indefinite" restart="never" nodeType="tmRoot">
+          <p:childTnLst>
+            <p:seq concurrent="1" nextAc="seek">
+              <p:cTn id="2" dur="indefinite" nodeType="mainSeq">
+                <p:childTnLst>
+                  <p:par>
+                    <p:cTn id="3" fill="hold">
+                      <p:stCondLst>
+                        <p:cond delay="indefinite"/>
+                        <p:cond evt="onBegin" delay="0">
+                          <p:tn val="2"/>
+                        </p:cond>
+                      </p:stCondLst>
+                      <p:childTnLst>
+                        <p:par>
+                          <p:cTn id="4" fill="hold">
+                            <p:stCondLst>
+                              <p:cond delay="900"/>
+                            </p:stCondLst>
+                            <p:childTnLst>
+                              <p:par>
+                                <p:cTn id="5" presetID="10" presetClass="entr" presetSubtype="0" fill="hold" grpId="0" nodeType="withEffect">
+                                  <p:stCondLst>
+                                    <p:cond delay="0"/>
+                                  </p:stCondLst>
+                                  <p:childTnLst>
+                                    <p:set>
+                                      <p:cBhvr>
+                                        <p:cTn id="6" dur="1" fill="hold">
+                                          <p:stCondLst>
+                                            <p:cond delay="0"/>
+                                          </p:stCondLst>
+                                        </p:cTn>
+                                        <p:tgtEl>
+                                          <p:spTgt spid="7"/>
+                                        </p:tgtEl>
+                                        <p:attrNameLst>
+                                          <p:attrName>style.visibility</p:attrName>
+                                        </p:attrNameLst>
+                                      </p:cBhvr>
+                                      <p:to>
+                                        <p:strVal val="visible"/>
+                                      </p:to>
+                                    </p:set>
+                                    <p:animEffect transition="in" filter="fade">
+                                      <p:cBhvr>
+                                        <p:cTn id="7" dur="900"/>
+                                        <p:tgtEl>
+                                          <p:spTgt spid="7"/>
+                                        </p:tgtEl>
+                                      </p:cBhvr>
+                                    </p:animEffect>
+                                  </p:childTnLst>
+                                </p:cTn>
+                              </p:par>
+                            </p:childTnLst>
+                          </p:cTn>
+                        </p:par>
+                        <p:par>
+                          <p:cTn id="8" fill="hold">
+                            <p:stCondLst>
+                              <p:cond delay="1080"/>
+                            </p:stCondLst>
+                            <p:childTnLst>
+                              <p:par>
+                                <p:cTn id="9" presetID="10" presetClass="entr" presetSubtype="0" fill="hold" grpId="0" nodeType="withEffect">
+                                  <p:stCondLst>
+                                    <p:cond delay="0"/>
+                                  </p:stCondLst>
+                                  <p:childTnLst>
+                                    <p:set>
+                                      <p:cBhvr>
+                                        <p:cTn id="10" dur="1" fill="hold">
+                                          <p:stCondLst>
+                                            <p:cond delay="0"/>
+                                          </p:stCondLst>
+                                        </p:cTn>
+                                        <p:tgtEl>
+                                          <p:spTgt spid="8"/>
+                                        </p:tgtEl>
+                                        <p:attrNameLst>
+                                          <p:attrName>style.visibility</p:attrName>
+                                        </p:attrNameLst>
+                                      </p:cBhvr>
+                                      <p:to>
+                                        <p:strVal val="visible"/>
+                                      </p:to>
+                                    </p:set>
+                                    <p:animEffect transition="in" filter="fade">
+                                      <p:cBhvr>
+                                        <p:cTn id="11" dur="900"/>
+                                        <p:tgtEl>
+                                          <p:spTgt spid="8"/>
+                                        </p:tgtEl>
+                                      </p:cBhvr>
+                                    </p:animEffect>
+                                  </p:childTnLst>
+                                </p:cTn>
+                              </p:par>
+                            </p:childTnLst>
+                          </p:cTn>
+                        </p:par>
+                        <p:par>
+                          <p:cTn id="12" fill="hold">
+                            <p:stCondLst>
+                              <p:cond delay="1260"/>
+                            </p:stCondLst>
+                            <p:childTnLst>
+                              <p:par>
+                                <p:cTn id="13" presetID="10" presetClass="entr" presetSubtype="0" fill="hold" grpId="0" nodeType="withEffect">
+                                  <p:stCondLst>
+                                    <p:cond delay="0"/>
+                                  </p:stCondLst>
+                                  <p:childTnLst>
+                                    <p:set>
+                                      <p:cBhvr>
+                                        <p:cTn id="14" dur="1" fill="hold">
+                                          <p:stCondLst>
+                                            <p:cond delay="0"/>
+                                          </p:stCondLst>
+                                        </p:cTn>
+                                        <p:tgtEl>
+                                          <p:spTgt spid="9"/>
+                                        </p:tgtEl>
+                                        <p:attrNameLst>
+                                          <p:attrName>style.visibility</p:attrName>
+                                        </p:attrNameLst>
+                                      </p:cBhvr>
+                                      <p:to>
+                                        <p:strVal val="visible"/>
+                                      </p:to>
+                                    </p:set>
+                                    <p:animEffect transition="in" filter="fade">
+                                      <p:cBhvr>
+                                        <p:cTn id="15" dur="900"/>
+                                        <p:tgtEl>
+                                          <p:spTgt spid="9"/>
+                                        </p:tgtEl>
+                                      </p:cBhvr>
+                                    </p:animEffect>
+                                  </p:childTnLst>
+                                </p:cTn>
+                              </p:par>
+                            </p:childTnLst>
+                          </p:cTn>
+                        </p:par>
+                        <p:par>
+                          <p:cTn id="16" fill="hold">
+                            <p:stCondLst>
+                              <p:cond delay="1440"/>
+                            </p:stCondLst>
+                            <p:childTnLst>
+                              <p:par>
+                                <p:cTn id="17" presetID="10" presetClass="entr" presetSubtype="0" fill="hold" grpId="0" nodeType="withEffect">
+                                  <p:stCondLst>
+                                    <p:cond delay="0"/>
+                                  </p:stCondLst>
+                                  <p:childTnLst>
+                                    <p:set>
+                                      <p:cBhvr>
+                                        <p:cTn id="18" dur="1" fill="hold">
+                                          <p:stCondLst>
+                                            <p:cond delay="0"/>
+                                          </p:stCondLst>
+                                        </p:cTn>
+                                        <p:tgtEl>
+                                          <p:spTgt spid="10"/>
+                                        </p:tgtEl>
+                                        <p:attrNameLst>
+                                          <p:attrName>style.visibility</p:attrName>
+                                        </p:attrNameLst>
+                                      </p:cBhvr>
+                                      <p:to>
+                                        <p:strVal val="visible"/>
+                                      </p:to>
+                                    </p:set>
+                                    <p:animEffect transition="in" filter="fade">
+                                      <p:cBhvr>
+                                        <p:cTn id="19" dur="900"/>
+                                        <p:tgtEl>
+                                          <p:spTgt spid="10"/>
+                                        </p:tgtEl>
+                                      </p:cBhvr>
+                                    </p:animEffect>
+                                  </p:childTnLst>
+                                </p:cTn>
+                              </p:par>
+                            </p:childTnLst>
+                          </p:cTn>
+                        </p:par>
+                      </p:childTnLst>
+                    </p:cTn>
+                  </p:par>
+                </p:childTnLst>
+              </p:cTn>
+              <p:prevCondLst>
+                <p:cond evt="onPrev" delay="0">
+                  <p:tgtEl>
+                    <p:sldTgt/>
+                  </p:tgtEl>
+                </p:cond>
+              </p:prevCondLst>
+              <p:nextCondLst>
+                <p:cond evt="onNext" delay="0">
+                  <p:tgtEl>
+                    <p:sldTgt/>
+                  </p:tgtEl>
+                </p:cond>
+              </p:nextCondLst>
+            </p:seq>
+          </p:childTnLst>
+        </p:cTn>
+      </p:par>
+    </p:tnLst>
+    <p:bldLst>
+      <p:bldP spid="7" grpId="0"/>
+      <p:bldP spid="8" grpId="0"/>
+      <p:bldP spid="9" grpId="0"/>
+      <p:bldP spid="10" grpId="0"/>
+    </p:bldLst>
+  </p:timing>
 </p:sld>
 </file>
 
@@ -2042,7 +2439,7 @@
         <p:spPr>
           <a:xfrm>
             <a:off x="0" y="0"/>
-            <a:ext cx="12191695" cy="2240280"/>
+            <a:ext cx="12191695" cy="2057400"/>
           </a:xfrm>
           <a:prstGeom prst="rect">
             <a:avLst/>
@@ -2081,7 +2478,7 @@
         <p:spPr>
           <a:xfrm>
             <a:off x="0" y="0"/>
-            <a:ext cx="12191695" cy="2148840"/>
+            <a:ext cx="12191695" cy="1965960"/>
           </a:xfrm>
           <a:prstGeom prst="rect">
             <a:avLst/>
@@ -2120,7 +2517,7 @@
         </p:nvSpPr>
         <p:spPr>
           <a:xfrm>
-            <a:off x="777240" y="2606040"/>
+            <a:off x="777240" y="2377440"/>
             <a:ext cx="4572000" cy="320040"/>
           </a:xfrm>
           <a:prstGeom prst="rect">
@@ -2159,7 +2556,7 @@
         </p:nvSpPr>
         <p:spPr>
           <a:xfrm>
-            <a:off x="777240" y="2926080"/>
+            <a:off x="777240" y="2697480"/>
             <a:ext cx="8229600" cy="731520"/>
           </a:xfrm>
           <a:prstGeom prst="rect">
@@ -2184,7 +2581,7 @@
                 <a:ea typeface="Bookman Old Style" pitchFamily="34" charset="-122"/>
                 <a:cs typeface="Bookman Old Style" pitchFamily="34" charset="-120"/>
               </a:rPr>
-              <a:t>Три главные идеи</a:t>
+              <a:t>Три опоры Швейцарии</a:t>
             </a:r>
             <a:endParaRPr lang="en-US" sz="3600" dirty="0"/>
           </a:p>
@@ -2198,8 +2595,8 @@
         </p:nvSpPr>
         <p:spPr>
           <a:xfrm>
-            <a:off x="777240" y="3931920"/>
-            <a:ext cx="1188720" cy="685800"/>
+            <a:off x="777240" y="3611880"/>
+            <a:ext cx="1188720" cy="640080"/>
           </a:xfrm>
           <a:prstGeom prst="rect">
             <a:avLst/>
@@ -2215,7 +2612,7 @@
               <a:buNone/>
             </a:pPr>
             <a:r>
-              <a:rPr lang="en-US" sz="4000" b="1" dirty="0">
+              <a:rPr lang="en-US" sz="3600" b="1" dirty="0">
                 <a:solidFill>
                   <a:srgbClr val="7A1C1A"/>
                 </a:solidFill>
@@ -2225,7 +2622,7 @@
               </a:rPr>
               <a:t>I</a:t>
             </a:r>
-            <a:endParaRPr lang="en-US" sz="4000" dirty="0"/>
+            <a:endParaRPr lang="en-US" sz="3600" dirty="0"/>
           </a:p>
         </p:txBody>
       </p:sp>
@@ -2237,7 +2634,7 @@
         </p:nvSpPr>
         <p:spPr>
           <a:xfrm>
-            <a:off x="777240" y="4663440"/>
+            <a:off x="777240" y="4297680"/>
             <a:ext cx="3291840" cy="411480"/>
           </a:xfrm>
           <a:prstGeom prst="rect">
@@ -2254,7 +2651,7 @@
               <a:buNone/>
             </a:pPr>
             <a:r>
-              <a:rPr lang="en-US" sz="2000" b="1" dirty="0">
+              <a:rPr lang="en-US" sz="1900" b="1" dirty="0">
                 <a:solidFill>
                   <a:srgbClr val="2A1E16"/>
                 </a:solidFill>
@@ -2262,9 +2659,9 @@
                 <a:ea typeface="Bookman Old Style" pitchFamily="34" charset="-122"/>
                 <a:cs typeface="Bookman Old Style" pitchFamily="34" charset="-120"/>
               </a:rPr>
-              <a:t>Первая идея</a:t>
+              <a:t>Свобода общин</a:t>
             </a:r>
-            <a:endParaRPr lang="en-US" sz="2000" dirty="0"/>
+            <a:endParaRPr lang="en-US" sz="1900" dirty="0"/>
           </a:p>
         </p:txBody>
       </p:sp>
@@ -2276,8 +2673,8 @@
         </p:nvSpPr>
         <p:spPr>
           <a:xfrm>
-            <a:off x="777240" y="5120640"/>
-            <a:ext cx="3291840" cy="914400"/>
+            <a:off x="777240" y="4754880"/>
+            <a:ext cx="3291840" cy="1234440"/>
           </a:xfrm>
           <a:prstGeom prst="rect">
             <a:avLst/>
@@ -2290,10 +2687,13 @@
           <a:lstStyle/>
           <a:p>
             <a:pPr indent="0" marL="0">
+              <a:lnSpc>
+                <a:spcPct val="105000"/>
+              </a:lnSpc>
               <a:buNone/>
             </a:pPr>
             <a:r>
-              <a:rPr lang="en-US" sz="1500" dirty="0">
+              <a:rPr lang="en-US" sz="1400" dirty="0">
                 <a:solidFill>
                   <a:srgbClr val="6B5640"/>
                 </a:solidFill>
@@ -2301,9 +2701,9 @@
                 <a:ea typeface="Cambria" pitchFamily="34" charset="-122"/>
                 <a:cs typeface="Cambria" pitchFamily="34" charset="-120"/>
               </a:rPr>
-              <a:t>Короткое пояснение в две-три строки: факт, довод или вывод.</a:t>
+              <a:t>Вместо короля — ландсгемайнде: собрание всех свободных мужчин кантона, голосование поднятием руки.</a:t>
             </a:r>
-            <a:endParaRPr lang="en-US" sz="1500" dirty="0"/>
+            <a:endParaRPr lang="en-US" sz="1400" dirty="0"/>
           </a:p>
         </p:txBody>
       </p:sp>
@@ -2315,8 +2715,8 @@
         </p:nvSpPr>
         <p:spPr>
           <a:xfrm>
-            <a:off x="4498848" y="3931920"/>
-            <a:ext cx="1188720" cy="685800"/>
+            <a:off x="4498848" y="3611880"/>
+            <a:ext cx="1188720" cy="640080"/>
           </a:xfrm>
           <a:prstGeom prst="rect">
             <a:avLst/>
@@ -2332,7 +2732,7 @@
               <a:buNone/>
             </a:pPr>
             <a:r>
-              <a:rPr lang="en-US" sz="4000" b="1" dirty="0">
+              <a:rPr lang="en-US" sz="3600" b="1" dirty="0">
                 <a:solidFill>
                   <a:srgbClr val="7A1C1A"/>
                 </a:solidFill>
@@ -2342,7 +2742,7 @@
               </a:rPr>
               <a:t>II</a:t>
             </a:r>
-            <a:endParaRPr lang="en-US" sz="4000" dirty="0"/>
+            <a:endParaRPr lang="en-US" sz="3600" dirty="0"/>
           </a:p>
         </p:txBody>
       </p:sp>
@@ -2354,7 +2754,7 @@
         </p:nvSpPr>
         <p:spPr>
           <a:xfrm>
-            <a:off x="4498848" y="4663440"/>
+            <a:off x="4498848" y="4297680"/>
             <a:ext cx="3291840" cy="411480"/>
           </a:xfrm>
           <a:prstGeom prst="rect">
@@ -2371,7 +2771,7 @@
               <a:buNone/>
             </a:pPr>
             <a:r>
-              <a:rPr lang="en-US" sz="2000" b="1" dirty="0">
+              <a:rPr lang="en-US" sz="1900" b="1" dirty="0">
                 <a:solidFill>
                   <a:srgbClr val="2A1E16"/>
                 </a:solidFill>
@@ -2379,9 +2779,9 @@
                 <a:ea typeface="Bookman Old Style" pitchFamily="34" charset="-122"/>
                 <a:cs typeface="Bookman Old Style" pitchFamily="34" charset="-120"/>
               </a:rPr>
-              <a:t>Вторая идея</a:t>
+              <a:t>Сильная пехота</a:t>
             </a:r>
-            <a:endParaRPr lang="en-US" sz="2000" dirty="0"/>
+            <a:endParaRPr lang="en-US" sz="1900" dirty="0"/>
           </a:p>
         </p:txBody>
       </p:sp>
@@ -2393,8 +2793,8 @@
         </p:nvSpPr>
         <p:spPr>
           <a:xfrm>
-            <a:off x="4498848" y="5120640"/>
-            <a:ext cx="3291840" cy="914400"/>
+            <a:off x="4498848" y="4754880"/>
+            <a:ext cx="3291840" cy="1234440"/>
           </a:xfrm>
           <a:prstGeom prst="rect">
             <a:avLst/>
@@ -2407,10 +2807,13 @@
           <a:lstStyle/>
           <a:p>
             <a:pPr indent="0" marL="0">
+              <a:lnSpc>
+                <a:spcPct val="105000"/>
+              </a:lnSpc>
               <a:buNone/>
             </a:pPr>
             <a:r>
-              <a:rPr lang="en-US" sz="1500" dirty="0">
+              <a:rPr lang="en-US" sz="1400" dirty="0">
                 <a:solidFill>
                   <a:srgbClr val="6B5640"/>
                 </a:solidFill>
@@ -2418,9 +2821,9 @@
                 <a:ea typeface="Cambria" pitchFamily="34" charset="-122"/>
                 <a:cs typeface="Cambria" pitchFamily="34" charset="-120"/>
               </a:rPr>
-              <a:t>Короткое пояснение в две-три строки: факт, довод или вывод.</a:t>
+              <a:t>Пики и алебарды против рыцарской конницы. С 1506 года папу римского охраняет Швейцарская гвардия.</a:t>
             </a:r>
-            <a:endParaRPr lang="en-US" sz="1500" dirty="0"/>
+            <a:endParaRPr lang="en-US" sz="1400" dirty="0"/>
           </a:p>
         </p:txBody>
       </p:sp>
@@ -2432,8 +2835,8 @@
         </p:nvSpPr>
         <p:spPr>
           <a:xfrm>
-            <a:off x="8220456" y="3931920"/>
-            <a:ext cx="1188720" cy="685800"/>
+            <a:off x="8220456" y="3611880"/>
+            <a:ext cx="1188720" cy="640080"/>
           </a:xfrm>
           <a:prstGeom prst="rect">
             <a:avLst/>
@@ -2449,7 +2852,7 @@
               <a:buNone/>
             </a:pPr>
             <a:r>
-              <a:rPr lang="en-US" sz="4000" b="1" dirty="0">
+              <a:rPr lang="en-US" sz="3600" b="1" dirty="0">
                 <a:solidFill>
                   <a:srgbClr val="7A1C1A"/>
                 </a:solidFill>
@@ -2459,7 +2862,7 @@
               </a:rPr>
               <a:t>III</a:t>
             </a:r>
-            <a:endParaRPr lang="en-US" sz="4000" dirty="0"/>
+            <a:endParaRPr lang="en-US" sz="3600" dirty="0"/>
           </a:p>
         </p:txBody>
       </p:sp>
@@ -2471,7 +2874,7 @@
         </p:nvSpPr>
         <p:spPr>
           <a:xfrm>
-            <a:off x="8220456" y="4663440"/>
+            <a:off x="8220456" y="4297680"/>
             <a:ext cx="3291840" cy="411480"/>
           </a:xfrm>
           <a:prstGeom prst="rect">
@@ -2488,7 +2891,7 @@
               <a:buNone/>
             </a:pPr>
             <a:r>
-              <a:rPr lang="en-US" sz="2000" b="1" dirty="0">
+              <a:rPr lang="en-US" sz="1900" b="1" dirty="0">
                 <a:solidFill>
                   <a:srgbClr val="2A1E16"/>
                 </a:solidFill>
@@ -2496,9 +2899,9 @@
                 <a:ea typeface="Bookman Old Style" pitchFamily="34" charset="-122"/>
                 <a:cs typeface="Bookman Old Style" pitchFamily="34" charset="-120"/>
               </a:rPr>
-              <a:t>Третья идея</a:t>
+              <a:t>Вера и ремесло</a:t>
             </a:r>
-            <a:endParaRPr lang="en-US" sz="2000" dirty="0"/>
+            <a:endParaRPr lang="en-US" sz="1900" dirty="0"/>
           </a:p>
         </p:txBody>
       </p:sp>
@@ -2510,8 +2913,8 @@
         </p:nvSpPr>
         <p:spPr>
           <a:xfrm>
-            <a:off x="8220456" y="5120640"/>
-            <a:ext cx="3291840" cy="914400"/>
+            <a:off x="8220456" y="4754880"/>
+            <a:ext cx="3291840" cy="1234440"/>
           </a:xfrm>
           <a:prstGeom prst="rect">
             <a:avLst/>
@@ -2524,10 +2927,13 @@
           <a:lstStyle/>
           <a:p>
             <a:pPr indent="0" marL="0">
+              <a:lnSpc>
+                <a:spcPct val="105000"/>
+              </a:lnSpc>
               <a:buNone/>
             </a:pPr>
             <a:r>
-              <a:rPr lang="en-US" sz="1500" dirty="0">
+              <a:rPr lang="en-US" sz="1400" dirty="0">
                 <a:solidFill>
                   <a:srgbClr val="6B5640"/>
                 </a:solidFill>
@@ -2535,9 +2941,48 @@
                 <a:ea typeface="Cambria" pitchFamily="34" charset="-122"/>
                 <a:cs typeface="Cambria" pitchFamily="34" charset="-120"/>
               </a:rPr>
-              <a:t>Короткое пояснение в две-три строки: факт, довод или вывод.</a:t>
+              <a:t>Реформация Цвингли в Цюрихе и Кальвина в Женеве. Женевские ювелиры стали часовщиками.</a:t>
             </a:r>
-            <a:endParaRPr lang="en-US" sz="1500" dirty="0"/>
+            <a:endParaRPr lang="en-US" sz="1400" dirty="0"/>
+          </a:p>
+        </p:txBody>
+      </p:sp>
+      <p:sp>
+        <p:nvSpPr>
+          <p:cNvPr id="16" name="pageNum"/>
+          <p:cNvSpPr txBox="1"/>
+          <p:nvPr/>
+        </p:nvSpPr>
+        <p:spPr>
+          <a:xfrm>
+            <a:off x="10332720" y="6263640"/>
+            <a:ext cx="1097280" cy="274320"/>
+          </a:xfrm>
+          <a:prstGeom prst="rect">
+            <a:avLst/>
+          </a:prstGeom>
+          <a:noFill/>
+          <a:ln/>
+        </p:spPr>
+        <p:txBody>
+          <a:bodyPr wrap="square" lIns="0" tIns="0" rIns="0" bIns="0" rtlCol="0" anchor="ctr"/>
+          <a:lstStyle/>
+          <a:p>
+            <a:pPr algn="r" indent="0" marL="0">
+              <a:buNone/>
+            </a:pPr>
+            <a:r>
+              <a:rPr lang="en-US" sz="1000" spc="300" kern="0" dirty="0">
+                <a:solidFill>
+                  <a:srgbClr val="6B5640"/>
+                </a:solidFill>
+                <a:latin typeface="Bookman Old Style" pitchFamily="34" charset="0"/>
+                <a:ea typeface="Bookman Old Style" pitchFamily="34" charset="-122"/>
+                <a:cs typeface="Bookman Old Style" pitchFamily="34" charset="-120"/>
+              </a:rPr>
+              <a:t>III  ·  VI</a:t>
+            </a:r>
+            <a:endParaRPr lang="en-US" sz="1000" dirty="0"/>
           </a:p>
         </p:txBody>
       </p:sp>
@@ -2558,6 +3003,455 @@
       </p:transition>
     </mc:Fallback>
   </mc:AlternateContent>
+  <p:timing>
+    <p:tnLst>
+      <p:par>
+        <p:cTn id="1" dur="indefinite" restart="never" nodeType="tmRoot">
+          <p:childTnLst>
+            <p:seq concurrent="1" nextAc="seek">
+              <p:cTn id="2" dur="indefinite" nodeType="mainSeq">
+                <p:childTnLst>
+                  <p:par>
+                    <p:cTn id="3" fill="hold">
+                      <p:stCondLst>
+                        <p:cond delay="indefinite"/>
+                        <p:cond evt="onBegin" delay="0">
+                          <p:tn val="2"/>
+                        </p:cond>
+                      </p:stCondLst>
+                      <p:childTnLst>
+                        <p:par>
+                          <p:cTn id="4" fill="hold">
+                            <p:stCondLst>
+                              <p:cond delay="900"/>
+                            </p:stCondLst>
+                            <p:childTnLst>
+                              <p:par>
+                                <p:cTn id="5" presetID="10" presetClass="entr" presetSubtype="0" fill="hold" grpId="0" nodeType="withEffect">
+                                  <p:stCondLst>
+                                    <p:cond delay="0"/>
+                                  </p:stCondLst>
+                                  <p:childTnLst>
+                                    <p:set>
+                                      <p:cBhvr>
+                                        <p:cTn id="6" dur="1" fill="hold">
+                                          <p:stCondLst>
+                                            <p:cond delay="0"/>
+                                          </p:stCondLst>
+                                        </p:cTn>
+                                        <p:tgtEl>
+                                          <p:spTgt spid="7"/>
+                                        </p:tgtEl>
+                                        <p:attrNameLst>
+                                          <p:attrName>style.visibility</p:attrName>
+                                        </p:attrNameLst>
+                                      </p:cBhvr>
+                                      <p:to>
+                                        <p:strVal val="visible"/>
+                                      </p:to>
+                                    </p:set>
+                                    <p:animEffect transition="in" filter="fade">
+                                      <p:cBhvr>
+                                        <p:cTn id="7" dur="900"/>
+                                        <p:tgtEl>
+                                          <p:spTgt spid="7"/>
+                                        </p:tgtEl>
+                                      </p:cBhvr>
+                                    </p:animEffect>
+                                  </p:childTnLst>
+                                </p:cTn>
+                              </p:par>
+                            </p:childTnLst>
+                          </p:cTn>
+                        </p:par>
+                        <p:par>
+                          <p:cTn id="8" fill="hold">
+                            <p:stCondLst>
+                              <p:cond delay="1080"/>
+                            </p:stCondLst>
+                            <p:childTnLst>
+                              <p:par>
+                                <p:cTn id="9" presetID="10" presetClass="entr" presetSubtype="0" fill="hold" grpId="0" nodeType="withEffect">
+                                  <p:stCondLst>
+                                    <p:cond delay="0"/>
+                                  </p:stCondLst>
+                                  <p:childTnLst>
+                                    <p:set>
+                                      <p:cBhvr>
+                                        <p:cTn id="10" dur="1" fill="hold">
+                                          <p:stCondLst>
+                                            <p:cond delay="0"/>
+                                          </p:stCondLst>
+                                        </p:cTn>
+                                        <p:tgtEl>
+                                          <p:spTgt spid="8"/>
+                                        </p:tgtEl>
+                                        <p:attrNameLst>
+                                          <p:attrName>style.visibility</p:attrName>
+                                        </p:attrNameLst>
+                                      </p:cBhvr>
+                                      <p:to>
+                                        <p:strVal val="visible"/>
+                                      </p:to>
+                                    </p:set>
+                                    <p:animEffect transition="in" filter="fade">
+                                      <p:cBhvr>
+                                        <p:cTn id="11" dur="900"/>
+                                        <p:tgtEl>
+                                          <p:spTgt spid="8"/>
+                                        </p:tgtEl>
+                                      </p:cBhvr>
+                                    </p:animEffect>
+                                  </p:childTnLst>
+                                </p:cTn>
+                              </p:par>
+                            </p:childTnLst>
+                          </p:cTn>
+                        </p:par>
+                        <p:par>
+                          <p:cTn id="12" fill="hold">
+                            <p:stCondLst>
+                              <p:cond delay="1260"/>
+                            </p:stCondLst>
+                            <p:childTnLst>
+                              <p:par>
+                                <p:cTn id="13" presetID="10" presetClass="entr" presetSubtype="0" fill="hold" grpId="0" nodeType="withEffect">
+                                  <p:stCondLst>
+                                    <p:cond delay="0"/>
+                                  </p:stCondLst>
+                                  <p:childTnLst>
+                                    <p:set>
+                                      <p:cBhvr>
+                                        <p:cTn id="14" dur="1" fill="hold">
+                                          <p:stCondLst>
+                                            <p:cond delay="0"/>
+                                          </p:stCondLst>
+                                        </p:cTn>
+                                        <p:tgtEl>
+                                          <p:spTgt spid="9"/>
+                                        </p:tgtEl>
+                                        <p:attrNameLst>
+                                          <p:attrName>style.visibility</p:attrName>
+                                        </p:attrNameLst>
+                                      </p:cBhvr>
+                                      <p:to>
+                                        <p:strVal val="visible"/>
+                                      </p:to>
+                                    </p:set>
+                                    <p:animEffect transition="in" filter="fade">
+                                      <p:cBhvr>
+                                        <p:cTn id="15" dur="900"/>
+                                        <p:tgtEl>
+                                          <p:spTgt spid="9"/>
+                                        </p:tgtEl>
+                                      </p:cBhvr>
+                                    </p:animEffect>
+                                  </p:childTnLst>
+                                </p:cTn>
+                              </p:par>
+                            </p:childTnLst>
+                          </p:cTn>
+                        </p:par>
+                        <p:par>
+                          <p:cTn id="16" fill="hold">
+                            <p:stCondLst>
+                              <p:cond delay="1440"/>
+                            </p:stCondLst>
+                            <p:childTnLst>
+                              <p:par>
+                                <p:cTn id="17" presetID="10" presetClass="entr" presetSubtype="0" fill="hold" grpId="0" nodeType="withEffect">
+                                  <p:stCondLst>
+                                    <p:cond delay="0"/>
+                                  </p:stCondLst>
+                                  <p:childTnLst>
+                                    <p:set>
+                                      <p:cBhvr>
+                                        <p:cTn id="18" dur="1" fill="hold">
+                                          <p:stCondLst>
+                                            <p:cond delay="0"/>
+                                          </p:stCondLst>
+                                        </p:cTn>
+                                        <p:tgtEl>
+                                          <p:spTgt spid="10"/>
+                                        </p:tgtEl>
+                                        <p:attrNameLst>
+                                          <p:attrName>style.visibility</p:attrName>
+                                        </p:attrNameLst>
+                                      </p:cBhvr>
+                                      <p:to>
+                                        <p:strVal val="visible"/>
+                                      </p:to>
+                                    </p:set>
+                                    <p:animEffect transition="in" filter="fade">
+                                      <p:cBhvr>
+                                        <p:cTn id="19" dur="900"/>
+                                        <p:tgtEl>
+                                          <p:spTgt spid="10"/>
+                                        </p:tgtEl>
+                                      </p:cBhvr>
+                                    </p:animEffect>
+                                  </p:childTnLst>
+                                </p:cTn>
+                              </p:par>
+                            </p:childTnLst>
+                          </p:cTn>
+                        </p:par>
+                        <p:par>
+                          <p:cTn id="20" fill="hold">
+                            <p:stCondLst>
+                              <p:cond delay="1620"/>
+                            </p:stCondLst>
+                            <p:childTnLst>
+                              <p:par>
+                                <p:cTn id="21" presetID="10" presetClass="entr" presetSubtype="0" fill="hold" grpId="0" nodeType="withEffect">
+                                  <p:stCondLst>
+                                    <p:cond delay="0"/>
+                                  </p:stCondLst>
+                                  <p:childTnLst>
+                                    <p:set>
+                                      <p:cBhvr>
+                                        <p:cTn id="22" dur="1" fill="hold">
+                                          <p:stCondLst>
+                                            <p:cond delay="0"/>
+                                          </p:stCondLst>
+                                        </p:cTn>
+                                        <p:tgtEl>
+                                          <p:spTgt spid="11"/>
+                                        </p:tgtEl>
+                                        <p:attrNameLst>
+                                          <p:attrName>style.visibility</p:attrName>
+                                        </p:attrNameLst>
+                                      </p:cBhvr>
+                                      <p:to>
+                                        <p:strVal val="visible"/>
+                                      </p:to>
+                                    </p:set>
+                                    <p:animEffect transition="in" filter="fade">
+                                      <p:cBhvr>
+                                        <p:cTn id="23" dur="900"/>
+                                        <p:tgtEl>
+                                          <p:spTgt spid="11"/>
+                                        </p:tgtEl>
+                                      </p:cBhvr>
+                                    </p:animEffect>
+                                  </p:childTnLst>
+                                </p:cTn>
+                              </p:par>
+                            </p:childTnLst>
+                          </p:cTn>
+                        </p:par>
+                        <p:par>
+                          <p:cTn id="24" fill="hold">
+                            <p:stCondLst>
+                              <p:cond delay="1800"/>
+                            </p:stCondLst>
+                            <p:childTnLst>
+                              <p:par>
+                                <p:cTn id="25" presetID="10" presetClass="entr" presetSubtype="0" fill="hold" grpId="0" nodeType="withEffect">
+                                  <p:stCondLst>
+                                    <p:cond delay="0"/>
+                                  </p:stCondLst>
+                                  <p:childTnLst>
+                                    <p:set>
+                                      <p:cBhvr>
+                                        <p:cTn id="26" dur="1" fill="hold">
+                                          <p:stCondLst>
+                                            <p:cond delay="0"/>
+                                          </p:stCondLst>
+                                        </p:cTn>
+                                        <p:tgtEl>
+                                          <p:spTgt spid="12"/>
+                                        </p:tgtEl>
+                                        <p:attrNameLst>
+                                          <p:attrName>style.visibility</p:attrName>
+                                        </p:attrNameLst>
+                                      </p:cBhvr>
+                                      <p:to>
+                                        <p:strVal val="visible"/>
+                                      </p:to>
+                                    </p:set>
+                                    <p:animEffect transition="in" filter="fade">
+                                      <p:cBhvr>
+                                        <p:cTn id="27" dur="900"/>
+                                        <p:tgtEl>
+                                          <p:spTgt spid="12"/>
+                                        </p:tgtEl>
+                                      </p:cBhvr>
+                                    </p:animEffect>
+                                  </p:childTnLst>
+                                </p:cTn>
+                              </p:par>
+                            </p:childTnLst>
+                          </p:cTn>
+                        </p:par>
+                        <p:par>
+                          <p:cTn id="28" fill="hold">
+                            <p:stCondLst>
+                              <p:cond delay="1980"/>
+                            </p:stCondLst>
+                            <p:childTnLst>
+                              <p:par>
+                                <p:cTn id="29" presetID="10" presetClass="entr" presetSubtype="0" fill="hold" grpId="0" nodeType="withEffect">
+                                  <p:stCondLst>
+                                    <p:cond delay="0"/>
+                                  </p:stCondLst>
+                                  <p:childTnLst>
+                                    <p:set>
+                                      <p:cBhvr>
+                                        <p:cTn id="30" dur="1" fill="hold">
+                                          <p:stCondLst>
+                                            <p:cond delay="0"/>
+                                          </p:stCondLst>
+                                        </p:cTn>
+                                        <p:tgtEl>
+                                          <p:spTgt spid="13"/>
+                                        </p:tgtEl>
+                                        <p:attrNameLst>
+                                          <p:attrName>style.visibility</p:attrName>
+                                        </p:attrNameLst>
+                                      </p:cBhvr>
+                                      <p:to>
+                                        <p:strVal val="visible"/>
+                                      </p:to>
+                                    </p:set>
+                                    <p:animEffect transition="in" filter="fade">
+                                      <p:cBhvr>
+                                        <p:cTn id="31" dur="900"/>
+                                        <p:tgtEl>
+                                          <p:spTgt spid="13"/>
+                                        </p:tgtEl>
+                                      </p:cBhvr>
+                                    </p:animEffect>
+                                  </p:childTnLst>
+                                </p:cTn>
+                              </p:par>
+                            </p:childTnLst>
+                          </p:cTn>
+                        </p:par>
+                        <p:par>
+                          <p:cTn id="32" fill="hold">
+                            <p:stCondLst>
+                              <p:cond delay="2160"/>
+                            </p:stCondLst>
+                            <p:childTnLst>
+                              <p:par>
+                                <p:cTn id="33" presetID="10" presetClass="entr" presetSubtype="0" fill="hold" grpId="0" nodeType="withEffect">
+                                  <p:stCondLst>
+                                    <p:cond delay="0"/>
+                                  </p:stCondLst>
+                                  <p:childTnLst>
+                                    <p:set>
+                                      <p:cBhvr>
+                                        <p:cTn id="34" dur="1" fill="hold">
+                                          <p:stCondLst>
+                                            <p:cond delay="0"/>
+                                          </p:stCondLst>
+                                        </p:cTn>
+                                        <p:tgtEl>
+                                          <p:spTgt spid="14"/>
+                                        </p:tgtEl>
+                                        <p:attrNameLst>
+                                          <p:attrName>style.visibility</p:attrName>
+                                        </p:attrNameLst>
+                                      </p:cBhvr>
+                                      <p:to>
+                                        <p:strVal val="visible"/>
+                                      </p:to>
+                                    </p:set>
+                                    <p:animEffect transition="in" filter="fade">
+                                      <p:cBhvr>
+                                        <p:cTn id="35" dur="900"/>
+                                        <p:tgtEl>
+                                          <p:spTgt spid="14"/>
+                                        </p:tgtEl>
+                                      </p:cBhvr>
+                                    </p:animEffect>
+                                  </p:childTnLst>
+                                </p:cTn>
+                              </p:par>
+                            </p:childTnLst>
+                          </p:cTn>
+                        </p:par>
+                        <p:par>
+                          <p:cTn id="36" fill="hold">
+                            <p:stCondLst>
+                              <p:cond delay="2340"/>
+                            </p:stCondLst>
+                            <p:childTnLst>
+                              <p:par>
+                                <p:cTn id="37" presetID="10" presetClass="entr" presetSubtype="0" fill="hold" grpId="0" nodeType="withEffect">
+                                  <p:stCondLst>
+                                    <p:cond delay="0"/>
+                                  </p:stCondLst>
+                                  <p:childTnLst>
+                                    <p:set>
+                                      <p:cBhvr>
+                                        <p:cTn id="38" dur="1" fill="hold">
+                                          <p:stCondLst>
+                                            <p:cond delay="0"/>
+                                          </p:stCondLst>
+                                        </p:cTn>
+                                        <p:tgtEl>
+                                          <p:spTgt spid="15"/>
+                                        </p:tgtEl>
+                                        <p:attrNameLst>
+                                          <p:attrName>style.visibility</p:attrName>
+                                        </p:attrNameLst>
+                                      </p:cBhvr>
+                                      <p:to>
+                                        <p:strVal val="visible"/>
+                                      </p:to>
+                                    </p:set>
+                                    <p:animEffect transition="in" filter="fade">
+                                      <p:cBhvr>
+                                        <p:cTn id="39" dur="900"/>
+                                        <p:tgtEl>
+                                          <p:spTgt spid="15"/>
+                                        </p:tgtEl>
+                                      </p:cBhvr>
+                                    </p:animEffect>
+                                  </p:childTnLst>
+                                </p:cTn>
+                              </p:par>
+                            </p:childTnLst>
+                          </p:cTn>
+                        </p:par>
+                      </p:childTnLst>
+                    </p:cTn>
+                  </p:par>
+                </p:childTnLst>
+              </p:cTn>
+              <p:prevCondLst>
+                <p:cond evt="onPrev" delay="0">
+                  <p:tgtEl>
+                    <p:sldTgt/>
+                  </p:tgtEl>
+                </p:cond>
+              </p:prevCondLst>
+              <p:nextCondLst>
+                <p:cond evt="onNext" delay="0">
+                  <p:tgtEl>
+                    <p:sldTgt/>
+                  </p:tgtEl>
+                </p:cond>
+              </p:nextCondLst>
+            </p:seq>
+          </p:childTnLst>
+        </p:cTn>
+      </p:par>
+    </p:tnLst>
+    <p:bldLst>
+      <p:bldP spid="7" grpId="0"/>
+      <p:bldP spid="8" grpId="0"/>
+      <p:bldP spid="9" grpId="0"/>
+      <p:bldP spid="10" grpId="0"/>
+      <p:bldP spid="11" grpId="0"/>
+      <p:bldP spid="12" grpId="0"/>
+      <p:bldP spid="13" grpId="0"/>
+      <p:bldP spid="14" grpId="0"/>
+      <p:bldP spid="15" grpId="0"/>
+    </p:bldLst>
+  </p:timing>
 </p:sld>
 </file>
 
@@ -2651,7 +3545,7 @@
           </a:prstGeom>
           <a:solidFill>
             <a:srgbClr val="140E0A">
-              <a:alpha val="50000"/>
+              <a:alpha val="55000"/>
             </a:srgbClr>
           </a:solidFill>
           <a:ln/>
@@ -2753,7 +3647,7 @@
                 <a:ea typeface="Bookman Old Style" pitchFamily="34" charset="-122"/>
                 <a:cs typeface="Bookman Old Style" pitchFamily="34" charset="-120"/>
               </a:rPr>
-              <a:t>Хроника</a:t>
+              <a:t>Хроника свободы</a:t>
             </a:r>
             <a:endParaRPr lang="en-US" sz="4000" dirty="0"/>
           </a:p>
@@ -2815,8 +3709,8 @@
         </p:nvSpPr>
         <p:spPr>
           <a:xfrm>
-            <a:off x="822960" y="2377440"/>
-            <a:ext cx="2377440" cy="731520"/>
+            <a:off x="822960" y="2423160"/>
+            <a:ext cx="2011680" cy="731520"/>
           </a:xfrm>
           <a:prstGeom prst="rect">
             <a:avLst/>
@@ -2832,7 +3726,7 @@
               <a:buNone/>
             </a:pPr>
             <a:r>
-              <a:rPr lang="en-US" sz="3800" b="1" dirty="0">
+              <a:rPr lang="en-US" sz="3400" b="1" dirty="0">
                 <a:solidFill>
                   <a:srgbClr val="C9A15A"/>
                 </a:solidFill>
@@ -2842,7 +3736,7 @@
               </a:rPr>
               <a:t>1291</a:t>
             </a:r>
-            <a:endParaRPr lang="en-US" sz="3800" dirty="0"/>
+            <a:endParaRPr lang="en-US" sz="3400" dirty="0"/>
           </a:p>
         </p:txBody>
       </p:sp>
@@ -2855,7 +3749,7 @@
         <p:spPr>
           <a:xfrm>
             <a:off x="822960" y="3749040"/>
-            <a:ext cx="2606040" cy="411480"/>
+            <a:ext cx="2011680" cy="365760"/>
           </a:xfrm>
           <a:prstGeom prst="rect">
             <a:avLst/>
@@ -2871,7 +3765,7 @@
               <a:buNone/>
             </a:pPr>
             <a:r>
-              <a:rPr lang="en-US" sz="1500" b="1" dirty="0">
+              <a:rPr lang="en-US" sz="1400" b="1" dirty="0">
                 <a:solidFill>
                   <a:srgbClr val="F1E6CF"/>
                 </a:solidFill>
@@ -2879,9 +3773,9 @@
                 <a:ea typeface="Bookman Old Style" pitchFamily="34" charset="-122"/>
                 <a:cs typeface="Bookman Old Style" pitchFamily="34" charset="-120"/>
               </a:rPr>
-              <a:t>Союзная грамота</a:t>
+              <a:t>Вечный союз</a:t>
             </a:r>
-            <a:endParaRPr lang="en-US" sz="1500" dirty="0"/>
+            <a:endParaRPr lang="en-US" sz="1400" dirty="0"/>
           </a:p>
         </p:txBody>
       </p:sp>
@@ -2893,8 +3787,8 @@
         </p:nvSpPr>
         <p:spPr>
           <a:xfrm>
-            <a:off x="822960" y="4206240"/>
-            <a:ext cx="2377440" cy="822960"/>
+            <a:off x="822960" y="4160520"/>
+            <a:ext cx="1920240" cy="914400"/>
           </a:xfrm>
           <a:prstGeom prst="rect">
             <a:avLst/>
@@ -2910,7 +3804,7 @@
               <a:buNone/>
             </a:pPr>
             <a:r>
-              <a:rPr lang="en-US" sz="1400" dirty="0">
+              <a:rPr lang="en-US" sz="1300" dirty="0">
                 <a:solidFill>
                   <a:srgbClr val="D9C9A8"/>
                 </a:solidFill>
@@ -2918,9 +3812,9 @@
                 <a:ea typeface="Cambria" pitchFamily="34" charset="-122"/>
                 <a:cs typeface="Cambria" pitchFamily="34" charset="-120"/>
               </a:rPr>
-              <a:t>Ури, Швиц и Унтервальден заключают вечный союз</a:t>
+              <a:t>Ури, Швиц и Унтервальден объединяются</a:t>
             </a:r>
-            <a:endParaRPr lang="en-US" sz="1400" dirty="0"/>
+            <a:endParaRPr lang="en-US" sz="1300" dirty="0"/>
           </a:p>
         </p:txBody>
       </p:sp>
@@ -2932,7 +3826,7 @@
         </p:nvSpPr>
         <p:spPr>
           <a:xfrm>
-            <a:off x="3483864" y="3300984"/>
+            <a:off x="2999232" y="3300984"/>
             <a:ext cx="256032" cy="256032"/>
           </a:xfrm>
           <a:prstGeom prst="diamond">
@@ -2957,8 +3851,8 @@
         </p:nvSpPr>
         <p:spPr>
           <a:xfrm>
-            <a:off x="3520440" y="2377440"/>
-            <a:ext cx="2377440" cy="731520"/>
+            <a:off x="3035808" y="2423160"/>
+            <a:ext cx="2011680" cy="731520"/>
           </a:xfrm>
           <a:prstGeom prst="rect">
             <a:avLst/>
@@ -2974,7 +3868,7 @@
               <a:buNone/>
             </a:pPr>
             <a:r>
-              <a:rPr lang="en-US" sz="3800" b="1" dirty="0">
+              <a:rPr lang="en-US" sz="3400" b="1" dirty="0">
                 <a:solidFill>
                   <a:srgbClr val="C9A15A"/>
                 </a:solidFill>
@@ -2984,7 +3878,7 @@
               </a:rPr>
               <a:t>1315</a:t>
             </a:r>
-            <a:endParaRPr lang="en-US" sz="3800" dirty="0"/>
+            <a:endParaRPr lang="en-US" sz="3400" dirty="0"/>
           </a:p>
         </p:txBody>
       </p:sp>
@@ -2996,8 +3890,8 @@
         </p:nvSpPr>
         <p:spPr>
           <a:xfrm>
-            <a:off x="3520440" y="3749040"/>
-            <a:ext cx="2606040" cy="411480"/>
+            <a:off x="3035808" y="3749040"/>
+            <a:ext cx="2011680" cy="365760"/>
           </a:xfrm>
           <a:prstGeom prst="rect">
             <a:avLst/>
@@ -3013,7 +3907,7 @@
               <a:buNone/>
             </a:pPr>
             <a:r>
-              <a:rPr lang="en-US" sz="1500" b="1" dirty="0">
+              <a:rPr lang="en-US" sz="1400" b="1" dirty="0">
                 <a:solidFill>
                   <a:srgbClr val="F1E6CF"/>
                 </a:solidFill>
@@ -3023,7 +3917,7 @@
               </a:rPr>
               <a:t>Моргартен</a:t>
             </a:r>
-            <a:endParaRPr lang="en-US" sz="1500" dirty="0"/>
+            <a:endParaRPr lang="en-US" sz="1400" dirty="0"/>
           </a:p>
         </p:txBody>
       </p:sp>
@@ -3035,8 +3929,8 @@
         </p:nvSpPr>
         <p:spPr>
           <a:xfrm>
-            <a:off x="3520440" y="4206240"/>
-            <a:ext cx="2377440" cy="822960"/>
+            <a:off x="3035808" y="4160520"/>
+            <a:ext cx="1920240" cy="914400"/>
           </a:xfrm>
           <a:prstGeom prst="rect">
             <a:avLst/>
@@ -3052,7 +3946,7 @@
               <a:buNone/>
             </a:pPr>
             <a:r>
-              <a:rPr lang="en-US" sz="1400" dirty="0">
+              <a:rPr lang="en-US" sz="1300" dirty="0">
                 <a:solidFill>
                   <a:srgbClr val="D9C9A8"/>
                 </a:solidFill>
@@ -3060,9 +3954,9 @@
                 <a:ea typeface="Cambria" pitchFamily="34" charset="-122"/>
                 <a:cs typeface="Cambria" pitchFamily="34" charset="-120"/>
               </a:rPr>
-              <a:t>Первая крупная победа конфедератов</a:t>
+              <a:t>Ополченцы разбили австрийских рыцарей</a:t>
             </a:r>
-            <a:endParaRPr lang="en-US" sz="1400" dirty="0"/>
+            <a:endParaRPr lang="en-US" sz="1300" dirty="0"/>
           </a:p>
         </p:txBody>
       </p:sp>
@@ -3074,7 +3968,7 @@
         </p:nvSpPr>
         <p:spPr>
           <a:xfrm>
-            <a:off x="6181344" y="3300984"/>
+            <a:off x="5212080" y="3300984"/>
             <a:ext cx="256032" cy="256032"/>
           </a:xfrm>
           <a:prstGeom prst="diamond">
@@ -3099,8 +3993,8 @@
         </p:nvSpPr>
         <p:spPr>
           <a:xfrm>
-            <a:off x="6217920" y="2377440"/>
-            <a:ext cx="2377440" cy="731520"/>
+            <a:off x="5248656" y="2423160"/>
+            <a:ext cx="2011680" cy="731520"/>
           </a:xfrm>
           <a:prstGeom prst="rect">
             <a:avLst/>
@@ -3116,7 +4010,7 @@
               <a:buNone/>
             </a:pPr>
             <a:r>
-              <a:rPr lang="en-US" sz="3800" b="1" dirty="0">
+              <a:rPr lang="en-US" sz="3400" b="1" dirty="0">
                 <a:solidFill>
                   <a:srgbClr val="C9A15A"/>
                 </a:solidFill>
@@ -3124,9 +4018,9 @@
                 <a:ea typeface="Bookman Old Style" pitchFamily="34" charset="-122"/>
                 <a:cs typeface="Bookman Old Style" pitchFamily="34" charset="-120"/>
               </a:rPr>
-              <a:t>1499</a:t>
+              <a:t>1476</a:t>
             </a:r>
-            <a:endParaRPr lang="en-US" sz="3800" dirty="0"/>
+            <a:endParaRPr lang="en-US" sz="3400" dirty="0"/>
           </a:p>
         </p:txBody>
       </p:sp>
@@ -3138,8 +4032,8 @@
         </p:nvSpPr>
         <p:spPr>
           <a:xfrm>
-            <a:off x="6217920" y="3749040"/>
-            <a:ext cx="2606040" cy="411480"/>
+            <a:off x="5248656" y="3749040"/>
+            <a:ext cx="2011680" cy="365760"/>
           </a:xfrm>
           <a:prstGeom prst="rect">
             <a:avLst/>
@@ -3155,7 +4049,7 @@
               <a:buNone/>
             </a:pPr>
             <a:r>
-              <a:rPr lang="en-US" sz="1500" b="1" dirty="0">
+              <a:rPr lang="en-US" sz="1400" b="1" dirty="0">
                 <a:solidFill>
                   <a:srgbClr val="F1E6CF"/>
                 </a:solidFill>
@@ -3163,9 +4057,9 @@
                 <a:ea typeface="Bookman Old Style" pitchFamily="34" charset="-122"/>
                 <a:cs typeface="Bookman Old Style" pitchFamily="34" charset="-120"/>
               </a:rPr>
-              <a:t>Швабская война</a:t>
+              <a:t>Грансон и Муртен</a:t>
             </a:r>
-            <a:endParaRPr lang="en-US" sz="1500" dirty="0"/>
+            <a:endParaRPr lang="en-US" sz="1400" dirty="0"/>
           </a:p>
         </p:txBody>
       </p:sp>
@@ -3177,8 +4071,8 @@
         </p:nvSpPr>
         <p:spPr>
           <a:xfrm>
-            <a:off x="6217920" y="4206240"/>
-            <a:ext cx="2377440" cy="822960"/>
+            <a:off x="5248656" y="4160520"/>
+            <a:ext cx="1920240" cy="914400"/>
           </a:xfrm>
           <a:prstGeom prst="rect">
             <a:avLst/>
@@ -3194,7 +4088,7 @@
               <a:buNone/>
             </a:pPr>
             <a:r>
-              <a:rPr lang="en-US" sz="1400" dirty="0">
+              <a:rPr lang="en-US" sz="1300" dirty="0">
                 <a:solidFill>
                   <a:srgbClr val="D9C9A8"/>
                 </a:solidFill>
@@ -3202,9 +4096,9 @@
                 <a:ea typeface="Cambria" pitchFamily="34" charset="-122"/>
                 <a:cs typeface="Cambria" pitchFamily="34" charset="-120"/>
               </a:rPr>
-              <a:t>Фактическая независимость от Империи</a:t>
+              <a:t>Разгром Карла Смелого Бургундского</a:t>
             </a:r>
-            <a:endParaRPr lang="en-US" sz="1400" dirty="0"/>
+            <a:endParaRPr lang="en-US" sz="1300" dirty="0"/>
           </a:p>
         </p:txBody>
       </p:sp>
@@ -3216,7 +4110,7 @@
         </p:nvSpPr>
         <p:spPr>
           <a:xfrm>
-            <a:off x="8878824" y="3300984"/>
+            <a:off x="7424928" y="3300984"/>
             <a:ext cx="256032" cy="256032"/>
           </a:xfrm>
           <a:prstGeom prst="diamond">
@@ -3241,8 +4135,8 @@
         </p:nvSpPr>
         <p:spPr>
           <a:xfrm>
-            <a:off x="8915400" y="2377440"/>
-            <a:ext cx="2377440" cy="731520"/>
+            <a:off x="7461504" y="2423160"/>
+            <a:ext cx="2011680" cy="731520"/>
           </a:xfrm>
           <a:prstGeom prst="rect">
             <a:avLst/>
@@ -3258,7 +4152,149 @@
               <a:buNone/>
             </a:pPr>
             <a:r>
-              <a:rPr lang="en-US" sz="3800" b="1" dirty="0">
+              <a:rPr lang="en-US" sz="3400" b="1" dirty="0">
+                <a:solidFill>
+                  <a:srgbClr val="C9A15A"/>
+                </a:solidFill>
+                <a:latin typeface="Bookman Old Style" pitchFamily="34" charset="0"/>
+                <a:ea typeface="Bookman Old Style" pitchFamily="34" charset="-122"/>
+                <a:cs typeface="Bookman Old Style" pitchFamily="34" charset="-120"/>
+              </a:rPr>
+              <a:t>1515</a:t>
+            </a:r>
+            <a:endParaRPr lang="en-US" sz="3400" dirty="0"/>
+          </a:p>
+        </p:txBody>
+      </p:sp>
+      <p:sp>
+        <p:nvSpPr>
+          <p:cNvPr id="23" name="Text 19"/>
+          <p:cNvSpPr txBox="1"/>
+          <p:nvPr/>
+        </p:nvSpPr>
+        <p:spPr>
+          <a:xfrm>
+            <a:off x="7461504" y="3749040"/>
+            <a:ext cx="2011680" cy="365760"/>
+          </a:xfrm>
+          <a:prstGeom prst="rect">
+            <a:avLst/>
+          </a:prstGeom>
+          <a:noFill/>
+          <a:ln/>
+        </p:spPr>
+        <p:txBody>
+          <a:bodyPr wrap="square" lIns="0" tIns="0" rIns="0" bIns="0" rtlCol="0" anchor="ctr"/>
+          <a:lstStyle/>
+          <a:p>
+            <a:pPr indent="0" marL="0">
+              <a:buNone/>
+            </a:pPr>
+            <a:r>
+              <a:rPr lang="en-US" sz="1400" b="1" dirty="0">
+                <a:solidFill>
+                  <a:srgbClr val="F1E6CF"/>
+                </a:solidFill>
+                <a:latin typeface="Bookman Old Style" pitchFamily="34" charset="0"/>
+                <a:ea typeface="Bookman Old Style" pitchFamily="34" charset="-122"/>
+                <a:cs typeface="Bookman Old Style" pitchFamily="34" charset="-120"/>
+              </a:rPr>
+              <a:t>Мариньяно</a:t>
+            </a:r>
+            <a:endParaRPr lang="en-US" sz="1400" dirty="0"/>
+          </a:p>
+        </p:txBody>
+      </p:sp>
+      <p:sp>
+        <p:nvSpPr>
+          <p:cNvPr id="24" name="Text 20"/>
+          <p:cNvSpPr txBox="1"/>
+          <p:nvPr/>
+        </p:nvSpPr>
+        <p:spPr>
+          <a:xfrm>
+            <a:off x="7461504" y="4160520"/>
+            <a:ext cx="1920240" cy="914400"/>
+          </a:xfrm>
+          <a:prstGeom prst="rect">
+            <a:avLst/>
+          </a:prstGeom>
+          <a:noFill/>
+          <a:ln/>
+        </p:spPr>
+        <p:txBody>
+          <a:bodyPr wrap="square" lIns="0" tIns="0" rIns="0" bIns="0" rtlCol="0" anchor="t"/>
+          <a:lstStyle/>
+          <a:p>
+            <a:pPr indent="0" marL="0">
+              <a:buNone/>
+            </a:pPr>
+            <a:r>
+              <a:rPr lang="en-US" sz="1300" dirty="0">
+                <a:solidFill>
+                  <a:srgbClr val="D9C9A8"/>
+                </a:solidFill>
+                <a:latin typeface="Cambria" pitchFamily="34" charset="0"/>
+                <a:ea typeface="Cambria" pitchFamily="34" charset="-122"/>
+                <a:cs typeface="Cambria" pitchFamily="34" charset="-120"/>
+              </a:rPr>
+              <a:t>Поражение от Франции — курс на нейтралитет</a:t>
+            </a:r>
+            <a:endParaRPr lang="en-US" sz="1300" dirty="0"/>
+          </a:p>
+        </p:txBody>
+      </p:sp>
+      <p:sp>
+        <p:nvSpPr>
+          <p:cNvPr id="25" name="Shape 21"/>
+          <p:cNvSpPr/>
+          <p:nvPr/>
+        </p:nvSpPr>
+        <p:spPr>
+          <a:xfrm>
+            <a:off x="9637776" y="3300984"/>
+            <a:ext cx="256032" cy="256032"/>
+          </a:xfrm>
+          <a:prstGeom prst="diamond">
+            <a:avLst/>
+          </a:prstGeom>
+          <a:solidFill>
+            <a:srgbClr val="7A1C1A"/>
+          </a:solidFill>
+          <a:ln w="15875">
+            <a:solidFill>
+              <a:srgbClr val="C9A15A"/>
+            </a:solidFill>
+            <a:prstDash val="solid"/>
+          </a:ln>
+        </p:spPr>
+      </p:sp>
+      <p:sp>
+        <p:nvSpPr>
+          <p:cNvPr id="26" name="Text 22"/>
+          <p:cNvSpPr txBox="1"/>
+          <p:nvPr/>
+        </p:nvSpPr>
+        <p:spPr>
+          <a:xfrm>
+            <a:off x="9674352" y="2423160"/>
+            <a:ext cx="2011680" cy="731520"/>
+          </a:xfrm>
+          <a:prstGeom prst="rect">
+            <a:avLst/>
+          </a:prstGeom>
+          <a:noFill/>
+          <a:ln/>
+        </p:spPr>
+        <p:txBody>
+          <a:bodyPr wrap="square" lIns="0" tIns="0" rIns="0" bIns="0" rtlCol="0" anchor="ctr"/>
+          <a:lstStyle/>
+          <a:p>
+            <a:pPr indent="0" marL="0">
+              <a:buNone/>
+            </a:pPr>
+            <a:r>
+              <a:rPr lang="en-US" sz="3400" b="1" dirty="0">
                 <a:solidFill>
                   <a:srgbClr val="C9A15A"/>
                 </a:solidFill>
@@ -3268,20 +4304,20 @@
               </a:rPr>
               <a:t>1648</a:t>
             </a:r>
-            <a:endParaRPr lang="en-US" sz="3800" dirty="0"/>
-          </a:p>
-        </p:txBody>
-      </p:sp>
-      <p:sp>
-        <p:nvSpPr>
-          <p:cNvPr id="23" name="Text 19"/>
+            <a:endParaRPr lang="en-US" sz="3400" dirty="0"/>
+          </a:p>
+        </p:txBody>
+      </p:sp>
+      <p:sp>
+        <p:nvSpPr>
+          <p:cNvPr id="27" name="Text 23"/>
           <p:cNvSpPr txBox="1"/>
           <p:nvPr/>
         </p:nvSpPr>
         <p:spPr>
           <a:xfrm>
-            <a:off x="8915400" y="3749040"/>
-            <a:ext cx="2606040" cy="411480"/>
+            <a:off x="9674352" y="3749040"/>
+            <a:ext cx="2011680" cy="365760"/>
           </a:xfrm>
           <a:prstGeom prst="rect">
             <a:avLst/>
@@ -3297,7 +4333,7 @@
               <a:buNone/>
             </a:pPr>
             <a:r>
-              <a:rPr lang="en-US" sz="1500" b="1" dirty="0">
+              <a:rPr lang="en-US" sz="1400" b="1" dirty="0">
                 <a:solidFill>
                   <a:srgbClr val="F1E6CF"/>
                 </a:solidFill>
@@ -3307,20 +4343,20 @@
               </a:rPr>
               <a:t>Вестфальский мир</a:t>
             </a:r>
-            <a:endParaRPr lang="en-US" sz="1500" dirty="0"/>
-          </a:p>
-        </p:txBody>
-      </p:sp>
-      <p:sp>
-        <p:nvSpPr>
-          <p:cNvPr id="24" name="Text 20"/>
+            <a:endParaRPr lang="en-US" sz="1400" dirty="0"/>
+          </a:p>
+        </p:txBody>
+      </p:sp>
+      <p:sp>
+        <p:nvSpPr>
+          <p:cNvPr id="28" name="Text 24"/>
           <p:cNvSpPr txBox="1"/>
           <p:nvPr/>
         </p:nvSpPr>
         <p:spPr>
           <a:xfrm>
-            <a:off x="8915400" y="4206240"/>
-            <a:ext cx="2377440" cy="822960"/>
+            <a:off x="9674352" y="4160520"/>
+            <a:ext cx="1920240" cy="914400"/>
           </a:xfrm>
           <a:prstGeom prst="rect">
             <a:avLst/>
@@ -3336,7 +4372,7 @@
               <a:buNone/>
             </a:pPr>
             <a:r>
-              <a:rPr lang="en-US" sz="1400" dirty="0">
+              <a:rPr lang="en-US" sz="1300" dirty="0">
                 <a:solidFill>
                   <a:srgbClr val="D9C9A8"/>
                 </a:solidFill>
@@ -3344,22 +4380,22 @@
                 <a:ea typeface="Cambria" pitchFamily="34" charset="-122"/>
                 <a:cs typeface="Cambria" pitchFamily="34" charset="-120"/>
               </a:rPr>
-              <a:t>Независимость признана всей Европой</a:t>
+              <a:t>Европа признала независимость</a:t>
             </a:r>
-            <a:endParaRPr lang="en-US" sz="1400" dirty="0"/>
-          </a:p>
-        </p:txBody>
-      </p:sp>
-      <p:sp>
-        <p:nvSpPr>
-          <p:cNvPr id="25" name="Text 21"/>
+            <a:endParaRPr lang="en-US" sz="1300" dirty="0"/>
+          </a:p>
+        </p:txBody>
+      </p:sp>
+      <p:sp>
+        <p:nvSpPr>
+          <p:cNvPr id="29" name="Text 25"/>
           <p:cNvSpPr txBox="1"/>
           <p:nvPr/>
         </p:nvSpPr>
         <p:spPr>
           <a:xfrm>
-            <a:off x="777240" y="5760720"/>
-            <a:ext cx="10058400" cy="365760"/>
+            <a:off x="777240" y="5715000"/>
+            <a:ext cx="9418320" cy="365760"/>
           </a:xfrm>
           <a:prstGeom prst="rect">
             <a:avLst/>
@@ -3383,9 +4419,48 @@
                 <a:ea typeface="Cambria" pitchFamily="34" charset="-122"/>
                 <a:cs typeface="Cambria" pitchFamily="34" charset="-120"/>
               </a:rPr>
-              <a:t>Замените даты на этапы своего проекта — четыре узла держат ритм слайда.</a:t>
+              <a:t>После Швабской войны 1499 года Швейцария фактически не подчинялась Империи.</a:t>
             </a:r>
             <a:endParaRPr lang="en-US" sz="1200" dirty="0"/>
+          </a:p>
+        </p:txBody>
+      </p:sp>
+      <p:sp>
+        <p:nvSpPr>
+          <p:cNvPr id="30" name="pageNum"/>
+          <p:cNvSpPr txBox="1"/>
+          <p:nvPr/>
+        </p:nvSpPr>
+        <p:spPr>
+          <a:xfrm>
+            <a:off x="10332720" y="6263640"/>
+            <a:ext cx="1097280" cy="274320"/>
+          </a:xfrm>
+          <a:prstGeom prst="rect">
+            <a:avLst/>
+          </a:prstGeom>
+          <a:noFill/>
+          <a:ln/>
+        </p:spPr>
+        <p:txBody>
+          <a:bodyPr wrap="square" lIns="0" tIns="0" rIns="0" bIns="0" rtlCol="0" anchor="ctr"/>
+          <a:lstStyle/>
+          <a:p>
+            <a:pPr algn="r" indent="0" marL="0">
+              <a:buNone/>
+            </a:pPr>
+            <a:r>
+              <a:rPr lang="en-US" sz="1000" spc="300" kern="0" dirty="0">
+                <a:solidFill>
+                  <a:srgbClr val="C9A15A"/>
+                </a:solidFill>
+                <a:latin typeface="Bookman Old Style" pitchFamily="34" charset="0"/>
+                <a:ea typeface="Bookman Old Style" pitchFamily="34" charset="-122"/>
+                <a:cs typeface="Bookman Old Style" pitchFamily="34" charset="-120"/>
+              </a:rPr>
+              <a:t>IV  ·  VI</a:t>
+            </a:r>
+            <a:endParaRPr lang="en-US" sz="1000" dirty="0"/>
           </a:p>
         </p:txBody>
       </p:sp>
@@ -3406,6 +4481,770 @@
       </p:transition>
     </mc:Fallback>
   </mc:AlternateContent>
+  <p:timing>
+    <p:tnLst>
+      <p:par>
+        <p:cTn id="1" dur="indefinite" restart="never" nodeType="tmRoot">
+          <p:childTnLst>
+            <p:seq concurrent="1" nextAc="seek">
+              <p:cTn id="2" dur="indefinite" nodeType="mainSeq">
+                <p:childTnLst>
+                  <p:par>
+                    <p:cTn id="3" fill="hold">
+                      <p:stCondLst>
+                        <p:cond delay="indefinite"/>
+                        <p:cond evt="onBegin" delay="0">
+                          <p:tn val="2"/>
+                        </p:cond>
+                      </p:stCondLst>
+                      <p:childTnLst>
+                        <p:par>
+                          <p:cTn id="4" fill="hold">
+                            <p:stCondLst>
+                              <p:cond delay="900"/>
+                            </p:stCondLst>
+                            <p:childTnLst>
+                              <p:par>
+                                <p:cTn id="5" presetID="10" presetClass="entr" presetSubtype="0" fill="hold" grpId="0" nodeType="withEffect">
+                                  <p:stCondLst>
+                                    <p:cond delay="0"/>
+                                  </p:stCondLst>
+                                  <p:childTnLst>
+                                    <p:set>
+                                      <p:cBhvr>
+                                        <p:cTn id="6" dur="1" fill="hold">
+                                          <p:stCondLst>
+                                            <p:cond delay="0"/>
+                                          </p:stCondLst>
+                                        </p:cTn>
+                                        <p:tgtEl>
+                                          <p:spTgt spid="10"/>
+                                        </p:tgtEl>
+                                        <p:attrNameLst>
+                                          <p:attrName>style.visibility</p:attrName>
+                                        </p:attrNameLst>
+                                      </p:cBhvr>
+                                      <p:to>
+                                        <p:strVal val="visible"/>
+                                      </p:to>
+                                    </p:set>
+                                    <p:animEffect transition="in" filter="fade">
+                                      <p:cBhvr>
+                                        <p:cTn id="7" dur="900"/>
+                                        <p:tgtEl>
+                                          <p:spTgt spid="10"/>
+                                        </p:tgtEl>
+                                      </p:cBhvr>
+                                    </p:animEffect>
+                                  </p:childTnLst>
+                                </p:cTn>
+                              </p:par>
+                            </p:childTnLst>
+                          </p:cTn>
+                        </p:par>
+                        <p:par>
+                          <p:cTn id="8" fill="hold">
+                            <p:stCondLst>
+                              <p:cond delay="1080"/>
+                            </p:stCondLst>
+                            <p:childTnLst>
+                              <p:par>
+                                <p:cTn id="9" presetID="10" presetClass="entr" presetSubtype="0" fill="hold" grpId="0" nodeType="withEffect">
+                                  <p:stCondLst>
+                                    <p:cond delay="0"/>
+                                  </p:stCondLst>
+                                  <p:childTnLst>
+                                    <p:set>
+                                      <p:cBhvr>
+                                        <p:cTn id="10" dur="1" fill="hold">
+                                          <p:stCondLst>
+                                            <p:cond delay="0"/>
+                                          </p:stCondLst>
+                                        </p:cTn>
+                                        <p:tgtEl>
+                                          <p:spTgt spid="11"/>
+                                        </p:tgtEl>
+                                        <p:attrNameLst>
+                                          <p:attrName>style.visibility</p:attrName>
+                                        </p:attrNameLst>
+                                      </p:cBhvr>
+                                      <p:to>
+                                        <p:strVal val="visible"/>
+                                      </p:to>
+                                    </p:set>
+                                    <p:animEffect transition="in" filter="fade">
+                                      <p:cBhvr>
+                                        <p:cTn id="11" dur="900"/>
+                                        <p:tgtEl>
+                                          <p:spTgt spid="11"/>
+                                        </p:tgtEl>
+                                      </p:cBhvr>
+                                    </p:animEffect>
+                                  </p:childTnLst>
+                                </p:cTn>
+                              </p:par>
+                            </p:childTnLst>
+                          </p:cTn>
+                        </p:par>
+                        <p:par>
+                          <p:cTn id="12" fill="hold">
+                            <p:stCondLst>
+                              <p:cond delay="1260"/>
+                            </p:stCondLst>
+                            <p:childTnLst>
+                              <p:par>
+                                <p:cTn id="13" presetID="10" presetClass="entr" presetSubtype="0" fill="hold" grpId="0" nodeType="withEffect">
+                                  <p:stCondLst>
+                                    <p:cond delay="0"/>
+                                  </p:stCondLst>
+                                  <p:childTnLst>
+                                    <p:set>
+                                      <p:cBhvr>
+                                        <p:cTn id="14" dur="1" fill="hold">
+                                          <p:stCondLst>
+                                            <p:cond delay="0"/>
+                                          </p:stCondLst>
+                                        </p:cTn>
+                                        <p:tgtEl>
+                                          <p:spTgt spid="12"/>
+                                        </p:tgtEl>
+                                        <p:attrNameLst>
+                                          <p:attrName>style.visibility</p:attrName>
+                                        </p:attrNameLst>
+                                      </p:cBhvr>
+                                      <p:to>
+                                        <p:strVal val="visible"/>
+                                      </p:to>
+                                    </p:set>
+                                    <p:animEffect transition="in" filter="fade">
+                                      <p:cBhvr>
+                                        <p:cTn id="15" dur="900"/>
+                                        <p:tgtEl>
+                                          <p:spTgt spid="12"/>
+                                        </p:tgtEl>
+                                      </p:cBhvr>
+                                    </p:animEffect>
+                                  </p:childTnLst>
+                                </p:cTn>
+                              </p:par>
+                            </p:childTnLst>
+                          </p:cTn>
+                        </p:par>
+                        <p:par>
+                          <p:cTn id="16" fill="hold">
+                            <p:stCondLst>
+                              <p:cond delay="1440"/>
+                            </p:stCondLst>
+                            <p:childTnLst>
+                              <p:par>
+                                <p:cTn id="17" presetID="10" presetClass="entr" presetSubtype="0" fill="hold" grpId="0" nodeType="withEffect">
+                                  <p:stCondLst>
+                                    <p:cond delay="0"/>
+                                  </p:stCondLst>
+                                  <p:childTnLst>
+                                    <p:set>
+                                      <p:cBhvr>
+                                        <p:cTn id="18" dur="1" fill="hold">
+                                          <p:stCondLst>
+                                            <p:cond delay="0"/>
+                                          </p:stCondLst>
+                                        </p:cTn>
+                                        <p:tgtEl>
+                                          <p:spTgt spid="14"/>
+                                        </p:tgtEl>
+                                        <p:attrNameLst>
+                                          <p:attrName>style.visibility</p:attrName>
+                                        </p:attrNameLst>
+                                      </p:cBhvr>
+                                      <p:to>
+                                        <p:strVal val="visible"/>
+                                      </p:to>
+                                    </p:set>
+                                    <p:animEffect transition="in" filter="fade">
+                                      <p:cBhvr>
+                                        <p:cTn id="19" dur="900"/>
+                                        <p:tgtEl>
+                                          <p:spTgt spid="14"/>
+                                        </p:tgtEl>
+                                      </p:cBhvr>
+                                    </p:animEffect>
+                                  </p:childTnLst>
+                                </p:cTn>
+                              </p:par>
+                            </p:childTnLst>
+                          </p:cTn>
+                        </p:par>
+                        <p:par>
+                          <p:cTn id="20" fill="hold">
+                            <p:stCondLst>
+                              <p:cond delay="1620"/>
+                            </p:stCondLst>
+                            <p:childTnLst>
+                              <p:par>
+                                <p:cTn id="21" presetID="10" presetClass="entr" presetSubtype="0" fill="hold" grpId="0" nodeType="withEffect">
+                                  <p:stCondLst>
+                                    <p:cond delay="0"/>
+                                  </p:stCondLst>
+                                  <p:childTnLst>
+                                    <p:set>
+                                      <p:cBhvr>
+                                        <p:cTn id="22" dur="1" fill="hold">
+                                          <p:stCondLst>
+                                            <p:cond delay="0"/>
+                                          </p:stCondLst>
+                                        </p:cTn>
+                                        <p:tgtEl>
+                                          <p:spTgt spid="15"/>
+                                        </p:tgtEl>
+                                        <p:attrNameLst>
+                                          <p:attrName>style.visibility</p:attrName>
+                                        </p:attrNameLst>
+                                      </p:cBhvr>
+                                      <p:to>
+                                        <p:strVal val="visible"/>
+                                      </p:to>
+                                    </p:set>
+                                    <p:animEffect transition="in" filter="fade">
+                                      <p:cBhvr>
+                                        <p:cTn id="23" dur="900"/>
+                                        <p:tgtEl>
+                                          <p:spTgt spid="15"/>
+                                        </p:tgtEl>
+                                      </p:cBhvr>
+                                    </p:animEffect>
+                                  </p:childTnLst>
+                                </p:cTn>
+                              </p:par>
+                            </p:childTnLst>
+                          </p:cTn>
+                        </p:par>
+                        <p:par>
+                          <p:cTn id="24" fill="hold">
+                            <p:stCondLst>
+                              <p:cond delay="1800"/>
+                            </p:stCondLst>
+                            <p:childTnLst>
+                              <p:par>
+                                <p:cTn id="25" presetID="10" presetClass="entr" presetSubtype="0" fill="hold" grpId="0" nodeType="withEffect">
+                                  <p:stCondLst>
+                                    <p:cond delay="0"/>
+                                  </p:stCondLst>
+                                  <p:childTnLst>
+                                    <p:set>
+                                      <p:cBhvr>
+                                        <p:cTn id="26" dur="1" fill="hold">
+                                          <p:stCondLst>
+                                            <p:cond delay="0"/>
+                                          </p:stCondLst>
+                                        </p:cTn>
+                                        <p:tgtEl>
+                                          <p:spTgt spid="16"/>
+                                        </p:tgtEl>
+                                        <p:attrNameLst>
+                                          <p:attrName>style.visibility</p:attrName>
+                                        </p:attrNameLst>
+                                      </p:cBhvr>
+                                      <p:to>
+                                        <p:strVal val="visible"/>
+                                      </p:to>
+                                    </p:set>
+                                    <p:animEffect transition="in" filter="fade">
+                                      <p:cBhvr>
+                                        <p:cTn id="27" dur="900"/>
+                                        <p:tgtEl>
+                                          <p:spTgt spid="16"/>
+                                        </p:tgtEl>
+                                      </p:cBhvr>
+                                    </p:animEffect>
+                                  </p:childTnLst>
+                                </p:cTn>
+                              </p:par>
+                            </p:childTnLst>
+                          </p:cTn>
+                        </p:par>
+                        <p:par>
+                          <p:cTn id="28" fill="hold">
+                            <p:stCondLst>
+                              <p:cond delay="1980"/>
+                            </p:stCondLst>
+                            <p:childTnLst>
+                              <p:par>
+                                <p:cTn id="29" presetID="10" presetClass="entr" presetSubtype="0" fill="hold" grpId="0" nodeType="withEffect">
+                                  <p:stCondLst>
+                                    <p:cond delay="0"/>
+                                  </p:stCondLst>
+                                  <p:childTnLst>
+                                    <p:set>
+                                      <p:cBhvr>
+                                        <p:cTn id="30" dur="1" fill="hold">
+                                          <p:stCondLst>
+                                            <p:cond delay="0"/>
+                                          </p:stCondLst>
+                                        </p:cTn>
+                                        <p:tgtEl>
+                                          <p:spTgt spid="18"/>
+                                        </p:tgtEl>
+                                        <p:attrNameLst>
+                                          <p:attrName>style.visibility</p:attrName>
+                                        </p:attrNameLst>
+                                      </p:cBhvr>
+                                      <p:to>
+                                        <p:strVal val="visible"/>
+                                      </p:to>
+                                    </p:set>
+                                    <p:animEffect transition="in" filter="fade">
+                                      <p:cBhvr>
+                                        <p:cTn id="31" dur="900"/>
+                                        <p:tgtEl>
+                                          <p:spTgt spid="18"/>
+                                        </p:tgtEl>
+                                      </p:cBhvr>
+                                    </p:animEffect>
+                                  </p:childTnLst>
+                                </p:cTn>
+                              </p:par>
+                            </p:childTnLst>
+                          </p:cTn>
+                        </p:par>
+                        <p:par>
+                          <p:cTn id="32" fill="hold">
+                            <p:stCondLst>
+                              <p:cond delay="2160"/>
+                            </p:stCondLst>
+                            <p:childTnLst>
+                              <p:par>
+                                <p:cTn id="33" presetID="10" presetClass="entr" presetSubtype="0" fill="hold" grpId="0" nodeType="withEffect">
+                                  <p:stCondLst>
+                                    <p:cond delay="0"/>
+                                  </p:stCondLst>
+                                  <p:childTnLst>
+                                    <p:set>
+                                      <p:cBhvr>
+                                        <p:cTn id="34" dur="1" fill="hold">
+                                          <p:stCondLst>
+                                            <p:cond delay="0"/>
+                                          </p:stCondLst>
+                                        </p:cTn>
+                                        <p:tgtEl>
+                                          <p:spTgt spid="19"/>
+                                        </p:tgtEl>
+                                        <p:attrNameLst>
+                                          <p:attrName>style.visibility</p:attrName>
+                                        </p:attrNameLst>
+                                      </p:cBhvr>
+                                      <p:to>
+                                        <p:strVal val="visible"/>
+                                      </p:to>
+                                    </p:set>
+                                    <p:animEffect transition="in" filter="fade">
+                                      <p:cBhvr>
+                                        <p:cTn id="35" dur="900"/>
+                                        <p:tgtEl>
+                                          <p:spTgt spid="19"/>
+                                        </p:tgtEl>
+                                      </p:cBhvr>
+                                    </p:animEffect>
+                                  </p:childTnLst>
+                                </p:cTn>
+                              </p:par>
+                            </p:childTnLst>
+                          </p:cTn>
+                        </p:par>
+                        <p:par>
+                          <p:cTn id="36" fill="hold">
+                            <p:stCondLst>
+                              <p:cond delay="2340"/>
+                            </p:stCondLst>
+                            <p:childTnLst>
+                              <p:par>
+                                <p:cTn id="37" presetID="10" presetClass="entr" presetSubtype="0" fill="hold" grpId="0" nodeType="withEffect">
+                                  <p:stCondLst>
+                                    <p:cond delay="0"/>
+                                  </p:stCondLst>
+                                  <p:childTnLst>
+                                    <p:set>
+                                      <p:cBhvr>
+                                        <p:cTn id="38" dur="1" fill="hold">
+                                          <p:stCondLst>
+                                            <p:cond delay="0"/>
+                                          </p:stCondLst>
+                                        </p:cTn>
+                                        <p:tgtEl>
+                                          <p:spTgt spid="20"/>
+                                        </p:tgtEl>
+                                        <p:attrNameLst>
+                                          <p:attrName>style.visibility</p:attrName>
+                                        </p:attrNameLst>
+                                      </p:cBhvr>
+                                      <p:to>
+                                        <p:strVal val="visible"/>
+                                      </p:to>
+                                    </p:set>
+                                    <p:animEffect transition="in" filter="fade">
+                                      <p:cBhvr>
+                                        <p:cTn id="39" dur="900"/>
+                                        <p:tgtEl>
+                                          <p:spTgt spid="20"/>
+                                        </p:tgtEl>
+                                      </p:cBhvr>
+                                    </p:animEffect>
+                                  </p:childTnLst>
+                                </p:cTn>
+                              </p:par>
+                            </p:childTnLst>
+                          </p:cTn>
+                        </p:par>
+                        <p:par>
+                          <p:cTn id="40" fill="hold">
+                            <p:stCondLst>
+                              <p:cond delay="2520"/>
+                            </p:stCondLst>
+                            <p:childTnLst>
+                              <p:par>
+                                <p:cTn id="41" presetID="10" presetClass="entr" presetSubtype="0" fill="hold" grpId="0" nodeType="withEffect">
+                                  <p:stCondLst>
+                                    <p:cond delay="0"/>
+                                  </p:stCondLst>
+                                  <p:childTnLst>
+                                    <p:set>
+                                      <p:cBhvr>
+                                        <p:cTn id="42" dur="1" fill="hold">
+                                          <p:stCondLst>
+                                            <p:cond delay="0"/>
+                                          </p:stCondLst>
+                                        </p:cTn>
+                                        <p:tgtEl>
+                                          <p:spTgt spid="22"/>
+                                        </p:tgtEl>
+                                        <p:attrNameLst>
+                                          <p:attrName>style.visibility</p:attrName>
+                                        </p:attrNameLst>
+                                      </p:cBhvr>
+                                      <p:to>
+                                        <p:strVal val="visible"/>
+                                      </p:to>
+                                    </p:set>
+                                    <p:animEffect transition="in" filter="fade">
+                                      <p:cBhvr>
+                                        <p:cTn id="43" dur="900"/>
+                                        <p:tgtEl>
+                                          <p:spTgt spid="22"/>
+                                        </p:tgtEl>
+                                      </p:cBhvr>
+                                    </p:animEffect>
+                                  </p:childTnLst>
+                                </p:cTn>
+                              </p:par>
+                            </p:childTnLst>
+                          </p:cTn>
+                        </p:par>
+                        <p:par>
+                          <p:cTn id="44" fill="hold">
+                            <p:stCondLst>
+                              <p:cond delay="2700"/>
+                            </p:stCondLst>
+                            <p:childTnLst>
+                              <p:par>
+                                <p:cTn id="45" presetID="10" presetClass="entr" presetSubtype="0" fill="hold" grpId="0" nodeType="withEffect">
+                                  <p:stCondLst>
+                                    <p:cond delay="0"/>
+                                  </p:stCondLst>
+                                  <p:childTnLst>
+                                    <p:set>
+                                      <p:cBhvr>
+                                        <p:cTn id="46" dur="1" fill="hold">
+                                          <p:stCondLst>
+                                            <p:cond delay="0"/>
+                                          </p:stCondLst>
+                                        </p:cTn>
+                                        <p:tgtEl>
+                                          <p:spTgt spid="23"/>
+                                        </p:tgtEl>
+                                        <p:attrNameLst>
+                                          <p:attrName>style.visibility</p:attrName>
+                                        </p:attrNameLst>
+                                      </p:cBhvr>
+                                      <p:to>
+                                        <p:strVal val="visible"/>
+                                      </p:to>
+                                    </p:set>
+                                    <p:animEffect transition="in" filter="fade">
+                                      <p:cBhvr>
+                                        <p:cTn id="47" dur="900"/>
+                                        <p:tgtEl>
+                                          <p:spTgt spid="23"/>
+                                        </p:tgtEl>
+                                      </p:cBhvr>
+                                    </p:animEffect>
+                                  </p:childTnLst>
+                                </p:cTn>
+                              </p:par>
+                            </p:childTnLst>
+                          </p:cTn>
+                        </p:par>
+                        <p:par>
+                          <p:cTn id="48" fill="hold">
+                            <p:stCondLst>
+                              <p:cond delay="2880"/>
+                            </p:stCondLst>
+                            <p:childTnLst>
+                              <p:par>
+                                <p:cTn id="49" presetID="10" presetClass="entr" presetSubtype="0" fill="hold" grpId="0" nodeType="withEffect">
+                                  <p:stCondLst>
+                                    <p:cond delay="0"/>
+                                  </p:stCondLst>
+                                  <p:childTnLst>
+                                    <p:set>
+                                      <p:cBhvr>
+                                        <p:cTn id="50" dur="1" fill="hold">
+                                          <p:stCondLst>
+                                            <p:cond delay="0"/>
+                                          </p:stCondLst>
+                                        </p:cTn>
+                                        <p:tgtEl>
+                                          <p:spTgt spid="24"/>
+                                        </p:tgtEl>
+                                        <p:attrNameLst>
+                                          <p:attrName>style.visibility</p:attrName>
+                                        </p:attrNameLst>
+                                      </p:cBhvr>
+                                      <p:to>
+                                        <p:strVal val="visible"/>
+                                      </p:to>
+                                    </p:set>
+                                    <p:animEffect transition="in" filter="fade">
+                                      <p:cBhvr>
+                                        <p:cTn id="51" dur="900"/>
+                                        <p:tgtEl>
+                                          <p:spTgt spid="24"/>
+                                        </p:tgtEl>
+                                      </p:cBhvr>
+                                    </p:animEffect>
+                                  </p:childTnLst>
+                                </p:cTn>
+                              </p:par>
+                            </p:childTnLst>
+                          </p:cTn>
+                        </p:par>
+                        <p:par>
+                          <p:cTn id="52" fill="hold">
+                            <p:stCondLst>
+                              <p:cond delay="3060"/>
+                            </p:stCondLst>
+                            <p:childTnLst>
+                              <p:par>
+                                <p:cTn id="53" presetID="10" presetClass="entr" presetSubtype="0" fill="hold" grpId="0" nodeType="withEffect">
+                                  <p:stCondLst>
+                                    <p:cond delay="0"/>
+                                  </p:stCondLst>
+                                  <p:childTnLst>
+                                    <p:set>
+                                      <p:cBhvr>
+                                        <p:cTn id="54" dur="1" fill="hold">
+                                          <p:stCondLst>
+                                            <p:cond delay="0"/>
+                                          </p:stCondLst>
+                                        </p:cTn>
+                                        <p:tgtEl>
+                                          <p:spTgt spid="26"/>
+                                        </p:tgtEl>
+                                        <p:attrNameLst>
+                                          <p:attrName>style.visibility</p:attrName>
+                                        </p:attrNameLst>
+                                      </p:cBhvr>
+                                      <p:to>
+                                        <p:strVal val="visible"/>
+                                      </p:to>
+                                    </p:set>
+                                    <p:animEffect transition="in" filter="fade">
+                                      <p:cBhvr>
+                                        <p:cTn id="55" dur="900"/>
+                                        <p:tgtEl>
+                                          <p:spTgt spid="26"/>
+                                        </p:tgtEl>
+                                      </p:cBhvr>
+                                    </p:animEffect>
+                                  </p:childTnLst>
+                                </p:cTn>
+                              </p:par>
+                            </p:childTnLst>
+                          </p:cTn>
+                        </p:par>
+                        <p:par>
+                          <p:cTn id="56" fill="hold">
+                            <p:stCondLst>
+                              <p:cond delay="3240"/>
+                            </p:stCondLst>
+                            <p:childTnLst>
+                              <p:par>
+                                <p:cTn id="57" presetID="10" presetClass="entr" presetSubtype="0" fill="hold" grpId="0" nodeType="withEffect">
+                                  <p:stCondLst>
+                                    <p:cond delay="0"/>
+                                  </p:stCondLst>
+                                  <p:childTnLst>
+                                    <p:set>
+                                      <p:cBhvr>
+                                        <p:cTn id="58" dur="1" fill="hold">
+                                          <p:stCondLst>
+                                            <p:cond delay="0"/>
+                                          </p:stCondLst>
+                                        </p:cTn>
+                                        <p:tgtEl>
+                                          <p:spTgt spid="27"/>
+                                        </p:tgtEl>
+                                        <p:attrNameLst>
+                                          <p:attrName>style.visibility</p:attrName>
+                                        </p:attrNameLst>
+                                      </p:cBhvr>
+                                      <p:to>
+                                        <p:strVal val="visible"/>
+                                      </p:to>
+                                    </p:set>
+                                    <p:animEffect transition="in" filter="fade">
+                                      <p:cBhvr>
+                                        <p:cTn id="59" dur="900"/>
+                                        <p:tgtEl>
+                                          <p:spTgt spid="27"/>
+                                        </p:tgtEl>
+                                      </p:cBhvr>
+                                    </p:animEffect>
+                                  </p:childTnLst>
+                                </p:cTn>
+                              </p:par>
+                            </p:childTnLst>
+                          </p:cTn>
+                        </p:par>
+                        <p:par>
+                          <p:cTn id="60" fill="hold">
+                            <p:stCondLst>
+                              <p:cond delay="3420"/>
+                            </p:stCondLst>
+                            <p:childTnLst>
+                              <p:par>
+                                <p:cTn id="61" presetID="10" presetClass="entr" presetSubtype="0" fill="hold" grpId="0" nodeType="withEffect">
+                                  <p:stCondLst>
+                                    <p:cond delay="0"/>
+                                  </p:stCondLst>
+                                  <p:childTnLst>
+                                    <p:set>
+                                      <p:cBhvr>
+                                        <p:cTn id="62" dur="1" fill="hold">
+                                          <p:stCondLst>
+                                            <p:cond delay="0"/>
+                                          </p:stCondLst>
+                                        </p:cTn>
+                                        <p:tgtEl>
+                                          <p:spTgt spid="28"/>
+                                        </p:tgtEl>
+                                        <p:attrNameLst>
+                                          <p:attrName>style.visibility</p:attrName>
+                                        </p:attrNameLst>
+                                      </p:cBhvr>
+                                      <p:to>
+                                        <p:strVal val="visible"/>
+                                      </p:to>
+                                    </p:set>
+                                    <p:animEffect transition="in" filter="fade">
+                                      <p:cBhvr>
+                                        <p:cTn id="63" dur="900"/>
+                                        <p:tgtEl>
+                                          <p:spTgt spid="28"/>
+                                        </p:tgtEl>
+                                      </p:cBhvr>
+                                    </p:animEffect>
+                                  </p:childTnLst>
+                                </p:cTn>
+                              </p:par>
+                            </p:childTnLst>
+                          </p:cTn>
+                        </p:par>
+                        <p:par>
+                          <p:cTn id="64" fill="hold">
+                            <p:stCondLst>
+                              <p:cond delay="3600"/>
+                            </p:stCondLst>
+                            <p:childTnLst>
+                              <p:par>
+                                <p:cTn id="65" presetID="10" presetClass="entr" presetSubtype="0" fill="hold" grpId="0" nodeType="withEffect">
+                                  <p:stCondLst>
+                                    <p:cond delay="0"/>
+                                  </p:stCondLst>
+                                  <p:childTnLst>
+                                    <p:set>
+                                      <p:cBhvr>
+                                        <p:cTn id="66" dur="1" fill="hold">
+                                          <p:stCondLst>
+                                            <p:cond delay="0"/>
+                                          </p:stCondLst>
+                                        </p:cTn>
+                                        <p:tgtEl>
+                                          <p:spTgt spid="29"/>
+                                        </p:tgtEl>
+                                        <p:attrNameLst>
+                                          <p:attrName>style.visibility</p:attrName>
+                                        </p:attrNameLst>
+                                      </p:cBhvr>
+                                      <p:to>
+                                        <p:strVal val="visible"/>
+                                      </p:to>
+                                    </p:set>
+                                    <p:animEffect transition="in" filter="fade">
+                                      <p:cBhvr>
+                                        <p:cTn id="67" dur="900"/>
+                                        <p:tgtEl>
+                                          <p:spTgt spid="29"/>
+                                        </p:tgtEl>
+                                      </p:cBhvr>
+                                    </p:animEffect>
+                                  </p:childTnLst>
+                                </p:cTn>
+                              </p:par>
+                            </p:childTnLst>
+                          </p:cTn>
+                        </p:par>
+                      </p:childTnLst>
+                    </p:cTn>
+                  </p:par>
+                </p:childTnLst>
+              </p:cTn>
+              <p:prevCondLst>
+                <p:cond evt="onPrev" delay="0">
+                  <p:tgtEl>
+                    <p:sldTgt/>
+                  </p:tgtEl>
+                </p:cond>
+              </p:prevCondLst>
+              <p:nextCondLst>
+                <p:cond evt="onNext" delay="0">
+                  <p:tgtEl>
+                    <p:sldTgt/>
+                  </p:tgtEl>
+                </p:cond>
+              </p:nextCondLst>
+            </p:seq>
+          </p:childTnLst>
+        </p:cTn>
+      </p:par>
+    </p:tnLst>
+    <p:bldLst>
+      <p:bldP spid="10" grpId="0"/>
+      <p:bldP spid="11" grpId="0"/>
+      <p:bldP spid="12" grpId="0"/>
+      <p:bldP spid="14" grpId="0"/>
+      <p:bldP spid="15" grpId="0"/>
+      <p:bldP spid="16" grpId="0"/>
+      <p:bldP spid="18" grpId="0"/>
+      <p:bldP spid="19" grpId="0"/>
+      <p:bldP spid="20" grpId="0"/>
+      <p:bldP spid="22" grpId="0"/>
+      <p:bldP spid="23" grpId="0"/>
+      <p:bldP spid="24" grpId="0"/>
+      <p:bldP spid="26" grpId="0"/>
+      <p:bldP spid="27" grpId="0"/>
+      <p:bldP spid="28" grpId="0"/>
+      <p:bldP spid="29" grpId="0"/>
+    </p:bldLst>
+  </p:timing>
 </p:sld>
 </file>
 
@@ -3546,7 +5385,7 @@
         </p:nvSpPr>
         <p:spPr>
           <a:xfrm>
-            <a:off x="6492240" y="1280160"/>
+            <a:off x="6492240" y="1097280"/>
             <a:ext cx="4937760" cy="1828800"/>
           </a:xfrm>
           <a:prstGeom prst="rect">
@@ -3585,7 +5424,7 @@
         </p:nvSpPr>
         <p:spPr>
           <a:xfrm>
-            <a:off x="6492240" y="3108960"/>
+            <a:off x="6492240" y="2926080"/>
             <a:ext cx="4937760" cy="548640"/>
           </a:xfrm>
           <a:prstGeom prst="rect">
@@ -3602,7 +5441,7 @@
               <a:buNone/>
             </a:pPr>
             <a:r>
-              <a:rPr lang="en-US" sz="2600" dirty="0">
+              <a:rPr lang="en-US" sz="2400" dirty="0">
                 <a:solidFill>
                   <a:srgbClr val="2A1E16"/>
                 </a:solidFill>
@@ -3610,9 +5449,9 @@
                 <a:ea typeface="Bookman Old Style" pitchFamily="34" charset="-122"/>
                 <a:cs typeface="Bookman Old Style" pitchFamily="34" charset="-120"/>
               </a:rPr>
-              <a:t>кантонов</a:t>
+              <a:t>кантонов к 1513 году</a:t>
             </a:r>
-            <a:endParaRPr lang="en-US" sz="2600" dirty="0"/>
+            <a:endParaRPr lang="en-US" sz="2400" dirty="0"/>
           </a:p>
         </p:txBody>
       </p:sp>
@@ -3624,8 +5463,8 @@
         </p:nvSpPr>
         <p:spPr>
           <a:xfrm>
-            <a:off x="7040880" y="3931920"/>
-            <a:ext cx="3840480" cy="1280160"/>
+            <a:off x="6949440" y="3749040"/>
+            <a:ext cx="4023360" cy="1463040"/>
           </a:xfrm>
           <a:prstGeom prst="rect">
             <a:avLst/>
@@ -3649,7 +5488,7 @@
                 <a:ea typeface="Cambria" pitchFamily="34" charset="-122"/>
                 <a:cs typeface="Cambria" pitchFamily="34" charset="-120"/>
               </a:rPr>
-              <a:t>Ключевая цифра и короткая подпись к ней — одна мысль, которую должны запомнить.</a:t>
+              <a:t>Союз тринадцати кантонов просуществовал до 1798 года. У каждого — свои законы, а общие дела решал сейм (Tagsatzung).</a:t>
             </a:r>
             <a:endParaRPr lang="en-US" sz="1500" dirty="0"/>
           </a:p>
@@ -3657,14 +5496,14 @@
       </p:sp>
       <p:sp>
         <p:nvSpPr>
-          <p:cNvPr id="9" name="Text 5"/>
+          <p:cNvPr id="9" name="!!kicker"/>
           <p:cNvSpPr txBox="1"/>
           <p:nvPr/>
         </p:nvSpPr>
         <p:spPr>
           <a:xfrm>
-            <a:off x="777240" y="2377440"/>
-            <a:ext cx="5303520" cy="1828800"/>
+            <a:off x="777240" y="1828800"/>
+            <a:ext cx="4572000" cy="320040"/>
           </a:xfrm>
           <a:prstGeom prst="rect">
             <a:avLst/>
@@ -3673,14 +5512,53 @@
           <a:ln/>
         </p:spPr>
         <p:txBody>
-          <a:bodyPr wrap="square" lIns="0" tIns="0" rIns="0" bIns="0" rtlCol="0" anchor="t"/>
+          <a:bodyPr wrap="square" lIns="0" tIns="0" rIns="0" bIns="0" rtlCol="0" anchor="ctr"/>
           <a:lstStyle/>
           <a:p>
             <a:pPr indent="0" marL="0">
               <a:buNone/>
             </a:pPr>
             <a:r>
-              <a:rPr lang="en-US" sz="3800" i="1" dirty="0">
+              <a:rPr lang="en-US" sz="1300" spc="600" kern="0" dirty="0">
+                <a:solidFill>
+                  <a:srgbClr val="C9A15A"/>
+                </a:solidFill>
+                <a:latin typeface="Bookman Old Style" pitchFamily="34" charset="0"/>
+                <a:ea typeface="Bookman Old Style" pitchFamily="34" charset="-122"/>
+                <a:cs typeface="Bookman Old Style" pitchFamily="34" charset="-120"/>
+              </a:rPr>
+              <a:t>CAPUT  IV</a:t>
+            </a:r>
+            <a:endParaRPr lang="en-US" sz="1300" dirty="0"/>
+          </a:p>
+        </p:txBody>
+      </p:sp>
+      <p:sp>
+        <p:nvSpPr>
+          <p:cNvPr id="10" name="Text 6"/>
+          <p:cNvSpPr txBox="1"/>
+          <p:nvPr/>
+        </p:nvSpPr>
+        <p:spPr>
+          <a:xfrm>
+            <a:off x="777240" y="2286000"/>
+            <a:ext cx="5303520" cy="2103120"/>
+          </a:xfrm>
+          <a:prstGeom prst="rect">
+            <a:avLst/>
+          </a:prstGeom>
+          <a:noFill/>
+          <a:ln/>
+        </p:spPr>
+        <p:txBody>
+          <a:bodyPr wrap="square" lIns="0" tIns="0" rIns="0" bIns="0" rtlCol="0" anchor="t"/>
+          <a:lstStyle/>
+          <a:p>
+            <a:pPr indent="0" marL="0">
+              <a:buNone/>
+            </a:pPr>
+            <a:r>
+              <a:rPr lang="en-US" sz="3000" i="1" dirty="0">
                 <a:solidFill>
                   <a:srgbClr val="F1E6CF"/>
                 </a:solidFill>
@@ -3688,39 +5566,22 @@
                 <a:ea typeface="Bookman Old Style" pitchFamily="34" charset="-122"/>
                 <a:cs typeface="Bookman Old Style" pitchFamily="34" charset="-120"/>
               </a:rPr>
-              <a:t>Unus pro omnibus,</a:t>
+              <a:t>«Швейцарцы превосходно вооружены и пользуются полной свободой»</a:t>
             </a:r>
-            <a:endParaRPr lang="en-US" sz="3800" dirty="0"/>
-          </a:p>
-          <a:p>
-            <a:pPr indent="0" marL="0">
-              <a:buNone/>
-            </a:pPr>
-            <a:r>
-              <a:rPr lang="en-US" sz="3800" i="1" dirty="0">
-                <a:solidFill>
-                  <a:srgbClr val="F1E6CF"/>
-                </a:solidFill>
-                <a:latin typeface="Bookman Old Style" pitchFamily="34" charset="0"/>
-                <a:ea typeface="Bookman Old Style" pitchFamily="34" charset="-122"/>
-                <a:cs typeface="Bookman Old Style" pitchFamily="34" charset="-120"/>
-              </a:rPr>
-              <a:t>omnes pro uno</a:t>
-            </a:r>
-            <a:endParaRPr lang="en-US" sz="3800" dirty="0"/>
-          </a:p>
-        </p:txBody>
-      </p:sp>
-      <p:sp>
-        <p:nvSpPr>
-          <p:cNvPr id="10" name="Text 6"/>
+            <a:endParaRPr lang="en-US" sz="3000" dirty="0"/>
+          </a:p>
+        </p:txBody>
+      </p:sp>
+      <p:sp>
+        <p:nvSpPr>
+          <p:cNvPr id="11" name="Text 7"/>
           <p:cNvSpPr txBox="1"/>
           <p:nvPr/>
         </p:nvSpPr>
         <p:spPr>
           <a:xfrm>
-            <a:off x="777240" y="4343400"/>
-            <a:ext cx="5120640" cy="731520"/>
+            <a:off x="777240" y="4526280"/>
+            <a:ext cx="5120640" cy="365760"/>
           </a:xfrm>
           <a:prstGeom prst="rect">
             <a:avLst/>
@@ -3744,9 +5605,48 @@
                 <a:ea typeface="Cambria" pitchFamily="34" charset="-122"/>
                 <a:cs typeface="Cambria" pitchFamily="34" charset="-120"/>
               </a:rPr>
-              <a:t>Один за всех, все за одного — неофициальный девиз Конфедерации</a:t>
+              <a:t>Никколо Макиавелли, «Государь», 1513</a:t>
             </a:r>
             <a:endParaRPr lang="en-US" sz="1500" dirty="0"/>
+          </a:p>
+        </p:txBody>
+      </p:sp>
+      <p:sp>
+        <p:nvSpPr>
+          <p:cNvPr id="12" name="pageNum"/>
+          <p:cNvSpPr txBox="1"/>
+          <p:nvPr/>
+        </p:nvSpPr>
+        <p:spPr>
+          <a:xfrm>
+            <a:off x="10332720" y="6263640"/>
+            <a:ext cx="1097280" cy="274320"/>
+          </a:xfrm>
+          <a:prstGeom prst="rect">
+            <a:avLst/>
+          </a:prstGeom>
+          <a:noFill/>
+          <a:ln/>
+        </p:spPr>
+        <p:txBody>
+          <a:bodyPr wrap="square" lIns="0" tIns="0" rIns="0" bIns="0" rtlCol="0" anchor="ctr"/>
+          <a:lstStyle/>
+          <a:p>
+            <a:pPr algn="r" indent="0" marL="0">
+              <a:buNone/>
+            </a:pPr>
+            <a:r>
+              <a:rPr lang="en-US" sz="1000" spc="300" kern="0" dirty="0">
+                <a:solidFill>
+                  <a:srgbClr val="C9A15A"/>
+                </a:solidFill>
+                <a:latin typeface="Bookman Old Style" pitchFamily="34" charset="0"/>
+                <a:ea typeface="Bookman Old Style" pitchFamily="34" charset="-122"/>
+                <a:cs typeface="Bookman Old Style" pitchFamily="34" charset="-120"/>
+              </a:rPr>
+              <a:t>V  ·  VI</a:t>
+            </a:r>
+            <a:endParaRPr lang="en-US" sz="1000" dirty="0"/>
           </a:p>
         </p:txBody>
       </p:sp>
@@ -3767,6 +5667,230 @@
       </p:transition>
     </mc:Fallback>
   </mc:AlternateContent>
+  <p:timing>
+    <p:tnLst>
+      <p:par>
+        <p:cTn id="1" dur="indefinite" restart="never" nodeType="tmRoot">
+          <p:childTnLst>
+            <p:seq concurrent="1" nextAc="seek">
+              <p:cTn id="2" dur="indefinite" nodeType="mainSeq">
+                <p:childTnLst>
+                  <p:par>
+                    <p:cTn id="3" fill="hold">
+                      <p:stCondLst>
+                        <p:cond delay="indefinite"/>
+                        <p:cond evt="onBegin" delay="0">
+                          <p:tn val="2"/>
+                        </p:cond>
+                      </p:stCondLst>
+                      <p:childTnLst>
+                        <p:par>
+                          <p:cTn id="4" fill="hold">
+                            <p:stCondLst>
+                              <p:cond delay="900"/>
+                            </p:stCondLst>
+                            <p:childTnLst>
+                              <p:par>
+                                <p:cTn id="5" presetID="10" presetClass="entr" presetSubtype="0" fill="hold" grpId="0" nodeType="withEffect">
+                                  <p:stCondLst>
+                                    <p:cond delay="0"/>
+                                  </p:stCondLst>
+                                  <p:childTnLst>
+                                    <p:set>
+                                      <p:cBhvr>
+                                        <p:cTn id="6" dur="1" fill="hold">
+                                          <p:stCondLst>
+                                            <p:cond delay="0"/>
+                                          </p:stCondLst>
+                                        </p:cTn>
+                                        <p:tgtEl>
+                                          <p:spTgt spid="7"/>
+                                        </p:tgtEl>
+                                        <p:attrNameLst>
+                                          <p:attrName>style.visibility</p:attrName>
+                                        </p:attrNameLst>
+                                      </p:cBhvr>
+                                      <p:to>
+                                        <p:strVal val="visible"/>
+                                      </p:to>
+                                    </p:set>
+                                    <p:animEffect transition="in" filter="fade">
+                                      <p:cBhvr>
+                                        <p:cTn id="7" dur="900"/>
+                                        <p:tgtEl>
+                                          <p:spTgt spid="7"/>
+                                        </p:tgtEl>
+                                      </p:cBhvr>
+                                    </p:animEffect>
+                                  </p:childTnLst>
+                                </p:cTn>
+                              </p:par>
+                            </p:childTnLst>
+                          </p:cTn>
+                        </p:par>
+                        <p:par>
+                          <p:cTn id="8" fill="hold">
+                            <p:stCondLst>
+                              <p:cond delay="1080"/>
+                            </p:stCondLst>
+                            <p:childTnLst>
+                              <p:par>
+                                <p:cTn id="9" presetID="10" presetClass="entr" presetSubtype="0" fill="hold" grpId="0" nodeType="withEffect">
+                                  <p:stCondLst>
+                                    <p:cond delay="0"/>
+                                  </p:stCondLst>
+                                  <p:childTnLst>
+                                    <p:set>
+                                      <p:cBhvr>
+                                        <p:cTn id="10" dur="1" fill="hold">
+                                          <p:stCondLst>
+                                            <p:cond delay="0"/>
+                                          </p:stCondLst>
+                                        </p:cTn>
+                                        <p:tgtEl>
+                                          <p:spTgt spid="8"/>
+                                        </p:tgtEl>
+                                        <p:attrNameLst>
+                                          <p:attrName>style.visibility</p:attrName>
+                                        </p:attrNameLst>
+                                      </p:cBhvr>
+                                      <p:to>
+                                        <p:strVal val="visible"/>
+                                      </p:to>
+                                    </p:set>
+                                    <p:animEffect transition="in" filter="fade">
+                                      <p:cBhvr>
+                                        <p:cTn id="11" dur="900"/>
+                                        <p:tgtEl>
+                                          <p:spTgt spid="8"/>
+                                        </p:tgtEl>
+                                      </p:cBhvr>
+                                    </p:animEffect>
+                                  </p:childTnLst>
+                                </p:cTn>
+                              </p:par>
+                            </p:childTnLst>
+                          </p:cTn>
+                        </p:par>
+                        <p:par>
+                          <p:cTn id="12" fill="hold">
+                            <p:stCondLst>
+                              <p:cond delay="1260"/>
+                            </p:stCondLst>
+                            <p:childTnLst>
+                              <p:par>
+                                <p:cTn id="13" presetID="10" presetClass="entr" presetSubtype="0" fill="hold" grpId="0" nodeType="withEffect">
+                                  <p:stCondLst>
+                                    <p:cond delay="0"/>
+                                  </p:stCondLst>
+                                  <p:childTnLst>
+                                    <p:set>
+                                      <p:cBhvr>
+                                        <p:cTn id="14" dur="1" fill="hold">
+                                          <p:stCondLst>
+                                            <p:cond delay="0"/>
+                                          </p:stCondLst>
+                                        </p:cTn>
+                                        <p:tgtEl>
+                                          <p:spTgt spid="10"/>
+                                        </p:tgtEl>
+                                        <p:attrNameLst>
+                                          <p:attrName>style.visibility</p:attrName>
+                                        </p:attrNameLst>
+                                      </p:cBhvr>
+                                      <p:to>
+                                        <p:strVal val="visible"/>
+                                      </p:to>
+                                    </p:set>
+                                    <p:animEffect transition="in" filter="fade">
+                                      <p:cBhvr>
+                                        <p:cTn id="15" dur="900"/>
+                                        <p:tgtEl>
+                                          <p:spTgt spid="10"/>
+                                        </p:tgtEl>
+                                      </p:cBhvr>
+                                    </p:animEffect>
+                                  </p:childTnLst>
+                                </p:cTn>
+                              </p:par>
+                            </p:childTnLst>
+                          </p:cTn>
+                        </p:par>
+                        <p:par>
+                          <p:cTn id="16" fill="hold">
+                            <p:stCondLst>
+                              <p:cond delay="1440"/>
+                            </p:stCondLst>
+                            <p:childTnLst>
+                              <p:par>
+                                <p:cTn id="17" presetID="10" presetClass="entr" presetSubtype="0" fill="hold" grpId="0" nodeType="withEffect">
+                                  <p:stCondLst>
+                                    <p:cond delay="0"/>
+                                  </p:stCondLst>
+                                  <p:childTnLst>
+                                    <p:set>
+                                      <p:cBhvr>
+                                        <p:cTn id="18" dur="1" fill="hold">
+                                          <p:stCondLst>
+                                            <p:cond delay="0"/>
+                                          </p:stCondLst>
+                                        </p:cTn>
+                                        <p:tgtEl>
+                                          <p:spTgt spid="11"/>
+                                        </p:tgtEl>
+                                        <p:attrNameLst>
+                                          <p:attrName>style.visibility</p:attrName>
+                                        </p:attrNameLst>
+                                      </p:cBhvr>
+                                      <p:to>
+                                        <p:strVal val="visible"/>
+                                      </p:to>
+                                    </p:set>
+                                    <p:animEffect transition="in" filter="fade">
+                                      <p:cBhvr>
+                                        <p:cTn id="19" dur="900"/>
+                                        <p:tgtEl>
+                                          <p:spTgt spid="11"/>
+                                        </p:tgtEl>
+                                      </p:cBhvr>
+                                    </p:animEffect>
+                                  </p:childTnLst>
+                                </p:cTn>
+                              </p:par>
+                            </p:childTnLst>
+                          </p:cTn>
+                        </p:par>
+                      </p:childTnLst>
+                    </p:cTn>
+                  </p:par>
+                </p:childTnLst>
+              </p:cTn>
+              <p:prevCondLst>
+                <p:cond evt="onPrev" delay="0">
+                  <p:tgtEl>
+                    <p:sldTgt/>
+                  </p:tgtEl>
+                </p:cond>
+              </p:prevCondLst>
+              <p:nextCondLst>
+                <p:cond evt="onNext" delay="0">
+                  <p:tgtEl>
+                    <p:sldTgt/>
+                  </p:tgtEl>
+                </p:cond>
+              </p:nextCondLst>
+            </p:seq>
+          </p:childTnLst>
+        </p:cTn>
+      </p:par>
+    </p:tnLst>
+    <p:bldLst>
+      <p:bldP spid="7" grpId="0"/>
+      <p:bldP spid="8" grpId="0"/>
+      <p:bldP spid="10" grpId="0"/>
+      <p:bldP spid="11" grpId="0"/>
+    </p:bldLst>
+  </p:timing>
 </p:sld>
 </file>
 
@@ -3883,8 +6007,8 @@
         </p:blipFill>
         <p:spPr>
           <a:xfrm>
-            <a:off x="5410048" y="685800"/>
-            <a:ext cx="1371600" cy="1618488"/>
+            <a:off x="5501488" y="685800"/>
+            <a:ext cx="1188720" cy="1402690"/>
           </a:xfrm>
           <a:prstGeom prst="rect">
             <a:avLst/>
@@ -3899,7 +6023,7 @@
         </p:nvSpPr>
         <p:spPr>
           <a:xfrm>
-            <a:off x="914400" y="2880360"/>
+            <a:off x="914400" y="2286000"/>
             <a:ext cx="10362895" cy="411480"/>
           </a:xfrm>
           <a:prstGeom prst="rect">
@@ -3938,7 +6062,7 @@
         </p:nvSpPr>
         <p:spPr>
           <a:xfrm>
-            <a:off x="914400" y="3337560"/>
+            <a:off x="914400" y="2697480"/>
             <a:ext cx="10362895" cy="1005840"/>
           </a:xfrm>
           <a:prstGeom prst="rect">
@@ -3955,7 +6079,7 @@
               <a:buNone/>
             </a:pPr>
             <a:r>
-              <a:rPr lang="en-US" sz="4800" b="1" dirty="0">
+              <a:rPr lang="en-US" sz="4600" b="1" dirty="0">
                 <a:solidFill>
                   <a:srgbClr val="F1E6CF"/>
                 </a:solidFill>
@@ -3963,9 +6087,9 @@
                 <a:ea typeface="Bookman Old Style" pitchFamily="34" charset="-122"/>
                 <a:cs typeface="Bookman Old Style" pitchFamily="34" charset="-120"/>
               </a:rPr>
-              <a:t>Благодарю за внимание</a:t>
+              <a:t>Спасибо за внимание</a:t>
             </a:r>
-            <a:endParaRPr lang="en-US" sz="4800" dirty="0"/>
+            <a:endParaRPr lang="en-US" sz="4600" dirty="0"/>
           </a:p>
         </p:txBody>
       </p:sp>
@@ -3977,8 +6101,8 @@
         </p:nvSpPr>
         <p:spPr>
           <a:xfrm>
-            <a:off x="1371600" y="4572000"/>
-            <a:ext cx="9448495" cy="457200"/>
+            <a:off x="2011680" y="3840480"/>
+            <a:ext cx="8168335" cy="868680"/>
           </a:xfrm>
           <a:prstGeom prst="rect">
             <a:avLst/>
@@ -3987,14 +6111,14 @@
           <a:ln/>
         </p:spPr>
         <p:txBody>
-          <a:bodyPr wrap="square" lIns="0" tIns="0" rIns="0" bIns="0" rtlCol="0" anchor="ctr"/>
+          <a:bodyPr wrap="square" lIns="0" tIns="0" rIns="0" bIns="0" rtlCol="0" anchor="t"/>
           <a:lstStyle/>
           <a:p>
             <a:pPr algn="ctr" indent="0" marL="0">
               <a:buNone/>
             </a:pPr>
             <a:r>
-              <a:rPr lang="en-US" sz="1800" i="1" dirty="0">
+              <a:rPr lang="en-US" sz="1900" i="1" dirty="0">
                 <a:solidFill>
                   <a:srgbClr val="E2D2B0"/>
                 </a:solidFill>
@@ -4002,9 +6126,87 @@
                 <a:ea typeface="Cambria" pitchFamily="34" charset="-122"/>
                 <a:cs typeface="Cambria" pitchFamily="34" charset="-120"/>
               </a:rPr>
-              <a:t>имя@почта.ru  ·  +7 000 000-00-00</a:t>
+              <a:t>Свобода общин, сильная пехота и честный труд помогли маленькой горной стране отстоять независимость среди великих держав.</a:t>
             </a:r>
-            <a:endParaRPr lang="en-US" sz="1800" dirty="0"/>
+            <a:endParaRPr lang="en-US" sz="1900" dirty="0"/>
+          </a:p>
+        </p:txBody>
+      </p:sp>
+      <p:sp>
+        <p:nvSpPr>
+          <p:cNvPr id="9" name="Text 6"/>
+          <p:cNvSpPr txBox="1"/>
+          <p:nvPr/>
+        </p:nvSpPr>
+        <p:spPr>
+          <a:xfrm>
+            <a:off x="1371600" y="4892040"/>
+            <a:ext cx="9448495" cy="365760"/>
+          </a:xfrm>
+          <a:prstGeom prst="rect">
+            <a:avLst/>
+          </a:prstGeom>
+          <a:noFill/>
+          <a:ln/>
+        </p:spPr>
+        <p:txBody>
+          <a:bodyPr wrap="square" lIns="0" tIns="0" rIns="0" bIns="0" rtlCol="0" anchor="ctr"/>
+          <a:lstStyle/>
+          <a:p>
+            <a:pPr algn="ctr" indent="0" marL="0">
+              <a:buNone/>
+            </a:pPr>
+            <a:r>
+              <a:rPr lang="en-US" sz="1400" spc="200" kern="0" dirty="0">
+                <a:solidFill>
+                  <a:srgbClr val="C9A15A"/>
+                </a:solidFill>
+                <a:latin typeface="Cambria" pitchFamily="34" charset="0"/>
+                <a:ea typeface="Cambria" pitchFamily="34" charset="-122"/>
+                <a:cs typeface="Cambria" pitchFamily="34" charset="-120"/>
+              </a:rPr>
+              <a:t>Выполнил(а): ученик(ца) 8 «__» класса  ·  Фамилия Имя</a:t>
+            </a:r>
+            <a:endParaRPr lang="en-US" sz="1400" dirty="0"/>
+          </a:p>
+        </p:txBody>
+      </p:sp>
+      <p:sp>
+        <p:nvSpPr>
+          <p:cNvPr id="10" name="Text 7"/>
+          <p:cNvSpPr txBox="1"/>
+          <p:nvPr/>
+        </p:nvSpPr>
+        <p:spPr>
+          <a:xfrm>
+            <a:off x="1371600" y="5715000"/>
+            <a:ext cx="9448495" cy="365760"/>
+          </a:xfrm>
+          <a:prstGeom prst="rect">
+            <a:avLst/>
+          </a:prstGeom>
+          <a:noFill/>
+          <a:ln/>
+        </p:spPr>
+        <p:txBody>
+          <a:bodyPr wrap="square" lIns="0" tIns="0" rIns="0" bIns="0" rtlCol="0" anchor="ctr"/>
+          <a:lstStyle/>
+          <a:p>
+            <a:pPr algn="ctr" indent="0" marL="0">
+              <a:buNone/>
+            </a:pPr>
+            <a:r>
+              <a:rPr lang="en-US" sz="1000" dirty="0">
+                <a:solidFill>
+                  <a:srgbClr val="BFAE8C"/>
+                </a:solidFill>
+                <a:latin typeface="Cambria" pitchFamily="34" charset="0"/>
+                <a:ea typeface="Cambria" pitchFamily="34" charset="-122"/>
+                <a:cs typeface="Cambria" pitchFamily="34" charset="-120"/>
+              </a:rPr>
+              <a:t>Источники: А. Я. Юдовская и др. «Всеобщая история. История Нового времени», 7–8 кл.; энциклопедические статьи о Швейцарской конфедерации</a:t>
+            </a:r>
+            <a:endParaRPr lang="en-US" sz="1000" dirty="0"/>
           </a:p>
         </p:txBody>
       </p:sp>
@@ -4025,6 +6227,185 @@
       </p:transition>
     </mc:Fallback>
   </mc:AlternateContent>
+  <p:timing>
+    <p:tnLst>
+      <p:par>
+        <p:cTn id="1" dur="indefinite" restart="never" nodeType="tmRoot">
+          <p:childTnLst>
+            <p:seq concurrent="1" nextAc="seek">
+              <p:cTn id="2" dur="indefinite" nodeType="mainSeq">
+                <p:childTnLst>
+                  <p:par>
+                    <p:cTn id="3" fill="hold">
+                      <p:stCondLst>
+                        <p:cond delay="indefinite"/>
+                        <p:cond evt="onBegin" delay="0">
+                          <p:tn val="2"/>
+                        </p:cond>
+                      </p:stCondLst>
+                      <p:childTnLst>
+                        <p:par>
+                          <p:cTn id="4" fill="hold">
+                            <p:stCondLst>
+                              <p:cond delay="900"/>
+                            </p:stCondLst>
+                            <p:childTnLst>
+                              <p:par>
+                                <p:cTn id="5" presetID="10" presetClass="entr" presetSubtype="0" fill="hold" grpId="0" nodeType="withEffect">
+                                  <p:stCondLst>
+                                    <p:cond delay="0"/>
+                                  </p:stCondLst>
+                                  <p:childTnLst>
+                                    <p:set>
+                                      <p:cBhvr>
+                                        <p:cTn id="6" dur="1" fill="hold">
+                                          <p:stCondLst>
+                                            <p:cond delay="0"/>
+                                          </p:stCondLst>
+                                        </p:cTn>
+                                        <p:tgtEl>
+                                          <p:spTgt spid="8"/>
+                                        </p:tgtEl>
+                                        <p:attrNameLst>
+                                          <p:attrName>style.visibility</p:attrName>
+                                        </p:attrNameLst>
+                                      </p:cBhvr>
+                                      <p:to>
+                                        <p:strVal val="visible"/>
+                                      </p:to>
+                                    </p:set>
+                                    <p:animEffect transition="in" filter="fade">
+                                      <p:cBhvr>
+                                        <p:cTn id="7" dur="900"/>
+                                        <p:tgtEl>
+                                          <p:spTgt spid="8"/>
+                                        </p:tgtEl>
+                                      </p:cBhvr>
+                                    </p:animEffect>
+                                  </p:childTnLst>
+                                </p:cTn>
+                              </p:par>
+                            </p:childTnLst>
+                          </p:cTn>
+                        </p:par>
+                        <p:par>
+                          <p:cTn id="8" fill="hold">
+                            <p:stCondLst>
+                              <p:cond delay="1080"/>
+                            </p:stCondLst>
+                            <p:childTnLst>
+                              <p:par>
+                                <p:cTn id="9" presetID="10" presetClass="entr" presetSubtype="0" fill="hold" grpId="0" nodeType="withEffect">
+                                  <p:stCondLst>
+                                    <p:cond delay="0"/>
+                                  </p:stCondLst>
+                                  <p:childTnLst>
+                                    <p:set>
+                                      <p:cBhvr>
+                                        <p:cTn id="10" dur="1" fill="hold">
+                                          <p:stCondLst>
+                                            <p:cond delay="0"/>
+                                          </p:stCondLst>
+                                        </p:cTn>
+                                        <p:tgtEl>
+                                          <p:spTgt spid="9"/>
+                                        </p:tgtEl>
+                                        <p:attrNameLst>
+                                          <p:attrName>style.visibility</p:attrName>
+                                        </p:attrNameLst>
+                                      </p:cBhvr>
+                                      <p:to>
+                                        <p:strVal val="visible"/>
+                                      </p:to>
+                                    </p:set>
+                                    <p:animEffect transition="in" filter="fade">
+                                      <p:cBhvr>
+                                        <p:cTn id="11" dur="900"/>
+                                        <p:tgtEl>
+                                          <p:spTgt spid="9"/>
+                                        </p:tgtEl>
+                                      </p:cBhvr>
+                                    </p:animEffect>
+                                  </p:childTnLst>
+                                </p:cTn>
+                              </p:par>
+                            </p:childTnLst>
+                          </p:cTn>
+                        </p:par>
+                        <p:par>
+                          <p:cTn id="12" fill="hold">
+                            <p:stCondLst>
+                              <p:cond delay="1260"/>
+                            </p:stCondLst>
+                            <p:childTnLst>
+                              <p:par>
+                                <p:cTn id="13" presetID="10" presetClass="entr" presetSubtype="0" fill="hold" grpId="0" nodeType="withEffect">
+                                  <p:stCondLst>
+                                    <p:cond delay="0"/>
+                                  </p:stCondLst>
+                                  <p:childTnLst>
+                                    <p:set>
+                                      <p:cBhvr>
+                                        <p:cTn id="14" dur="1" fill="hold">
+                                          <p:stCondLst>
+                                            <p:cond delay="0"/>
+                                          </p:stCondLst>
+                                        </p:cTn>
+                                        <p:tgtEl>
+                                          <p:spTgt spid="10"/>
+                                        </p:tgtEl>
+                                        <p:attrNameLst>
+                                          <p:attrName>style.visibility</p:attrName>
+                                        </p:attrNameLst>
+                                      </p:cBhvr>
+                                      <p:to>
+                                        <p:strVal val="visible"/>
+                                      </p:to>
+                                    </p:set>
+                                    <p:animEffect transition="in" filter="fade">
+                                      <p:cBhvr>
+                                        <p:cTn id="15" dur="900"/>
+                                        <p:tgtEl>
+                                          <p:spTgt spid="10"/>
+                                        </p:tgtEl>
+                                      </p:cBhvr>
+                                    </p:animEffect>
+                                  </p:childTnLst>
+                                </p:cTn>
+                              </p:par>
+                            </p:childTnLst>
+                          </p:cTn>
+                        </p:par>
+                      </p:childTnLst>
+                    </p:cTn>
+                  </p:par>
+                </p:childTnLst>
+              </p:cTn>
+              <p:prevCondLst>
+                <p:cond evt="onPrev" delay="0">
+                  <p:tgtEl>
+                    <p:sldTgt/>
+                  </p:tgtEl>
+                </p:cond>
+              </p:prevCondLst>
+              <p:nextCondLst>
+                <p:cond evt="onNext" delay="0">
+                  <p:tgtEl>
+                    <p:sldTgt/>
+                  </p:tgtEl>
+                </p:cond>
+              </p:nextCondLst>
+            </p:seq>
+          </p:childTnLst>
+        </p:cTn>
+      </p:par>
+    </p:tnLst>
+    <p:bldLst>
+      <p:bldP spid="8" grpId="0"/>
+      <p:bldP spid="9" grpId="0"/>
+      <p:bldP spid="10" grpId="0"/>
+    </p:bldLst>
+  </p:timing>
 </p:sld>
 </file>
 

</xml_diff>

<commit_message>
Sharpen Helvetia paintings, drop slide 1 transition and animation
Co-Authored-By: Claude Opus 5.5 <noreply@anthropic.com>
Claude-Session: https://claude.ai/code/session_01ETjVcpBAzS2WJAYjtqxef9
</commit_message>
<xml_diff>
--- a/presentation/Helvetia.pptx
+++ b/presentation/Helvetia.pptx
@@ -1578,152 +1578,6 @@
   <p:clrMapOvr>
     <a:masterClrMapping/>
   </p:clrMapOvr>
-  <mc:AlternateContent xmlns:mc="http://schemas.openxmlformats.org/markup-compatibility/2006">
-    <mc:Choice xmlns:p14="http://schemas.microsoft.com/office/powerpoint/2010/main" Requires="p14">
-      <p:transition spd="slow" p14:dur="2000">
-        <p:fade thruBlk="1"/>
-      </p:transition>
-    </mc:Choice>
-    <mc:Fallback>
-      <p:transition spd="slow">
-        <p:fade thruBlk="1"/>
-      </p:transition>
-    </mc:Fallback>
-  </mc:AlternateContent>
-  <p:timing>
-    <p:tnLst>
-      <p:par>
-        <p:cTn id="1" dur="indefinite" restart="never" nodeType="tmRoot">
-          <p:childTnLst>
-            <p:seq concurrent="1" nextAc="seek">
-              <p:cTn id="2" dur="indefinite" nodeType="mainSeq">
-                <p:childTnLst>
-                  <p:par>
-                    <p:cTn id="3" fill="hold">
-                      <p:stCondLst>
-                        <p:cond delay="indefinite"/>
-                        <p:cond evt="onBegin" delay="0">
-                          <p:tn val="2"/>
-                        </p:cond>
-                      </p:stCondLst>
-                      <p:childTnLst>
-                        <p:par>
-                          <p:cTn id="4" fill="hold">
-                            <p:stCondLst>
-                              <p:cond delay="900"/>
-                            </p:stCondLst>
-                            <p:childTnLst>
-                              <p:par>
-                                <p:cTn id="5" presetID="10" presetClass="entr" presetSubtype="0" fill="hold" grpId="0" nodeType="withEffect">
-                                  <p:stCondLst>
-                                    <p:cond delay="0"/>
-                                  </p:stCondLst>
-                                  <p:childTnLst>
-                                    <p:set>
-                                      <p:cBhvr>
-                                        <p:cTn id="6" dur="1" fill="hold">
-                                          <p:stCondLst>
-                                            <p:cond delay="0"/>
-                                          </p:stCondLst>
-                                        </p:cTn>
-                                        <p:tgtEl>
-                                          <p:spTgt spid="8"/>
-                                        </p:tgtEl>
-                                        <p:attrNameLst>
-                                          <p:attrName>style.visibility</p:attrName>
-                                        </p:attrNameLst>
-                                      </p:cBhvr>
-                                      <p:to>
-                                        <p:strVal val="visible"/>
-                                      </p:to>
-                                    </p:set>
-                                    <p:animEffect transition="in" filter="fade">
-                                      <p:cBhvr>
-                                        <p:cTn id="7" dur="900"/>
-                                        <p:tgtEl>
-                                          <p:spTgt spid="8"/>
-                                        </p:tgtEl>
-                                      </p:cBhvr>
-                                    </p:animEffect>
-                                  </p:childTnLst>
-                                </p:cTn>
-                              </p:par>
-                            </p:childTnLst>
-                          </p:cTn>
-                        </p:par>
-                        <p:par>
-                          <p:cTn id="8" fill="hold">
-                            <p:stCondLst>
-                              <p:cond delay="1080"/>
-                            </p:stCondLst>
-                            <p:childTnLst>
-                              <p:par>
-                                <p:cTn id="9" presetID="10" presetClass="entr" presetSubtype="0" fill="hold" grpId="0" nodeType="withEffect">
-                                  <p:stCondLst>
-                                    <p:cond delay="0"/>
-                                  </p:stCondLst>
-                                  <p:childTnLst>
-                                    <p:set>
-                                      <p:cBhvr>
-                                        <p:cTn id="10" dur="1" fill="hold">
-                                          <p:stCondLst>
-                                            <p:cond delay="0"/>
-                                          </p:stCondLst>
-                                        </p:cTn>
-                                        <p:tgtEl>
-                                          <p:spTgt spid="9"/>
-                                        </p:tgtEl>
-                                        <p:attrNameLst>
-                                          <p:attrName>style.visibility</p:attrName>
-                                        </p:attrNameLst>
-                                      </p:cBhvr>
-                                      <p:to>
-                                        <p:strVal val="visible"/>
-                                      </p:to>
-                                    </p:set>
-                                    <p:animEffect transition="in" filter="fade">
-                                      <p:cBhvr>
-                                        <p:cTn id="11" dur="900"/>
-                                        <p:tgtEl>
-                                          <p:spTgt spid="9"/>
-                                        </p:tgtEl>
-                                      </p:cBhvr>
-                                    </p:animEffect>
-                                  </p:childTnLst>
-                                </p:cTn>
-                              </p:par>
-                            </p:childTnLst>
-                          </p:cTn>
-                        </p:par>
-                      </p:childTnLst>
-                    </p:cTn>
-                  </p:par>
-                </p:childTnLst>
-              </p:cTn>
-              <p:prevCondLst>
-                <p:cond evt="onPrev" delay="0">
-                  <p:tgtEl>
-                    <p:sldTgt/>
-                  </p:tgtEl>
-                </p:cond>
-              </p:prevCondLst>
-              <p:nextCondLst>
-                <p:cond evt="onNext" delay="0">
-                  <p:tgtEl>
-                    <p:sldTgt/>
-                  </p:tgtEl>
-                </p:cond>
-              </p:nextCondLst>
-            </p:seq>
-          </p:childTnLst>
-        </p:cTn>
-      </p:par>
-    </p:tnLst>
-    <p:bldLst>
-      <p:bldP spid="8" grpId="0"/>
-      <p:bldP spid="9" grpId="0"/>
-    </p:bldLst>
-  </p:timing>
 </p:sld>
 </file>
 

</xml_diff>

<commit_message>
Slide titles move sideways with content; only shield and painting persist
Co-Authored-By: Claude Opus 5.5 <noreply@anthropic.com>
Claude-Session: https://claude.ai/code/session_01ETjVcpBAzS2WJAYjtqxef9
</commit_message>
<xml_diff>
--- a/presentation/Helvetia.pptx
+++ b/presentation/Helvetia.pptx
@@ -1419,14 +1419,14 @@
       </p:pic>
       <p:sp>
         <p:nvSpPr>
-          <p:cNvPr id="6" name="!!kicker"/>
-          <p:cNvSpPr txBox="1"/>
-          <p:nvPr/>
-        </p:nvSpPr>
-        <p:spPr>
-          <a:xfrm>
-            <a:off x="914400" y="2148840"/>
-            <a:ext cx="10362895" cy="365760"/>
+          <p:cNvPr id="6" name="!!c1_0"/>
+          <p:cNvSpPr txBox="1"/>
+          <p:nvPr/>
+        </p:nvSpPr>
+        <p:spPr>
+          <a:xfrm>
+            <a:off x="13426135" y="6263640"/>
+            <a:ext cx="5120640" cy="274320"/>
           </a:xfrm>
           <a:prstGeom prst="rect">
             <a:avLst/>
@@ -1442,15 +1442,54 @@
               <a:buNone/>
             </a:pPr>
             <a:r>
+              <a:rPr lang="en-US" sz="1000" i="1" dirty="0">
+                <a:solidFill>
+                  <a:srgbClr val="6B5640"/>
+                </a:solidFill>
+                <a:latin typeface="Cambria" pitchFamily="34" charset="0"/>
+                <a:ea typeface="Cambria" pitchFamily="34" charset="-122"/>
+                <a:cs typeface="Cambria" pitchFamily="34" charset="-120"/>
+              </a:rPr>
+              <a:t>Фирвальдштетское озеро — колыбель союза (иллюстрация)</a:t>
+            </a:r>
+            <a:endParaRPr lang="en-US" sz="1000" dirty="0"/>
+          </a:p>
+        </p:txBody>
+      </p:sp>
+      <p:sp>
+        <p:nvSpPr>
+          <p:cNvPr id="7" name="!!c1_1"/>
+          <p:cNvSpPr txBox="1"/>
+          <p:nvPr/>
+        </p:nvSpPr>
+        <p:spPr>
+          <a:xfrm>
+            <a:off x="19186855" y="868680"/>
+            <a:ext cx="4114800" cy="320040"/>
+          </a:xfrm>
+          <a:prstGeom prst="rect">
+            <a:avLst/>
+          </a:prstGeom>
+          <a:noFill/>
+          <a:ln/>
+        </p:spPr>
+        <p:txBody>
+          <a:bodyPr wrap="square" lIns="0" tIns="0" rIns="0" bIns="0" rtlCol="0" anchor="ctr"/>
+          <a:lstStyle/>
+          <a:p>
+            <a:pPr indent="0" marL="0">
+              <a:buNone/>
+            </a:pPr>
+            <a:r>
               <a:rPr lang="en-US" sz="1300" spc="600" kern="0" dirty="0">
                 <a:solidFill>
-                  <a:srgbClr val="C9A15A"/>
-                </a:solidFill>
-                <a:latin typeface="Bookman Old Style" pitchFamily="34" charset="0"/>
-                <a:ea typeface="Bookman Old Style" pitchFamily="34" charset="-122"/>
-                <a:cs typeface="Bookman Old Style" pitchFamily="34" charset="-120"/>
-              </a:rPr>
-              <a:t>CONFOEDERATIO  HELVETICA  ·  MCCXCI — MDCXLVIII</a:t>
+                  <a:srgbClr val="7A1C1A"/>
+                </a:solidFill>
+                <a:latin typeface="Bookman Old Style" pitchFamily="34" charset="0"/>
+                <a:ea typeface="Bookman Old Style" pitchFamily="34" charset="-122"/>
+                <a:cs typeface="Bookman Old Style" pitchFamily="34" charset="-120"/>
+              </a:rPr>
+              <a:t>CAPUT  I  ·  1291</a:t>
             </a:r>
             <a:endParaRPr lang="en-US" sz="1300" dirty="0"/>
           </a:p>
@@ -1458,46 +1497,85 @@
       </p:sp>
       <p:sp>
         <p:nvSpPr>
-          <p:cNvPr id="7" name="!!title"/>
-          <p:cNvSpPr txBox="1"/>
-          <p:nvPr/>
-        </p:nvSpPr>
-        <p:spPr>
-          <a:xfrm>
-            <a:off x="914400" y="2606040"/>
-            <a:ext cx="10362895" cy="1188720"/>
-          </a:xfrm>
-          <a:prstGeom prst="rect">
-            <a:avLst/>
-          </a:prstGeom>
-          <a:noFill/>
-          <a:ln/>
-        </p:spPr>
-        <p:txBody>
-          <a:bodyPr wrap="square" lIns="0" tIns="0" rIns="0" bIns="0" rtlCol="0" anchor="ctr"/>
-          <a:lstStyle/>
-          <a:p>
-            <a:pPr algn="ctr" indent="0" marL="0">
-              <a:buNone/>
-            </a:pPr>
-            <a:r>
-              <a:rPr lang="en-US" sz="5200" b="1" dirty="0">
-                <a:solidFill>
-                  <a:srgbClr val="F1E6CF"/>
-                </a:solidFill>
-                <a:latin typeface="Bookman Old Style" pitchFamily="34" charset="0"/>
-                <a:ea typeface="Bookman Old Style" pitchFamily="34" charset="-122"/>
-                <a:cs typeface="Bookman Old Style" pitchFamily="34" charset="-120"/>
-              </a:rPr>
-              <a:t>Швейцария до XVIII века</a:t>
-            </a:r>
-            <a:endParaRPr lang="en-US" sz="5200" dirty="0"/>
-          </a:p>
-        </p:txBody>
-      </p:sp>
-      <p:sp>
-        <p:nvSpPr>
-          <p:cNvPr id="8" name="!!c1_0"/>
+          <p:cNvPr id="8" name="!!c1_2"/>
+          <p:cNvSpPr txBox="1"/>
+          <p:nvPr/>
+        </p:nvSpPr>
+        <p:spPr>
+          <a:xfrm>
+            <a:off x="19186855" y="1234440"/>
+            <a:ext cx="4983480" cy="822960"/>
+          </a:xfrm>
+          <a:prstGeom prst="rect">
+            <a:avLst/>
+          </a:prstGeom>
+          <a:noFill/>
+          <a:ln/>
+        </p:spPr>
+        <p:txBody>
+          <a:bodyPr wrap="square" lIns="0" tIns="0" rIns="0" bIns="0" rtlCol="0" anchor="ctr"/>
+          <a:lstStyle/>
+          <a:p>
+            <a:pPr indent="0" marL="0">
+              <a:buNone/>
+            </a:pPr>
+            <a:r>
+              <a:rPr lang="en-US" sz="3200" b="1" dirty="0">
+                <a:solidFill>
+                  <a:srgbClr val="2A1E16"/>
+                </a:solidFill>
+                <a:latin typeface="Bookman Old Style" pitchFamily="34" charset="0"/>
+                <a:ea typeface="Bookman Old Style" pitchFamily="34" charset="-122"/>
+                <a:cs typeface="Bookman Old Style" pitchFamily="34" charset="-120"/>
+              </a:rPr>
+              <a:t>Как всё началось</a:t>
+            </a:r>
+            <a:endParaRPr lang="en-US" sz="3200" dirty="0"/>
+          </a:p>
+        </p:txBody>
+      </p:sp>
+      <p:sp>
+        <p:nvSpPr>
+          <p:cNvPr id="9" name="!!c1_3"/>
+          <p:cNvSpPr txBox="1"/>
+          <p:nvPr/>
+        </p:nvSpPr>
+        <p:spPr>
+          <a:xfrm>
+            <a:off x="22981615" y="6263640"/>
+            <a:ext cx="1097280" cy="274320"/>
+          </a:xfrm>
+          <a:prstGeom prst="rect">
+            <a:avLst/>
+          </a:prstGeom>
+          <a:noFill/>
+          <a:ln/>
+        </p:spPr>
+        <p:txBody>
+          <a:bodyPr wrap="square" lIns="0" tIns="0" rIns="0" bIns="0" rtlCol="0" anchor="ctr"/>
+          <a:lstStyle/>
+          <a:p>
+            <a:pPr algn="r" indent="0" marL="0">
+              <a:buNone/>
+            </a:pPr>
+            <a:r>
+              <a:rPr lang="en-US" sz="1000" spc="300" kern="0" dirty="0">
+                <a:solidFill>
+                  <a:srgbClr val="6B5640"/>
+                </a:solidFill>
+                <a:latin typeface="Bookman Old Style" pitchFamily="34" charset="0"/>
+                <a:ea typeface="Bookman Old Style" pitchFamily="34" charset="-122"/>
+                <a:cs typeface="Bookman Old Style" pitchFamily="34" charset="-120"/>
+              </a:rPr>
+              <a:t>II  ·  VI</a:t>
+            </a:r>
+            <a:endParaRPr lang="en-US" sz="1000" dirty="0"/>
+          </a:p>
+        </p:txBody>
+      </p:sp>
+      <p:sp>
+        <p:nvSpPr>
+          <p:cNvPr id="10" name="!!c1_4"/>
           <p:cNvSpPr txBox="1"/>
           <p:nvPr/>
         </p:nvSpPr>
@@ -1536,7 +1614,7 @@
       </p:sp>
       <p:sp>
         <p:nvSpPr>
-          <p:cNvPr id="9" name="!!c1_1"/>
+          <p:cNvPr id="11" name="!!c1_5"/>
           <p:cNvSpPr txBox="1"/>
           <p:nvPr/>
         </p:nvSpPr>
@@ -1578,7 +1656,7 @@
       </p:sp>
       <p:sp>
         <p:nvSpPr>
-          <p:cNvPr id="10" name="!!c1_2"/>
+          <p:cNvPr id="12" name="!!c1_6"/>
           <p:cNvSpPr txBox="1"/>
           <p:nvPr/>
         </p:nvSpPr>
@@ -1620,7 +1698,7 @@
       </p:sp>
       <p:sp>
         <p:nvSpPr>
-          <p:cNvPr id="11" name="!!c1_3"/>
+          <p:cNvPr id="13" name="!!c1_7"/>
           <p:cNvSpPr txBox="1"/>
           <p:nvPr/>
         </p:nvSpPr>
@@ -1659,7 +1737,85 @@
       </p:sp>
       <p:sp>
         <p:nvSpPr>
-          <p:cNvPr id="12" name="!!c0_0"/>
+          <p:cNvPr id="14" name="!!c0_0"/>
+          <p:cNvSpPr txBox="1"/>
+          <p:nvPr/>
+        </p:nvSpPr>
+        <p:spPr>
+          <a:xfrm>
+            <a:off x="914400" y="2148840"/>
+            <a:ext cx="10362895" cy="365760"/>
+          </a:xfrm>
+          <a:prstGeom prst="rect">
+            <a:avLst/>
+          </a:prstGeom>
+          <a:noFill/>
+          <a:ln/>
+        </p:spPr>
+        <p:txBody>
+          <a:bodyPr wrap="square" lIns="0" tIns="0" rIns="0" bIns="0" rtlCol="0" anchor="ctr"/>
+          <a:lstStyle/>
+          <a:p>
+            <a:pPr algn="ctr" indent="0" marL="0">
+              <a:buNone/>
+            </a:pPr>
+            <a:r>
+              <a:rPr lang="en-US" sz="1300" spc="600" kern="0" dirty="0">
+                <a:solidFill>
+                  <a:srgbClr val="C9A15A"/>
+                </a:solidFill>
+                <a:latin typeface="Bookman Old Style" pitchFamily="34" charset="0"/>
+                <a:ea typeface="Bookman Old Style" pitchFamily="34" charset="-122"/>
+                <a:cs typeface="Bookman Old Style" pitchFamily="34" charset="-120"/>
+              </a:rPr>
+              <a:t>CONFOEDERATIO  HELVETICA  ·  MCCXCI — MDCXLVIII</a:t>
+            </a:r>
+            <a:endParaRPr lang="en-US" sz="1300" dirty="0"/>
+          </a:p>
+        </p:txBody>
+      </p:sp>
+      <p:sp>
+        <p:nvSpPr>
+          <p:cNvPr id="15" name="!!c0_1"/>
+          <p:cNvSpPr txBox="1"/>
+          <p:nvPr/>
+        </p:nvSpPr>
+        <p:spPr>
+          <a:xfrm>
+            <a:off x="914400" y="2606040"/>
+            <a:ext cx="10362895" cy="1188720"/>
+          </a:xfrm>
+          <a:prstGeom prst="rect">
+            <a:avLst/>
+          </a:prstGeom>
+          <a:noFill/>
+          <a:ln/>
+        </p:spPr>
+        <p:txBody>
+          <a:bodyPr wrap="square" lIns="0" tIns="0" rIns="0" bIns="0" rtlCol="0" anchor="ctr"/>
+          <a:lstStyle/>
+          <a:p>
+            <a:pPr algn="ctr" indent="0" marL="0">
+              <a:buNone/>
+            </a:pPr>
+            <a:r>
+              <a:rPr lang="en-US" sz="5200" b="1" dirty="0">
+                <a:solidFill>
+                  <a:srgbClr val="F1E6CF"/>
+                </a:solidFill>
+                <a:latin typeface="Bookman Old Style" pitchFamily="34" charset="0"/>
+                <a:ea typeface="Bookman Old Style" pitchFamily="34" charset="-122"/>
+                <a:cs typeface="Bookman Old Style" pitchFamily="34" charset="-120"/>
+              </a:rPr>
+              <a:t>Швейцария до XVIII века</a:t>
+            </a:r>
+            <a:endParaRPr lang="en-US" sz="5200" dirty="0"/>
+          </a:p>
+        </p:txBody>
+      </p:sp>
+      <p:sp>
+        <p:nvSpPr>
+          <p:cNvPr id="16" name="!!c0_2"/>
           <p:cNvSpPr txBox="1"/>
           <p:nvPr/>
         </p:nvSpPr>
@@ -1698,7 +1854,7 @@
       </p:sp>
       <p:sp>
         <p:nvSpPr>
-          <p:cNvPr id="13" name="!!c0_1"/>
+          <p:cNvPr id="17" name="!!c0_3"/>
           <p:cNvSpPr txBox="1"/>
           <p:nvPr/>
         </p:nvSpPr>
@@ -1829,48 +1985,9 @@
           </a:prstGeom>
         </p:spPr>
       </p:pic>
-      <p:sp>
-        <p:nvSpPr>
-          <p:cNvPr id="4" name="!!caption"/>
-          <p:cNvSpPr txBox="1"/>
-          <p:nvPr/>
-        </p:nvSpPr>
-        <p:spPr>
-          <a:xfrm>
-            <a:off x="777240" y="6263640"/>
-            <a:ext cx="5120640" cy="274320"/>
-          </a:xfrm>
-          <a:prstGeom prst="rect">
-            <a:avLst/>
-          </a:prstGeom>
-          <a:noFill/>
-          <a:ln/>
-        </p:spPr>
-        <p:txBody>
-          <a:bodyPr wrap="square" lIns="0" tIns="0" rIns="0" bIns="0" rtlCol="0" anchor="ctr"/>
-          <a:lstStyle/>
-          <a:p>
-            <a:pPr algn="ctr" indent="0" marL="0">
-              <a:buNone/>
-            </a:pPr>
-            <a:r>
-              <a:rPr lang="en-US" sz="1000" i="1" dirty="0">
-                <a:solidFill>
-                  <a:srgbClr val="6B5640"/>
-                </a:solidFill>
-                <a:latin typeface="Cambria" pitchFamily="34" charset="0"/>
-                <a:ea typeface="Cambria" pitchFamily="34" charset="-122"/>
-                <a:cs typeface="Cambria" pitchFamily="34" charset="-120"/>
-              </a:rPr>
-              <a:t>Фирвальдштетское озеро — колыбель союза (иллюстрация)</a:t>
-            </a:r>
-            <a:endParaRPr lang="en-US" sz="1000" dirty="0"/>
-          </a:p>
-        </p:txBody>
-      </p:sp>
       <p:pic>
         <p:nvPicPr>
-          <p:cNvPr id="5" name="!!shield" descr="img/shield.png">    </p:cNvPr>
+          <p:cNvPr id="4" name="!!shield" descr="img/shield.png">    </p:cNvPr>
           <p:cNvPicPr>
             <a:picLocks noChangeAspect="1"/>
           </p:cNvPicPr>
@@ -1894,38 +2011,38 @@
       </p:pic>
       <p:sp>
         <p:nvSpPr>
-          <p:cNvPr id="6" name="!!kicker"/>
-          <p:cNvSpPr txBox="1"/>
-          <p:nvPr/>
-        </p:nvSpPr>
-        <p:spPr>
-          <a:xfrm>
-            <a:off x="6537960" y="868680"/>
-            <a:ext cx="4114800" cy="320040"/>
-          </a:xfrm>
-          <a:prstGeom prst="rect">
-            <a:avLst/>
-          </a:prstGeom>
-          <a:noFill/>
-          <a:ln/>
-        </p:spPr>
-        <p:txBody>
-          <a:bodyPr wrap="square" lIns="0" tIns="0" rIns="0" bIns="0" rtlCol="0" anchor="ctr"/>
-          <a:lstStyle/>
-          <a:p>
-            <a:pPr indent="0" marL="0">
+          <p:cNvPr id="5" name="!!c0_0"/>
+          <p:cNvSpPr txBox="1"/>
+          <p:nvPr/>
+        </p:nvSpPr>
+        <p:spPr>
+          <a:xfrm>
+            <a:off x="-11734495" y="2148840"/>
+            <a:ext cx="10362895" cy="365760"/>
+          </a:xfrm>
+          <a:prstGeom prst="rect">
+            <a:avLst/>
+          </a:prstGeom>
+          <a:noFill/>
+          <a:ln/>
+        </p:spPr>
+        <p:txBody>
+          <a:bodyPr wrap="square" lIns="0" tIns="0" rIns="0" bIns="0" rtlCol="0" anchor="ctr"/>
+          <a:lstStyle/>
+          <a:p>
+            <a:pPr algn="ctr" indent="0" marL="0">
               <a:buNone/>
             </a:pPr>
             <a:r>
               <a:rPr lang="en-US" sz="1300" spc="600" kern="0" dirty="0">
                 <a:solidFill>
-                  <a:srgbClr val="7A1C1A"/>
-                </a:solidFill>
-                <a:latin typeface="Bookman Old Style" pitchFamily="34" charset="0"/>
-                <a:ea typeface="Bookman Old Style" pitchFamily="34" charset="-122"/>
-                <a:cs typeface="Bookman Old Style" pitchFamily="34" charset="-120"/>
-              </a:rPr>
-              <a:t>CAPUT  I  ·  1291</a:t>
+                  <a:srgbClr val="C9A15A"/>
+                </a:solidFill>
+                <a:latin typeface="Bookman Old Style" pitchFamily="34" charset="0"/>
+                <a:ea typeface="Bookman Old Style" pitchFamily="34" charset="-122"/>
+                <a:cs typeface="Bookman Old Style" pitchFamily="34" charset="-120"/>
+              </a:rPr>
+              <a:t>CONFOEDERATIO  HELVETICA  ·  MCCXCI — MDCXLVIII</a:t>
             </a:r>
             <a:endParaRPr lang="en-US" sz="1300" dirty="0"/>
           </a:p>
@@ -1933,85 +2050,46 @@
       </p:sp>
       <p:sp>
         <p:nvSpPr>
-          <p:cNvPr id="7" name="!!title"/>
-          <p:cNvSpPr txBox="1"/>
-          <p:nvPr/>
-        </p:nvSpPr>
-        <p:spPr>
-          <a:xfrm>
-            <a:off x="6537960" y="1234440"/>
-            <a:ext cx="4983480" cy="822960"/>
-          </a:xfrm>
-          <a:prstGeom prst="rect">
-            <a:avLst/>
-          </a:prstGeom>
-          <a:noFill/>
-          <a:ln/>
-        </p:spPr>
-        <p:txBody>
-          <a:bodyPr wrap="square" lIns="0" tIns="0" rIns="0" bIns="0" rtlCol="0" anchor="ctr"/>
-          <a:lstStyle/>
-          <a:p>
-            <a:pPr indent="0" marL="0">
-              <a:buNone/>
-            </a:pPr>
-            <a:r>
-              <a:rPr lang="en-US" sz="3200" b="1" dirty="0">
-                <a:solidFill>
-                  <a:srgbClr val="2A1E16"/>
-                </a:solidFill>
-                <a:latin typeface="Bookman Old Style" pitchFamily="34" charset="0"/>
-                <a:ea typeface="Bookman Old Style" pitchFamily="34" charset="-122"/>
-                <a:cs typeface="Bookman Old Style" pitchFamily="34" charset="-120"/>
-              </a:rPr>
-              <a:t>Как всё началось</a:t>
-            </a:r>
-            <a:endParaRPr lang="en-US" sz="3200" dirty="0"/>
-          </a:p>
-        </p:txBody>
-      </p:sp>
-      <p:sp>
-        <p:nvSpPr>
-          <p:cNvPr id="8" name="!!page"/>
-          <p:cNvSpPr txBox="1"/>
-          <p:nvPr/>
-        </p:nvSpPr>
-        <p:spPr>
-          <a:xfrm>
-            <a:off x="10332720" y="6263640"/>
-            <a:ext cx="1097280" cy="274320"/>
-          </a:xfrm>
-          <a:prstGeom prst="rect">
-            <a:avLst/>
-          </a:prstGeom>
-          <a:noFill/>
-          <a:ln/>
-        </p:spPr>
-        <p:txBody>
-          <a:bodyPr wrap="square" lIns="0" tIns="0" rIns="0" bIns="0" rtlCol="0" anchor="ctr"/>
-          <a:lstStyle/>
-          <a:p>
-            <a:pPr algn="r" indent="0" marL="0">
-              <a:buNone/>
-            </a:pPr>
-            <a:r>
-              <a:rPr lang="en-US" sz="1000" spc="300" kern="0" dirty="0">
-                <a:solidFill>
-                  <a:srgbClr val="6B5640"/>
-                </a:solidFill>
-                <a:latin typeface="Bookman Old Style" pitchFamily="34" charset="0"/>
-                <a:ea typeface="Bookman Old Style" pitchFamily="34" charset="-122"/>
-                <a:cs typeface="Bookman Old Style" pitchFamily="34" charset="-120"/>
-              </a:rPr>
-              <a:t>II  ·  VI</a:t>
-            </a:r>
-            <a:endParaRPr lang="en-US" sz="1000" dirty="0"/>
-          </a:p>
-        </p:txBody>
-      </p:sp>
-      <p:sp>
-        <p:nvSpPr>
-          <p:cNvPr id="9" name="!!c0_0"/>
+          <p:cNvPr id="6" name="!!c0_1"/>
+          <p:cNvSpPr txBox="1"/>
+          <p:nvPr/>
+        </p:nvSpPr>
+        <p:spPr>
+          <a:xfrm>
+            <a:off x="-11734495" y="2606040"/>
+            <a:ext cx="10362895" cy="1188720"/>
+          </a:xfrm>
+          <a:prstGeom prst="rect">
+            <a:avLst/>
+          </a:prstGeom>
+          <a:noFill/>
+          <a:ln/>
+        </p:spPr>
+        <p:txBody>
+          <a:bodyPr wrap="square" lIns="0" tIns="0" rIns="0" bIns="0" rtlCol="0" anchor="ctr"/>
+          <a:lstStyle/>
+          <a:p>
+            <a:pPr algn="ctr" indent="0" marL="0">
+              <a:buNone/>
+            </a:pPr>
+            <a:r>
+              <a:rPr lang="en-US" sz="5200" b="1" dirty="0">
+                <a:solidFill>
+                  <a:srgbClr val="F1E6CF"/>
+                </a:solidFill>
+                <a:latin typeface="Bookman Old Style" pitchFamily="34" charset="0"/>
+                <a:ea typeface="Bookman Old Style" pitchFamily="34" charset="-122"/>
+                <a:cs typeface="Bookman Old Style" pitchFamily="34" charset="-120"/>
+              </a:rPr>
+              <a:t>Швейцария до XVIII века</a:t>
+            </a:r>
+            <a:endParaRPr lang="en-US" sz="5200" dirty="0"/>
+          </a:p>
+        </p:txBody>
+      </p:sp>
+      <p:sp>
+        <p:nvSpPr>
+          <p:cNvPr id="7" name="!!c0_2"/>
           <p:cNvSpPr txBox="1"/>
           <p:nvPr/>
         </p:nvSpPr>
@@ -2050,7 +2128,7 @@
       </p:sp>
       <p:sp>
         <p:nvSpPr>
-          <p:cNvPr id="10" name="!!c0_1"/>
+          <p:cNvPr id="8" name="!!c0_3"/>
           <p:cNvSpPr txBox="1"/>
           <p:nvPr/>
         </p:nvSpPr>
@@ -2089,7 +2167,124 @@
       </p:sp>
       <p:sp>
         <p:nvSpPr>
-          <p:cNvPr id="11" name="!!c2_0"/>
+          <p:cNvPr id="9" name="!!c2_0"/>
+          <p:cNvSpPr txBox="1"/>
+          <p:nvPr/>
+        </p:nvSpPr>
+        <p:spPr>
+          <a:xfrm>
+            <a:off x="13426135" y="2377440"/>
+            <a:ext cx="4572000" cy="320040"/>
+          </a:xfrm>
+          <a:prstGeom prst="rect">
+            <a:avLst/>
+          </a:prstGeom>
+          <a:noFill/>
+          <a:ln/>
+        </p:spPr>
+        <p:txBody>
+          <a:bodyPr wrap="square" lIns="0" tIns="0" rIns="0" bIns="0" rtlCol="0" anchor="ctr"/>
+          <a:lstStyle/>
+          <a:p>
+            <a:pPr indent="0" marL="0">
+              <a:buNone/>
+            </a:pPr>
+            <a:r>
+              <a:rPr lang="en-US" sz="1300" spc="600" kern="0" dirty="0">
+                <a:solidFill>
+                  <a:srgbClr val="7A1C1A"/>
+                </a:solidFill>
+                <a:latin typeface="Bookman Old Style" pitchFamily="34" charset="0"/>
+                <a:ea typeface="Bookman Old Style" pitchFamily="34" charset="-122"/>
+                <a:cs typeface="Bookman Old Style" pitchFamily="34" charset="-120"/>
+              </a:rPr>
+              <a:t>CAPUT  II</a:t>
+            </a:r>
+            <a:endParaRPr lang="en-US" sz="1300" dirty="0"/>
+          </a:p>
+        </p:txBody>
+      </p:sp>
+      <p:sp>
+        <p:nvSpPr>
+          <p:cNvPr id="10" name="!!c2_1"/>
+          <p:cNvSpPr txBox="1"/>
+          <p:nvPr/>
+        </p:nvSpPr>
+        <p:spPr>
+          <a:xfrm>
+            <a:off x="13426135" y="2697480"/>
+            <a:ext cx="8229600" cy="731520"/>
+          </a:xfrm>
+          <a:prstGeom prst="rect">
+            <a:avLst/>
+          </a:prstGeom>
+          <a:noFill/>
+          <a:ln/>
+        </p:spPr>
+        <p:txBody>
+          <a:bodyPr wrap="square" lIns="0" tIns="0" rIns="0" bIns="0" rtlCol="0" anchor="ctr"/>
+          <a:lstStyle/>
+          <a:p>
+            <a:pPr indent="0" marL="0">
+              <a:buNone/>
+            </a:pPr>
+            <a:r>
+              <a:rPr lang="en-US" sz="3600" b="1" dirty="0">
+                <a:solidFill>
+                  <a:srgbClr val="2A1E16"/>
+                </a:solidFill>
+                <a:latin typeface="Bookman Old Style" pitchFamily="34" charset="0"/>
+                <a:ea typeface="Bookman Old Style" pitchFamily="34" charset="-122"/>
+                <a:cs typeface="Bookman Old Style" pitchFamily="34" charset="-120"/>
+              </a:rPr>
+              <a:t>Три опоры Швейцарии</a:t>
+            </a:r>
+            <a:endParaRPr lang="en-US" sz="3600" dirty="0"/>
+          </a:p>
+        </p:txBody>
+      </p:sp>
+      <p:sp>
+        <p:nvSpPr>
+          <p:cNvPr id="11" name="!!c2_2"/>
+          <p:cNvSpPr txBox="1"/>
+          <p:nvPr/>
+        </p:nvSpPr>
+        <p:spPr>
+          <a:xfrm>
+            <a:off x="22981615" y="6263640"/>
+            <a:ext cx="1097280" cy="274320"/>
+          </a:xfrm>
+          <a:prstGeom prst="rect">
+            <a:avLst/>
+          </a:prstGeom>
+          <a:noFill/>
+          <a:ln/>
+        </p:spPr>
+        <p:txBody>
+          <a:bodyPr wrap="square" lIns="0" tIns="0" rIns="0" bIns="0" rtlCol="0" anchor="ctr"/>
+          <a:lstStyle/>
+          <a:p>
+            <a:pPr algn="r" indent="0" marL="0">
+              <a:buNone/>
+            </a:pPr>
+            <a:r>
+              <a:rPr lang="en-US" sz="1000" spc="300" kern="0" dirty="0">
+                <a:solidFill>
+                  <a:srgbClr val="6B5640"/>
+                </a:solidFill>
+                <a:latin typeface="Bookman Old Style" pitchFamily="34" charset="0"/>
+                <a:ea typeface="Bookman Old Style" pitchFamily="34" charset="-122"/>
+                <a:cs typeface="Bookman Old Style" pitchFamily="34" charset="-120"/>
+              </a:rPr>
+              <a:t>III  ·  VI</a:t>
+            </a:r>
+            <a:endParaRPr lang="en-US" sz="1000" dirty="0"/>
+          </a:p>
+        </p:txBody>
+      </p:sp>
+      <p:sp>
+        <p:nvSpPr>
+          <p:cNvPr id="12" name="!!c2_3"/>
           <p:cNvSpPr txBox="1"/>
           <p:nvPr/>
         </p:nvSpPr>
@@ -2128,7 +2323,7 @@
       </p:sp>
       <p:sp>
         <p:nvSpPr>
-          <p:cNvPr id="12" name="!!c2_1"/>
+          <p:cNvPr id="13" name="!!c2_4"/>
           <p:cNvSpPr txBox="1"/>
           <p:nvPr/>
         </p:nvSpPr>
@@ -2167,7 +2362,7 @@
       </p:sp>
       <p:sp>
         <p:nvSpPr>
-          <p:cNvPr id="13" name="!!c2_2"/>
+          <p:cNvPr id="14" name="!!c2_5"/>
           <p:cNvSpPr txBox="1"/>
           <p:nvPr/>
         </p:nvSpPr>
@@ -2209,7 +2404,7 @@
       </p:sp>
       <p:sp>
         <p:nvSpPr>
-          <p:cNvPr id="14" name="!!c2_3"/>
+          <p:cNvPr id="15" name="!!c2_6"/>
           <p:cNvSpPr txBox="1"/>
           <p:nvPr/>
         </p:nvSpPr>
@@ -2248,7 +2443,7 @@
       </p:sp>
       <p:sp>
         <p:nvSpPr>
-          <p:cNvPr id="15" name="!!c2_4"/>
+          <p:cNvPr id="16" name="!!c2_7"/>
           <p:cNvSpPr txBox="1"/>
           <p:nvPr/>
         </p:nvSpPr>
@@ -2287,7 +2482,7 @@
       </p:sp>
       <p:sp>
         <p:nvSpPr>
-          <p:cNvPr id="16" name="!!c2_5"/>
+          <p:cNvPr id="17" name="!!c2_8"/>
           <p:cNvSpPr txBox="1"/>
           <p:nvPr/>
         </p:nvSpPr>
@@ -2329,7 +2524,7 @@
       </p:sp>
       <p:sp>
         <p:nvSpPr>
-          <p:cNvPr id="17" name="!!c2_6"/>
+          <p:cNvPr id="18" name="!!c2_9"/>
           <p:cNvSpPr txBox="1"/>
           <p:nvPr/>
         </p:nvSpPr>
@@ -2368,7 +2563,7 @@
       </p:sp>
       <p:sp>
         <p:nvSpPr>
-          <p:cNvPr id="18" name="!!c2_7"/>
+          <p:cNvPr id="19" name="!!c2_10"/>
           <p:cNvSpPr txBox="1"/>
           <p:nvPr/>
         </p:nvSpPr>
@@ -2407,7 +2602,7 @@
       </p:sp>
       <p:sp>
         <p:nvSpPr>
-          <p:cNvPr id="19" name="!!c2_8"/>
+          <p:cNvPr id="20" name="!!c2_11"/>
           <p:cNvSpPr txBox="1"/>
           <p:nvPr/>
         </p:nvSpPr>
@@ -2449,7 +2644,163 @@
       </p:sp>
       <p:sp>
         <p:nvSpPr>
-          <p:cNvPr id="20" name="!!c1_0"/>
+          <p:cNvPr id="21" name="!!c1_0"/>
+          <p:cNvSpPr txBox="1"/>
+          <p:nvPr/>
+        </p:nvSpPr>
+        <p:spPr>
+          <a:xfrm>
+            <a:off x="777240" y="6263640"/>
+            <a:ext cx="5120640" cy="274320"/>
+          </a:xfrm>
+          <a:prstGeom prst="rect">
+            <a:avLst/>
+          </a:prstGeom>
+          <a:noFill/>
+          <a:ln/>
+        </p:spPr>
+        <p:txBody>
+          <a:bodyPr wrap="square" lIns="0" tIns="0" rIns="0" bIns="0" rtlCol="0" anchor="ctr"/>
+          <a:lstStyle/>
+          <a:p>
+            <a:pPr algn="ctr" indent="0" marL="0">
+              <a:buNone/>
+            </a:pPr>
+            <a:r>
+              <a:rPr lang="en-US" sz="1000" i="1" dirty="0">
+                <a:solidFill>
+                  <a:srgbClr val="6B5640"/>
+                </a:solidFill>
+                <a:latin typeface="Cambria" pitchFamily="34" charset="0"/>
+                <a:ea typeface="Cambria" pitchFamily="34" charset="-122"/>
+                <a:cs typeface="Cambria" pitchFamily="34" charset="-120"/>
+              </a:rPr>
+              <a:t>Фирвальдштетское озеро — колыбель союза (иллюстрация)</a:t>
+            </a:r>
+            <a:endParaRPr lang="en-US" sz="1000" dirty="0"/>
+          </a:p>
+        </p:txBody>
+      </p:sp>
+      <p:sp>
+        <p:nvSpPr>
+          <p:cNvPr id="22" name="!!c1_1"/>
+          <p:cNvSpPr txBox="1"/>
+          <p:nvPr/>
+        </p:nvSpPr>
+        <p:spPr>
+          <a:xfrm>
+            <a:off x="6537960" y="868680"/>
+            <a:ext cx="4114800" cy="320040"/>
+          </a:xfrm>
+          <a:prstGeom prst="rect">
+            <a:avLst/>
+          </a:prstGeom>
+          <a:noFill/>
+          <a:ln/>
+        </p:spPr>
+        <p:txBody>
+          <a:bodyPr wrap="square" lIns="0" tIns="0" rIns="0" bIns="0" rtlCol="0" anchor="ctr"/>
+          <a:lstStyle/>
+          <a:p>
+            <a:pPr indent="0" marL="0">
+              <a:buNone/>
+            </a:pPr>
+            <a:r>
+              <a:rPr lang="en-US" sz="1300" spc="600" kern="0" dirty="0">
+                <a:solidFill>
+                  <a:srgbClr val="7A1C1A"/>
+                </a:solidFill>
+                <a:latin typeface="Bookman Old Style" pitchFamily="34" charset="0"/>
+                <a:ea typeface="Bookman Old Style" pitchFamily="34" charset="-122"/>
+                <a:cs typeface="Bookman Old Style" pitchFamily="34" charset="-120"/>
+              </a:rPr>
+              <a:t>CAPUT  I  ·  1291</a:t>
+            </a:r>
+            <a:endParaRPr lang="en-US" sz="1300" dirty="0"/>
+          </a:p>
+        </p:txBody>
+      </p:sp>
+      <p:sp>
+        <p:nvSpPr>
+          <p:cNvPr id="23" name="!!c1_2"/>
+          <p:cNvSpPr txBox="1"/>
+          <p:nvPr/>
+        </p:nvSpPr>
+        <p:spPr>
+          <a:xfrm>
+            <a:off x="6537960" y="1234440"/>
+            <a:ext cx="4983480" cy="822960"/>
+          </a:xfrm>
+          <a:prstGeom prst="rect">
+            <a:avLst/>
+          </a:prstGeom>
+          <a:noFill/>
+          <a:ln/>
+        </p:spPr>
+        <p:txBody>
+          <a:bodyPr wrap="square" lIns="0" tIns="0" rIns="0" bIns="0" rtlCol="0" anchor="ctr"/>
+          <a:lstStyle/>
+          <a:p>
+            <a:pPr indent="0" marL="0">
+              <a:buNone/>
+            </a:pPr>
+            <a:r>
+              <a:rPr lang="en-US" sz="3200" b="1" dirty="0">
+                <a:solidFill>
+                  <a:srgbClr val="2A1E16"/>
+                </a:solidFill>
+                <a:latin typeface="Bookman Old Style" pitchFamily="34" charset="0"/>
+                <a:ea typeface="Bookman Old Style" pitchFamily="34" charset="-122"/>
+                <a:cs typeface="Bookman Old Style" pitchFamily="34" charset="-120"/>
+              </a:rPr>
+              <a:t>Как всё началось</a:t>
+            </a:r>
+            <a:endParaRPr lang="en-US" sz="3200" dirty="0"/>
+          </a:p>
+        </p:txBody>
+      </p:sp>
+      <p:sp>
+        <p:nvSpPr>
+          <p:cNvPr id="24" name="!!c1_3"/>
+          <p:cNvSpPr txBox="1"/>
+          <p:nvPr/>
+        </p:nvSpPr>
+        <p:spPr>
+          <a:xfrm>
+            <a:off x="10332720" y="6263640"/>
+            <a:ext cx="1097280" cy="274320"/>
+          </a:xfrm>
+          <a:prstGeom prst="rect">
+            <a:avLst/>
+          </a:prstGeom>
+          <a:noFill/>
+          <a:ln/>
+        </p:spPr>
+        <p:txBody>
+          <a:bodyPr wrap="square" lIns="0" tIns="0" rIns="0" bIns="0" rtlCol="0" anchor="ctr"/>
+          <a:lstStyle/>
+          <a:p>
+            <a:pPr algn="r" indent="0" marL="0">
+              <a:buNone/>
+            </a:pPr>
+            <a:r>
+              <a:rPr lang="en-US" sz="1000" spc="300" kern="0" dirty="0">
+                <a:solidFill>
+                  <a:srgbClr val="6B5640"/>
+                </a:solidFill>
+                <a:latin typeface="Bookman Old Style" pitchFamily="34" charset="0"/>
+                <a:ea typeface="Bookman Old Style" pitchFamily="34" charset="-122"/>
+                <a:cs typeface="Bookman Old Style" pitchFamily="34" charset="-120"/>
+              </a:rPr>
+              <a:t>II  ·  VI</a:t>
+            </a:r>
+            <a:endParaRPr lang="en-US" sz="1000" dirty="0"/>
+          </a:p>
+        </p:txBody>
+      </p:sp>
+      <p:sp>
+        <p:nvSpPr>
+          <p:cNvPr id="25" name="!!c1_4"/>
           <p:cNvSpPr txBox="1"/>
           <p:nvPr/>
         </p:nvSpPr>
@@ -2488,7 +2839,7 @@
       </p:sp>
       <p:sp>
         <p:nvSpPr>
-          <p:cNvPr id="21" name="!!c1_1"/>
+          <p:cNvPr id="26" name="!!c1_5"/>
           <p:cNvSpPr txBox="1"/>
           <p:nvPr/>
         </p:nvSpPr>
@@ -2530,7 +2881,7 @@
       </p:sp>
       <p:sp>
         <p:nvSpPr>
-          <p:cNvPr id="22" name="!!c1_2"/>
+          <p:cNvPr id="27" name="!!c1_6"/>
           <p:cNvSpPr txBox="1"/>
           <p:nvPr/>
         </p:nvSpPr>
@@ -2572,7 +2923,7 @@
       </p:sp>
       <p:sp>
         <p:nvSpPr>
-          <p:cNvPr id="23" name="!!c1_3"/>
+          <p:cNvPr id="28" name="!!c1_7"/>
           <p:cNvSpPr txBox="1"/>
           <p:nvPr/>
         </p:nvSpPr>
@@ -2741,14 +3092,53 @@
       </p:pic>
       <p:sp>
         <p:nvSpPr>
-          <p:cNvPr id="5" name="!!kicker"/>
-          <p:cNvSpPr txBox="1"/>
-          <p:nvPr/>
-        </p:nvSpPr>
-        <p:spPr>
-          <a:xfrm>
-            <a:off x="777240" y="2377440"/>
-            <a:ext cx="4572000" cy="320040"/>
+          <p:cNvPr id="5" name="!!c1_0"/>
+          <p:cNvSpPr txBox="1"/>
+          <p:nvPr/>
+        </p:nvSpPr>
+        <p:spPr>
+          <a:xfrm>
+            <a:off x="-11871655" y="6263640"/>
+            <a:ext cx="5120640" cy="274320"/>
+          </a:xfrm>
+          <a:prstGeom prst="rect">
+            <a:avLst/>
+          </a:prstGeom>
+          <a:noFill/>
+          <a:ln/>
+        </p:spPr>
+        <p:txBody>
+          <a:bodyPr wrap="square" lIns="0" tIns="0" rIns="0" bIns="0" rtlCol="0" anchor="ctr"/>
+          <a:lstStyle/>
+          <a:p>
+            <a:pPr algn="ctr" indent="0" marL="0">
+              <a:buNone/>
+            </a:pPr>
+            <a:r>
+              <a:rPr lang="en-US" sz="1000" i="1" dirty="0">
+                <a:solidFill>
+                  <a:srgbClr val="6B5640"/>
+                </a:solidFill>
+                <a:latin typeface="Cambria" pitchFamily="34" charset="0"/>
+                <a:ea typeface="Cambria" pitchFamily="34" charset="-122"/>
+                <a:cs typeface="Cambria" pitchFamily="34" charset="-120"/>
+              </a:rPr>
+              <a:t>Фирвальдштетское озеро — колыбель союза (иллюстрация)</a:t>
+            </a:r>
+            <a:endParaRPr lang="en-US" sz="1000" dirty="0"/>
+          </a:p>
+        </p:txBody>
+      </p:sp>
+      <p:sp>
+        <p:nvSpPr>
+          <p:cNvPr id="6" name="!!c1_1"/>
+          <p:cNvSpPr txBox="1"/>
+          <p:nvPr/>
+        </p:nvSpPr>
+        <p:spPr>
+          <a:xfrm>
+            <a:off x="-6110935" y="868680"/>
+            <a:ext cx="4114800" cy="320040"/>
           </a:xfrm>
           <a:prstGeom prst="rect">
             <a:avLst/>
@@ -2772,7 +3162,7 @@
                 <a:ea typeface="Bookman Old Style" pitchFamily="34" charset="-122"/>
                 <a:cs typeface="Bookman Old Style" pitchFamily="34" charset="-120"/>
               </a:rPr>
-              <a:t>CAPUT  II</a:t>
+              <a:t>CAPUT  I  ·  1291</a:t>
             </a:r>
             <a:endParaRPr lang="en-US" sz="1300" dirty="0"/>
           </a:p>
@@ -2780,30 +3170,30 @@
       </p:sp>
       <p:sp>
         <p:nvSpPr>
-          <p:cNvPr id="6" name="!!title"/>
-          <p:cNvSpPr txBox="1"/>
-          <p:nvPr/>
-        </p:nvSpPr>
-        <p:spPr>
-          <a:xfrm>
-            <a:off x="777240" y="2697480"/>
-            <a:ext cx="8229600" cy="731520"/>
-          </a:xfrm>
-          <a:prstGeom prst="rect">
-            <a:avLst/>
-          </a:prstGeom>
-          <a:noFill/>
-          <a:ln/>
-        </p:spPr>
-        <p:txBody>
-          <a:bodyPr wrap="square" lIns="0" tIns="0" rIns="0" bIns="0" rtlCol="0" anchor="ctr"/>
-          <a:lstStyle/>
-          <a:p>
-            <a:pPr indent="0" marL="0">
-              <a:buNone/>
-            </a:pPr>
-            <a:r>
-              <a:rPr lang="en-US" sz="3600" b="1" dirty="0">
+          <p:cNvPr id="7" name="!!c1_2"/>
+          <p:cNvSpPr txBox="1"/>
+          <p:nvPr/>
+        </p:nvSpPr>
+        <p:spPr>
+          <a:xfrm>
+            <a:off x="-6110935" y="1234440"/>
+            <a:ext cx="4983480" cy="822960"/>
+          </a:xfrm>
+          <a:prstGeom prst="rect">
+            <a:avLst/>
+          </a:prstGeom>
+          <a:noFill/>
+          <a:ln/>
+        </p:spPr>
+        <p:txBody>
+          <a:bodyPr wrap="square" lIns="0" tIns="0" rIns="0" bIns="0" rtlCol="0" anchor="ctr"/>
+          <a:lstStyle/>
+          <a:p>
+            <a:pPr indent="0" marL="0">
+              <a:buNone/>
+            </a:pPr>
+            <a:r>
+              <a:rPr lang="en-US" sz="3200" b="1" dirty="0">
                 <a:solidFill>
                   <a:srgbClr val="2A1E16"/>
                 </a:solidFill>
@@ -2811,21 +3201,21 @@
                 <a:ea typeface="Bookman Old Style" pitchFamily="34" charset="-122"/>
                 <a:cs typeface="Bookman Old Style" pitchFamily="34" charset="-120"/>
               </a:rPr>
-              <a:t>Три опоры Швейцарии</a:t>
-            </a:r>
-            <a:endParaRPr lang="en-US" sz="3600" dirty="0"/>
-          </a:p>
-        </p:txBody>
-      </p:sp>
-      <p:sp>
-        <p:nvSpPr>
-          <p:cNvPr id="7" name="!!page"/>
-          <p:cNvSpPr txBox="1"/>
-          <p:nvPr/>
-        </p:nvSpPr>
-        <p:spPr>
-          <a:xfrm>
-            <a:off x="10332720" y="6263640"/>
+              <a:t>Как всё началось</a:t>
+            </a:r>
+            <a:endParaRPr lang="en-US" sz="3200" dirty="0"/>
+          </a:p>
+        </p:txBody>
+      </p:sp>
+      <p:sp>
+        <p:nvSpPr>
+          <p:cNvPr id="8" name="!!c1_3"/>
+          <p:cNvSpPr txBox="1"/>
+          <p:nvPr/>
+        </p:nvSpPr>
+        <p:spPr>
+          <a:xfrm>
+            <a:off x="-2316175" y="6263640"/>
             <a:ext cx="1097280" cy="274320"/>
           </a:xfrm>
           <a:prstGeom prst="rect">
@@ -2850,7 +3240,7 @@
                 <a:ea typeface="Bookman Old Style" pitchFamily="34" charset="-122"/>
                 <a:cs typeface="Bookman Old Style" pitchFamily="34" charset="-120"/>
               </a:rPr>
-              <a:t>III  ·  VI</a:t>
+              <a:t>II  ·  VI</a:t>
             </a:r>
             <a:endParaRPr lang="en-US" sz="1000" dirty="0"/>
           </a:p>
@@ -2858,7 +3248,7 @@
       </p:sp>
       <p:sp>
         <p:nvSpPr>
-          <p:cNvPr id="8" name="!!c1_0"/>
+          <p:cNvPr id="9" name="!!c1_4"/>
           <p:cNvSpPr txBox="1"/>
           <p:nvPr/>
         </p:nvSpPr>
@@ -2897,7 +3287,7 @@
       </p:sp>
       <p:sp>
         <p:nvSpPr>
-          <p:cNvPr id="9" name="!!c1_1"/>
+          <p:cNvPr id="10" name="!!c1_5"/>
           <p:cNvSpPr txBox="1"/>
           <p:nvPr/>
         </p:nvSpPr>
@@ -2939,7 +3329,7 @@
       </p:sp>
       <p:sp>
         <p:nvSpPr>
-          <p:cNvPr id="10" name="!!c1_2"/>
+          <p:cNvPr id="11" name="!!c1_6"/>
           <p:cNvSpPr txBox="1"/>
           <p:nvPr/>
         </p:nvSpPr>
@@ -2981,7 +3371,7 @@
       </p:sp>
       <p:sp>
         <p:nvSpPr>
-          <p:cNvPr id="11" name="!!c1_3"/>
+          <p:cNvPr id="12" name="!!c1_7"/>
           <p:cNvSpPr txBox="1"/>
           <p:nvPr/>
         </p:nvSpPr>
@@ -3020,7 +3410,124 @@
       </p:sp>
       <p:sp>
         <p:nvSpPr>
-          <p:cNvPr id="12" name="!!c3_0"/>
+          <p:cNvPr id="13" name="!!c3_0"/>
+          <p:cNvSpPr txBox="1"/>
+          <p:nvPr/>
+        </p:nvSpPr>
+        <p:spPr>
+          <a:xfrm>
+            <a:off x="13426135" y="777240"/>
+            <a:ext cx="4572000" cy="320040"/>
+          </a:xfrm>
+          <a:prstGeom prst="rect">
+            <a:avLst/>
+          </a:prstGeom>
+          <a:noFill/>
+          <a:ln/>
+        </p:spPr>
+        <p:txBody>
+          <a:bodyPr wrap="square" lIns="0" tIns="0" rIns="0" bIns="0" rtlCol="0" anchor="ctr"/>
+          <a:lstStyle/>
+          <a:p>
+            <a:pPr indent="0" marL="0">
+              <a:buNone/>
+            </a:pPr>
+            <a:r>
+              <a:rPr lang="en-US" sz="1300" spc="600" kern="0" dirty="0">
+                <a:solidFill>
+                  <a:srgbClr val="C9A15A"/>
+                </a:solidFill>
+                <a:latin typeface="Bookman Old Style" pitchFamily="34" charset="0"/>
+                <a:ea typeface="Bookman Old Style" pitchFamily="34" charset="-122"/>
+                <a:cs typeface="Bookman Old Style" pitchFamily="34" charset="-120"/>
+              </a:rPr>
+              <a:t>CAPUT  III</a:t>
+            </a:r>
+            <a:endParaRPr lang="en-US" sz="1300" dirty="0"/>
+          </a:p>
+        </p:txBody>
+      </p:sp>
+      <p:sp>
+        <p:nvSpPr>
+          <p:cNvPr id="14" name="!!c3_1"/>
+          <p:cNvSpPr txBox="1"/>
+          <p:nvPr/>
+        </p:nvSpPr>
+        <p:spPr>
+          <a:xfrm>
+            <a:off x="13426135" y="1097280"/>
+            <a:ext cx="8229600" cy="822960"/>
+          </a:xfrm>
+          <a:prstGeom prst="rect">
+            <a:avLst/>
+          </a:prstGeom>
+          <a:noFill/>
+          <a:ln/>
+        </p:spPr>
+        <p:txBody>
+          <a:bodyPr wrap="square" lIns="0" tIns="0" rIns="0" bIns="0" rtlCol="0" anchor="ctr"/>
+          <a:lstStyle/>
+          <a:p>
+            <a:pPr indent="0" marL="0">
+              <a:buNone/>
+            </a:pPr>
+            <a:r>
+              <a:rPr lang="en-US" sz="4000" b="1" dirty="0">
+                <a:solidFill>
+                  <a:srgbClr val="F1E6CF"/>
+                </a:solidFill>
+                <a:latin typeface="Bookman Old Style" pitchFamily="34" charset="0"/>
+                <a:ea typeface="Bookman Old Style" pitchFamily="34" charset="-122"/>
+                <a:cs typeface="Bookman Old Style" pitchFamily="34" charset="-120"/>
+              </a:rPr>
+              <a:t>Хроника свободы</a:t>
+            </a:r>
+            <a:endParaRPr lang="en-US" sz="4000" dirty="0"/>
+          </a:p>
+        </p:txBody>
+      </p:sp>
+      <p:sp>
+        <p:nvSpPr>
+          <p:cNvPr id="15" name="!!c3_2"/>
+          <p:cNvSpPr txBox="1"/>
+          <p:nvPr/>
+        </p:nvSpPr>
+        <p:spPr>
+          <a:xfrm>
+            <a:off x="22981615" y="6263640"/>
+            <a:ext cx="1097280" cy="274320"/>
+          </a:xfrm>
+          <a:prstGeom prst="rect">
+            <a:avLst/>
+          </a:prstGeom>
+          <a:noFill/>
+          <a:ln/>
+        </p:spPr>
+        <p:txBody>
+          <a:bodyPr wrap="square" lIns="0" tIns="0" rIns="0" bIns="0" rtlCol="0" anchor="ctr"/>
+          <a:lstStyle/>
+          <a:p>
+            <a:pPr algn="r" indent="0" marL="0">
+              <a:buNone/>
+            </a:pPr>
+            <a:r>
+              <a:rPr lang="en-US" sz="1000" spc="300" kern="0" dirty="0">
+                <a:solidFill>
+                  <a:srgbClr val="C9A15A"/>
+                </a:solidFill>
+                <a:latin typeface="Bookman Old Style" pitchFamily="34" charset="0"/>
+                <a:ea typeface="Bookman Old Style" pitchFamily="34" charset="-122"/>
+                <a:cs typeface="Bookman Old Style" pitchFamily="34" charset="-120"/>
+              </a:rPr>
+              <a:t>IV  ·  VI</a:t>
+            </a:r>
+            <a:endParaRPr lang="en-US" sz="1000" dirty="0"/>
+          </a:p>
+        </p:txBody>
+      </p:sp>
+      <p:sp>
+        <p:nvSpPr>
+          <p:cNvPr id="16" name="!!c3_3"/>
           <p:cNvSpPr/>
           <p:nvPr/>
         </p:nvSpPr>
@@ -3043,7 +3550,7 @@
       </p:sp>
       <p:sp>
         <p:nvSpPr>
-          <p:cNvPr id="13" name="!!c3_1"/>
+          <p:cNvPr id="17" name="!!c3_4"/>
           <p:cNvSpPr/>
           <p:nvPr/>
         </p:nvSpPr>
@@ -3068,7 +3575,7 @@
       </p:sp>
       <p:sp>
         <p:nvSpPr>
-          <p:cNvPr id="14" name="!!c3_2"/>
+          <p:cNvPr id="18" name="!!c3_5"/>
           <p:cNvSpPr txBox="1"/>
           <p:nvPr/>
         </p:nvSpPr>
@@ -3107,7 +3614,7 @@
       </p:sp>
       <p:sp>
         <p:nvSpPr>
-          <p:cNvPr id="15" name="!!c3_3"/>
+          <p:cNvPr id="19" name="!!c3_6"/>
           <p:cNvSpPr txBox="1"/>
           <p:nvPr/>
         </p:nvSpPr>
@@ -3146,7 +3653,7 @@
       </p:sp>
       <p:sp>
         <p:nvSpPr>
-          <p:cNvPr id="16" name="!!c3_4"/>
+          <p:cNvPr id="20" name="!!c3_7"/>
           <p:cNvSpPr txBox="1"/>
           <p:nvPr/>
         </p:nvSpPr>
@@ -3185,7 +3692,7 @@
       </p:sp>
       <p:sp>
         <p:nvSpPr>
-          <p:cNvPr id="17" name="!!c3_5"/>
+          <p:cNvPr id="21" name="!!c3_8"/>
           <p:cNvSpPr/>
           <p:nvPr/>
         </p:nvSpPr>
@@ -3210,7 +3717,7 @@
       </p:sp>
       <p:sp>
         <p:nvSpPr>
-          <p:cNvPr id="18" name="!!c3_6"/>
+          <p:cNvPr id="22" name="!!c3_9"/>
           <p:cNvSpPr txBox="1"/>
           <p:nvPr/>
         </p:nvSpPr>
@@ -3249,7 +3756,7 @@
       </p:sp>
       <p:sp>
         <p:nvSpPr>
-          <p:cNvPr id="19" name="!!c3_7"/>
+          <p:cNvPr id="23" name="!!c3_10"/>
           <p:cNvSpPr txBox="1"/>
           <p:nvPr/>
         </p:nvSpPr>
@@ -3288,7 +3795,7 @@
       </p:sp>
       <p:sp>
         <p:nvSpPr>
-          <p:cNvPr id="20" name="!!c3_8"/>
+          <p:cNvPr id="24" name="!!c3_11"/>
           <p:cNvSpPr txBox="1"/>
           <p:nvPr/>
         </p:nvSpPr>
@@ -3327,7 +3834,7 @@
       </p:sp>
       <p:sp>
         <p:nvSpPr>
-          <p:cNvPr id="21" name="!!c3_9"/>
+          <p:cNvPr id="25" name="!!c3_12"/>
           <p:cNvSpPr/>
           <p:nvPr/>
         </p:nvSpPr>
@@ -3352,7 +3859,7 @@
       </p:sp>
       <p:sp>
         <p:nvSpPr>
-          <p:cNvPr id="22" name="!!c3_10"/>
+          <p:cNvPr id="26" name="!!c3_13"/>
           <p:cNvSpPr txBox="1"/>
           <p:nvPr/>
         </p:nvSpPr>
@@ -3391,7 +3898,7 @@
       </p:sp>
       <p:sp>
         <p:nvSpPr>
-          <p:cNvPr id="23" name="!!c3_11"/>
+          <p:cNvPr id="27" name="!!c3_14"/>
           <p:cNvSpPr txBox="1"/>
           <p:nvPr/>
         </p:nvSpPr>
@@ -3430,7 +3937,7 @@
       </p:sp>
       <p:sp>
         <p:nvSpPr>
-          <p:cNvPr id="24" name="!!c3_12"/>
+          <p:cNvPr id="28" name="!!c3_15"/>
           <p:cNvSpPr txBox="1"/>
           <p:nvPr/>
         </p:nvSpPr>
@@ -3469,7 +3976,7 @@
       </p:sp>
       <p:sp>
         <p:nvSpPr>
-          <p:cNvPr id="25" name="!!c3_13"/>
+          <p:cNvPr id="29" name="!!c3_16"/>
           <p:cNvSpPr/>
           <p:nvPr/>
         </p:nvSpPr>
@@ -3494,7 +4001,7 @@
       </p:sp>
       <p:sp>
         <p:nvSpPr>
-          <p:cNvPr id="26" name="!!c3_14"/>
+          <p:cNvPr id="30" name="!!c3_17"/>
           <p:cNvSpPr txBox="1"/>
           <p:nvPr/>
         </p:nvSpPr>
@@ -3533,7 +4040,7 @@
       </p:sp>
       <p:sp>
         <p:nvSpPr>
-          <p:cNvPr id="27" name="!!c3_15"/>
+          <p:cNvPr id="31" name="!!c3_18"/>
           <p:cNvSpPr txBox="1"/>
           <p:nvPr/>
         </p:nvSpPr>
@@ -3572,7 +4079,7 @@
       </p:sp>
       <p:sp>
         <p:nvSpPr>
-          <p:cNvPr id="28" name="!!c3_16"/>
+          <p:cNvPr id="32" name="!!c3_19"/>
           <p:cNvSpPr txBox="1"/>
           <p:nvPr/>
         </p:nvSpPr>
@@ -3611,7 +4118,7 @@
       </p:sp>
       <p:sp>
         <p:nvSpPr>
-          <p:cNvPr id="29" name="!!c3_17"/>
+          <p:cNvPr id="33" name="!!c3_20"/>
           <p:cNvSpPr/>
           <p:nvPr/>
         </p:nvSpPr>
@@ -3636,7 +4143,7 @@
       </p:sp>
       <p:sp>
         <p:nvSpPr>
-          <p:cNvPr id="30" name="!!c3_18"/>
+          <p:cNvPr id="34" name="!!c3_21"/>
           <p:cNvSpPr txBox="1"/>
           <p:nvPr/>
         </p:nvSpPr>
@@ -3675,7 +4182,7 @@
       </p:sp>
       <p:sp>
         <p:nvSpPr>
-          <p:cNvPr id="31" name="!!c3_19"/>
+          <p:cNvPr id="35" name="!!c3_22"/>
           <p:cNvSpPr txBox="1"/>
           <p:nvPr/>
         </p:nvSpPr>
@@ -3714,7 +4221,7 @@
       </p:sp>
       <p:sp>
         <p:nvSpPr>
-          <p:cNvPr id="32" name="!!c3_20"/>
+          <p:cNvPr id="36" name="!!c3_23"/>
           <p:cNvSpPr txBox="1"/>
           <p:nvPr/>
         </p:nvSpPr>
@@ -3753,7 +4260,7 @@
       </p:sp>
       <p:sp>
         <p:nvSpPr>
-          <p:cNvPr id="33" name="!!c3_21"/>
+          <p:cNvPr id="37" name="!!c3_24"/>
           <p:cNvSpPr txBox="1"/>
           <p:nvPr/>
         </p:nvSpPr>
@@ -3792,7 +4299,124 @@
       </p:sp>
       <p:sp>
         <p:nvSpPr>
-          <p:cNvPr id="34" name="!!c2_0"/>
+          <p:cNvPr id="38" name="!!c2_0"/>
+          <p:cNvSpPr txBox="1"/>
+          <p:nvPr/>
+        </p:nvSpPr>
+        <p:spPr>
+          <a:xfrm>
+            <a:off x="777240" y="2377440"/>
+            <a:ext cx="4572000" cy="320040"/>
+          </a:xfrm>
+          <a:prstGeom prst="rect">
+            <a:avLst/>
+          </a:prstGeom>
+          <a:noFill/>
+          <a:ln/>
+        </p:spPr>
+        <p:txBody>
+          <a:bodyPr wrap="square" lIns="0" tIns="0" rIns="0" bIns="0" rtlCol="0" anchor="ctr"/>
+          <a:lstStyle/>
+          <a:p>
+            <a:pPr indent="0" marL="0">
+              <a:buNone/>
+            </a:pPr>
+            <a:r>
+              <a:rPr lang="en-US" sz="1300" spc="600" kern="0" dirty="0">
+                <a:solidFill>
+                  <a:srgbClr val="7A1C1A"/>
+                </a:solidFill>
+                <a:latin typeface="Bookman Old Style" pitchFamily="34" charset="0"/>
+                <a:ea typeface="Bookman Old Style" pitchFamily="34" charset="-122"/>
+                <a:cs typeface="Bookman Old Style" pitchFamily="34" charset="-120"/>
+              </a:rPr>
+              <a:t>CAPUT  II</a:t>
+            </a:r>
+            <a:endParaRPr lang="en-US" sz="1300" dirty="0"/>
+          </a:p>
+        </p:txBody>
+      </p:sp>
+      <p:sp>
+        <p:nvSpPr>
+          <p:cNvPr id="39" name="!!c2_1"/>
+          <p:cNvSpPr txBox="1"/>
+          <p:nvPr/>
+        </p:nvSpPr>
+        <p:spPr>
+          <a:xfrm>
+            <a:off x="777240" y="2697480"/>
+            <a:ext cx="8229600" cy="731520"/>
+          </a:xfrm>
+          <a:prstGeom prst="rect">
+            <a:avLst/>
+          </a:prstGeom>
+          <a:noFill/>
+          <a:ln/>
+        </p:spPr>
+        <p:txBody>
+          <a:bodyPr wrap="square" lIns="0" tIns="0" rIns="0" bIns="0" rtlCol="0" anchor="ctr"/>
+          <a:lstStyle/>
+          <a:p>
+            <a:pPr indent="0" marL="0">
+              <a:buNone/>
+            </a:pPr>
+            <a:r>
+              <a:rPr lang="en-US" sz="3600" b="1" dirty="0">
+                <a:solidFill>
+                  <a:srgbClr val="2A1E16"/>
+                </a:solidFill>
+                <a:latin typeface="Bookman Old Style" pitchFamily="34" charset="0"/>
+                <a:ea typeface="Bookman Old Style" pitchFamily="34" charset="-122"/>
+                <a:cs typeface="Bookman Old Style" pitchFamily="34" charset="-120"/>
+              </a:rPr>
+              <a:t>Три опоры Швейцарии</a:t>
+            </a:r>
+            <a:endParaRPr lang="en-US" sz="3600" dirty="0"/>
+          </a:p>
+        </p:txBody>
+      </p:sp>
+      <p:sp>
+        <p:nvSpPr>
+          <p:cNvPr id="40" name="!!c2_2"/>
+          <p:cNvSpPr txBox="1"/>
+          <p:nvPr/>
+        </p:nvSpPr>
+        <p:spPr>
+          <a:xfrm>
+            <a:off x="10332720" y="6263640"/>
+            <a:ext cx="1097280" cy="274320"/>
+          </a:xfrm>
+          <a:prstGeom prst="rect">
+            <a:avLst/>
+          </a:prstGeom>
+          <a:noFill/>
+          <a:ln/>
+        </p:spPr>
+        <p:txBody>
+          <a:bodyPr wrap="square" lIns="0" tIns="0" rIns="0" bIns="0" rtlCol="0" anchor="ctr"/>
+          <a:lstStyle/>
+          <a:p>
+            <a:pPr algn="r" indent="0" marL="0">
+              <a:buNone/>
+            </a:pPr>
+            <a:r>
+              <a:rPr lang="en-US" sz="1000" spc="300" kern="0" dirty="0">
+                <a:solidFill>
+                  <a:srgbClr val="6B5640"/>
+                </a:solidFill>
+                <a:latin typeface="Bookman Old Style" pitchFamily="34" charset="0"/>
+                <a:ea typeface="Bookman Old Style" pitchFamily="34" charset="-122"/>
+                <a:cs typeface="Bookman Old Style" pitchFamily="34" charset="-120"/>
+              </a:rPr>
+              <a:t>III  ·  VI</a:t>
+            </a:r>
+            <a:endParaRPr lang="en-US" sz="1000" dirty="0"/>
+          </a:p>
+        </p:txBody>
+      </p:sp>
+      <p:sp>
+        <p:nvSpPr>
+          <p:cNvPr id="41" name="!!c2_3"/>
           <p:cNvSpPr txBox="1"/>
           <p:nvPr/>
         </p:nvSpPr>
@@ -3831,7 +4455,7 @@
       </p:sp>
       <p:sp>
         <p:nvSpPr>
-          <p:cNvPr id="35" name="!!c2_1"/>
+          <p:cNvPr id="42" name="!!c2_4"/>
           <p:cNvSpPr txBox="1"/>
           <p:nvPr/>
         </p:nvSpPr>
@@ -3870,7 +4494,7 @@
       </p:sp>
       <p:sp>
         <p:nvSpPr>
-          <p:cNvPr id="36" name="!!c2_2"/>
+          <p:cNvPr id="43" name="!!c2_5"/>
           <p:cNvSpPr txBox="1"/>
           <p:nvPr/>
         </p:nvSpPr>
@@ -3912,7 +4536,7 @@
       </p:sp>
       <p:sp>
         <p:nvSpPr>
-          <p:cNvPr id="37" name="!!c2_3"/>
+          <p:cNvPr id="44" name="!!c2_6"/>
           <p:cNvSpPr txBox="1"/>
           <p:nvPr/>
         </p:nvSpPr>
@@ -3951,7 +4575,7 @@
       </p:sp>
       <p:sp>
         <p:nvSpPr>
-          <p:cNvPr id="38" name="!!c2_4"/>
+          <p:cNvPr id="45" name="!!c2_7"/>
           <p:cNvSpPr txBox="1"/>
           <p:nvPr/>
         </p:nvSpPr>
@@ -3990,7 +4614,7 @@
       </p:sp>
       <p:sp>
         <p:nvSpPr>
-          <p:cNvPr id="39" name="!!c2_5"/>
+          <p:cNvPr id="46" name="!!c2_8"/>
           <p:cNvSpPr txBox="1"/>
           <p:nvPr/>
         </p:nvSpPr>
@@ -4032,7 +4656,7 @@
       </p:sp>
       <p:sp>
         <p:nvSpPr>
-          <p:cNvPr id="40" name="!!c2_6"/>
+          <p:cNvPr id="47" name="!!c2_9"/>
           <p:cNvSpPr txBox="1"/>
           <p:nvPr/>
         </p:nvSpPr>
@@ -4071,7 +4695,7 @@
       </p:sp>
       <p:sp>
         <p:nvSpPr>
-          <p:cNvPr id="41" name="!!c2_7"/>
+          <p:cNvPr id="48" name="!!c2_10"/>
           <p:cNvSpPr txBox="1"/>
           <p:nvPr/>
         </p:nvSpPr>
@@ -4110,7 +4734,7 @@
       </p:sp>
       <p:sp>
         <p:nvSpPr>
-          <p:cNvPr id="42" name="!!c2_8"/>
+          <p:cNvPr id="49" name="!!c2_11"/>
           <p:cNvSpPr txBox="1"/>
           <p:nvPr/>
         </p:nvSpPr>
@@ -4292,13 +4916,13 @@
       </p:pic>
       <p:sp>
         <p:nvSpPr>
-          <p:cNvPr id="6" name="!!kicker"/>
-          <p:cNvSpPr txBox="1"/>
-          <p:nvPr/>
-        </p:nvSpPr>
-        <p:spPr>
-          <a:xfrm>
-            <a:off x="777240" y="777240"/>
+          <p:cNvPr id="6" name="!!c2_0"/>
+          <p:cNvSpPr txBox="1"/>
+          <p:nvPr/>
+        </p:nvSpPr>
+        <p:spPr>
+          <a:xfrm>
+            <a:off x="-11871655" y="2377440"/>
             <a:ext cx="4572000" cy="320040"/>
           </a:xfrm>
           <a:prstGeom prst="rect">
@@ -4317,13 +4941,13 @@
             <a:r>
               <a:rPr lang="en-US" sz="1300" spc="600" kern="0" dirty="0">
                 <a:solidFill>
-                  <a:srgbClr val="C9A15A"/>
-                </a:solidFill>
-                <a:latin typeface="Bookman Old Style" pitchFamily="34" charset="0"/>
-                <a:ea typeface="Bookman Old Style" pitchFamily="34" charset="-122"/>
-                <a:cs typeface="Bookman Old Style" pitchFamily="34" charset="-120"/>
-              </a:rPr>
-              <a:t>CAPUT  III</a:t>
+                  <a:srgbClr val="7A1C1A"/>
+                </a:solidFill>
+                <a:latin typeface="Bookman Old Style" pitchFamily="34" charset="0"/>
+                <a:ea typeface="Bookman Old Style" pitchFamily="34" charset="-122"/>
+                <a:cs typeface="Bookman Old Style" pitchFamily="34" charset="-120"/>
+              </a:rPr>
+              <a:t>CAPUT  II</a:t>
             </a:r>
             <a:endParaRPr lang="en-US" sz="1300" dirty="0"/>
           </a:p>
@@ -4331,52 +4955,52 @@
       </p:sp>
       <p:sp>
         <p:nvSpPr>
-          <p:cNvPr id="7" name="!!title"/>
-          <p:cNvSpPr txBox="1"/>
-          <p:nvPr/>
-        </p:nvSpPr>
-        <p:spPr>
-          <a:xfrm>
-            <a:off x="777240" y="1097280"/>
-            <a:ext cx="8229600" cy="822960"/>
-          </a:xfrm>
-          <a:prstGeom prst="rect">
-            <a:avLst/>
-          </a:prstGeom>
-          <a:noFill/>
-          <a:ln/>
-        </p:spPr>
-        <p:txBody>
-          <a:bodyPr wrap="square" lIns="0" tIns="0" rIns="0" bIns="0" rtlCol="0" anchor="ctr"/>
-          <a:lstStyle/>
-          <a:p>
-            <a:pPr indent="0" marL="0">
-              <a:buNone/>
-            </a:pPr>
-            <a:r>
-              <a:rPr lang="en-US" sz="4000" b="1" dirty="0">
-                <a:solidFill>
-                  <a:srgbClr val="F1E6CF"/>
-                </a:solidFill>
-                <a:latin typeface="Bookman Old Style" pitchFamily="34" charset="0"/>
-                <a:ea typeface="Bookman Old Style" pitchFamily="34" charset="-122"/>
-                <a:cs typeface="Bookman Old Style" pitchFamily="34" charset="-120"/>
-              </a:rPr>
-              <a:t>Хроника свободы</a:t>
-            </a:r>
-            <a:endParaRPr lang="en-US" sz="4000" dirty="0"/>
-          </a:p>
-        </p:txBody>
-      </p:sp>
-      <p:sp>
-        <p:nvSpPr>
-          <p:cNvPr id="8" name="!!page"/>
-          <p:cNvSpPr txBox="1"/>
-          <p:nvPr/>
-        </p:nvSpPr>
-        <p:spPr>
-          <a:xfrm>
-            <a:off x="10332720" y="6263640"/>
+          <p:cNvPr id="7" name="!!c2_1"/>
+          <p:cNvSpPr txBox="1"/>
+          <p:nvPr/>
+        </p:nvSpPr>
+        <p:spPr>
+          <a:xfrm>
+            <a:off x="-11871655" y="2697480"/>
+            <a:ext cx="8229600" cy="731520"/>
+          </a:xfrm>
+          <a:prstGeom prst="rect">
+            <a:avLst/>
+          </a:prstGeom>
+          <a:noFill/>
+          <a:ln/>
+        </p:spPr>
+        <p:txBody>
+          <a:bodyPr wrap="square" lIns="0" tIns="0" rIns="0" bIns="0" rtlCol="0" anchor="ctr"/>
+          <a:lstStyle/>
+          <a:p>
+            <a:pPr indent="0" marL="0">
+              <a:buNone/>
+            </a:pPr>
+            <a:r>
+              <a:rPr lang="en-US" sz="3600" b="1" dirty="0">
+                <a:solidFill>
+                  <a:srgbClr val="2A1E16"/>
+                </a:solidFill>
+                <a:latin typeface="Bookman Old Style" pitchFamily="34" charset="0"/>
+                <a:ea typeface="Bookman Old Style" pitchFamily="34" charset="-122"/>
+                <a:cs typeface="Bookman Old Style" pitchFamily="34" charset="-120"/>
+              </a:rPr>
+              <a:t>Три опоры Швейцарии</a:t>
+            </a:r>
+            <a:endParaRPr lang="en-US" sz="3600" dirty="0"/>
+          </a:p>
+        </p:txBody>
+      </p:sp>
+      <p:sp>
+        <p:nvSpPr>
+          <p:cNvPr id="8" name="!!c2_2"/>
+          <p:cNvSpPr txBox="1"/>
+          <p:nvPr/>
+        </p:nvSpPr>
+        <p:spPr>
+          <a:xfrm>
+            <a:off x="-2316175" y="6263640"/>
             <a:ext cx="1097280" cy="274320"/>
           </a:xfrm>
           <a:prstGeom prst="rect">
@@ -4395,13 +5019,13 @@
             <a:r>
               <a:rPr lang="en-US" sz="1000" spc="300" kern="0" dirty="0">
                 <a:solidFill>
-                  <a:srgbClr val="C9A15A"/>
-                </a:solidFill>
-                <a:latin typeface="Bookman Old Style" pitchFamily="34" charset="0"/>
-                <a:ea typeface="Bookman Old Style" pitchFamily="34" charset="-122"/>
-                <a:cs typeface="Bookman Old Style" pitchFamily="34" charset="-120"/>
-              </a:rPr>
-              <a:t>IV  ·  VI</a:t>
+                  <a:srgbClr val="6B5640"/>
+                </a:solidFill>
+                <a:latin typeface="Bookman Old Style" pitchFamily="34" charset="0"/>
+                <a:ea typeface="Bookman Old Style" pitchFamily="34" charset="-122"/>
+                <a:cs typeface="Bookman Old Style" pitchFamily="34" charset="-120"/>
+              </a:rPr>
+              <a:t>III  ·  VI</a:t>
             </a:r>
             <a:endParaRPr lang="en-US" sz="1000" dirty="0"/>
           </a:p>
@@ -4409,7 +5033,7 @@
       </p:sp>
       <p:sp>
         <p:nvSpPr>
-          <p:cNvPr id="9" name="!!c2_0"/>
+          <p:cNvPr id="9" name="!!c2_3"/>
           <p:cNvSpPr txBox="1"/>
           <p:nvPr/>
         </p:nvSpPr>
@@ -4448,7 +5072,7 @@
       </p:sp>
       <p:sp>
         <p:nvSpPr>
-          <p:cNvPr id="10" name="!!c2_1"/>
+          <p:cNvPr id="10" name="!!c2_4"/>
           <p:cNvSpPr txBox="1"/>
           <p:nvPr/>
         </p:nvSpPr>
@@ -4487,7 +5111,7 @@
       </p:sp>
       <p:sp>
         <p:nvSpPr>
-          <p:cNvPr id="11" name="!!c2_2"/>
+          <p:cNvPr id="11" name="!!c2_5"/>
           <p:cNvSpPr txBox="1"/>
           <p:nvPr/>
         </p:nvSpPr>
@@ -4529,7 +5153,7 @@
       </p:sp>
       <p:sp>
         <p:nvSpPr>
-          <p:cNvPr id="12" name="!!c2_3"/>
+          <p:cNvPr id="12" name="!!c2_6"/>
           <p:cNvSpPr txBox="1"/>
           <p:nvPr/>
         </p:nvSpPr>
@@ -4568,7 +5192,7 @@
       </p:sp>
       <p:sp>
         <p:nvSpPr>
-          <p:cNvPr id="13" name="!!c2_4"/>
+          <p:cNvPr id="13" name="!!c2_7"/>
           <p:cNvSpPr txBox="1"/>
           <p:nvPr/>
         </p:nvSpPr>
@@ -4607,7 +5231,7 @@
       </p:sp>
       <p:sp>
         <p:nvSpPr>
-          <p:cNvPr id="14" name="!!c2_5"/>
+          <p:cNvPr id="14" name="!!c2_8"/>
           <p:cNvSpPr txBox="1"/>
           <p:nvPr/>
         </p:nvSpPr>
@@ -4649,7 +5273,7 @@
       </p:sp>
       <p:sp>
         <p:nvSpPr>
-          <p:cNvPr id="15" name="!!c2_6"/>
+          <p:cNvPr id="15" name="!!c2_9"/>
           <p:cNvSpPr txBox="1"/>
           <p:nvPr/>
         </p:nvSpPr>
@@ -4688,7 +5312,7 @@
       </p:sp>
       <p:sp>
         <p:nvSpPr>
-          <p:cNvPr id="16" name="!!c2_7"/>
+          <p:cNvPr id="16" name="!!c2_10"/>
           <p:cNvSpPr txBox="1"/>
           <p:nvPr/>
         </p:nvSpPr>
@@ -4727,7 +5351,7 @@
       </p:sp>
       <p:sp>
         <p:nvSpPr>
-          <p:cNvPr id="17" name="!!c2_8"/>
+          <p:cNvPr id="17" name="!!c2_11"/>
           <p:cNvSpPr txBox="1"/>
           <p:nvPr/>
         </p:nvSpPr>
@@ -4767,9 +5391,87 @@
           </a:p>
         </p:txBody>
       </p:sp>
+      <p:sp>
+        <p:nvSpPr>
+          <p:cNvPr id="18" name="!!c4_0"/>
+          <p:cNvSpPr txBox="1"/>
+          <p:nvPr/>
+        </p:nvSpPr>
+        <p:spPr>
+          <a:xfrm>
+            <a:off x="13426135" y="1828800"/>
+            <a:ext cx="4572000" cy="320040"/>
+          </a:xfrm>
+          <a:prstGeom prst="rect">
+            <a:avLst/>
+          </a:prstGeom>
+          <a:noFill/>
+          <a:ln/>
+        </p:spPr>
+        <p:txBody>
+          <a:bodyPr wrap="square" lIns="0" tIns="0" rIns="0" bIns="0" rtlCol="0" anchor="ctr"/>
+          <a:lstStyle/>
+          <a:p>
+            <a:pPr indent="0" marL="0">
+              <a:buNone/>
+            </a:pPr>
+            <a:r>
+              <a:rPr lang="en-US" sz="1300" spc="600" kern="0" dirty="0">
+                <a:solidFill>
+                  <a:srgbClr val="C9A15A"/>
+                </a:solidFill>
+                <a:latin typeface="Bookman Old Style" pitchFamily="34" charset="0"/>
+                <a:ea typeface="Bookman Old Style" pitchFamily="34" charset="-122"/>
+                <a:cs typeface="Bookman Old Style" pitchFamily="34" charset="-120"/>
+              </a:rPr>
+              <a:t>CAPUT  IV</a:t>
+            </a:r>
+            <a:endParaRPr lang="en-US" sz="1300" dirty="0"/>
+          </a:p>
+        </p:txBody>
+      </p:sp>
+      <p:sp>
+        <p:nvSpPr>
+          <p:cNvPr id="19" name="!!c4_1"/>
+          <p:cNvSpPr txBox="1"/>
+          <p:nvPr/>
+        </p:nvSpPr>
+        <p:spPr>
+          <a:xfrm>
+            <a:off x="22981615" y="6263640"/>
+            <a:ext cx="1097280" cy="274320"/>
+          </a:xfrm>
+          <a:prstGeom prst="rect">
+            <a:avLst/>
+          </a:prstGeom>
+          <a:noFill/>
+          <a:ln/>
+        </p:spPr>
+        <p:txBody>
+          <a:bodyPr wrap="square" lIns="0" tIns="0" rIns="0" bIns="0" rtlCol="0" anchor="ctr"/>
+          <a:lstStyle/>
+          <a:p>
+            <a:pPr algn="r" indent="0" marL="0">
+              <a:buNone/>
+            </a:pPr>
+            <a:r>
+              <a:rPr lang="en-US" sz="1000" spc="300" kern="0" dirty="0">
+                <a:solidFill>
+                  <a:srgbClr val="C9A15A"/>
+                </a:solidFill>
+                <a:latin typeface="Bookman Old Style" pitchFamily="34" charset="0"/>
+                <a:ea typeface="Bookman Old Style" pitchFamily="34" charset="-122"/>
+                <a:cs typeface="Bookman Old Style" pitchFamily="34" charset="-120"/>
+              </a:rPr>
+              <a:t>V  ·  VI</a:t>
+            </a:r>
+            <a:endParaRPr lang="en-US" sz="1000" dirty="0"/>
+          </a:p>
+        </p:txBody>
+      </p:sp>
       <p:pic>
         <p:nvPicPr>
-          <p:cNvPr id="18" name="!!c4_0" descr="img/parchment.jpg">    </p:cNvPr>
+          <p:cNvPr id="20" name="!!c4_2" descr="img/parchment.jpg">    </p:cNvPr>
           <p:cNvPicPr>
             <a:picLocks noChangeAspect="1"/>
           </p:cNvPicPr>
@@ -4792,7 +5494,7 @@
       </p:pic>
       <p:sp>
         <p:nvSpPr>
-          <p:cNvPr id="19" name="!!c4_1"/>
+          <p:cNvPr id="21" name="!!c4_3"/>
           <p:cNvSpPr/>
           <p:nvPr/>
         </p:nvSpPr>
@@ -4821,7 +5523,7 @@
       </p:sp>
       <p:sp>
         <p:nvSpPr>
-          <p:cNvPr id="20" name="!!c4_2"/>
+          <p:cNvPr id="22" name="!!c4_4"/>
           <p:cNvSpPr txBox="1"/>
           <p:nvPr/>
         </p:nvSpPr>
@@ -4860,7 +5562,7 @@
       </p:sp>
       <p:sp>
         <p:nvSpPr>
-          <p:cNvPr id="21" name="!!c4_3"/>
+          <p:cNvPr id="23" name="!!c4_5"/>
           <p:cNvSpPr txBox="1"/>
           <p:nvPr/>
         </p:nvSpPr>
@@ -4899,7 +5601,7 @@
       </p:sp>
       <p:sp>
         <p:nvSpPr>
-          <p:cNvPr id="22" name="!!c4_4"/>
+          <p:cNvPr id="24" name="!!c4_6"/>
           <p:cNvSpPr txBox="1"/>
           <p:nvPr/>
         </p:nvSpPr>
@@ -4938,7 +5640,7 @@
       </p:sp>
       <p:sp>
         <p:nvSpPr>
-          <p:cNvPr id="23" name="!!c4_5"/>
+          <p:cNvPr id="25" name="!!c4_7"/>
           <p:cNvSpPr txBox="1"/>
           <p:nvPr/>
         </p:nvSpPr>
@@ -4977,7 +5679,7 @@
       </p:sp>
       <p:sp>
         <p:nvSpPr>
-          <p:cNvPr id="24" name="!!c4_6"/>
+          <p:cNvPr id="26" name="!!c4_8"/>
           <p:cNvSpPr txBox="1"/>
           <p:nvPr/>
         </p:nvSpPr>
@@ -5016,7 +5718,124 @@
       </p:sp>
       <p:sp>
         <p:nvSpPr>
-          <p:cNvPr id="25" name="!!c3_0"/>
+          <p:cNvPr id="27" name="!!c3_0"/>
+          <p:cNvSpPr txBox="1"/>
+          <p:nvPr/>
+        </p:nvSpPr>
+        <p:spPr>
+          <a:xfrm>
+            <a:off x="777240" y="777240"/>
+            <a:ext cx="4572000" cy="320040"/>
+          </a:xfrm>
+          <a:prstGeom prst="rect">
+            <a:avLst/>
+          </a:prstGeom>
+          <a:noFill/>
+          <a:ln/>
+        </p:spPr>
+        <p:txBody>
+          <a:bodyPr wrap="square" lIns="0" tIns="0" rIns="0" bIns="0" rtlCol="0" anchor="ctr"/>
+          <a:lstStyle/>
+          <a:p>
+            <a:pPr indent="0" marL="0">
+              <a:buNone/>
+            </a:pPr>
+            <a:r>
+              <a:rPr lang="en-US" sz="1300" spc="600" kern="0" dirty="0">
+                <a:solidFill>
+                  <a:srgbClr val="C9A15A"/>
+                </a:solidFill>
+                <a:latin typeface="Bookman Old Style" pitchFamily="34" charset="0"/>
+                <a:ea typeface="Bookman Old Style" pitchFamily="34" charset="-122"/>
+                <a:cs typeface="Bookman Old Style" pitchFamily="34" charset="-120"/>
+              </a:rPr>
+              <a:t>CAPUT  III</a:t>
+            </a:r>
+            <a:endParaRPr lang="en-US" sz="1300" dirty="0"/>
+          </a:p>
+        </p:txBody>
+      </p:sp>
+      <p:sp>
+        <p:nvSpPr>
+          <p:cNvPr id="28" name="!!c3_1"/>
+          <p:cNvSpPr txBox="1"/>
+          <p:nvPr/>
+        </p:nvSpPr>
+        <p:spPr>
+          <a:xfrm>
+            <a:off x="777240" y="1097280"/>
+            <a:ext cx="8229600" cy="822960"/>
+          </a:xfrm>
+          <a:prstGeom prst="rect">
+            <a:avLst/>
+          </a:prstGeom>
+          <a:noFill/>
+          <a:ln/>
+        </p:spPr>
+        <p:txBody>
+          <a:bodyPr wrap="square" lIns="0" tIns="0" rIns="0" bIns="0" rtlCol="0" anchor="ctr"/>
+          <a:lstStyle/>
+          <a:p>
+            <a:pPr indent="0" marL="0">
+              <a:buNone/>
+            </a:pPr>
+            <a:r>
+              <a:rPr lang="en-US" sz="4000" b="1" dirty="0">
+                <a:solidFill>
+                  <a:srgbClr val="F1E6CF"/>
+                </a:solidFill>
+                <a:latin typeface="Bookman Old Style" pitchFamily="34" charset="0"/>
+                <a:ea typeface="Bookman Old Style" pitchFamily="34" charset="-122"/>
+                <a:cs typeface="Bookman Old Style" pitchFamily="34" charset="-120"/>
+              </a:rPr>
+              <a:t>Хроника свободы</a:t>
+            </a:r>
+            <a:endParaRPr lang="en-US" sz="4000" dirty="0"/>
+          </a:p>
+        </p:txBody>
+      </p:sp>
+      <p:sp>
+        <p:nvSpPr>
+          <p:cNvPr id="29" name="!!c3_2"/>
+          <p:cNvSpPr txBox="1"/>
+          <p:nvPr/>
+        </p:nvSpPr>
+        <p:spPr>
+          <a:xfrm>
+            <a:off x="10332720" y="6263640"/>
+            <a:ext cx="1097280" cy="274320"/>
+          </a:xfrm>
+          <a:prstGeom prst="rect">
+            <a:avLst/>
+          </a:prstGeom>
+          <a:noFill/>
+          <a:ln/>
+        </p:spPr>
+        <p:txBody>
+          <a:bodyPr wrap="square" lIns="0" tIns="0" rIns="0" bIns="0" rtlCol="0" anchor="ctr"/>
+          <a:lstStyle/>
+          <a:p>
+            <a:pPr algn="r" indent="0" marL="0">
+              <a:buNone/>
+            </a:pPr>
+            <a:r>
+              <a:rPr lang="en-US" sz="1000" spc="300" kern="0" dirty="0">
+                <a:solidFill>
+                  <a:srgbClr val="C9A15A"/>
+                </a:solidFill>
+                <a:latin typeface="Bookman Old Style" pitchFamily="34" charset="0"/>
+                <a:ea typeface="Bookman Old Style" pitchFamily="34" charset="-122"/>
+                <a:cs typeface="Bookman Old Style" pitchFamily="34" charset="-120"/>
+              </a:rPr>
+              <a:t>IV  ·  VI</a:t>
+            </a:r>
+            <a:endParaRPr lang="en-US" sz="1000" dirty="0"/>
+          </a:p>
+        </p:txBody>
+      </p:sp>
+      <p:sp>
+        <p:nvSpPr>
+          <p:cNvPr id="30" name="!!c3_3"/>
           <p:cNvSpPr/>
           <p:nvPr/>
         </p:nvSpPr>
@@ -5039,7 +5858,7 @@
       </p:sp>
       <p:sp>
         <p:nvSpPr>
-          <p:cNvPr id="26" name="!!c3_1"/>
+          <p:cNvPr id="31" name="!!c3_4"/>
           <p:cNvSpPr/>
           <p:nvPr/>
         </p:nvSpPr>
@@ -5064,7 +5883,7 @@
       </p:sp>
       <p:sp>
         <p:nvSpPr>
-          <p:cNvPr id="27" name="!!c3_2"/>
+          <p:cNvPr id="32" name="!!c3_5"/>
           <p:cNvSpPr txBox="1"/>
           <p:nvPr/>
         </p:nvSpPr>
@@ -5103,7 +5922,7 @@
       </p:sp>
       <p:sp>
         <p:nvSpPr>
-          <p:cNvPr id="28" name="!!c3_3"/>
+          <p:cNvPr id="33" name="!!c3_6"/>
           <p:cNvSpPr txBox="1"/>
           <p:nvPr/>
         </p:nvSpPr>
@@ -5142,7 +5961,7 @@
       </p:sp>
       <p:sp>
         <p:nvSpPr>
-          <p:cNvPr id="29" name="!!c3_4"/>
+          <p:cNvPr id="34" name="!!c3_7"/>
           <p:cNvSpPr txBox="1"/>
           <p:nvPr/>
         </p:nvSpPr>
@@ -5181,7 +6000,7 @@
       </p:sp>
       <p:sp>
         <p:nvSpPr>
-          <p:cNvPr id="30" name="!!c3_5"/>
+          <p:cNvPr id="35" name="!!c3_8"/>
           <p:cNvSpPr/>
           <p:nvPr/>
         </p:nvSpPr>
@@ -5206,7 +6025,7 @@
       </p:sp>
       <p:sp>
         <p:nvSpPr>
-          <p:cNvPr id="31" name="!!c3_6"/>
+          <p:cNvPr id="36" name="!!c3_9"/>
           <p:cNvSpPr txBox="1"/>
           <p:nvPr/>
         </p:nvSpPr>
@@ -5245,7 +6064,7 @@
       </p:sp>
       <p:sp>
         <p:nvSpPr>
-          <p:cNvPr id="32" name="!!c3_7"/>
+          <p:cNvPr id="37" name="!!c3_10"/>
           <p:cNvSpPr txBox="1"/>
           <p:nvPr/>
         </p:nvSpPr>
@@ -5284,7 +6103,7 @@
       </p:sp>
       <p:sp>
         <p:nvSpPr>
-          <p:cNvPr id="33" name="!!c3_8"/>
+          <p:cNvPr id="38" name="!!c3_11"/>
           <p:cNvSpPr txBox="1"/>
           <p:nvPr/>
         </p:nvSpPr>
@@ -5323,7 +6142,7 @@
       </p:sp>
       <p:sp>
         <p:nvSpPr>
-          <p:cNvPr id="34" name="!!c3_9"/>
+          <p:cNvPr id="39" name="!!c3_12"/>
           <p:cNvSpPr/>
           <p:nvPr/>
         </p:nvSpPr>
@@ -5348,7 +6167,7 @@
       </p:sp>
       <p:sp>
         <p:nvSpPr>
-          <p:cNvPr id="35" name="!!c3_10"/>
+          <p:cNvPr id="40" name="!!c3_13"/>
           <p:cNvSpPr txBox="1"/>
           <p:nvPr/>
         </p:nvSpPr>
@@ -5387,7 +6206,7 @@
       </p:sp>
       <p:sp>
         <p:nvSpPr>
-          <p:cNvPr id="36" name="!!c3_11"/>
+          <p:cNvPr id="41" name="!!c3_14"/>
           <p:cNvSpPr txBox="1"/>
           <p:nvPr/>
         </p:nvSpPr>
@@ -5426,7 +6245,7 @@
       </p:sp>
       <p:sp>
         <p:nvSpPr>
-          <p:cNvPr id="37" name="!!c3_12"/>
+          <p:cNvPr id="42" name="!!c3_15"/>
           <p:cNvSpPr txBox="1"/>
           <p:nvPr/>
         </p:nvSpPr>
@@ -5465,7 +6284,7 @@
       </p:sp>
       <p:sp>
         <p:nvSpPr>
-          <p:cNvPr id="38" name="!!c3_13"/>
+          <p:cNvPr id="43" name="!!c3_16"/>
           <p:cNvSpPr/>
           <p:nvPr/>
         </p:nvSpPr>
@@ -5490,7 +6309,7 @@
       </p:sp>
       <p:sp>
         <p:nvSpPr>
-          <p:cNvPr id="39" name="!!c3_14"/>
+          <p:cNvPr id="44" name="!!c3_17"/>
           <p:cNvSpPr txBox="1"/>
           <p:nvPr/>
         </p:nvSpPr>
@@ -5529,7 +6348,7 @@
       </p:sp>
       <p:sp>
         <p:nvSpPr>
-          <p:cNvPr id="40" name="!!c3_15"/>
+          <p:cNvPr id="45" name="!!c3_18"/>
           <p:cNvSpPr txBox="1"/>
           <p:nvPr/>
         </p:nvSpPr>
@@ -5568,7 +6387,7 @@
       </p:sp>
       <p:sp>
         <p:nvSpPr>
-          <p:cNvPr id="41" name="!!c3_16"/>
+          <p:cNvPr id="46" name="!!c3_19"/>
           <p:cNvSpPr txBox="1"/>
           <p:nvPr/>
         </p:nvSpPr>
@@ -5607,7 +6426,7 @@
       </p:sp>
       <p:sp>
         <p:nvSpPr>
-          <p:cNvPr id="42" name="!!c3_17"/>
+          <p:cNvPr id="47" name="!!c3_20"/>
           <p:cNvSpPr/>
           <p:nvPr/>
         </p:nvSpPr>
@@ -5632,7 +6451,7 @@
       </p:sp>
       <p:sp>
         <p:nvSpPr>
-          <p:cNvPr id="43" name="!!c3_18"/>
+          <p:cNvPr id="48" name="!!c3_21"/>
           <p:cNvSpPr txBox="1"/>
           <p:nvPr/>
         </p:nvSpPr>
@@ -5671,7 +6490,7 @@
       </p:sp>
       <p:sp>
         <p:nvSpPr>
-          <p:cNvPr id="44" name="!!c3_19"/>
+          <p:cNvPr id="49" name="!!c3_22"/>
           <p:cNvSpPr txBox="1"/>
           <p:nvPr/>
         </p:nvSpPr>
@@ -5710,7 +6529,7 @@
       </p:sp>
       <p:sp>
         <p:nvSpPr>
-          <p:cNvPr id="45" name="!!c3_20"/>
+          <p:cNvPr id="50" name="!!c3_23"/>
           <p:cNvSpPr txBox="1"/>
           <p:nvPr/>
         </p:nvSpPr>
@@ -5749,7 +6568,7 @@
       </p:sp>
       <p:sp>
         <p:nvSpPr>
-          <p:cNvPr id="46" name="!!c3_21"/>
+          <p:cNvPr id="51" name="!!c3_24"/>
           <p:cNvSpPr txBox="1"/>
           <p:nvPr/>
         </p:nvSpPr>
@@ -5885,13 +6704,13 @@
       </p:pic>
       <p:sp>
         <p:nvSpPr>
-          <p:cNvPr id="4" name="!!kicker"/>
-          <p:cNvSpPr txBox="1"/>
-          <p:nvPr/>
-        </p:nvSpPr>
-        <p:spPr>
-          <a:xfrm>
-            <a:off x="777240" y="1828800"/>
+          <p:cNvPr id="4" name="!!c3_0"/>
+          <p:cNvSpPr txBox="1"/>
+          <p:nvPr/>
+        </p:nvSpPr>
+        <p:spPr>
+          <a:xfrm>
+            <a:off x="-11871655" y="777240"/>
             <a:ext cx="4572000" cy="320040"/>
           </a:xfrm>
           <a:prstGeom prst="rect">
@@ -5916,7 +6735,7 @@
                 <a:ea typeface="Bookman Old Style" pitchFamily="34" charset="-122"/>
                 <a:cs typeface="Bookman Old Style" pitchFamily="34" charset="-120"/>
               </a:rPr>
-              <a:t>CAPUT  IV</a:t>
+              <a:t>CAPUT  III</a:t>
             </a:r>
             <a:endParaRPr lang="en-US" sz="1300" dirty="0"/>
           </a:p>
@@ -5924,13 +6743,52 @@
       </p:sp>
       <p:sp>
         <p:nvSpPr>
-          <p:cNvPr id="5" name="!!page"/>
-          <p:cNvSpPr txBox="1"/>
-          <p:nvPr/>
-        </p:nvSpPr>
-        <p:spPr>
-          <a:xfrm>
-            <a:off x="10332720" y="6263640"/>
+          <p:cNvPr id="5" name="!!c3_1"/>
+          <p:cNvSpPr txBox="1"/>
+          <p:nvPr/>
+        </p:nvSpPr>
+        <p:spPr>
+          <a:xfrm>
+            <a:off x="-11871655" y="1097280"/>
+            <a:ext cx="8229600" cy="822960"/>
+          </a:xfrm>
+          <a:prstGeom prst="rect">
+            <a:avLst/>
+          </a:prstGeom>
+          <a:noFill/>
+          <a:ln/>
+        </p:spPr>
+        <p:txBody>
+          <a:bodyPr wrap="square" lIns="0" tIns="0" rIns="0" bIns="0" rtlCol="0" anchor="ctr"/>
+          <a:lstStyle/>
+          <a:p>
+            <a:pPr indent="0" marL="0">
+              <a:buNone/>
+            </a:pPr>
+            <a:r>
+              <a:rPr lang="en-US" sz="4000" b="1" dirty="0">
+                <a:solidFill>
+                  <a:srgbClr val="F1E6CF"/>
+                </a:solidFill>
+                <a:latin typeface="Bookman Old Style" pitchFamily="34" charset="0"/>
+                <a:ea typeface="Bookman Old Style" pitchFamily="34" charset="-122"/>
+                <a:cs typeface="Bookman Old Style" pitchFamily="34" charset="-120"/>
+              </a:rPr>
+              <a:t>Хроника свободы</a:t>
+            </a:r>
+            <a:endParaRPr lang="en-US" sz="4000" dirty="0"/>
+          </a:p>
+        </p:txBody>
+      </p:sp>
+      <p:sp>
+        <p:nvSpPr>
+          <p:cNvPr id="6" name="!!c3_2"/>
+          <p:cNvSpPr txBox="1"/>
+          <p:nvPr/>
+        </p:nvSpPr>
+        <p:spPr>
+          <a:xfrm>
+            <a:off x="-2316175" y="6263640"/>
             <a:ext cx="1097280" cy="274320"/>
           </a:xfrm>
           <a:prstGeom prst="rect">
@@ -5955,7 +6813,7 @@
                 <a:ea typeface="Bookman Old Style" pitchFamily="34" charset="-122"/>
                 <a:cs typeface="Bookman Old Style" pitchFamily="34" charset="-120"/>
               </a:rPr>
-              <a:t>V  ·  VI</a:t>
+              <a:t>IV  ·  VI</a:t>
             </a:r>
             <a:endParaRPr lang="en-US" sz="1000" dirty="0"/>
           </a:p>
@@ -5963,7 +6821,7 @@
       </p:sp>
       <p:sp>
         <p:nvSpPr>
-          <p:cNvPr id="6" name="!!c3_0"/>
+          <p:cNvPr id="7" name="!!c3_3"/>
           <p:cNvSpPr/>
           <p:nvPr/>
         </p:nvSpPr>
@@ -5986,7 +6844,7 @@
       </p:sp>
       <p:sp>
         <p:nvSpPr>
-          <p:cNvPr id="7" name="!!c3_1"/>
+          <p:cNvPr id="8" name="!!c3_4"/>
           <p:cNvSpPr/>
           <p:nvPr/>
         </p:nvSpPr>
@@ -6011,7 +6869,7 @@
       </p:sp>
       <p:sp>
         <p:nvSpPr>
-          <p:cNvPr id="8" name="!!c3_2"/>
+          <p:cNvPr id="9" name="!!c3_5"/>
           <p:cNvSpPr txBox="1"/>
           <p:nvPr/>
         </p:nvSpPr>
@@ -6050,7 +6908,7 @@
       </p:sp>
       <p:sp>
         <p:nvSpPr>
-          <p:cNvPr id="9" name="!!c3_3"/>
+          <p:cNvPr id="10" name="!!c3_6"/>
           <p:cNvSpPr txBox="1"/>
           <p:nvPr/>
         </p:nvSpPr>
@@ -6089,7 +6947,7 @@
       </p:sp>
       <p:sp>
         <p:nvSpPr>
-          <p:cNvPr id="10" name="!!c3_4"/>
+          <p:cNvPr id="11" name="!!c3_7"/>
           <p:cNvSpPr txBox="1"/>
           <p:nvPr/>
         </p:nvSpPr>
@@ -6128,7 +6986,7 @@
       </p:sp>
       <p:sp>
         <p:nvSpPr>
-          <p:cNvPr id="11" name="!!c3_5"/>
+          <p:cNvPr id="12" name="!!c3_8"/>
           <p:cNvSpPr/>
           <p:nvPr/>
         </p:nvSpPr>
@@ -6153,7 +7011,7 @@
       </p:sp>
       <p:sp>
         <p:nvSpPr>
-          <p:cNvPr id="12" name="!!c3_6"/>
+          <p:cNvPr id="13" name="!!c3_9"/>
           <p:cNvSpPr txBox="1"/>
           <p:nvPr/>
         </p:nvSpPr>
@@ -6192,7 +7050,7 @@
       </p:sp>
       <p:sp>
         <p:nvSpPr>
-          <p:cNvPr id="13" name="!!c3_7"/>
+          <p:cNvPr id="14" name="!!c3_10"/>
           <p:cNvSpPr txBox="1"/>
           <p:nvPr/>
         </p:nvSpPr>
@@ -6231,7 +7089,7 @@
       </p:sp>
       <p:sp>
         <p:nvSpPr>
-          <p:cNvPr id="14" name="!!c3_8"/>
+          <p:cNvPr id="15" name="!!c3_11"/>
           <p:cNvSpPr txBox="1"/>
           <p:nvPr/>
         </p:nvSpPr>
@@ -6270,7 +7128,7 @@
       </p:sp>
       <p:sp>
         <p:nvSpPr>
-          <p:cNvPr id="15" name="!!c3_9"/>
+          <p:cNvPr id="16" name="!!c3_12"/>
           <p:cNvSpPr/>
           <p:nvPr/>
         </p:nvSpPr>
@@ -6295,7 +7153,7 @@
       </p:sp>
       <p:sp>
         <p:nvSpPr>
-          <p:cNvPr id="16" name="!!c3_10"/>
+          <p:cNvPr id="17" name="!!c3_13"/>
           <p:cNvSpPr txBox="1"/>
           <p:nvPr/>
         </p:nvSpPr>
@@ -6334,7 +7192,7 @@
       </p:sp>
       <p:sp>
         <p:nvSpPr>
-          <p:cNvPr id="17" name="!!c3_11"/>
+          <p:cNvPr id="18" name="!!c3_14"/>
           <p:cNvSpPr txBox="1"/>
           <p:nvPr/>
         </p:nvSpPr>
@@ -6373,7 +7231,7 @@
       </p:sp>
       <p:sp>
         <p:nvSpPr>
-          <p:cNvPr id="18" name="!!c3_12"/>
+          <p:cNvPr id="19" name="!!c3_15"/>
           <p:cNvSpPr txBox="1"/>
           <p:nvPr/>
         </p:nvSpPr>
@@ -6412,7 +7270,7 @@
       </p:sp>
       <p:sp>
         <p:nvSpPr>
-          <p:cNvPr id="19" name="!!c3_13"/>
+          <p:cNvPr id="20" name="!!c3_16"/>
           <p:cNvSpPr/>
           <p:nvPr/>
         </p:nvSpPr>
@@ -6437,7 +7295,7 @@
       </p:sp>
       <p:sp>
         <p:nvSpPr>
-          <p:cNvPr id="20" name="!!c3_14"/>
+          <p:cNvPr id="21" name="!!c3_17"/>
           <p:cNvSpPr txBox="1"/>
           <p:nvPr/>
         </p:nvSpPr>
@@ -6476,7 +7334,7 @@
       </p:sp>
       <p:sp>
         <p:nvSpPr>
-          <p:cNvPr id="21" name="!!c3_15"/>
+          <p:cNvPr id="22" name="!!c3_18"/>
           <p:cNvSpPr txBox="1"/>
           <p:nvPr/>
         </p:nvSpPr>
@@ -6515,7 +7373,7 @@
       </p:sp>
       <p:sp>
         <p:nvSpPr>
-          <p:cNvPr id="22" name="!!c3_16"/>
+          <p:cNvPr id="23" name="!!c3_19"/>
           <p:cNvSpPr txBox="1"/>
           <p:nvPr/>
         </p:nvSpPr>
@@ -6554,7 +7412,7 @@
       </p:sp>
       <p:sp>
         <p:nvSpPr>
-          <p:cNvPr id="23" name="!!c3_17"/>
+          <p:cNvPr id="24" name="!!c3_20"/>
           <p:cNvSpPr/>
           <p:nvPr/>
         </p:nvSpPr>
@@ -6579,7 +7437,7 @@
       </p:sp>
       <p:sp>
         <p:nvSpPr>
-          <p:cNvPr id="24" name="!!c3_18"/>
+          <p:cNvPr id="25" name="!!c3_21"/>
           <p:cNvSpPr txBox="1"/>
           <p:nvPr/>
         </p:nvSpPr>
@@ -6618,7 +7476,7 @@
       </p:sp>
       <p:sp>
         <p:nvSpPr>
-          <p:cNvPr id="25" name="!!c3_19"/>
+          <p:cNvPr id="26" name="!!c3_22"/>
           <p:cNvSpPr txBox="1"/>
           <p:nvPr/>
         </p:nvSpPr>
@@ -6657,7 +7515,7 @@
       </p:sp>
       <p:sp>
         <p:nvSpPr>
-          <p:cNvPr id="26" name="!!c3_20"/>
+          <p:cNvPr id="27" name="!!c3_23"/>
           <p:cNvSpPr txBox="1"/>
           <p:nvPr/>
         </p:nvSpPr>
@@ -6696,7 +7554,7 @@
       </p:sp>
       <p:sp>
         <p:nvSpPr>
-          <p:cNvPr id="27" name="!!c3_21"/>
+          <p:cNvPr id="28" name="!!c3_24"/>
           <p:cNvSpPr txBox="1"/>
           <p:nvPr/>
         </p:nvSpPr>
@@ -6735,7 +7593,85 @@
       </p:sp>
       <p:sp>
         <p:nvSpPr>
-          <p:cNvPr id="28" name="!!c5_0"/>
+          <p:cNvPr id="29" name="!!c5_0"/>
+          <p:cNvSpPr txBox="1"/>
+          <p:nvPr/>
+        </p:nvSpPr>
+        <p:spPr>
+          <a:xfrm>
+            <a:off x="13563295" y="2286000"/>
+            <a:ext cx="10362895" cy="411480"/>
+          </a:xfrm>
+          <a:prstGeom prst="rect">
+            <a:avLst/>
+          </a:prstGeom>
+          <a:noFill/>
+          <a:ln/>
+        </p:spPr>
+        <p:txBody>
+          <a:bodyPr wrap="square" lIns="0" tIns="0" rIns="0" bIns="0" rtlCol="0" anchor="ctr"/>
+          <a:lstStyle/>
+          <a:p>
+            <a:pPr algn="ctr" indent="0" marL="0">
+              <a:buNone/>
+            </a:pPr>
+            <a:r>
+              <a:rPr lang="en-US" sz="1400" spc="1000" kern="0" dirty="0">
+                <a:solidFill>
+                  <a:srgbClr val="C9A15A"/>
+                </a:solidFill>
+                <a:latin typeface="Bookman Old Style" pitchFamily="34" charset="0"/>
+                <a:ea typeface="Bookman Old Style" pitchFamily="34" charset="-122"/>
+                <a:cs typeface="Bookman Old Style" pitchFamily="34" charset="-120"/>
+              </a:rPr>
+              <a:t>FINIS</a:t>
+            </a:r>
+            <a:endParaRPr lang="en-US" sz="1400" dirty="0"/>
+          </a:p>
+        </p:txBody>
+      </p:sp>
+      <p:sp>
+        <p:nvSpPr>
+          <p:cNvPr id="30" name="!!c5_1"/>
+          <p:cNvSpPr txBox="1"/>
+          <p:nvPr/>
+        </p:nvSpPr>
+        <p:spPr>
+          <a:xfrm>
+            <a:off x="13563295" y="2697480"/>
+            <a:ext cx="10362895" cy="1005840"/>
+          </a:xfrm>
+          <a:prstGeom prst="rect">
+            <a:avLst/>
+          </a:prstGeom>
+          <a:noFill/>
+          <a:ln/>
+        </p:spPr>
+        <p:txBody>
+          <a:bodyPr wrap="square" lIns="0" tIns="0" rIns="0" bIns="0" rtlCol="0" anchor="ctr"/>
+          <a:lstStyle/>
+          <a:p>
+            <a:pPr algn="ctr" indent="0" marL="0">
+              <a:buNone/>
+            </a:pPr>
+            <a:r>
+              <a:rPr lang="en-US" sz="4600" b="1" dirty="0">
+                <a:solidFill>
+                  <a:srgbClr val="F1E6CF"/>
+                </a:solidFill>
+                <a:latin typeface="Bookman Old Style" pitchFamily="34" charset="0"/>
+                <a:ea typeface="Bookman Old Style" pitchFamily="34" charset="-122"/>
+                <a:cs typeface="Bookman Old Style" pitchFamily="34" charset="-120"/>
+              </a:rPr>
+              <a:t>Спасибо за внимание</a:t>
+            </a:r>
+            <a:endParaRPr lang="en-US" sz="4600" dirty="0"/>
+          </a:p>
+        </p:txBody>
+      </p:sp>
+      <p:sp>
+        <p:nvSpPr>
+          <p:cNvPr id="31" name="!!c5_2"/>
           <p:cNvSpPr txBox="1"/>
           <p:nvPr/>
         </p:nvSpPr>
@@ -6774,7 +7710,7 @@
       </p:sp>
       <p:sp>
         <p:nvSpPr>
-          <p:cNvPr id="29" name="!!c5_1"/>
+          <p:cNvPr id="32" name="!!c5_3"/>
           <p:cNvSpPr txBox="1"/>
           <p:nvPr/>
         </p:nvSpPr>
@@ -6813,7 +7749,7 @@
       </p:sp>
       <p:sp>
         <p:nvSpPr>
-          <p:cNvPr id="30" name="!!c5_2"/>
+          <p:cNvPr id="33" name="!!c5_4"/>
           <p:cNvSpPr txBox="1"/>
           <p:nvPr/>
         </p:nvSpPr>
@@ -6850,9 +7786,87 @@
           </a:p>
         </p:txBody>
       </p:sp>
+      <p:sp>
+        <p:nvSpPr>
+          <p:cNvPr id="34" name="!!c4_0"/>
+          <p:cNvSpPr txBox="1"/>
+          <p:nvPr/>
+        </p:nvSpPr>
+        <p:spPr>
+          <a:xfrm>
+            <a:off x="777240" y="1828800"/>
+            <a:ext cx="4572000" cy="320040"/>
+          </a:xfrm>
+          <a:prstGeom prst="rect">
+            <a:avLst/>
+          </a:prstGeom>
+          <a:noFill/>
+          <a:ln/>
+        </p:spPr>
+        <p:txBody>
+          <a:bodyPr wrap="square" lIns="0" tIns="0" rIns="0" bIns="0" rtlCol="0" anchor="ctr"/>
+          <a:lstStyle/>
+          <a:p>
+            <a:pPr indent="0" marL="0">
+              <a:buNone/>
+            </a:pPr>
+            <a:r>
+              <a:rPr lang="en-US" sz="1300" spc="600" kern="0" dirty="0">
+                <a:solidFill>
+                  <a:srgbClr val="C9A15A"/>
+                </a:solidFill>
+                <a:latin typeface="Bookman Old Style" pitchFamily="34" charset="0"/>
+                <a:ea typeface="Bookman Old Style" pitchFamily="34" charset="-122"/>
+                <a:cs typeface="Bookman Old Style" pitchFamily="34" charset="-120"/>
+              </a:rPr>
+              <a:t>CAPUT  IV</a:t>
+            </a:r>
+            <a:endParaRPr lang="en-US" sz="1300" dirty="0"/>
+          </a:p>
+        </p:txBody>
+      </p:sp>
+      <p:sp>
+        <p:nvSpPr>
+          <p:cNvPr id="35" name="!!c4_1"/>
+          <p:cNvSpPr txBox="1"/>
+          <p:nvPr/>
+        </p:nvSpPr>
+        <p:spPr>
+          <a:xfrm>
+            <a:off x="10332720" y="6263640"/>
+            <a:ext cx="1097280" cy="274320"/>
+          </a:xfrm>
+          <a:prstGeom prst="rect">
+            <a:avLst/>
+          </a:prstGeom>
+          <a:noFill/>
+          <a:ln/>
+        </p:spPr>
+        <p:txBody>
+          <a:bodyPr wrap="square" lIns="0" tIns="0" rIns="0" bIns="0" rtlCol="0" anchor="ctr"/>
+          <a:lstStyle/>
+          <a:p>
+            <a:pPr algn="r" indent="0" marL="0">
+              <a:buNone/>
+            </a:pPr>
+            <a:r>
+              <a:rPr lang="en-US" sz="1000" spc="300" kern="0" dirty="0">
+                <a:solidFill>
+                  <a:srgbClr val="C9A15A"/>
+                </a:solidFill>
+                <a:latin typeface="Bookman Old Style" pitchFamily="34" charset="0"/>
+                <a:ea typeface="Bookman Old Style" pitchFamily="34" charset="-122"/>
+                <a:cs typeface="Bookman Old Style" pitchFamily="34" charset="-120"/>
+              </a:rPr>
+              <a:t>V  ·  VI</a:t>
+            </a:r>
+            <a:endParaRPr lang="en-US" sz="1000" dirty="0"/>
+          </a:p>
+        </p:txBody>
+      </p:sp>
       <p:pic>
         <p:nvPicPr>
-          <p:cNvPr id="31" name="!!c4_0" descr="img/parchment.jpg">    </p:cNvPr>
+          <p:cNvPr id="36" name="!!c4_2" descr="img/parchment.jpg">    </p:cNvPr>
           <p:cNvPicPr>
             <a:picLocks noChangeAspect="1"/>
           </p:cNvPicPr>
@@ -6875,7 +7889,7 @@
       </p:pic>
       <p:sp>
         <p:nvSpPr>
-          <p:cNvPr id="32" name="!!c4_1"/>
+          <p:cNvPr id="37" name="!!c4_3"/>
           <p:cNvSpPr/>
           <p:nvPr/>
         </p:nvSpPr>
@@ -6904,7 +7918,7 @@
       </p:sp>
       <p:sp>
         <p:nvSpPr>
-          <p:cNvPr id="33" name="!!c4_2"/>
+          <p:cNvPr id="38" name="!!c4_4"/>
           <p:cNvSpPr txBox="1"/>
           <p:nvPr/>
         </p:nvSpPr>
@@ -6943,7 +7957,7 @@
       </p:sp>
       <p:sp>
         <p:nvSpPr>
-          <p:cNvPr id="34" name="!!c4_3"/>
+          <p:cNvPr id="39" name="!!c4_5"/>
           <p:cNvSpPr txBox="1"/>
           <p:nvPr/>
         </p:nvSpPr>
@@ -6982,7 +7996,7 @@
       </p:sp>
       <p:sp>
         <p:nvSpPr>
-          <p:cNvPr id="35" name="!!c4_4"/>
+          <p:cNvPr id="40" name="!!c4_6"/>
           <p:cNvSpPr txBox="1"/>
           <p:nvPr/>
         </p:nvSpPr>
@@ -7021,7 +8035,7 @@
       </p:sp>
       <p:sp>
         <p:nvSpPr>
-          <p:cNvPr id="36" name="!!c4_5"/>
+          <p:cNvPr id="41" name="!!c4_7"/>
           <p:cNvSpPr txBox="1"/>
           <p:nvPr/>
         </p:nvSpPr>
@@ -7060,7 +8074,7 @@
       </p:sp>
       <p:sp>
         <p:nvSpPr>
-          <p:cNvPr id="37" name="!!c4_6"/>
+          <p:cNvPr id="42" name="!!c4_8"/>
           <p:cNvSpPr txBox="1"/>
           <p:nvPr/>
         </p:nvSpPr>
@@ -7240,30 +8254,30 @@
       </p:pic>
       <p:sp>
         <p:nvSpPr>
-          <p:cNvPr id="6" name="!!kicker"/>
-          <p:cNvSpPr txBox="1"/>
-          <p:nvPr/>
-        </p:nvSpPr>
-        <p:spPr>
-          <a:xfrm>
-            <a:off x="914400" y="2286000"/>
-            <a:ext cx="10362895" cy="411480"/>
-          </a:xfrm>
-          <a:prstGeom prst="rect">
-            <a:avLst/>
-          </a:prstGeom>
-          <a:noFill/>
-          <a:ln/>
-        </p:spPr>
-        <p:txBody>
-          <a:bodyPr wrap="square" lIns="0" tIns="0" rIns="0" bIns="0" rtlCol="0" anchor="ctr"/>
-          <a:lstStyle/>
-          <a:p>
-            <a:pPr algn="ctr" indent="0" marL="0">
-              <a:buNone/>
-            </a:pPr>
-            <a:r>
-              <a:rPr lang="en-US" sz="1400" spc="1000" kern="0" dirty="0">
+          <p:cNvPr id="6" name="!!c4_0"/>
+          <p:cNvSpPr txBox="1"/>
+          <p:nvPr/>
+        </p:nvSpPr>
+        <p:spPr>
+          <a:xfrm>
+            <a:off x="-11871655" y="1828800"/>
+            <a:ext cx="4572000" cy="320040"/>
+          </a:xfrm>
+          <a:prstGeom prst="rect">
+            <a:avLst/>
+          </a:prstGeom>
+          <a:noFill/>
+          <a:ln/>
+        </p:spPr>
+        <p:txBody>
+          <a:bodyPr wrap="square" lIns="0" tIns="0" rIns="0" bIns="0" rtlCol="0" anchor="ctr"/>
+          <a:lstStyle/>
+          <a:p>
+            <a:pPr indent="0" marL="0">
+              <a:buNone/>
+            </a:pPr>
+            <a:r>
+              <a:rPr lang="en-US" sz="1300" spc="600" kern="0" dirty="0">
                 <a:solidFill>
                   <a:srgbClr val="C9A15A"/>
                 </a:solidFill>
@@ -7271,54 +8285,54 @@
                 <a:ea typeface="Bookman Old Style" pitchFamily="34" charset="-122"/>
                 <a:cs typeface="Bookman Old Style" pitchFamily="34" charset="-120"/>
               </a:rPr>
-              <a:t>FINIS</a:t>
-            </a:r>
-            <a:endParaRPr lang="en-US" sz="1400" dirty="0"/>
-          </a:p>
-        </p:txBody>
-      </p:sp>
-      <p:sp>
-        <p:nvSpPr>
-          <p:cNvPr id="7" name="!!title"/>
-          <p:cNvSpPr txBox="1"/>
-          <p:nvPr/>
-        </p:nvSpPr>
-        <p:spPr>
-          <a:xfrm>
-            <a:off x="914400" y="2697480"/>
-            <a:ext cx="10362895" cy="1005840"/>
-          </a:xfrm>
-          <a:prstGeom prst="rect">
-            <a:avLst/>
-          </a:prstGeom>
-          <a:noFill/>
-          <a:ln/>
-        </p:spPr>
-        <p:txBody>
-          <a:bodyPr wrap="square" lIns="0" tIns="0" rIns="0" bIns="0" rtlCol="0" anchor="ctr"/>
-          <a:lstStyle/>
-          <a:p>
-            <a:pPr algn="ctr" indent="0" marL="0">
-              <a:buNone/>
-            </a:pPr>
-            <a:r>
-              <a:rPr lang="en-US" sz="4600" b="1" dirty="0">
-                <a:solidFill>
-                  <a:srgbClr val="F1E6CF"/>
-                </a:solidFill>
-                <a:latin typeface="Bookman Old Style" pitchFamily="34" charset="0"/>
-                <a:ea typeface="Bookman Old Style" pitchFamily="34" charset="-122"/>
-                <a:cs typeface="Bookman Old Style" pitchFamily="34" charset="-120"/>
-              </a:rPr>
-              <a:t>Спасибо за внимание</a:t>
-            </a:r>
-            <a:endParaRPr lang="en-US" sz="4600" dirty="0"/>
+              <a:t>CAPUT  IV</a:t>
+            </a:r>
+            <a:endParaRPr lang="en-US" sz="1300" dirty="0"/>
+          </a:p>
+        </p:txBody>
+      </p:sp>
+      <p:sp>
+        <p:nvSpPr>
+          <p:cNvPr id="7" name="!!c4_1"/>
+          <p:cNvSpPr txBox="1"/>
+          <p:nvPr/>
+        </p:nvSpPr>
+        <p:spPr>
+          <a:xfrm>
+            <a:off x="-2316175" y="6263640"/>
+            <a:ext cx="1097280" cy="274320"/>
+          </a:xfrm>
+          <a:prstGeom prst="rect">
+            <a:avLst/>
+          </a:prstGeom>
+          <a:noFill/>
+          <a:ln/>
+        </p:spPr>
+        <p:txBody>
+          <a:bodyPr wrap="square" lIns="0" tIns="0" rIns="0" bIns="0" rtlCol="0" anchor="ctr"/>
+          <a:lstStyle/>
+          <a:p>
+            <a:pPr algn="r" indent="0" marL="0">
+              <a:buNone/>
+            </a:pPr>
+            <a:r>
+              <a:rPr lang="en-US" sz="1000" spc="300" kern="0" dirty="0">
+                <a:solidFill>
+                  <a:srgbClr val="C9A15A"/>
+                </a:solidFill>
+                <a:latin typeface="Bookman Old Style" pitchFamily="34" charset="0"/>
+                <a:ea typeface="Bookman Old Style" pitchFamily="34" charset="-122"/>
+                <a:cs typeface="Bookman Old Style" pitchFamily="34" charset="-120"/>
+              </a:rPr>
+              <a:t>V  ·  VI</a:t>
+            </a:r>
+            <a:endParaRPr lang="en-US" sz="1000" dirty="0"/>
           </a:p>
         </p:txBody>
       </p:sp>
       <p:pic>
         <p:nvPicPr>
-          <p:cNvPr id="8" name="!!c4_0" descr="img/parchment.jpg">    </p:cNvPr>
+          <p:cNvPr id="8" name="!!c4_2" descr="img/parchment.jpg">    </p:cNvPr>
           <p:cNvPicPr>
             <a:picLocks noChangeAspect="1"/>
           </p:cNvPicPr>
@@ -7341,7 +8355,7 @@
       </p:pic>
       <p:sp>
         <p:nvSpPr>
-          <p:cNvPr id="9" name="!!c4_1"/>
+          <p:cNvPr id="9" name="!!c4_3"/>
           <p:cNvSpPr/>
           <p:nvPr/>
         </p:nvSpPr>
@@ -7370,7 +8384,7 @@
       </p:sp>
       <p:sp>
         <p:nvSpPr>
-          <p:cNvPr id="10" name="!!c4_2"/>
+          <p:cNvPr id="10" name="!!c4_4"/>
           <p:cNvSpPr txBox="1"/>
           <p:nvPr/>
         </p:nvSpPr>
@@ -7409,7 +8423,7 @@
       </p:sp>
       <p:sp>
         <p:nvSpPr>
-          <p:cNvPr id="11" name="!!c4_3"/>
+          <p:cNvPr id="11" name="!!c4_5"/>
           <p:cNvSpPr txBox="1"/>
           <p:nvPr/>
         </p:nvSpPr>
@@ -7448,7 +8462,7 @@
       </p:sp>
       <p:sp>
         <p:nvSpPr>
-          <p:cNvPr id="12" name="!!c4_4"/>
+          <p:cNvPr id="12" name="!!c4_6"/>
           <p:cNvSpPr txBox="1"/>
           <p:nvPr/>
         </p:nvSpPr>
@@ -7487,7 +8501,7 @@
       </p:sp>
       <p:sp>
         <p:nvSpPr>
-          <p:cNvPr id="13" name="!!c4_5"/>
+          <p:cNvPr id="13" name="!!c4_7"/>
           <p:cNvSpPr txBox="1"/>
           <p:nvPr/>
         </p:nvSpPr>
@@ -7526,7 +8540,7 @@
       </p:sp>
       <p:sp>
         <p:nvSpPr>
-          <p:cNvPr id="14" name="!!c4_6"/>
+          <p:cNvPr id="14" name="!!c4_8"/>
           <p:cNvSpPr txBox="1"/>
           <p:nvPr/>
         </p:nvSpPr>
@@ -7571,6 +8585,84 @@
         </p:nvSpPr>
         <p:spPr>
           <a:xfrm>
+            <a:off x="914400" y="2286000"/>
+            <a:ext cx="10362895" cy="411480"/>
+          </a:xfrm>
+          <a:prstGeom prst="rect">
+            <a:avLst/>
+          </a:prstGeom>
+          <a:noFill/>
+          <a:ln/>
+        </p:spPr>
+        <p:txBody>
+          <a:bodyPr wrap="square" lIns="0" tIns="0" rIns="0" bIns="0" rtlCol="0" anchor="ctr"/>
+          <a:lstStyle/>
+          <a:p>
+            <a:pPr algn="ctr" indent="0" marL="0">
+              <a:buNone/>
+            </a:pPr>
+            <a:r>
+              <a:rPr lang="en-US" sz="1400" spc="1000" kern="0" dirty="0">
+                <a:solidFill>
+                  <a:srgbClr val="C9A15A"/>
+                </a:solidFill>
+                <a:latin typeface="Bookman Old Style" pitchFamily="34" charset="0"/>
+                <a:ea typeface="Bookman Old Style" pitchFamily="34" charset="-122"/>
+                <a:cs typeface="Bookman Old Style" pitchFamily="34" charset="-120"/>
+              </a:rPr>
+              <a:t>FINIS</a:t>
+            </a:r>
+            <a:endParaRPr lang="en-US" sz="1400" dirty="0"/>
+          </a:p>
+        </p:txBody>
+      </p:sp>
+      <p:sp>
+        <p:nvSpPr>
+          <p:cNvPr id="16" name="!!c5_1"/>
+          <p:cNvSpPr txBox="1"/>
+          <p:nvPr/>
+        </p:nvSpPr>
+        <p:spPr>
+          <a:xfrm>
+            <a:off x="914400" y="2697480"/>
+            <a:ext cx="10362895" cy="1005840"/>
+          </a:xfrm>
+          <a:prstGeom prst="rect">
+            <a:avLst/>
+          </a:prstGeom>
+          <a:noFill/>
+          <a:ln/>
+        </p:spPr>
+        <p:txBody>
+          <a:bodyPr wrap="square" lIns="0" tIns="0" rIns="0" bIns="0" rtlCol="0" anchor="ctr"/>
+          <a:lstStyle/>
+          <a:p>
+            <a:pPr algn="ctr" indent="0" marL="0">
+              <a:buNone/>
+            </a:pPr>
+            <a:r>
+              <a:rPr lang="en-US" sz="4600" b="1" dirty="0">
+                <a:solidFill>
+                  <a:srgbClr val="F1E6CF"/>
+                </a:solidFill>
+                <a:latin typeface="Bookman Old Style" pitchFamily="34" charset="0"/>
+                <a:ea typeface="Bookman Old Style" pitchFamily="34" charset="-122"/>
+                <a:cs typeface="Bookman Old Style" pitchFamily="34" charset="-120"/>
+              </a:rPr>
+              <a:t>Спасибо за внимание</a:t>
+            </a:r>
+            <a:endParaRPr lang="en-US" sz="4600" dirty="0"/>
+          </a:p>
+        </p:txBody>
+      </p:sp>
+      <p:sp>
+        <p:nvSpPr>
+          <p:cNvPr id="17" name="!!c5_2"/>
+          <p:cNvSpPr txBox="1"/>
+          <p:nvPr/>
+        </p:nvSpPr>
+        <p:spPr>
+          <a:xfrm>
             <a:off x="2011680" y="3840480"/>
             <a:ext cx="8168335" cy="868680"/>
           </a:xfrm>
@@ -7604,7 +8696,7 @@
       </p:sp>
       <p:sp>
         <p:nvSpPr>
-          <p:cNvPr id="16" name="!!c5_1"/>
+          <p:cNvPr id="18" name="!!c5_3"/>
           <p:cNvSpPr txBox="1"/>
           <p:nvPr/>
         </p:nvSpPr>
@@ -7643,7 +8735,7 @@
       </p:sp>
       <p:sp>
         <p:nvSpPr>
-          <p:cNvPr id="17" name="!!c5_2"/>
+          <p:cNvPr id="19" name="!!c5_4"/>
           <p:cNvSpPr txBox="1"/>
           <p:nvPr/>
         </p:nvSpPr>

</xml_diff>

<commit_message>
Story backgrounds per slide (castle, battle, town, village) and balanced slide text
Co-Authored-By: Claude Opus 5.5 <noreply@anthropic.com>
Claude-Session: https://claude.ai/code/session_01ETjVcpBAzS2WJAYjtqxef9
</commit_message>
<xml_diff>
--- a/presentation/Helvetia.pptx
+++ b/presentation/Helvetia.pptx
@@ -1343,7 +1343,7 @@
           </a:prstGeom>
           <a:solidFill>
             <a:srgbClr val="140E0A">
-              <a:alpha val="55000"/>
+              <a:alpha val="68000"/>
             </a:srgbClr>
           </a:solidFill>
           <a:ln/>
@@ -1690,7 +1690,7 @@
                 <a:ea typeface="Cambria" pitchFamily="34" charset="-122"/>
                 <a:cs typeface="Cambria" pitchFamily="34" charset="-120"/>
               </a:rPr>
-              <a:t>Через их земли шла дорога через перевал Сен-Готард из Германии в Италию. Название страны дал кантон Швиц, а 1 августа — её национальный праздник.</a:t>
+              <a:t>Через их земли шёл путь через перевал Сен-Готард в Италию. От кантона Швиц пошло название всей страны.</a:t>
             </a:r>
             <a:endParaRPr lang="en-US" sz="1500" dirty="0"/>
           </a:p>
@@ -1729,7 +1729,7 @@
                 <a:ea typeface="Cambria" pitchFamily="34" charset="-122"/>
                 <a:cs typeface="Cambria" pitchFamily="34" charset="-120"/>
               </a:rPr>
-              <a:t>Легенда о Вильгельме Телле, сбившем стрелой яблоко с головы сына, стала символом свободы швейцарцев.</a:t>
+              <a:t>Символ этой борьбы — легендарный стрелок Вильгельм Телль.</a:t>
             </a:r>
             <a:endParaRPr lang="en-US" sz="1600" dirty="0"/>
           </a:p>
@@ -2915,7 +2915,7 @@
                 <a:ea typeface="Cambria" pitchFamily="34" charset="-122"/>
                 <a:cs typeface="Cambria" pitchFamily="34" charset="-120"/>
               </a:rPr>
-              <a:t>Через их земли шла дорога через перевал Сен-Готард из Германии в Италию. Название страны дал кантон Швиц, а 1 августа — её национальный праздник.</a:t>
+              <a:t>Через их земли шёл путь через перевал Сен-Готард в Италию. От кантона Швиц пошло название всей страны.</a:t>
             </a:r>
             <a:endParaRPr lang="en-US" sz="1500" dirty="0"/>
           </a:p>
@@ -2954,7 +2954,7 @@
                 <a:ea typeface="Cambria" pitchFamily="34" charset="-122"/>
                 <a:cs typeface="Cambria" pitchFamily="34" charset="-120"/>
               </a:rPr>
-              <a:t>Легенда о Вильгельме Телле, сбившем стрелой яблоко с головы сына, стала символом свободы швейцарцев.</a:t>
+              <a:t>Символ этой борьбы — легендарный стрелок Вильгельм Телль.</a:t>
             </a:r>
             <a:endParaRPr lang="en-US" sz="1600" dirty="0"/>
           </a:p>
@@ -3363,7 +3363,7 @@
                 <a:ea typeface="Cambria" pitchFamily="34" charset="-122"/>
                 <a:cs typeface="Cambria" pitchFamily="34" charset="-120"/>
               </a:rPr>
-              <a:t>Через их земли шла дорога через перевал Сен-Готард из Германии в Италию. Название страны дал кантон Швиц, а 1 августа — её национальный праздник.</a:t>
+              <a:t>Через их земли шёл путь через перевал Сен-Готард в Италию. От кантона Швиц пошло название всей страны.</a:t>
             </a:r>
             <a:endParaRPr lang="en-US" sz="1500" dirty="0"/>
           </a:p>
@@ -3402,7 +3402,7 @@
                 <a:ea typeface="Cambria" pitchFamily="34" charset="-122"/>
                 <a:cs typeface="Cambria" pitchFamily="34" charset="-120"/>
               </a:rPr>
-              <a:t>Легенда о Вильгельме Телле, сбившем стрелой яблоко с головы сына, стала символом свободы швейцарцев.</a:t>
+              <a:t>Символ этой борьбы — легендарный стрелок Вильгельм Телль.</a:t>
             </a:r>
             <a:endParaRPr lang="en-US" sz="1600" dirty="0"/>
           </a:p>
@@ -4266,7 +4266,7 @@
         </p:nvSpPr>
         <p:spPr>
           <a:xfrm>
-            <a:off x="13426135" y="5715000"/>
+            <a:off x="13426135" y="4846320"/>
             <a:ext cx="9418320" cy="365760"/>
           </a:xfrm>
           <a:prstGeom prst="rect">
@@ -4825,29 +4825,9 @@
           <a:chExt cx="0" cy="0"/>
         </a:xfrm>
       </p:grpSpPr>
-      <p:sp>
-        <p:nvSpPr>
-          <p:cNvPr id="2" name="!!gilt"/>
-          <p:cNvSpPr/>
-          <p:nvPr/>
-        </p:nvSpPr>
-        <p:spPr>
-          <a:xfrm>
-            <a:off x="-146304" y="-146304"/>
-            <a:ext cx="12484303" cy="7150608"/>
-          </a:xfrm>
-          <a:prstGeom prst="rect">
-            <a:avLst/>
-          </a:prstGeom>
-          <a:solidFill>
-            <a:srgbClr val="8E6A2E"/>
-          </a:solidFill>
-          <a:ln/>
-        </p:spPr>
-      </p:sp>
       <p:pic>
         <p:nvPicPr>
-          <p:cNvPr id="3" name="!!scene" descr="img/lake.jpg">    </p:cNvPr>
+          <p:cNvPr id="2" name="shade" descr="img/shade.png">    </p:cNvPr>
           <p:cNvPicPr>
             <a:picLocks noChangeAspect="1"/>
           </p:cNvPicPr>
@@ -4855,8 +4835,9 @@
         </p:nvPicPr>
         <p:blipFill>
           <a:blip r:embed="rId2"/>
-          <a:srcRect l="0" r="0" t="0" b="0"/>
-          <a:stretch/>
+          <a:stretch>
+            <a:fillRect/>
+          </a:stretch>
         </p:blipFill>
         <p:spPr>
           <a:xfrm>
@@ -4868,31 +4849,9 @@
           </a:prstGeom>
         </p:spPr>
       </p:pic>
-      <p:sp>
-        <p:nvSpPr>
-          <p:cNvPr id="4" name="veil"/>
-          <p:cNvSpPr/>
-          <p:nvPr/>
-        </p:nvSpPr>
-        <p:spPr>
-          <a:xfrm>
-            <a:off x="0" y="0"/>
-            <a:ext cx="12191695" cy="6858000"/>
-          </a:xfrm>
-          <a:prstGeom prst="rect">
-            <a:avLst/>
-          </a:prstGeom>
-          <a:solidFill>
-            <a:srgbClr val="140E0A">
-              <a:alpha val="55000"/>
-            </a:srgbClr>
-          </a:solidFill>
-          <a:ln/>
-        </p:spPr>
-      </p:sp>
       <p:pic>
         <p:nvPicPr>
-          <p:cNvPr id="5" name="!!shield" descr="img/shield.png">    </p:cNvPr>
+          <p:cNvPr id="3" name="!!shield" descr="img/shield.png">    </p:cNvPr>
           <p:cNvPicPr>
             <a:picLocks noChangeAspect="1"/>
           </p:cNvPicPr>
@@ -4916,7 +4875,7 @@
       </p:pic>
       <p:sp>
         <p:nvSpPr>
-          <p:cNvPr id="6" name="!!c2_0"/>
+          <p:cNvPr id="4" name="!!c2_0"/>
           <p:cNvSpPr txBox="1"/>
           <p:nvPr/>
         </p:nvSpPr>
@@ -4955,7 +4914,7 @@
       </p:sp>
       <p:sp>
         <p:nvSpPr>
-          <p:cNvPr id="7" name="!!c2_1"/>
+          <p:cNvPr id="5" name="!!c2_1"/>
           <p:cNvSpPr txBox="1"/>
           <p:nvPr/>
         </p:nvSpPr>
@@ -4994,7 +4953,7 @@
       </p:sp>
       <p:sp>
         <p:nvSpPr>
-          <p:cNvPr id="8" name="!!c2_2"/>
+          <p:cNvPr id="6" name="!!c2_2"/>
           <p:cNvSpPr txBox="1"/>
           <p:nvPr/>
         </p:nvSpPr>
@@ -5033,7 +4992,7 @@
       </p:sp>
       <p:sp>
         <p:nvSpPr>
-          <p:cNvPr id="9" name="!!c2_3"/>
+          <p:cNvPr id="7" name="!!c2_3"/>
           <p:cNvSpPr txBox="1"/>
           <p:nvPr/>
         </p:nvSpPr>
@@ -5072,7 +5031,7 @@
       </p:sp>
       <p:sp>
         <p:nvSpPr>
-          <p:cNvPr id="10" name="!!c2_4"/>
+          <p:cNvPr id="8" name="!!c2_4"/>
           <p:cNvSpPr txBox="1"/>
           <p:nvPr/>
         </p:nvSpPr>
@@ -5111,7 +5070,7 @@
       </p:sp>
       <p:sp>
         <p:nvSpPr>
-          <p:cNvPr id="11" name="!!c2_5"/>
+          <p:cNvPr id="9" name="!!c2_5"/>
           <p:cNvSpPr txBox="1"/>
           <p:nvPr/>
         </p:nvSpPr>
@@ -5153,7 +5112,7 @@
       </p:sp>
       <p:sp>
         <p:nvSpPr>
-          <p:cNvPr id="12" name="!!c2_6"/>
+          <p:cNvPr id="10" name="!!c2_6"/>
           <p:cNvSpPr txBox="1"/>
           <p:nvPr/>
         </p:nvSpPr>
@@ -5192,7 +5151,7 @@
       </p:sp>
       <p:sp>
         <p:nvSpPr>
-          <p:cNvPr id="13" name="!!c2_7"/>
+          <p:cNvPr id="11" name="!!c2_7"/>
           <p:cNvSpPr txBox="1"/>
           <p:nvPr/>
         </p:nvSpPr>
@@ -5231,7 +5190,7 @@
       </p:sp>
       <p:sp>
         <p:nvSpPr>
-          <p:cNvPr id="14" name="!!c2_8"/>
+          <p:cNvPr id="12" name="!!c2_8"/>
           <p:cNvSpPr txBox="1"/>
           <p:nvPr/>
         </p:nvSpPr>
@@ -5273,7 +5232,7 @@
       </p:sp>
       <p:sp>
         <p:nvSpPr>
-          <p:cNvPr id="15" name="!!c2_9"/>
+          <p:cNvPr id="13" name="!!c2_9"/>
           <p:cNvSpPr txBox="1"/>
           <p:nvPr/>
         </p:nvSpPr>
@@ -5312,7 +5271,7 @@
       </p:sp>
       <p:sp>
         <p:nvSpPr>
-          <p:cNvPr id="16" name="!!c2_10"/>
+          <p:cNvPr id="14" name="!!c2_10"/>
           <p:cNvSpPr txBox="1"/>
           <p:nvPr/>
         </p:nvSpPr>
@@ -5351,7 +5310,7 @@
       </p:sp>
       <p:sp>
         <p:nvSpPr>
-          <p:cNvPr id="17" name="!!c2_11"/>
+          <p:cNvPr id="15" name="!!c2_11"/>
           <p:cNvSpPr txBox="1"/>
           <p:nvPr/>
         </p:nvSpPr>
@@ -5393,13 +5352,13 @@
       </p:sp>
       <p:sp>
         <p:nvSpPr>
-          <p:cNvPr id="18" name="!!c4_0"/>
-          <p:cNvSpPr txBox="1"/>
-          <p:nvPr/>
-        </p:nvSpPr>
-        <p:spPr>
-          <a:xfrm>
-            <a:off x="13426135" y="1828800"/>
+          <p:cNvPr id="16" name="!!c4_0"/>
+          <p:cNvSpPr txBox="1"/>
+          <p:nvPr/>
+        </p:nvSpPr>
+        <p:spPr>
+          <a:xfrm>
+            <a:off x="13426135" y="1417320"/>
             <a:ext cx="4572000" cy="320040"/>
           </a:xfrm>
           <a:prstGeom prst="rect">
@@ -5432,7 +5391,7 @@
       </p:sp>
       <p:sp>
         <p:nvSpPr>
-          <p:cNvPr id="19" name="!!c4_1"/>
+          <p:cNvPr id="17" name="!!c4_1"/>
           <p:cNvSpPr txBox="1"/>
           <p:nvPr/>
         </p:nvSpPr>
@@ -5471,7 +5430,7 @@
       </p:sp>
       <p:pic>
         <p:nvPicPr>
-          <p:cNvPr id="20" name="!!c4_2" descr="img/parchment.jpg">    </p:cNvPr>
+          <p:cNvPr id="18" name="!!c4_2" descr="img/parchment.jpg">    </p:cNvPr>
           <p:cNvPicPr>
             <a:picLocks noChangeAspect="1"/>
           </p:cNvPicPr>
@@ -5494,7 +5453,7 @@
       </p:pic>
       <p:sp>
         <p:nvSpPr>
-          <p:cNvPr id="21" name="!!c4_3"/>
+          <p:cNvPr id="19" name="!!c4_3"/>
           <p:cNvSpPr/>
           <p:nvPr/>
         </p:nvSpPr>
@@ -5523,7 +5482,7 @@
       </p:sp>
       <p:sp>
         <p:nvSpPr>
-          <p:cNvPr id="22" name="!!c4_4"/>
+          <p:cNvPr id="20" name="!!c4_4"/>
           <p:cNvSpPr txBox="1"/>
           <p:nvPr/>
         </p:nvSpPr>
@@ -5562,7 +5521,7 @@
       </p:sp>
       <p:sp>
         <p:nvSpPr>
-          <p:cNvPr id="23" name="!!c4_5"/>
+          <p:cNvPr id="21" name="!!c4_5"/>
           <p:cNvSpPr txBox="1"/>
           <p:nvPr/>
         </p:nvSpPr>
@@ -5601,7 +5560,7 @@
       </p:sp>
       <p:sp>
         <p:nvSpPr>
-          <p:cNvPr id="24" name="!!c4_6"/>
+          <p:cNvPr id="22" name="!!c4_6"/>
           <p:cNvSpPr txBox="1"/>
           <p:nvPr/>
         </p:nvSpPr>
@@ -5640,13 +5599,13 @@
       </p:sp>
       <p:sp>
         <p:nvSpPr>
-          <p:cNvPr id="25" name="!!c4_7"/>
-          <p:cNvSpPr txBox="1"/>
-          <p:nvPr/>
-        </p:nvSpPr>
-        <p:spPr>
-          <a:xfrm>
-            <a:off x="13426135" y="2286000"/>
+          <p:cNvPr id="23" name="!!c4_7"/>
+          <p:cNvSpPr txBox="1"/>
+          <p:nvPr/>
+        </p:nvSpPr>
+        <p:spPr>
+          <a:xfrm>
+            <a:off x="13426135" y="1783080"/>
             <a:ext cx="5303520" cy="2103120"/>
           </a:xfrm>
           <a:prstGeom prst="rect">
@@ -5679,13 +5638,13 @@
       </p:sp>
       <p:sp>
         <p:nvSpPr>
-          <p:cNvPr id="26" name="!!c4_8"/>
-          <p:cNvSpPr txBox="1"/>
-          <p:nvPr/>
-        </p:nvSpPr>
-        <p:spPr>
-          <a:xfrm>
-            <a:off x="13426135" y="4526280"/>
+          <p:cNvPr id="24" name="!!c4_8"/>
+          <p:cNvSpPr txBox="1"/>
+          <p:nvPr/>
+        </p:nvSpPr>
+        <p:spPr>
+          <a:xfrm>
+            <a:off x="13426135" y="3931920"/>
             <a:ext cx="5120640" cy="365760"/>
           </a:xfrm>
           <a:prstGeom prst="rect">
@@ -5718,7 +5677,7 @@
       </p:sp>
       <p:sp>
         <p:nvSpPr>
-          <p:cNvPr id="27" name="!!c3_0"/>
+          <p:cNvPr id="25" name="!!c3_0"/>
           <p:cNvSpPr txBox="1"/>
           <p:nvPr/>
         </p:nvSpPr>
@@ -5757,7 +5716,7 @@
       </p:sp>
       <p:sp>
         <p:nvSpPr>
-          <p:cNvPr id="28" name="!!c3_1"/>
+          <p:cNvPr id="26" name="!!c3_1"/>
           <p:cNvSpPr txBox="1"/>
           <p:nvPr/>
         </p:nvSpPr>
@@ -5796,7 +5755,7 @@
       </p:sp>
       <p:sp>
         <p:nvSpPr>
-          <p:cNvPr id="29" name="!!c3_2"/>
+          <p:cNvPr id="27" name="!!c3_2"/>
           <p:cNvSpPr txBox="1"/>
           <p:nvPr/>
         </p:nvSpPr>
@@ -5835,7 +5794,7 @@
       </p:sp>
       <p:sp>
         <p:nvSpPr>
-          <p:cNvPr id="30" name="!!c3_3"/>
+          <p:cNvPr id="28" name="!!c3_3"/>
           <p:cNvSpPr/>
           <p:nvPr/>
         </p:nvSpPr>
@@ -5858,7 +5817,7 @@
       </p:sp>
       <p:sp>
         <p:nvSpPr>
-          <p:cNvPr id="31" name="!!c3_4"/>
+          <p:cNvPr id="29" name="!!c3_4"/>
           <p:cNvSpPr/>
           <p:nvPr/>
         </p:nvSpPr>
@@ -5883,7 +5842,7 @@
       </p:sp>
       <p:sp>
         <p:nvSpPr>
-          <p:cNvPr id="32" name="!!c3_5"/>
+          <p:cNvPr id="30" name="!!c3_5"/>
           <p:cNvSpPr txBox="1"/>
           <p:nvPr/>
         </p:nvSpPr>
@@ -5922,7 +5881,7 @@
       </p:sp>
       <p:sp>
         <p:nvSpPr>
-          <p:cNvPr id="33" name="!!c3_6"/>
+          <p:cNvPr id="31" name="!!c3_6"/>
           <p:cNvSpPr txBox="1"/>
           <p:nvPr/>
         </p:nvSpPr>
@@ -5961,7 +5920,7 @@
       </p:sp>
       <p:sp>
         <p:nvSpPr>
-          <p:cNvPr id="34" name="!!c3_7"/>
+          <p:cNvPr id="32" name="!!c3_7"/>
           <p:cNvSpPr txBox="1"/>
           <p:nvPr/>
         </p:nvSpPr>
@@ -6000,7 +5959,7 @@
       </p:sp>
       <p:sp>
         <p:nvSpPr>
-          <p:cNvPr id="35" name="!!c3_8"/>
+          <p:cNvPr id="33" name="!!c3_8"/>
           <p:cNvSpPr/>
           <p:nvPr/>
         </p:nvSpPr>
@@ -6025,7 +5984,7 @@
       </p:sp>
       <p:sp>
         <p:nvSpPr>
-          <p:cNvPr id="36" name="!!c3_9"/>
+          <p:cNvPr id="34" name="!!c3_9"/>
           <p:cNvSpPr txBox="1"/>
           <p:nvPr/>
         </p:nvSpPr>
@@ -6064,7 +6023,7 @@
       </p:sp>
       <p:sp>
         <p:nvSpPr>
-          <p:cNvPr id="37" name="!!c3_10"/>
+          <p:cNvPr id="35" name="!!c3_10"/>
           <p:cNvSpPr txBox="1"/>
           <p:nvPr/>
         </p:nvSpPr>
@@ -6103,7 +6062,7 @@
       </p:sp>
       <p:sp>
         <p:nvSpPr>
-          <p:cNvPr id="38" name="!!c3_11"/>
+          <p:cNvPr id="36" name="!!c3_11"/>
           <p:cNvSpPr txBox="1"/>
           <p:nvPr/>
         </p:nvSpPr>
@@ -6142,7 +6101,7 @@
       </p:sp>
       <p:sp>
         <p:nvSpPr>
-          <p:cNvPr id="39" name="!!c3_12"/>
+          <p:cNvPr id="37" name="!!c3_12"/>
           <p:cNvSpPr/>
           <p:nvPr/>
         </p:nvSpPr>
@@ -6167,7 +6126,7 @@
       </p:sp>
       <p:sp>
         <p:nvSpPr>
-          <p:cNvPr id="40" name="!!c3_13"/>
+          <p:cNvPr id="38" name="!!c3_13"/>
           <p:cNvSpPr txBox="1"/>
           <p:nvPr/>
         </p:nvSpPr>
@@ -6206,7 +6165,7 @@
       </p:sp>
       <p:sp>
         <p:nvSpPr>
-          <p:cNvPr id="41" name="!!c3_14"/>
+          <p:cNvPr id="39" name="!!c3_14"/>
           <p:cNvSpPr txBox="1"/>
           <p:nvPr/>
         </p:nvSpPr>
@@ -6245,7 +6204,7 @@
       </p:sp>
       <p:sp>
         <p:nvSpPr>
-          <p:cNvPr id="42" name="!!c3_15"/>
+          <p:cNvPr id="40" name="!!c3_15"/>
           <p:cNvSpPr txBox="1"/>
           <p:nvPr/>
         </p:nvSpPr>
@@ -6284,7 +6243,7 @@
       </p:sp>
       <p:sp>
         <p:nvSpPr>
-          <p:cNvPr id="43" name="!!c3_16"/>
+          <p:cNvPr id="41" name="!!c3_16"/>
           <p:cNvSpPr/>
           <p:nvPr/>
         </p:nvSpPr>
@@ -6309,7 +6268,7 @@
       </p:sp>
       <p:sp>
         <p:nvSpPr>
-          <p:cNvPr id="44" name="!!c3_17"/>
+          <p:cNvPr id="42" name="!!c3_17"/>
           <p:cNvSpPr txBox="1"/>
           <p:nvPr/>
         </p:nvSpPr>
@@ -6348,7 +6307,7 @@
       </p:sp>
       <p:sp>
         <p:nvSpPr>
-          <p:cNvPr id="45" name="!!c3_18"/>
+          <p:cNvPr id="43" name="!!c3_18"/>
           <p:cNvSpPr txBox="1"/>
           <p:nvPr/>
         </p:nvSpPr>
@@ -6387,7 +6346,7 @@
       </p:sp>
       <p:sp>
         <p:nvSpPr>
-          <p:cNvPr id="46" name="!!c3_19"/>
+          <p:cNvPr id="44" name="!!c3_19"/>
           <p:cNvSpPr txBox="1"/>
           <p:nvPr/>
         </p:nvSpPr>
@@ -6426,7 +6385,7 @@
       </p:sp>
       <p:sp>
         <p:nvSpPr>
-          <p:cNvPr id="47" name="!!c3_20"/>
+          <p:cNvPr id="45" name="!!c3_20"/>
           <p:cNvSpPr/>
           <p:nvPr/>
         </p:nvSpPr>
@@ -6451,7 +6410,7 @@
       </p:sp>
       <p:sp>
         <p:nvSpPr>
-          <p:cNvPr id="48" name="!!c3_21"/>
+          <p:cNvPr id="46" name="!!c3_21"/>
           <p:cNvSpPr txBox="1"/>
           <p:nvPr/>
         </p:nvSpPr>
@@ -6490,7 +6449,7 @@
       </p:sp>
       <p:sp>
         <p:nvSpPr>
-          <p:cNvPr id="49" name="!!c3_22"/>
+          <p:cNvPr id="47" name="!!c3_22"/>
           <p:cNvSpPr txBox="1"/>
           <p:nvPr/>
         </p:nvSpPr>
@@ -6529,7 +6488,7 @@
       </p:sp>
       <p:sp>
         <p:nvSpPr>
-          <p:cNvPr id="50" name="!!c3_23"/>
+          <p:cNvPr id="48" name="!!c3_23"/>
           <p:cNvSpPr txBox="1"/>
           <p:nvPr/>
         </p:nvSpPr>
@@ -6568,13 +6527,13 @@
       </p:sp>
       <p:sp>
         <p:nvSpPr>
-          <p:cNvPr id="51" name="!!c3_24"/>
-          <p:cNvSpPr txBox="1"/>
-          <p:nvPr/>
-        </p:nvSpPr>
-        <p:spPr>
-          <a:xfrm>
-            <a:off x="777240" y="5715000"/>
+          <p:cNvPr id="49" name="!!c3_24"/>
+          <p:cNvSpPr txBox="1"/>
+          <p:nvPr/>
+        </p:nvSpPr>
+        <p:spPr>
+          <a:xfrm>
+            <a:off x="777240" y="4846320"/>
             <a:ext cx="9418320" cy="365760"/>
           </a:xfrm>
           <a:prstGeom prst="rect">
@@ -6656,31 +6615,9 @@
           <a:chExt cx="0" cy="0"/>
         </a:xfrm>
       </p:grpSpPr>
-      <p:sp>
-        <p:nvSpPr>
-          <p:cNvPr id="2" name="veil"/>
-          <p:cNvSpPr/>
-          <p:nvPr/>
-        </p:nvSpPr>
-        <p:spPr>
-          <a:xfrm>
-            <a:off x="0" y="0"/>
-            <a:ext cx="12191695" cy="6858000"/>
-          </a:xfrm>
-          <a:prstGeom prst="rect">
-            <a:avLst/>
-          </a:prstGeom>
-          <a:solidFill>
-            <a:srgbClr val="140E0A">
-              <a:alpha val="30000"/>
-            </a:srgbClr>
-          </a:solidFill>
-          <a:ln/>
-        </p:spPr>
-      </p:sp>
       <p:pic>
         <p:nvPicPr>
-          <p:cNvPr id="3" name="!!shield" descr="img/shield.png">    </p:cNvPr>
+          <p:cNvPr id="2" name="shade" descr="img/shade.png">    </p:cNvPr>
           <p:cNvPicPr>
             <a:picLocks noChangeAspect="1"/>
           </p:cNvPicPr>
@@ -6694,7 +6631,31 @@
         </p:blipFill>
         <p:spPr>
           <a:xfrm>
-            <a:off x="777240" y="777240"/>
+            <a:off x="0" y="0"/>
+            <a:ext cx="12191695" cy="6858000"/>
+          </a:xfrm>
+          <a:prstGeom prst="rect">
+            <a:avLst/>
+          </a:prstGeom>
+        </p:spPr>
+      </p:pic>
+      <p:pic>
+        <p:nvPicPr>
+          <p:cNvPr id="3" name="!!shield" descr="img/shield.png">    </p:cNvPr>
+          <p:cNvPicPr>
+            <a:picLocks noChangeAspect="1"/>
+          </p:cNvPicPr>
+          <p:nvPr/>
+        </p:nvPicPr>
+        <p:blipFill>
+          <a:blip r:embed="rId3"/>
+          <a:stretch>
+            <a:fillRect/>
+          </a:stretch>
+        </p:blipFill>
+        <p:spPr>
+          <a:xfrm>
+            <a:off x="777240" y="411480"/>
             <a:ext cx="566928" cy="668975"/>
           </a:xfrm>
           <a:prstGeom prst="rect">
@@ -7560,7 +7521,7 @@
         </p:nvSpPr>
         <p:spPr>
           <a:xfrm>
-            <a:off x="-11871655" y="5715000"/>
+            <a:off x="-11871655" y="4846320"/>
             <a:ext cx="9418320" cy="365760"/>
           </a:xfrm>
           <a:prstGeom prst="rect">
@@ -7599,7 +7560,7 @@
         </p:nvSpPr>
         <p:spPr>
           <a:xfrm>
-            <a:off x="13563295" y="2286000"/>
+            <a:off x="13563295" y="1600200"/>
             <a:ext cx="10362895" cy="411480"/>
           </a:xfrm>
           <a:prstGeom prst="rect">
@@ -7638,7 +7599,7 @@
         </p:nvSpPr>
         <p:spPr>
           <a:xfrm>
-            <a:off x="13563295" y="2697480"/>
+            <a:off x="13563295" y="1965960"/>
             <a:ext cx="10362895" cy="1005840"/>
           </a:xfrm>
           <a:prstGeom prst="rect">
@@ -7677,7 +7638,7 @@
         </p:nvSpPr>
         <p:spPr>
           <a:xfrm>
-            <a:off x="14660575" y="3840480"/>
+            <a:off x="14660575" y="3063240"/>
             <a:ext cx="8168335" cy="868680"/>
           </a:xfrm>
           <a:prstGeom prst="rect">
@@ -7716,7 +7677,7 @@
         </p:nvSpPr>
         <p:spPr>
           <a:xfrm>
-            <a:off x="14020495" y="4892040"/>
+            <a:off x="14020495" y="4023360"/>
             <a:ext cx="9448495" cy="365760"/>
           </a:xfrm>
           <a:prstGeom prst="rect">
@@ -7755,7 +7716,7 @@
         </p:nvSpPr>
         <p:spPr>
           <a:xfrm>
-            <a:off x="14020495" y="5715000"/>
+            <a:off x="14020495" y="6172200"/>
             <a:ext cx="9448495" cy="365760"/>
           </a:xfrm>
           <a:prstGeom prst="rect">
@@ -7774,7 +7735,7 @@
             <a:r>
               <a:rPr lang="en-US" sz="1000" dirty="0">
                 <a:solidFill>
-                  <a:srgbClr val="BFAE8C"/>
+                  <a:srgbClr val="3A2A1E"/>
                 </a:solidFill>
                 <a:latin typeface="Cambria" pitchFamily="34" charset="0"/>
                 <a:ea typeface="Cambria" pitchFamily="34" charset="-122"/>
@@ -7794,7 +7755,7 @@
         </p:nvSpPr>
         <p:spPr>
           <a:xfrm>
-            <a:off x="777240" y="1828800"/>
+            <a:off x="777240" y="1417320"/>
             <a:ext cx="4572000" cy="320040"/>
           </a:xfrm>
           <a:prstGeom prst="rect">
@@ -7873,7 +7834,7 @@
           <p:nvPr/>
         </p:nvPicPr>
         <p:blipFill>
-          <a:blip r:embed="rId3"/>
+          <a:blip r:embed="rId4"/>
           <a:srcRect l="0" r="0" t="0" b="0"/>
           <a:stretch/>
         </p:blipFill>
@@ -8041,7 +8002,7 @@
         </p:nvSpPr>
         <p:spPr>
           <a:xfrm>
-            <a:off x="777240" y="2286000"/>
+            <a:off x="777240" y="1783080"/>
             <a:ext cx="5303520" cy="2103120"/>
           </a:xfrm>
           <a:prstGeom prst="rect">
@@ -8080,7 +8041,7 @@
         </p:nvSpPr>
         <p:spPr>
           <a:xfrm>
-            <a:off x="777240" y="4526280"/>
+            <a:off x="777240" y="3931920"/>
             <a:ext cx="5120640" cy="365760"/>
           </a:xfrm>
           <a:prstGeom prst="rect">
@@ -8162,75 +8123,9 @@
           <a:chExt cx="0" cy="0"/>
         </a:xfrm>
       </p:grpSpPr>
-      <p:sp>
-        <p:nvSpPr>
-          <p:cNvPr id="2" name="veil"/>
-          <p:cNvSpPr/>
-          <p:nvPr/>
-        </p:nvSpPr>
-        <p:spPr>
-          <a:xfrm>
-            <a:off x="0" y="0"/>
-            <a:ext cx="12191695" cy="6858000"/>
-          </a:xfrm>
-          <a:prstGeom prst="rect">
-            <a:avLst/>
-          </a:prstGeom>
-          <a:solidFill>
-            <a:srgbClr val="140E0A">
-              <a:alpha val="60000"/>
-            </a:srgbClr>
-          </a:solidFill>
-          <a:ln/>
-        </p:spPr>
-      </p:sp>
-      <p:sp>
-        <p:nvSpPr>
-          <p:cNvPr id="3" name="!!framea"/>
-          <p:cNvSpPr/>
-          <p:nvPr/>
-        </p:nvSpPr>
-        <p:spPr>
-          <a:xfrm>
-            <a:off x="320040" y="320040"/>
-            <a:ext cx="11551615" cy="6217920"/>
-          </a:xfrm>
-          <a:prstGeom prst="rect">
-            <a:avLst/>
-          </a:prstGeom>
-          <a:ln w="15875">
-            <a:solidFill>
-              <a:srgbClr val="C9A15A"/>
-            </a:solidFill>
-            <a:prstDash val="solid"/>
-          </a:ln>
-        </p:spPr>
-      </p:sp>
-      <p:sp>
-        <p:nvSpPr>
-          <p:cNvPr id="4" name="!!frameb"/>
-          <p:cNvSpPr/>
-          <p:nvPr/>
-        </p:nvSpPr>
-        <p:spPr>
-          <a:xfrm>
-            <a:off x="402336" y="402336"/>
-            <a:ext cx="11387023" cy="6053328"/>
-          </a:xfrm>
-          <a:prstGeom prst="rect">
-            <a:avLst/>
-          </a:prstGeom>
-          <a:ln w="6350">
-            <a:solidFill>
-              <a:srgbClr val="C9A15A"/>
-            </a:solidFill>
-            <a:prstDash val="solid"/>
-          </a:ln>
-        </p:spPr>
-      </p:sp>
       <p:pic>
         <p:nvPicPr>
-          <p:cNvPr id="5" name="!!shield" descr="img/shield.png">    </p:cNvPr>
+          <p:cNvPr id="2" name="shade" descr="img/shade.png">    </p:cNvPr>
           <p:cNvPicPr>
             <a:picLocks noChangeAspect="1"/>
           </p:cNvPicPr>
@@ -8244,8 +8139,8 @@
         </p:blipFill>
         <p:spPr>
           <a:xfrm>
-            <a:off x="5501488" y="685800"/>
-            <a:ext cx="1188720" cy="1402690"/>
+            <a:off x="0" y="0"/>
+            <a:ext cx="12191695" cy="6858000"/>
           </a:xfrm>
           <a:prstGeom prst="rect">
             <a:avLst/>
@@ -8254,13 +8149,81 @@
       </p:pic>
       <p:sp>
         <p:nvSpPr>
+          <p:cNvPr id="3" name="!!framea"/>
+          <p:cNvSpPr/>
+          <p:nvPr/>
+        </p:nvSpPr>
+        <p:spPr>
+          <a:xfrm>
+            <a:off x="320040" y="320040"/>
+            <a:ext cx="11551615" cy="6217920"/>
+          </a:xfrm>
+          <a:prstGeom prst="rect">
+            <a:avLst/>
+          </a:prstGeom>
+          <a:ln w="15875">
+            <a:solidFill>
+              <a:srgbClr val="C9A15A"/>
+            </a:solidFill>
+            <a:prstDash val="solid"/>
+          </a:ln>
+        </p:spPr>
+      </p:sp>
+      <p:sp>
+        <p:nvSpPr>
+          <p:cNvPr id="4" name="!!frameb"/>
+          <p:cNvSpPr/>
+          <p:nvPr/>
+        </p:nvSpPr>
+        <p:spPr>
+          <a:xfrm>
+            <a:off x="402336" y="402336"/>
+            <a:ext cx="11387023" cy="6053328"/>
+          </a:xfrm>
+          <a:prstGeom prst="rect">
+            <a:avLst/>
+          </a:prstGeom>
+          <a:ln w="6350">
+            <a:solidFill>
+              <a:srgbClr val="C9A15A"/>
+            </a:solidFill>
+            <a:prstDash val="solid"/>
+          </a:ln>
+        </p:spPr>
+      </p:sp>
+      <p:pic>
+        <p:nvPicPr>
+          <p:cNvPr id="5" name="!!shield" descr="img/shield.png">    </p:cNvPr>
+          <p:cNvPicPr>
+            <a:picLocks noChangeAspect="1"/>
+          </p:cNvPicPr>
+          <p:nvPr/>
+        </p:nvPicPr>
+        <p:blipFill>
+          <a:blip r:embed="rId3"/>
+          <a:stretch>
+            <a:fillRect/>
+          </a:stretch>
+        </p:blipFill>
+        <p:spPr>
+          <a:xfrm>
+            <a:off x="5638648" y="411480"/>
+            <a:ext cx="914400" cy="1078992"/>
+          </a:xfrm>
+          <a:prstGeom prst="rect">
+            <a:avLst/>
+          </a:prstGeom>
+        </p:spPr>
+      </p:pic>
+      <p:sp>
+        <p:nvSpPr>
           <p:cNvPr id="6" name="!!c4_0"/>
           <p:cNvSpPr txBox="1"/>
           <p:nvPr/>
         </p:nvSpPr>
         <p:spPr>
           <a:xfrm>
-            <a:off x="-11871655" y="1828800"/>
+            <a:off x="-11871655" y="1417320"/>
             <a:ext cx="4572000" cy="320040"/>
           </a:xfrm>
           <a:prstGeom prst="rect">
@@ -8339,7 +8302,7 @@
           <p:nvPr/>
         </p:nvPicPr>
         <p:blipFill>
-          <a:blip r:embed="rId3"/>
+          <a:blip r:embed="rId4"/>
           <a:srcRect l="0" r="0" t="0" b="0"/>
           <a:stretch/>
         </p:blipFill>
@@ -8507,7 +8470,7 @@
         </p:nvSpPr>
         <p:spPr>
           <a:xfrm>
-            <a:off x="-11871655" y="2286000"/>
+            <a:off x="-11871655" y="1783080"/>
             <a:ext cx="5303520" cy="2103120"/>
           </a:xfrm>
           <a:prstGeom prst="rect">
@@ -8546,7 +8509,7 @@
         </p:nvSpPr>
         <p:spPr>
           <a:xfrm>
-            <a:off x="-11871655" y="4526280"/>
+            <a:off x="-11871655" y="3931920"/>
             <a:ext cx="5120640" cy="365760"/>
           </a:xfrm>
           <a:prstGeom prst="rect">
@@ -8585,7 +8548,7 @@
         </p:nvSpPr>
         <p:spPr>
           <a:xfrm>
-            <a:off x="914400" y="2286000"/>
+            <a:off x="914400" y="1600200"/>
             <a:ext cx="10362895" cy="411480"/>
           </a:xfrm>
           <a:prstGeom prst="rect">
@@ -8624,7 +8587,7 @@
         </p:nvSpPr>
         <p:spPr>
           <a:xfrm>
-            <a:off x="914400" y="2697480"/>
+            <a:off x="914400" y="1965960"/>
             <a:ext cx="10362895" cy="1005840"/>
           </a:xfrm>
           <a:prstGeom prst="rect">
@@ -8663,7 +8626,7 @@
         </p:nvSpPr>
         <p:spPr>
           <a:xfrm>
-            <a:off x="2011680" y="3840480"/>
+            <a:off x="2011680" y="3063240"/>
             <a:ext cx="8168335" cy="868680"/>
           </a:xfrm>
           <a:prstGeom prst="rect">
@@ -8702,7 +8665,7 @@
         </p:nvSpPr>
         <p:spPr>
           <a:xfrm>
-            <a:off x="1371600" y="4892040"/>
+            <a:off x="1371600" y="4023360"/>
             <a:ext cx="9448495" cy="365760"/>
           </a:xfrm>
           <a:prstGeom prst="rect">
@@ -8741,7 +8704,7 @@
         </p:nvSpPr>
         <p:spPr>
           <a:xfrm>
-            <a:off x="1371600" y="5715000"/>
+            <a:off x="1371600" y="6172200"/>
             <a:ext cx="9448495" cy="365760"/>
           </a:xfrm>
           <a:prstGeom prst="rect">
@@ -8760,7 +8723,7 @@
             <a:r>
               <a:rPr lang="en-US" sz="1000" dirty="0">
                 <a:solidFill>
-                  <a:srgbClr val="BFAE8C"/>
+                  <a:srgbClr val="3A2A1E"/>
                 </a:solidFill>
                 <a:latin typeface="Cambria" pitchFamily="34" charset="0"/>
                 <a:ea typeface="Cambria" pitchFamily="34" charset="-122"/>

</xml_diff>

<commit_message>
Retarget deck to Switzerland in the early 18th century
Co-Authored-By: Claude Opus 5.5 <noreply@anthropic.com>
Claude-Session: https://claude.ai/code/session_01ETjVcpBAzS2WJAYjtqxef9
</commit_message>
<xml_diff>
--- a/presentation/Helvetia.pptx
+++ b/presentation/Helvetia.pptx
@@ -507,7 +507,7 @@
           <a:p>
             <a:r>
               <a:rPr lang="en-US" dirty="0"/>
-              <a:t>Здравствуйте! Тема моего проекта — «Швейцария до XVIII века». Сегодня Швейцарию знают по часам, сыру, банкам и тому, что она не участвует в войнах. Но как маленькая горная страна без моря и без короля смогла стать независимой среди больших империй? Официальное название страны по-латыни — Confoederatio Helvetica, то есть Гельветическая конфедерация: в древности здесь жило кельтское племя гельветов. Я расскажу, как появился швейцарский союз, на чём держалась его сила и как к 1648 году его независимость признала вся Европа.</a:t>
+              <a:t>Здравствуйте! Тема моего проекта — «Швейцария в начале XVIII века». Это время, когда по Европе шли большие войны: за испанское наследство, Северная война. Швейцария была маленьким союзом горных кантонов без короля и общей армии. Я расскажу, как она была устроена, чем жили её люди, какие события произошли в начале века и почему Швейцария смогла остаться в стороне от войн.</a:t>
             </a:r>
             <a:endParaRPr lang="en-US" dirty="0"/>
           </a:p>
@@ -595,7 +595,7 @@
           <a:p>
             <a:r>
               <a:rPr lang="en-US" dirty="0"/>
-              <a:t>В конце XIII века горные долины у Фирвальдштетского озера — Ури, Швиц и Унтервальден — пытались подчинить австрийские Габсбурги. Через эти земли шла важная торговая дорога через перевал Сен-Готард из Германии в Италию. В начале августа 1291 года жители трёх долин заключили «Вечный союз»: они пообещали помогать друг другу против любого врага и не признавать чужих судей. Поэтому 1 августа сегодня — национальный праздник Швейцарии. С этим временем связана легенда о Вильгельме Телле — стрелке, которого жестокий наместник Гесслер заставил сбить стрелой яблоко с головы собственного сына. Телль справился, а потом отомстил наместнику. Историки считают Телля легендарным героем, но он стал символом борьбы швейцарцев за свободу. А само название страны произошло от кантона Швиц.</a:t>
+              <a:t>К 1700 году Швейцария — это союз тринадцати кантонов: Ури, Швиц, Унтервальден, Люцерн, Цюрих, Гларус, Цуг, Берн, Фрибур, Золотурн, Базель, Шаффхаузен и Аппенцелль. Общего правительства и столицы не было. Общие дела обсуждал сейм — съезд послов от кантонов, а решения каждый кантон мог принять или не принять. Рядом с кантонами были их союзники — Женева, Граубюнден, Вале, Невшатель. А ещё были подвластные земли, например Тургау или земли на юге, в Тичино: ими кантоны управляли сообща и присылали туда своих наместников.</a:t>
             </a:r>
             <a:endParaRPr lang="en-US" dirty="0"/>
           </a:p>
@@ -683,7 +683,7 @@
           <a:p>
             <a:r>
               <a:rPr lang="en-US" dirty="0"/>
-              <a:t>Почему союз выжил? Я выделяю три причины. Первая — свобода общин. В кантонах не было короля: важные вопросы решало ландсгемайнде — собрание всех свободных мужчин кантона под открытым небом, где голосовали поднятием руки. Такие собрания до сих пор проходят в кантонах Гларус и Аппенцелль-Иннерроден. Вторая — сильная армия. Швейцарская пехота с длинными пиками и алебардами научилась побеждать рыцарскую конницу. Швейцарцев охотно нанимали короли и папы, а с 1506 года папу римского охраняет Швейцарская гвардия — она служит в Ватикане и сегодня. Третья — вера и ремесло. В XVI веке в Цюрихе Реформацию начал Ульрих Цвингли, а Женева при Жане Кальвине стала «протестантским Римом». Кальвинисты ценили труд и бережливость, а строгие законы против роскоши заставили женевских ювелиров перейти к изготовлению часов — так началась слава швейцарских часов.</a:t>
+              <a:t>Чем жила страна? Первое — наёмная служба. Швейцарские полки служили Франции, Голландии, Испании и другим странам. Деньги, которые получали солдаты и их командиры, кормили многие горные деревни. Второе — ремесло. В деревнях вокруг Цюриха крестьяне дома пряли хлопок и ткали ткани для городских купцов. В Женеве и в горах Юры делали часы; на рубеже XVII и XVIII веков часовое дело в Юре начал развивать мастер Даниэль Жанришар. Третье — власть патрициев. В Берне, Люцерне и других городах правили немногие знатные семьи. В Берне их называли «милостивые господа». Крестьяне и жители подвластных земель права голоса не имели.</a:t>
             </a:r>
             <a:endParaRPr lang="en-US" dirty="0"/>
           </a:p>
@@ -771,7 +771,7 @@
           <a:p>
             <a:r>
               <a:rPr lang="en-US" dirty="0"/>
-              <a:t>Пройдём по главным датам. 1291 год — «Вечный союз» трёх лесных кантонов. 1315 год — битва при Моргартене: крестьяне-ополченцы устроили засаду в горном проходе, сбрасывали на рыцарей герцога Леопольда Австрийского камни и брёвна и разгромили их. Это первая большая победа конфедератов. 1476 год — победы при Грансоне и Муртене над герцогом Бургундии Карлом Смелым, одним из самых богатых правителей Европы; в 1477 году он погиб в битве при Нанси. После этого швейцарскую пехоту стали считать лучшей в Европе. 1515 год — поражение при Мариньяно от французского короля Франциска I. Швейцарцы поняли, что большие завоевательные войны им не по силам, и постепенно перешли к политике нейтралитета. И наконец, 1648 год: по Вестфальскому миру, завершившему Тридцатилетнюю войну, независимость Швейцарии от Священной Римской империи признали официально. На деле империи она не подчинялась уже с 1499 года — после Швабской войны.</a:t>
+              <a:t>Теперь главные события начала века. С 1701 года шла война за испанское наследство, но Швейцарский союз в ней не участвовал и сохранил нейтралитет. В 1707 году княжество Невшатель выбрало своим правителем короля Пруссии. В 1709 году в битве при Мальплаке швейцарские полки на французской и на голландской службе сражались друг против друга — это показывает, как необычно жила страна наёмников. В 1712 году между кантонами вспыхнула война из-за веры: протестанты Цюриха и Берна разбили католические кантоны при Вильмергене и стали сильнейшими в союзе. А в 1723 году майор Давель поднял в земле Во восстание против власти Берна; восстание не удалось, и Давеля казнили.</a:t>
             </a:r>
             <a:endParaRPr lang="en-US" dirty="0"/>
           </a:p>
@@ -859,7 +859,7 @@
           <a:p>
             <a:r>
               <a:rPr lang="en-US" dirty="0"/>
-              <a:t>К 1513 году союз вырос до тринадцати кантонов: Ури, Швиц, Унтервальден, Люцерн, Цюрих, Гларус, Цуг, Берн, Фрибур, Золотурн, Базель, Шаффхаузен и Аппенцелль. Союз тринадцати кантонов просуществовал почти триста лет — до 1798 года. У каждого кантона были свои законы и своё правительство, а общие дела обсуждали послы кантонов на общем собрании — сейме, по-немецки Tagsatzung. Итальянский мыслитель Никколо Макиавелли в книге «Государь» (1513) писал: «Швейцарцы превосходно вооружены и пользуются полной свободой». Эти слова хорошо объясняют, почему соседям было так трудно покорить Швейцарию.</a:t>
+              <a:t>Начало XVIII века — время швейцарских учёных. В Базеле жила знаменитая семья математиков Бернулли. В 1707 году в Базеле родился Леонард Эйлер, ученик Иоганна Бернулли. С 1727 года он работал в Петербургской академии наук и большую часть жизни провёл в России. В 1708 году в Берне родился учёный и поэт Альбрехт фон Галлер, а в 1712 году в Женеве — философ Жан-Жак Руссо. Так маленькая страна дала Европе великих мыслителей.</a:t>
             </a:r>
             <a:endParaRPr lang="en-US" dirty="0"/>
           </a:p>
@@ -947,7 +947,7 @@
           <a:p>
             <a:r>
               <a:rPr lang="en-US" dirty="0"/>
-              <a:t>Подведём итог. Швейцария до XVIII века — это союз небольших горных общин, которые объединились, чтобы защищать свою свободу. Её силу составляли самоуправление, отличная пехота, а затем — трудолюбие и ремесло, которые укрепила Реформация. Пройдя путь от «Вечного союза» 1291 года до признания независимости в 1648 году, Швейцария показала, что маленькая страна может отстоять себя рядом с великими державами. Спасибо за внимание! Готов(а) ответить на ваши вопросы.</a:t>
+              <a:t>Подведём итог. В начале XVIII века Швейцария оставалась нейтральной, хотя вокруг шли большие войны, а её солдаты служили чужим армиям. Внутри страны были споры из-за веры и власти — как Вильмергенская война и восстание Давеля. Богатела Швейцария ремеслом, торговлей и наёмной службой, а её учёные, как Эйлер, прославились на всю Европу. Спасибо за внимание! Готов(а) ответить на ваши вопросы.</a:t>
             </a:r>
             <a:endParaRPr lang="en-US" dirty="0"/>
           </a:p>
@@ -1450,7 +1450,7 @@
                 <a:ea typeface="Cambria" pitchFamily="34" charset="-122"/>
                 <a:cs typeface="Cambria" pitchFamily="34" charset="-120"/>
               </a:rPr>
-              <a:t>Фирвальдштетское озеро — колыбель союза (иллюстрация)</a:t>
+              <a:t>Горное озеро в сердце Швейцарии (иллюстрация)</a:t>
             </a:r>
             <a:endParaRPr lang="en-US" sz="1000" dirty="0"/>
           </a:p>
@@ -1489,7 +1489,7 @@
                 <a:ea typeface="Bookman Old Style" pitchFamily="34" charset="-122"/>
                 <a:cs typeface="Bookman Old Style" pitchFamily="34" charset="-120"/>
               </a:rPr>
-              <a:t>CAPUT  I  ·  1291</a:t>
+              <a:t>CAPUT  I  ·  1700</a:t>
             </a:r>
             <a:endParaRPr lang="en-US" sz="1300" dirty="0"/>
           </a:p>
@@ -1528,7 +1528,7 @@
                 <a:ea typeface="Bookman Old Style" pitchFamily="34" charset="-122"/>
                 <a:cs typeface="Bookman Old Style" pitchFamily="34" charset="-120"/>
               </a:rPr>
-              <a:t>Как всё началось</a:t>
+              <a:t>Каким был союз</a:t>
             </a:r>
             <a:endParaRPr lang="en-US" sz="3200" dirty="0"/>
           </a:p>
@@ -1606,7 +1606,7 @@
                 <a:ea typeface="Bookman Old Style" pitchFamily="34" charset="-122"/>
                 <a:cs typeface="Bookman Old Style" pitchFamily="34" charset="-120"/>
               </a:rPr>
-              <a:t>В</a:t>
+              <a:t>К</a:t>
             </a:r>
             <a:endParaRPr lang="en-US" sz="6600" dirty="0"/>
           </a:p>
@@ -1648,7 +1648,7 @@
                 <a:ea typeface="Cambria" pitchFamily="34" charset="-122"/>
                 <a:cs typeface="Cambria" pitchFamily="34" charset="-120"/>
               </a:rPr>
-              <a:t>1291 году три горные долины — Ури, Швиц и Унтервальден — заключили «Вечный союз» против власти Габсбургов.</a:t>
+              <a:t>1700 году Швейцарию составляли 13 кантонов. Общего правительства не было: дела решал сейм — съезд послов кантонов.</a:t>
             </a:r>
             <a:endParaRPr lang="en-US" sz="1500" dirty="0"/>
           </a:p>
@@ -1690,7 +1690,7 @@
                 <a:ea typeface="Cambria" pitchFamily="34" charset="-122"/>
                 <a:cs typeface="Cambria" pitchFamily="34" charset="-120"/>
               </a:rPr>
-              <a:t>Через их земли шёл путь через перевал Сен-Готард в Италию. От кантона Швиц пошло название всей страны.</a:t>
+              <a:t>Рядом были союзники — Женева, Граубюнден, Вале, Невшатель — и подвластные земли, которыми кантоны управляли сообща.</a:t>
             </a:r>
             <a:endParaRPr lang="en-US" sz="1500" dirty="0"/>
           </a:p>
@@ -1729,7 +1729,7 @@
                 <a:ea typeface="Cambria" pitchFamily="34" charset="-122"/>
                 <a:cs typeface="Cambria" pitchFamily="34" charset="-120"/>
               </a:rPr>
-              <a:t>Символ этой борьбы — легендарный стрелок Вильгельм Телль.</a:t>
+              <a:t>Каждый кантон жил по своим законам и сам решал, с кем дружить.</a:t>
             </a:r>
             <a:endParaRPr lang="en-US" sz="1600" dirty="0"/>
           </a:p>
@@ -1768,7 +1768,7 @@
                 <a:ea typeface="Bookman Old Style" pitchFamily="34" charset="-122"/>
                 <a:cs typeface="Bookman Old Style" pitchFamily="34" charset="-120"/>
               </a:rPr>
-              <a:t>CONFOEDERATIO  HELVETICA  ·  MCCXCI — MDCXLVIII</a:t>
+              <a:t>CONFOEDERATIO  HELVETICA  ·  MDCC — MDCCXXX</a:t>
             </a:r>
             <a:endParaRPr lang="en-US" sz="1300" dirty="0"/>
           </a:p>
@@ -1782,8 +1782,8 @@
         </p:nvSpPr>
         <p:spPr>
           <a:xfrm>
-            <a:off x="914400" y="2606040"/>
-            <a:ext cx="10362895" cy="1188720"/>
+            <a:off x="640080" y="2651760"/>
+            <a:ext cx="10911535" cy="1097280"/>
           </a:xfrm>
           <a:prstGeom prst="rect">
             <a:avLst/>
@@ -1799,7 +1799,7 @@
               <a:buNone/>
             </a:pPr>
             <a:r>
-              <a:rPr lang="en-US" sz="5200" b="1" dirty="0">
+              <a:rPr lang="en-US" sz="4400" b="1" dirty="0">
                 <a:solidFill>
                   <a:srgbClr val="F1E6CF"/>
                 </a:solidFill>
@@ -1807,9 +1807,9 @@
                 <a:ea typeface="Bookman Old Style" pitchFamily="34" charset="-122"/>
                 <a:cs typeface="Bookman Old Style" pitchFamily="34" charset="-120"/>
               </a:rPr>
-              <a:t>Швейцария до XVIII века</a:t>
-            </a:r>
-            <a:endParaRPr lang="en-US" sz="5200" dirty="0"/>
+              <a:t>Швейцария в начале XVIII века</a:t>
+            </a:r>
+            <a:endParaRPr lang="en-US" sz="4400" dirty="0"/>
           </a:p>
         </p:txBody>
       </p:sp>
@@ -1846,7 +1846,7 @@
                 <a:ea typeface="Cambria" pitchFamily="34" charset="-122"/>
                 <a:cs typeface="Cambria" pitchFamily="34" charset="-120"/>
               </a:rPr>
-              <a:t>Как горные общины создали союз, который не смогла покорить ни одна империя</a:t>
+              <a:t>Союз тринадцати кантонов среди больших войн Европы</a:t>
             </a:r>
             <a:endParaRPr lang="en-US" sz="2100" dirty="0"/>
           </a:p>
@@ -2042,7 +2042,7 @@
                 <a:ea typeface="Bookman Old Style" pitchFamily="34" charset="-122"/>
                 <a:cs typeface="Bookman Old Style" pitchFamily="34" charset="-120"/>
               </a:rPr>
-              <a:t>CONFOEDERATIO  HELVETICA  ·  MCCXCI — MDCXLVIII</a:t>
+              <a:t>CONFOEDERATIO  HELVETICA  ·  MDCC — MDCCXXX</a:t>
             </a:r>
             <a:endParaRPr lang="en-US" sz="1300" dirty="0"/>
           </a:p>
@@ -2056,8 +2056,8 @@
         </p:nvSpPr>
         <p:spPr>
           <a:xfrm>
-            <a:off x="-11734495" y="2606040"/>
-            <a:ext cx="10362895" cy="1188720"/>
+            <a:off x="-12008815" y="2651760"/>
+            <a:ext cx="10911535" cy="1097280"/>
           </a:xfrm>
           <a:prstGeom prst="rect">
             <a:avLst/>
@@ -2073,7 +2073,7 @@
               <a:buNone/>
             </a:pPr>
             <a:r>
-              <a:rPr lang="en-US" sz="5200" b="1" dirty="0">
+              <a:rPr lang="en-US" sz="4400" b="1" dirty="0">
                 <a:solidFill>
                   <a:srgbClr val="F1E6CF"/>
                 </a:solidFill>
@@ -2081,9 +2081,9 @@
                 <a:ea typeface="Bookman Old Style" pitchFamily="34" charset="-122"/>
                 <a:cs typeface="Bookman Old Style" pitchFamily="34" charset="-120"/>
               </a:rPr>
-              <a:t>Швейцария до XVIII века</a:t>
-            </a:r>
-            <a:endParaRPr lang="en-US" sz="5200" dirty="0"/>
+              <a:t>Швейцария в начале XVIII века</a:t>
+            </a:r>
+            <a:endParaRPr lang="en-US" sz="4400" dirty="0"/>
           </a:p>
         </p:txBody>
       </p:sp>
@@ -2120,7 +2120,7 @@
                 <a:ea typeface="Cambria" pitchFamily="34" charset="-122"/>
                 <a:cs typeface="Cambria" pitchFamily="34" charset="-120"/>
               </a:rPr>
-              <a:t>Как горные общины создали союз, который не смогла покорить ни одна империя</a:t>
+              <a:t>Союз тринадцати кантонов среди больших войн Европы</a:t>
             </a:r>
             <a:endParaRPr lang="en-US" sz="2100" dirty="0"/>
           </a:p>
@@ -2237,7 +2237,7 @@
                 <a:ea typeface="Bookman Old Style" pitchFamily="34" charset="-122"/>
                 <a:cs typeface="Bookman Old Style" pitchFamily="34" charset="-120"/>
               </a:rPr>
-              <a:t>Три опоры Швейцарии</a:t>
+              <a:t>Чем жила страна</a:t>
             </a:r>
             <a:endParaRPr lang="en-US" sz="3600" dirty="0"/>
           </a:p>
@@ -2354,7 +2354,7 @@
                 <a:ea typeface="Bookman Old Style" pitchFamily="34" charset="-122"/>
                 <a:cs typeface="Bookman Old Style" pitchFamily="34" charset="-120"/>
               </a:rPr>
-              <a:t>Свобода общин</a:t>
+              <a:t>Наёмная служба</a:t>
             </a:r>
             <a:endParaRPr lang="en-US" sz="1900" dirty="0"/>
           </a:p>
@@ -2396,7 +2396,7 @@
                 <a:ea typeface="Cambria" pitchFamily="34" charset="-122"/>
                 <a:cs typeface="Cambria" pitchFamily="34" charset="-120"/>
               </a:rPr>
-              <a:t>Вместо короля — ландсгемайнде: собрание всех свободных мужчин кантона, голосование поднятием руки.</a:t>
+              <a:t>Швейцарские полки служили Франции, Голландии и другим державам. Плата солдатам кормила многие деревни.</a:t>
             </a:r>
             <a:endParaRPr lang="en-US" sz="1400" dirty="0"/>
           </a:p>
@@ -2474,7 +2474,7 @@
                 <a:ea typeface="Bookman Old Style" pitchFamily="34" charset="-122"/>
                 <a:cs typeface="Bookman Old Style" pitchFamily="34" charset="-120"/>
               </a:rPr>
-              <a:t>Сильная пехота</a:t>
+              <a:t>Ремесло и часы</a:t>
             </a:r>
             <a:endParaRPr lang="en-US" sz="1900" dirty="0"/>
           </a:p>
@@ -2516,7 +2516,7 @@
                 <a:ea typeface="Cambria" pitchFamily="34" charset="-122"/>
                 <a:cs typeface="Cambria" pitchFamily="34" charset="-120"/>
               </a:rPr>
-              <a:t>Пики и алебарды против рыцарской конницы. С 1506 года папу римского охраняет Швейцарская гвардия.</a:t>
+              <a:t>Крестьяне у Цюриха пряли хлопок для купцов. В Женеве и горах Юры делали часы.</a:t>
             </a:r>
             <a:endParaRPr lang="en-US" sz="1400" dirty="0"/>
           </a:p>
@@ -2594,7 +2594,7 @@
                 <a:ea typeface="Bookman Old Style" pitchFamily="34" charset="-122"/>
                 <a:cs typeface="Bookman Old Style" pitchFamily="34" charset="-120"/>
               </a:rPr>
-              <a:t>Вера и ремесло</a:t>
+              <a:t>Власть патрициев</a:t>
             </a:r>
             <a:endParaRPr lang="en-US" sz="1900" dirty="0"/>
           </a:p>
@@ -2636,7 +2636,7 @@
                 <a:ea typeface="Cambria" pitchFamily="34" charset="-122"/>
                 <a:cs typeface="Cambria" pitchFamily="34" charset="-120"/>
               </a:rPr>
-              <a:t>Реформация Цвингли в Цюрихе и Кальвина в Женеве. Женевские ювелиры стали часовщиками.</a:t>
+              <a:t>Городами правили немногие знатные семьи. Крестьяне и подвластные земли права голоса не имели.</a:t>
             </a:r>
             <a:endParaRPr lang="en-US" sz="1400" dirty="0"/>
           </a:p>
@@ -2675,7 +2675,7 @@
                 <a:ea typeface="Cambria" pitchFamily="34" charset="-122"/>
                 <a:cs typeface="Cambria" pitchFamily="34" charset="-120"/>
               </a:rPr>
-              <a:t>Фирвальдштетское озеро — колыбель союза (иллюстрация)</a:t>
+              <a:t>Горное озеро в сердце Швейцарии (иллюстрация)</a:t>
             </a:r>
             <a:endParaRPr lang="en-US" sz="1000" dirty="0"/>
           </a:p>
@@ -2714,7 +2714,7 @@
                 <a:ea typeface="Bookman Old Style" pitchFamily="34" charset="-122"/>
                 <a:cs typeface="Bookman Old Style" pitchFamily="34" charset="-120"/>
               </a:rPr>
-              <a:t>CAPUT  I  ·  1291</a:t>
+              <a:t>CAPUT  I  ·  1700</a:t>
             </a:r>
             <a:endParaRPr lang="en-US" sz="1300" dirty="0"/>
           </a:p>
@@ -2753,7 +2753,7 @@
                 <a:ea typeface="Bookman Old Style" pitchFamily="34" charset="-122"/>
                 <a:cs typeface="Bookman Old Style" pitchFamily="34" charset="-120"/>
               </a:rPr>
-              <a:t>Как всё началось</a:t>
+              <a:t>Каким был союз</a:t>
             </a:r>
             <a:endParaRPr lang="en-US" sz="3200" dirty="0"/>
           </a:p>
@@ -2831,7 +2831,7 @@
                 <a:ea typeface="Bookman Old Style" pitchFamily="34" charset="-122"/>
                 <a:cs typeface="Bookman Old Style" pitchFamily="34" charset="-120"/>
               </a:rPr>
-              <a:t>В</a:t>
+              <a:t>К</a:t>
             </a:r>
             <a:endParaRPr lang="en-US" sz="6600" dirty="0"/>
           </a:p>
@@ -2873,7 +2873,7 @@
                 <a:ea typeface="Cambria" pitchFamily="34" charset="-122"/>
                 <a:cs typeface="Cambria" pitchFamily="34" charset="-120"/>
               </a:rPr>
-              <a:t>1291 году три горные долины — Ури, Швиц и Унтервальден — заключили «Вечный союз» против власти Габсбургов.</a:t>
+              <a:t>1700 году Швейцарию составляли 13 кантонов. Общего правительства не было: дела решал сейм — съезд послов кантонов.</a:t>
             </a:r>
             <a:endParaRPr lang="en-US" sz="1500" dirty="0"/>
           </a:p>
@@ -2915,7 +2915,7 @@
                 <a:ea typeface="Cambria" pitchFamily="34" charset="-122"/>
                 <a:cs typeface="Cambria" pitchFamily="34" charset="-120"/>
               </a:rPr>
-              <a:t>Через их земли шёл путь через перевал Сен-Готард в Италию. От кантона Швиц пошло название всей страны.</a:t>
+              <a:t>Рядом были союзники — Женева, Граубюнден, Вале, Невшатель — и подвластные земли, которыми кантоны управляли сообща.</a:t>
             </a:r>
             <a:endParaRPr lang="en-US" sz="1500" dirty="0"/>
           </a:p>
@@ -2954,7 +2954,7 @@
                 <a:ea typeface="Cambria" pitchFamily="34" charset="-122"/>
                 <a:cs typeface="Cambria" pitchFamily="34" charset="-120"/>
               </a:rPr>
-              <a:t>Символ этой борьбы — легендарный стрелок Вильгельм Телль.</a:t>
+              <a:t>Каждый кантон жил по своим законам и сам решал, с кем дружить.</a:t>
             </a:r>
             <a:endParaRPr lang="en-US" sz="1600" dirty="0"/>
           </a:p>
@@ -3123,7 +3123,7 @@
                 <a:ea typeface="Cambria" pitchFamily="34" charset="-122"/>
                 <a:cs typeface="Cambria" pitchFamily="34" charset="-120"/>
               </a:rPr>
-              <a:t>Фирвальдштетское озеро — колыбель союза (иллюстрация)</a:t>
+              <a:t>Горное озеро в сердце Швейцарии (иллюстрация)</a:t>
             </a:r>
             <a:endParaRPr lang="en-US" sz="1000" dirty="0"/>
           </a:p>
@@ -3162,7 +3162,7 @@
                 <a:ea typeface="Bookman Old Style" pitchFamily="34" charset="-122"/>
                 <a:cs typeface="Bookman Old Style" pitchFamily="34" charset="-120"/>
               </a:rPr>
-              <a:t>CAPUT  I  ·  1291</a:t>
+              <a:t>CAPUT  I  ·  1700</a:t>
             </a:r>
             <a:endParaRPr lang="en-US" sz="1300" dirty="0"/>
           </a:p>
@@ -3201,7 +3201,7 @@
                 <a:ea typeface="Bookman Old Style" pitchFamily="34" charset="-122"/>
                 <a:cs typeface="Bookman Old Style" pitchFamily="34" charset="-120"/>
               </a:rPr>
-              <a:t>Как всё началось</a:t>
+              <a:t>Каким был союз</a:t>
             </a:r>
             <a:endParaRPr lang="en-US" sz="3200" dirty="0"/>
           </a:p>
@@ -3279,7 +3279,7 @@
                 <a:ea typeface="Bookman Old Style" pitchFamily="34" charset="-122"/>
                 <a:cs typeface="Bookman Old Style" pitchFamily="34" charset="-120"/>
               </a:rPr>
-              <a:t>В</a:t>
+              <a:t>К</a:t>
             </a:r>
             <a:endParaRPr lang="en-US" sz="6600" dirty="0"/>
           </a:p>
@@ -3321,7 +3321,7 @@
                 <a:ea typeface="Cambria" pitchFamily="34" charset="-122"/>
                 <a:cs typeface="Cambria" pitchFamily="34" charset="-120"/>
               </a:rPr>
-              <a:t>1291 году три горные долины — Ури, Швиц и Унтервальден — заключили «Вечный союз» против власти Габсбургов.</a:t>
+              <a:t>1700 году Швейцарию составляли 13 кантонов. Общего правительства не было: дела решал сейм — съезд послов кантонов.</a:t>
             </a:r>
             <a:endParaRPr lang="en-US" sz="1500" dirty="0"/>
           </a:p>
@@ -3363,7 +3363,7 @@
                 <a:ea typeface="Cambria" pitchFamily="34" charset="-122"/>
                 <a:cs typeface="Cambria" pitchFamily="34" charset="-120"/>
               </a:rPr>
-              <a:t>Через их земли шёл путь через перевал Сен-Готард в Италию. От кантона Швиц пошло название всей страны.</a:t>
+              <a:t>Рядом были союзники — Женева, Граубюнден, Вале, Невшатель — и подвластные земли, которыми кантоны управляли сообща.</a:t>
             </a:r>
             <a:endParaRPr lang="en-US" sz="1500" dirty="0"/>
           </a:p>
@@ -3402,7 +3402,7 @@
                 <a:ea typeface="Cambria" pitchFamily="34" charset="-122"/>
                 <a:cs typeface="Cambria" pitchFamily="34" charset="-120"/>
               </a:rPr>
-              <a:t>Символ этой борьбы — легендарный стрелок Вильгельм Телль.</a:t>
+              <a:t>Каждый кантон жил по своим законам и сам решал, с кем дружить.</a:t>
             </a:r>
             <a:endParaRPr lang="en-US" sz="1600" dirty="0"/>
           </a:p>
@@ -3480,7 +3480,7 @@
                 <a:ea typeface="Bookman Old Style" pitchFamily="34" charset="-122"/>
                 <a:cs typeface="Bookman Old Style" pitchFamily="34" charset="-120"/>
               </a:rPr>
-              <a:t>Хроника свободы</a:t>
+              <a:t>Хроника начала века</a:t>
             </a:r>
             <a:endParaRPr lang="en-US" sz="4000" dirty="0"/>
           </a:p>
@@ -3606,7 +3606,7 @@
                 <a:ea typeface="Bookman Old Style" pitchFamily="34" charset="-122"/>
                 <a:cs typeface="Bookman Old Style" pitchFamily="34" charset="-120"/>
               </a:rPr>
-              <a:t>1291</a:t>
+              <a:t>1701</a:t>
             </a:r>
             <a:endParaRPr lang="en-US" sz="3400" dirty="0"/>
           </a:p>
@@ -3645,7 +3645,7 @@
                 <a:ea typeface="Bookman Old Style" pitchFamily="34" charset="-122"/>
                 <a:cs typeface="Bookman Old Style" pitchFamily="34" charset="-120"/>
               </a:rPr>
-              <a:t>Вечный союз</a:t>
+              <a:t>Нейтралитет</a:t>
             </a:r>
             <a:endParaRPr lang="en-US" sz="1400" dirty="0"/>
           </a:p>
@@ -3684,7 +3684,7 @@
                 <a:ea typeface="Cambria" pitchFamily="34" charset="-122"/>
                 <a:cs typeface="Cambria" pitchFamily="34" charset="-120"/>
               </a:rPr>
-              <a:t>Ури, Швиц и Унтервальден объединяются</a:t>
+              <a:t>В войне за испанское наследство союз не воюет</a:t>
             </a:r>
             <a:endParaRPr lang="en-US" sz="1300" dirty="0"/>
           </a:p>
@@ -3748,7 +3748,7 @@
                 <a:ea typeface="Bookman Old Style" pitchFamily="34" charset="-122"/>
                 <a:cs typeface="Bookman Old Style" pitchFamily="34" charset="-120"/>
               </a:rPr>
-              <a:t>1315</a:t>
+              <a:t>1707</a:t>
             </a:r>
             <a:endParaRPr lang="en-US" sz="3400" dirty="0"/>
           </a:p>
@@ -3787,7 +3787,7 @@
                 <a:ea typeface="Bookman Old Style" pitchFamily="34" charset="-122"/>
                 <a:cs typeface="Bookman Old Style" pitchFamily="34" charset="-120"/>
               </a:rPr>
-              <a:t>Моргартен</a:t>
+              <a:t>Невшатель</a:t>
             </a:r>
             <a:endParaRPr lang="en-US" sz="1400" dirty="0"/>
           </a:p>
@@ -3826,7 +3826,7 @@
                 <a:ea typeface="Cambria" pitchFamily="34" charset="-122"/>
                 <a:cs typeface="Cambria" pitchFamily="34" charset="-120"/>
               </a:rPr>
-              <a:t>Ополченцы разбили австрийских рыцарей</a:t>
+              <a:t>Княжество переходит к королю Пруссии</a:t>
             </a:r>
             <a:endParaRPr lang="en-US" sz="1300" dirty="0"/>
           </a:p>
@@ -3890,7 +3890,7 @@
                 <a:ea typeface="Bookman Old Style" pitchFamily="34" charset="-122"/>
                 <a:cs typeface="Bookman Old Style" pitchFamily="34" charset="-120"/>
               </a:rPr>
-              <a:t>1476</a:t>
+              <a:t>1709</a:t>
             </a:r>
             <a:endParaRPr lang="en-US" sz="3400" dirty="0"/>
           </a:p>
@@ -3929,7 +3929,7 @@
                 <a:ea typeface="Bookman Old Style" pitchFamily="34" charset="-122"/>
                 <a:cs typeface="Bookman Old Style" pitchFamily="34" charset="-120"/>
               </a:rPr>
-              <a:t>Грансон и Муртен</a:t>
+              <a:t>Мальплаке</a:t>
             </a:r>
             <a:endParaRPr lang="en-US" sz="1400" dirty="0"/>
           </a:p>
@@ -3968,7 +3968,7 @@
                 <a:ea typeface="Cambria" pitchFamily="34" charset="-122"/>
                 <a:cs typeface="Cambria" pitchFamily="34" charset="-120"/>
               </a:rPr>
-              <a:t>Разгром Карла Смелого Бургундского</a:t>
+              <a:t>Швейцарские полки сражаются по обе стороны</a:t>
             </a:r>
             <a:endParaRPr lang="en-US" sz="1300" dirty="0"/>
           </a:p>
@@ -4032,7 +4032,7 @@
                 <a:ea typeface="Bookman Old Style" pitchFamily="34" charset="-122"/>
                 <a:cs typeface="Bookman Old Style" pitchFamily="34" charset="-120"/>
               </a:rPr>
-              <a:t>1515</a:t>
+              <a:t>1712</a:t>
             </a:r>
             <a:endParaRPr lang="en-US" sz="3400" dirty="0"/>
           </a:p>
@@ -4071,7 +4071,7 @@
                 <a:ea typeface="Bookman Old Style" pitchFamily="34" charset="-122"/>
                 <a:cs typeface="Bookman Old Style" pitchFamily="34" charset="-120"/>
               </a:rPr>
-              <a:t>Мариньяно</a:t>
+              <a:t>Вильмерген</a:t>
             </a:r>
             <a:endParaRPr lang="en-US" sz="1400" dirty="0"/>
           </a:p>
@@ -4110,7 +4110,7 @@
                 <a:ea typeface="Cambria" pitchFamily="34" charset="-122"/>
                 <a:cs typeface="Cambria" pitchFamily="34" charset="-120"/>
               </a:rPr>
-              <a:t>Поражение от Франции — курс на нейтралитет</a:t>
+              <a:t>Протестанты Цюриха и Берна побеждают католиков</a:t>
             </a:r>
             <a:endParaRPr lang="en-US" sz="1300" dirty="0"/>
           </a:p>
@@ -4174,7 +4174,7 @@
                 <a:ea typeface="Bookman Old Style" pitchFamily="34" charset="-122"/>
                 <a:cs typeface="Bookman Old Style" pitchFamily="34" charset="-120"/>
               </a:rPr>
-              <a:t>1648</a:t>
+              <a:t>1723</a:t>
             </a:r>
             <a:endParaRPr lang="en-US" sz="3400" dirty="0"/>
           </a:p>
@@ -4213,7 +4213,7 @@
                 <a:ea typeface="Bookman Old Style" pitchFamily="34" charset="-122"/>
                 <a:cs typeface="Bookman Old Style" pitchFamily="34" charset="-120"/>
               </a:rPr>
-              <a:t>Вестфальский мир</a:t>
+              <a:t>Майор Давель</a:t>
             </a:r>
             <a:endParaRPr lang="en-US" sz="1400" dirty="0"/>
           </a:p>
@@ -4252,7 +4252,7 @@
                 <a:ea typeface="Cambria" pitchFamily="34" charset="-122"/>
                 <a:cs typeface="Cambria" pitchFamily="34" charset="-120"/>
               </a:rPr>
-              <a:t>Европа признала независимость</a:t>
+              <a:t>Восстание в земле Во против власти Берна</a:t>
             </a:r>
             <a:endParaRPr lang="en-US" sz="1300" dirty="0"/>
           </a:p>
@@ -4291,7 +4291,7 @@
                 <a:ea typeface="Cambria" pitchFamily="34" charset="-122"/>
                 <a:cs typeface="Cambria" pitchFamily="34" charset="-120"/>
               </a:rPr>
-              <a:t>После Швабской войны 1499 года Швейцария фактически не подчинялась Империи.</a:t>
+              <a:t>Войны шли вокруг, но на землю самой Швейцарии чужие армии не вступали.</a:t>
             </a:r>
             <a:endParaRPr lang="en-US" sz="1200" dirty="0"/>
           </a:p>
@@ -4369,7 +4369,7 @@
                 <a:ea typeface="Bookman Old Style" pitchFamily="34" charset="-122"/>
                 <a:cs typeface="Bookman Old Style" pitchFamily="34" charset="-120"/>
               </a:rPr>
-              <a:t>Три опоры Швейцарии</a:t>
+              <a:t>Чем жила страна</a:t>
             </a:r>
             <a:endParaRPr lang="en-US" sz="3600" dirty="0"/>
           </a:p>
@@ -4486,7 +4486,7 @@
                 <a:ea typeface="Bookman Old Style" pitchFamily="34" charset="-122"/>
                 <a:cs typeface="Bookman Old Style" pitchFamily="34" charset="-120"/>
               </a:rPr>
-              <a:t>Свобода общин</a:t>
+              <a:t>Наёмная служба</a:t>
             </a:r>
             <a:endParaRPr lang="en-US" sz="1900" dirty="0"/>
           </a:p>
@@ -4528,7 +4528,7 @@
                 <a:ea typeface="Cambria" pitchFamily="34" charset="-122"/>
                 <a:cs typeface="Cambria" pitchFamily="34" charset="-120"/>
               </a:rPr>
-              <a:t>Вместо короля — ландсгемайнде: собрание всех свободных мужчин кантона, голосование поднятием руки.</a:t>
+              <a:t>Швейцарские полки служили Франции, Голландии и другим державам. Плата солдатам кормила многие деревни.</a:t>
             </a:r>
             <a:endParaRPr lang="en-US" sz="1400" dirty="0"/>
           </a:p>
@@ -4606,7 +4606,7 @@
                 <a:ea typeface="Bookman Old Style" pitchFamily="34" charset="-122"/>
                 <a:cs typeface="Bookman Old Style" pitchFamily="34" charset="-120"/>
               </a:rPr>
-              <a:t>Сильная пехота</a:t>
+              <a:t>Ремесло и часы</a:t>
             </a:r>
             <a:endParaRPr lang="en-US" sz="1900" dirty="0"/>
           </a:p>
@@ -4648,7 +4648,7 @@
                 <a:ea typeface="Cambria" pitchFamily="34" charset="-122"/>
                 <a:cs typeface="Cambria" pitchFamily="34" charset="-120"/>
               </a:rPr>
-              <a:t>Пики и алебарды против рыцарской конницы. С 1506 года папу римского охраняет Швейцарская гвардия.</a:t>
+              <a:t>Крестьяне у Цюриха пряли хлопок для купцов. В Женеве и горах Юры делали часы.</a:t>
             </a:r>
             <a:endParaRPr lang="en-US" sz="1400" dirty="0"/>
           </a:p>
@@ -4726,7 +4726,7 @@
                 <a:ea typeface="Bookman Old Style" pitchFamily="34" charset="-122"/>
                 <a:cs typeface="Bookman Old Style" pitchFamily="34" charset="-120"/>
               </a:rPr>
-              <a:t>Вера и ремесло</a:t>
+              <a:t>Власть патрициев</a:t>
             </a:r>
             <a:endParaRPr lang="en-US" sz="1900" dirty="0"/>
           </a:p>
@@ -4768,7 +4768,7 @@
                 <a:ea typeface="Cambria" pitchFamily="34" charset="-122"/>
                 <a:cs typeface="Cambria" pitchFamily="34" charset="-120"/>
               </a:rPr>
-              <a:t>Реформация Цвингли в Цюрихе и Кальвина в Женеве. Женевские ювелиры стали часовщиками.</a:t>
+              <a:t>Городами правили немногие знатные семьи. Крестьяне и подвластные земли права голоса не имели.</a:t>
             </a:r>
             <a:endParaRPr lang="en-US" sz="1400" dirty="0"/>
           </a:p>
@@ -4945,7 +4945,7 @@
                 <a:ea typeface="Bookman Old Style" pitchFamily="34" charset="-122"/>
                 <a:cs typeface="Bookman Old Style" pitchFamily="34" charset="-120"/>
               </a:rPr>
-              <a:t>Три опоры Швейцарии</a:t>
+              <a:t>Чем жила страна</a:t>
             </a:r>
             <a:endParaRPr lang="en-US" sz="3600" dirty="0"/>
           </a:p>
@@ -5062,7 +5062,7 @@
                 <a:ea typeface="Bookman Old Style" pitchFamily="34" charset="-122"/>
                 <a:cs typeface="Bookman Old Style" pitchFamily="34" charset="-120"/>
               </a:rPr>
-              <a:t>Свобода общин</a:t>
+              <a:t>Наёмная служба</a:t>
             </a:r>
             <a:endParaRPr lang="en-US" sz="1900" dirty="0"/>
           </a:p>
@@ -5104,7 +5104,7 @@
                 <a:ea typeface="Cambria" pitchFamily="34" charset="-122"/>
                 <a:cs typeface="Cambria" pitchFamily="34" charset="-120"/>
               </a:rPr>
-              <a:t>Вместо короля — ландсгемайнде: собрание всех свободных мужчин кантона, голосование поднятием руки.</a:t>
+              <a:t>Швейцарские полки служили Франции, Голландии и другим державам. Плата солдатам кормила многие деревни.</a:t>
             </a:r>
             <a:endParaRPr lang="en-US" sz="1400" dirty="0"/>
           </a:p>
@@ -5182,7 +5182,7 @@
                 <a:ea typeface="Bookman Old Style" pitchFamily="34" charset="-122"/>
                 <a:cs typeface="Bookman Old Style" pitchFamily="34" charset="-120"/>
               </a:rPr>
-              <a:t>Сильная пехота</a:t>
+              <a:t>Ремесло и часы</a:t>
             </a:r>
             <a:endParaRPr lang="en-US" sz="1900" dirty="0"/>
           </a:p>
@@ -5224,7 +5224,7 @@
                 <a:ea typeface="Cambria" pitchFamily="34" charset="-122"/>
                 <a:cs typeface="Cambria" pitchFamily="34" charset="-120"/>
               </a:rPr>
-              <a:t>Пики и алебарды против рыцарской конницы. С 1506 года папу римского охраняет Швейцарская гвардия.</a:t>
+              <a:t>Крестьяне у Цюриха пряли хлопок для купцов. В Женеве и горах Юры делали часы.</a:t>
             </a:r>
             <a:endParaRPr lang="en-US" sz="1400" dirty="0"/>
           </a:p>
@@ -5302,7 +5302,7 @@
                 <a:ea typeface="Bookman Old Style" pitchFamily="34" charset="-122"/>
                 <a:cs typeface="Bookman Old Style" pitchFamily="34" charset="-120"/>
               </a:rPr>
-              <a:t>Вера и ремесло</a:t>
+              <a:t>Власть патрициев</a:t>
             </a:r>
             <a:endParaRPr lang="en-US" sz="1900" dirty="0"/>
           </a:p>
@@ -5344,7 +5344,7 @@
                 <a:ea typeface="Cambria" pitchFamily="34" charset="-122"/>
                 <a:cs typeface="Cambria" pitchFamily="34" charset="-120"/>
               </a:rPr>
-              <a:t>Реформация Цвингли в Цюрихе и Кальвина в Женеве. Женевские ювелиры стали часовщиками.</a:t>
+              <a:t>Городами правили немногие знатные семьи. Крестьяне и подвластные земли права голоса не имели.</a:t>
             </a:r>
             <a:endParaRPr lang="en-US" sz="1400" dirty="0"/>
           </a:p>
@@ -5488,8 +5488,8 @@
         </p:nvSpPr>
         <p:spPr>
           <a:xfrm>
-            <a:off x="19141135" y="1097280"/>
-            <a:ext cx="4937760" cy="1828800"/>
+            <a:off x="19141135" y="1188720"/>
+            <a:ext cx="4937760" cy="1737360"/>
           </a:xfrm>
           <a:prstGeom prst="rect">
             <a:avLst/>
@@ -5505,7 +5505,7 @@
               <a:buNone/>
             </a:pPr>
             <a:r>
-              <a:rPr lang="en-US" sz="12000" b="1" dirty="0">
+              <a:rPr lang="en-US" sz="10000" b="1" dirty="0">
                 <a:solidFill>
                   <a:srgbClr val="7A1C1A"/>
                 </a:solidFill>
@@ -5513,9 +5513,9 @@
                 <a:ea typeface="Bookman Old Style" pitchFamily="34" charset="-122"/>
                 <a:cs typeface="Bookman Old Style" pitchFamily="34" charset="-120"/>
               </a:rPr>
-              <a:t>XIII</a:t>
-            </a:r>
-            <a:endParaRPr lang="en-US" sz="12000" dirty="0"/>
+              <a:t>1707</a:t>
+            </a:r>
+            <a:endParaRPr lang="en-US" sz="10000" dirty="0"/>
           </a:p>
         </p:txBody>
       </p:sp>
@@ -5552,7 +5552,7 @@
                 <a:ea typeface="Bookman Old Style" pitchFamily="34" charset="-122"/>
                 <a:cs typeface="Bookman Old Style" pitchFamily="34" charset="-120"/>
               </a:rPr>
-              <a:t>кантонов к 1513 году</a:t>
+              <a:t>в Базеле родился Эйлер</a:t>
             </a:r>
             <a:endParaRPr lang="en-US" sz="2400" dirty="0"/>
           </a:p>
@@ -5591,7 +5591,7 @@
                 <a:ea typeface="Cambria" pitchFamily="34" charset="-122"/>
                 <a:cs typeface="Cambria" pitchFamily="34" charset="-120"/>
               </a:rPr>
-              <a:t>Союз тринадцати кантонов просуществовал до 1798 года. У каждого — свои законы, а общие дела решал сейм (Tagsatzung).</a:t>
+              <a:t>Леонард Эйлер — один из величайших математиков. С 1727 года он работал в Петербургской академии наук.</a:t>
             </a:r>
             <a:endParaRPr lang="en-US" sz="1500" dirty="0"/>
           </a:p>
@@ -5630,7 +5630,7 @@
                 <a:ea typeface="Bookman Old Style" pitchFamily="34" charset="-122"/>
                 <a:cs typeface="Bookman Old Style" pitchFamily="34" charset="-120"/>
               </a:rPr>
-              <a:t>«Швейцарцы превосходно вооружены и пользуются полной свободой»</a:t>
+              <a:t>Базель и Женева — города учёных</a:t>
             </a:r>
             <a:endParaRPr lang="en-US" sz="3000" dirty="0"/>
           </a:p>
@@ -5644,8 +5644,8 @@
         </p:nvSpPr>
         <p:spPr>
           <a:xfrm>
-            <a:off x="13426135" y="3931920"/>
-            <a:ext cx="5120640" cy="365760"/>
+            <a:off x="13426135" y="3108960"/>
+            <a:ext cx="5120640" cy="822960"/>
           </a:xfrm>
           <a:prstGeom prst="rect">
             <a:avLst/>
@@ -5661,7 +5661,7 @@
               <a:buNone/>
             </a:pPr>
             <a:r>
-              <a:rPr lang="en-US" sz="1500" dirty="0">
+              <a:rPr lang="en-US" sz="1600" dirty="0">
                 <a:solidFill>
                   <a:srgbClr val="C9A15A"/>
                 </a:solidFill>
@@ -5669,9 +5669,9 @@
                 <a:ea typeface="Cambria" pitchFamily="34" charset="-122"/>
                 <a:cs typeface="Cambria" pitchFamily="34" charset="-120"/>
               </a:rPr>
-              <a:t>Никколо Макиавелли, «Государь», 1513</a:t>
-            </a:r>
-            <a:endParaRPr lang="en-US" sz="1500" dirty="0"/>
+              <a:t>В Базеле жила семья математиков Бернулли, в 1712 году в Женеве родился Руссо.</a:t>
+            </a:r>
+            <a:endParaRPr lang="en-US" sz="1600" dirty="0"/>
           </a:p>
         </p:txBody>
       </p:sp>
@@ -5747,7 +5747,7 @@
                 <a:ea typeface="Bookman Old Style" pitchFamily="34" charset="-122"/>
                 <a:cs typeface="Bookman Old Style" pitchFamily="34" charset="-120"/>
               </a:rPr>
-              <a:t>Хроника свободы</a:t>
+              <a:t>Хроника начала века</a:t>
             </a:r>
             <a:endParaRPr lang="en-US" sz="4000" dirty="0"/>
           </a:p>
@@ -5873,7 +5873,7 @@
                 <a:ea typeface="Bookman Old Style" pitchFamily="34" charset="-122"/>
                 <a:cs typeface="Bookman Old Style" pitchFamily="34" charset="-120"/>
               </a:rPr>
-              <a:t>1291</a:t>
+              <a:t>1701</a:t>
             </a:r>
             <a:endParaRPr lang="en-US" sz="3400" dirty="0"/>
           </a:p>
@@ -5912,7 +5912,7 @@
                 <a:ea typeface="Bookman Old Style" pitchFamily="34" charset="-122"/>
                 <a:cs typeface="Bookman Old Style" pitchFamily="34" charset="-120"/>
               </a:rPr>
-              <a:t>Вечный союз</a:t>
+              <a:t>Нейтралитет</a:t>
             </a:r>
             <a:endParaRPr lang="en-US" sz="1400" dirty="0"/>
           </a:p>
@@ -5951,7 +5951,7 @@
                 <a:ea typeface="Cambria" pitchFamily="34" charset="-122"/>
                 <a:cs typeface="Cambria" pitchFamily="34" charset="-120"/>
               </a:rPr>
-              <a:t>Ури, Швиц и Унтервальден объединяются</a:t>
+              <a:t>В войне за испанское наследство союз не воюет</a:t>
             </a:r>
             <a:endParaRPr lang="en-US" sz="1300" dirty="0"/>
           </a:p>
@@ -6015,7 +6015,7 @@
                 <a:ea typeface="Bookman Old Style" pitchFamily="34" charset="-122"/>
                 <a:cs typeface="Bookman Old Style" pitchFamily="34" charset="-120"/>
               </a:rPr>
-              <a:t>1315</a:t>
+              <a:t>1707</a:t>
             </a:r>
             <a:endParaRPr lang="en-US" sz="3400" dirty="0"/>
           </a:p>
@@ -6054,7 +6054,7 @@
                 <a:ea typeface="Bookman Old Style" pitchFamily="34" charset="-122"/>
                 <a:cs typeface="Bookman Old Style" pitchFamily="34" charset="-120"/>
               </a:rPr>
-              <a:t>Моргартен</a:t>
+              <a:t>Невшатель</a:t>
             </a:r>
             <a:endParaRPr lang="en-US" sz="1400" dirty="0"/>
           </a:p>
@@ -6093,7 +6093,7 @@
                 <a:ea typeface="Cambria" pitchFamily="34" charset="-122"/>
                 <a:cs typeface="Cambria" pitchFamily="34" charset="-120"/>
               </a:rPr>
-              <a:t>Ополченцы разбили австрийских рыцарей</a:t>
+              <a:t>Княжество переходит к королю Пруссии</a:t>
             </a:r>
             <a:endParaRPr lang="en-US" sz="1300" dirty="0"/>
           </a:p>
@@ -6157,7 +6157,7 @@
                 <a:ea typeface="Bookman Old Style" pitchFamily="34" charset="-122"/>
                 <a:cs typeface="Bookman Old Style" pitchFamily="34" charset="-120"/>
               </a:rPr>
-              <a:t>1476</a:t>
+              <a:t>1709</a:t>
             </a:r>
             <a:endParaRPr lang="en-US" sz="3400" dirty="0"/>
           </a:p>
@@ -6196,7 +6196,7 @@
                 <a:ea typeface="Bookman Old Style" pitchFamily="34" charset="-122"/>
                 <a:cs typeface="Bookman Old Style" pitchFamily="34" charset="-120"/>
               </a:rPr>
-              <a:t>Грансон и Муртен</a:t>
+              <a:t>Мальплаке</a:t>
             </a:r>
             <a:endParaRPr lang="en-US" sz="1400" dirty="0"/>
           </a:p>
@@ -6235,7 +6235,7 @@
                 <a:ea typeface="Cambria" pitchFamily="34" charset="-122"/>
                 <a:cs typeface="Cambria" pitchFamily="34" charset="-120"/>
               </a:rPr>
-              <a:t>Разгром Карла Смелого Бургундского</a:t>
+              <a:t>Швейцарские полки сражаются по обе стороны</a:t>
             </a:r>
             <a:endParaRPr lang="en-US" sz="1300" dirty="0"/>
           </a:p>
@@ -6299,7 +6299,7 @@
                 <a:ea typeface="Bookman Old Style" pitchFamily="34" charset="-122"/>
                 <a:cs typeface="Bookman Old Style" pitchFamily="34" charset="-120"/>
               </a:rPr>
-              <a:t>1515</a:t>
+              <a:t>1712</a:t>
             </a:r>
             <a:endParaRPr lang="en-US" sz="3400" dirty="0"/>
           </a:p>
@@ -6338,7 +6338,7 @@
                 <a:ea typeface="Bookman Old Style" pitchFamily="34" charset="-122"/>
                 <a:cs typeface="Bookman Old Style" pitchFamily="34" charset="-120"/>
               </a:rPr>
-              <a:t>Мариньяно</a:t>
+              <a:t>Вильмерген</a:t>
             </a:r>
             <a:endParaRPr lang="en-US" sz="1400" dirty="0"/>
           </a:p>
@@ -6377,7 +6377,7 @@
                 <a:ea typeface="Cambria" pitchFamily="34" charset="-122"/>
                 <a:cs typeface="Cambria" pitchFamily="34" charset="-120"/>
               </a:rPr>
-              <a:t>Поражение от Франции — курс на нейтралитет</a:t>
+              <a:t>Протестанты Цюриха и Берна побеждают католиков</a:t>
             </a:r>
             <a:endParaRPr lang="en-US" sz="1300" dirty="0"/>
           </a:p>
@@ -6441,7 +6441,7 @@
                 <a:ea typeface="Bookman Old Style" pitchFamily="34" charset="-122"/>
                 <a:cs typeface="Bookman Old Style" pitchFamily="34" charset="-120"/>
               </a:rPr>
-              <a:t>1648</a:t>
+              <a:t>1723</a:t>
             </a:r>
             <a:endParaRPr lang="en-US" sz="3400" dirty="0"/>
           </a:p>
@@ -6480,7 +6480,7 @@
                 <a:ea typeface="Bookman Old Style" pitchFamily="34" charset="-122"/>
                 <a:cs typeface="Bookman Old Style" pitchFamily="34" charset="-120"/>
               </a:rPr>
-              <a:t>Вестфальский мир</a:t>
+              <a:t>Майор Давель</a:t>
             </a:r>
             <a:endParaRPr lang="en-US" sz="1400" dirty="0"/>
           </a:p>
@@ -6519,7 +6519,7 @@
                 <a:ea typeface="Cambria" pitchFamily="34" charset="-122"/>
                 <a:cs typeface="Cambria" pitchFamily="34" charset="-120"/>
               </a:rPr>
-              <a:t>Европа признала независимость</a:t>
+              <a:t>Восстание в земле Во против власти Берна</a:t>
             </a:r>
             <a:endParaRPr lang="en-US" sz="1300" dirty="0"/>
           </a:p>
@@ -6558,7 +6558,7 @@
                 <a:ea typeface="Cambria" pitchFamily="34" charset="-122"/>
                 <a:cs typeface="Cambria" pitchFamily="34" charset="-120"/>
               </a:rPr>
-              <a:t>После Швабской войны 1499 года Швейцария фактически не подчинялась Империи.</a:t>
+              <a:t>Войны шли вокруг, но на землю самой Швейцарии чужие армии не вступали.</a:t>
             </a:r>
             <a:endParaRPr lang="en-US" sz="1200" dirty="0"/>
           </a:p>
@@ -6735,7 +6735,7 @@
                 <a:ea typeface="Bookman Old Style" pitchFamily="34" charset="-122"/>
                 <a:cs typeface="Bookman Old Style" pitchFamily="34" charset="-120"/>
               </a:rPr>
-              <a:t>Хроника свободы</a:t>
+              <a:t>Хроника начала века</a:t>
             </a:r>
             <a:endParaRPr lang="en-US" sz="4000" dirty="0"/>
           </a:p>
@@ -6861,7 +6861,7 @@
                 <a:ea typeface="Bookman Old Style" pitchFamily="34" charset="-122"/>
                 <a:cs typeface="Bookman Old Style" pitchFamily="34" charset="-120"/>
               </a:rPr>
-              <a:t>1291</a:t>
+              <a:t>1701</a:t>
             </a:r>
             <a:endParaRPr lang="en-US" sz="3400" dirty="0"/>
           </a:p>
@@ -6900,7 +6900,7 @@
                 <a:ea typeface="Bookman Old Style" pitchFamily="34" charset="-122"/>
                 <a:cs typeface="Bookman Old Style" pitchFamily="34" charset="-120"/>
               </a:rPr>
-              <a:t>Вечный союз</a:t>
+              <a:t>Нейтралитет</a:t>
             </a:r>
             <a:endParaRPr lang="en-US" sz="1400" dirty="0"/>
           </a:p>
@@ -6939,7 +6939,7 @@
                 <a:ea typeface="Cambria" pitchFamily="34" charset="-122"/>
                 <a:cs typeface="Cambria" pitchFamily="34" charset="-120"/>
               </a:rPr>
-              <a:t>Ури, Швиц и Унтервальден объединяются</a:t>
+              <a:t>В войне за испанское наследство союз не воюет</a:t>
             </a:r>
             <a:endParaRPr lang="en-US" sz="1300" dirty="0"/>
           </a:p>
@@ -7003,7 +7003,7 @@
                 <a:ea typeface="Bookman Old Style" pitchFamily="34" charset="-122"/>
                 <a:cs typeface="Bookman Old Style" pitchFamily="34" charset="-120"/>
               </a:rPr>
-              <a:t>1315</a:t>
+              <a:t>1707</a:t>
             </a:r>
             <a:endParaRPr lang="en-US" sz="3400" dirty="0"/>
           </a:p>
@@ -7042,7 +7042,7 @@
                 <a:ea typeface="Bookman Old Style" pitchFamily="34" charset="-122"/>
                 <a:cs typeface="Bookman Old Style" pitchFamily="34" charset="-120"/>
               </a:rPr>
-              <a:t>Моргартен</a:t>
+              <a:t>Невшатель</a:t>
             </a:r>
             <a:endParaRPr lang="en-US" sz="1400" dirty="0"/>
           </a:p>
@@ -7081,7 +7081,7 @@
                 <a:ea typeface="Cambria" pitchFamily="34" charset="-122"/>
                 <a:cs typeface="Cambria" pitchFamily="34" charset="-120"/>
               </a:rPr>
-              <a:t>Ополченцы разбили австрийских рыцарей</a:t>
+              <a:t>Княжество переходит к королю Пруссии</a:t>
             </a:r>
             <a:endParaRPr lang="en-US" sz="1300" dirty="0"/>
           </a:p>
@@ -7145,7 +7145,7 @@
                 <a:ea typeface="Bookman Old Style" pitchFamily="34" charset="-122"/>
                 <a:cs typeface="Bookman Old Style" pitchFamily="34" charset="-120"/>
               </a:rPr>
-              <a:t>1476</a:t>
+              <a:t>1709</a:t>
             </a:r>
             <a:endParaRPr lang="en-US" sz="3400" dirty="0"/>
           </a:p>
@@ -7184,7 +7184,7 @@
                 <a:ea typeface="Bookman Old Style" pitchFamily="34" charset="-122"/>
                 <a:cs typeface="Bookman Old Style" pitchFamily="34" charset="-120"/>
               </a:rPr>
-              <a:t>Грансон и Муртен</a:t>
+              <a:t>Мальплаке</a:t>
             </a:r>
             <a:endParaRPr lang="en-US" sz="1400" dirty="0"/>
           </a:p>
@@ -7223,7 +7223,7 @@
                 <a:ea typeface="Cambria" pitchFamily="34" charset="-122"/>
                 <a:cs typeface="Cambria" pitchFamily="34" charset="-120"/>
               </a:rPr>
-              <a:t>Разгром Карла Смелого Бургундского</a:t>
+              <a:t>Швейцарские полки сражаются по обе стороны</a:t>
             </a:r>
             <a:endParaRPr lang="en-US" sz="1300" dirty="0"/>
           </a:p>
@@ -7287,7 +7287,7 @@
                 <a:ea typeface="Bookman Old Style" pitchFamily="34" charset="-122"/>
                 <a:cs typeface="Bookman Old Style" pitchFamily="34" charset="-120"/>
               </a:rPr>
-              <a:t>1515</a:t>
+              <a:t>1712</a:t>
             </a:r>
             <a:endParaRPr lang="en-US" sz="3400" dirty="0"/>
           </a:p>
@@ -7326,7 +7326,7 @@
                 <a:ea typeface="Bookman Old Style" pitchFamily="34" charset="-122"/>
                 <a:cs typeface="Bookman Old Style" pitchFamily="34" charset="-120"/>
               </a:rPr>
-              <a:t>Мариньяно</a:t>
+              <a:t>Вильмерген</a:t>
             </a:r>
             <a:endParaRPr lang="en-US" sz="1400" dirty="0"/>
           </a:p>
@@ -7365,7 +7365,7 @@
                 <a:ea typeface="Cambria" pitchFamily="34" charset="-122"/>
                 <a:cs typeface="Cambria" pitchFamily="34" charset="-120"/>
               </a:rPr>
-              <a:t>Поражение от Франции — курс на нейтралитет</a:t>
+              <a:t>Протестанты Цюриха и Берна побеждают католиков</a:t>
             </a:r>
             <a:endParaRPr lang="en-US" sz="1300" dirty="0"/>
           </a:p>
@@ -7429,7 +7429,7 @@
                 <a:ea typeface="Bookman Old Style" pitchFamily="34" charset="-122"/>
                 <a:cs typeface="Bookman Old Style" pitchFamily="34" charset="-120"/>
               </a:rPr>
-              <a:t>1648</a:t>
+              <a:t>1723</a:t>
             </a:r>
             <a:endParaRPr lang="en-US" sz="3400" dirty="0"/>
           </a:p>
@@ -7468,7 +7468,7 @@
                 <a:ea typeface="Bookman Old Style" pitchFamily="34" charset="-122"/>
                 <a:cs typeface="Bookman Old Style" pitchFamily="34" charset="-120"/>
               </a:rPr>
-              <a:t>Вестфальский мир</a:t>
+              <a:t>Майор Давель</a:t>
             </a:r>
             <a:endParaRPr lang="en-US" sz="1400" dirty="0"/>
           </a:p>
@@ -7507,7 +7507,7 @@
                 <a:ea typeface="Cambria" pitchFamily="34" charset="-122"/>
                 <a:cs typeface="Cambria" pitchFamily="34" charset="-120"/>
               </a:rPr>
-              <a:t>Европа признала независимость</a:t>
+              <a:t>Восстание в земле Во против власти Берна</a:t>
             </a:r>
             <a:endParaRPr lang="en-US" sz="1300" dirty="0"/>
           </a:p>
@@ -7546,7 +7546,7 @@
                 <a:ea typeface="Cambria" pitchFamily="34" charset="-122"/>
                 <a:cs typeface="Cambria" pitchFamily="34" charset="-120"/>
               </a:rPr>
-              <a:t>После Швабской войны 1499 года Швейцария фактически не подчинялась Империи.</a:t>
+              <a:t>Войны шли вокруг, но на землю самой Швейцарии чужие армии не вступали.</a:t>
             </a:r>
             <a:endParaRPr lang="en-US" sz="1200" dirty="0"/>
           </a:p>
@@ -7663,7 +7663,7 @@
                 <a:ea typeface="Cambria" pitchFamily="34" charset="-122"/>
                 <a:cs typeface="Cambria" pitchFamily="34" charset="-120"/>
               </a:rPr>
-              <a:t>Свобода общин, сильная пехота и честный труд помогли маленькой горной стране отстоять независимость среди великих держав.</a:t>
+              <a:t>Швейцария осталась нейтральной в войнах Европы, но внутри спорила из-за веры и власти. Богатела она ремеслом и наёмной службой.</a:t>
             </a:r>
             <a:endParaRPr lang="en-US" sz="1900" dirty="0"/>
           </a:p>
@@ -7885,8 +7885,8 @@
         </p:nvSpPr>
         <p:spPr>
           <a:xfrm>
-            <a:off x="6492240" y="1097280"/>
-            <a:ext cx="4937760" cy="1828800"/>
+            <a:off x="6492240" y="1188720"/>
+            <a:ext cx="4937760" cy="1737360"/>
           </a:xfrm>
           <a:prstGeom prst="rect">
             <a:avLst/>
@@ -7902,7 +7902,7 @@
               <a:buNone/>
             </a:pPr>
             <a:r>
-              <a:rPr lang="en-US" sz="12000" b="1" dirty="0">
+              <a:rPr lang="en-US" sz="10000" b="1" dirty="0">
                 <a:solidFill>
                   <a:srgbClr val="7A1C1A"/>
                 </a:solidFill>
@@ -7910,9 +7910,9 @@
                 <a:ea typeface="Bookman Old Style" pitchFamily="34" charset="-122"/>
                 <a:cs typeface="Bookman Old Style" pitchFamily="34" charset="-120"/>
               </a:rPr>
-              <a:t>XIII</a:t>
-            </a:r>
-            <a:endParaRPr lang="en-US" sz="12000" dirty="0"/>
+              <a:t>1707</a:t>
+            </a:r>
+            <a:endParaRPr lang="en-US" sz="10000" dirty="0"/>
           </a:p>
         </p:txBody>
       </p:sp>
@@ -7949,7 +7949,7 @@
                 <a:ea typeface="Bookman Old Style" pitchFamily="34" charset="-122"/>
                 <a:cs typeface="Bookman Old Style" pitchFamily="34" charset="-120"/>
               </a:rPr>
-              <a:t>кантонов к 1513 году</a:t>
+              <a:t>в Базеле родился Эйлер</a:t>
             </a:r>
             <a:endParaRPr lang="en-US" sz="2400" dirty="0"/>
           </a:p>
@@ -7988,7 +7988,7 @@
                 <a:ea typeface="Cambria" pitchFamily="34" charset="-122"/>
                 <a:cs typeface="Cambria" pitchFamily="34" charset="-120"/>
               </a:rPr>
-              <a:t>Союз тринадцати кантонов просуществовал до 1798 года. У каждого — свои законы, а общие дела решал сейм (Tagsatzung).</a:t>
+              <a:t>Леонард Эйлер — один из величайших математиков. С 1727 года он работал в Петербургской академии наук.</a:t>
             </a:r>
             <a:endParaRPr lang="en-US" sz="1500" dirty="0"/>
           </a:p>
@@ -8027,7 +8027,7 @@
                 <a:ea typeface="Bookman Old Style" pitchFamily="34" charset="-122"/>
                 <a:cs typeface="Bookman Old Style" pitchFamily="34" charset="-120"/>
               </a:rPr>
-              <a:t>«Швейцарцы превосходно вооружены и пользуются полной свободой»</a:t>
+              <a:t>Базель и Женева — города учёных</a:t>
             </a:r>
             <a:endParaRPr lang="en-US" sz="3000" dirty="0"/>
           </a:p>
@@ -8041,8 +8041,8 @@
         </p:nvSpPr>
         <p:spPr>
           <a:xfrm>
-            <a:off x="777240" y="3931920"/>
-            <a:ext cx="5120640" cy="365760"/>
+            <a:off x="777240" y="3108960"/>
+            <a:ext cx="5120640" cy="822960"/>
           </a:xfrm>
           <a:prstGeom prst="rect">
             <a:avLst/>
@@ -8058,7 +8058,7 @@
               <a:buNone/>
             </a:pPr>
             <a:r>
-              <a:rPr lang="en-US" sz="1500" dirty="0">
+              <a:rPr lang="en-US" sz="1600" dirty="0">
                 <a:solidFill>
                   <a:srgbClr val="C9A15A"/>
                 </a:solidFill>
@@ -8066,9 +8066,9 @@
                 <a:ea typeface="Cambria" pitchFamily="34" charset="-122"/>
                 <a:cs typeface="Cambria" pitchFamily="34" charset="-120"/>
               </a:rPr>
-              <a:t>Никколо Макиавелли, «Государь», 1513</a:t>
-            </a:r>
-            <a:endParaRPr lang="en-US" sz="1500" dirty="0"/>
+              <a:t>В Базеле жила семья математиков Бернулли, в 1712 году в Женеве родился Руссо.</a:t>
+            </a:r>
+            <a:endParaRPr lang="en-US" sz="1600" dirty="0"/>
           </a:p>
         </p:txBody>
       </p:sp>
@@ -8353,8 +8353,8 @@
         </p:nvSpPr>
         <p:spPr>
           <a:xfrm>
-            <a:off x="-6156655" y="1097280"/>
-            <a:ext cx="4937760" cy="1828800"/>
+            <a:off x="-6156655" y="1188720"/>
+            <a:ext cx="4937760" cy="1737360"/>
           </a:xfrm>
           <a:prstGeom prst="rect">
             <a:avLst/>
@@ -8370,7 +8370,7 @@
               <a:buNone/>
             </a:pPr>
             <a:r>
-              <a:rPr lang="en-US" sz="12000" b="1" dirty="0">
+              <a:rPr lang="en-US" sz="10000" b="1" dirty="0">
                 <a:solidFill>
                   <a:srgbClr val="7A1C1A"/>
                 </a:solidFill>
@@ -8378,9 +8378,9 @@
                 <a:ea typeface="Bookman Old Style" pitchFamily="34" charset="-122"/>
                 <a:cs typeface="Bookman Old Style" pitchFamily="34" charset="-120"/>
               </a:rPr>
-              <a:t>XIII</a:t>
-            </a:r>
-            <a:endParaRPr lang="en-US" sz="12000" dirty="0"/>
+              <a:t>1707</a:t>
+            </a:r>
+            <a:endParaRPr lang="en-US" sz="10000" dirty="0"/>
           </a:p>
         </p:txBody>
       </p:sp>
@@ -8417,7 +8417,7 @@
                 <a:ea typeface="Bookman Old Style" pitchFamily="34" charset="-122"/>
                 <a:cs typeface="Bookman Old Style" pitchFamily="34" charset="-120"/>
               </a:rPr>
-              <a:t>кантонов к 1513 году</a:t>
+              <a:t>в Базеле родился Эйлер</a:t>
             </a:r>
             <a:endParaRPr lang="en-US" sz="2400" dirty="0"/>
           </a:p>
@@ -8456,7 +8456,7 @@
                 <a:ea typeface="Cambria" pitchFamily="34" charset="-122"/>
                 <a:cs typeface="Cambria" pitchFamily="34" charset="-120"/>
               </a:rPr>
-              <a:t>Союз тринадцати кантонов просуществовал до 1798 года. У каждого — свои законы, а общие дела решал сейм (Tagsatzung).</a:t>
+              <a:t>Леонард Эйлер — один из величайших математиков. С 1727 года он работал в Петербургской академии наук.</a:t>
             </a:r>
             <a:endParaRPr lang="en-US" sz="1500" dirty="0"/>
           </a:p>
@@ -8495,7 +8495,7 @@
                 <a:ea typeface="Bookman Old Style" pitchFamily="34" charset="-122"/>
                 <a:cs typeface="Bookman Old Style" pitchFamily="34" charset="-120"/>
               </a:rPr>
-              <a:t>«Швейцарцы превосходно вооружены и пользуются полной свободой»</a:t>
+              <a:t>Базель и Женева — города учёных</a:t>
             </a:r>
             <a:endParaRPr lang="en-US" sz="3000" dirty="0"/>
           </a:p>
@@ -8509,8 +8509,8 @@
         </p:nvSpPr>
         <p:spPr>
           <a:xfrm>
-            <a:off x="-11871655" y="3931920"/>
-            <a:ext cx="5120640" cy="365760"/>
+            <a:off x="-11871655" y="3108960"/>
+            <a:ext cx="5120640" cy="822960"/>
           </a:xfrm>
           <a:prstGeom prst="rect">
             <a:avLst/>
@@ -8526,7 +8526,7 @@
               <a:buNone/>
             </a:pPr>
             <a:r>
-              <a:rPr lang="en-US" sz="1500" dirty="0">
+              <a:rPr lang="en-US" sz="1600" dirty="0">
                 <a:solidFill>
                   <a:srgbClr val="C9A15A"/>
                 </a:solidFill>
@@ -8534,9 +8534,9 @@
                 <a:ea typeface="Cambria" pitchFamily="34" charset="-122"/>
                 <a:cs typeface="Cambria" pitchFamily="34" charset="-120"/>
               </a:rPr>
-              <a:t>Никколо Макиавелли, «Государь», 1513</a:t>
-            </a:r>
-            <a:endParaRPr lang="en-US" sz="1500" dirty="0"/>
+              <a:t>В Базеле жила семья математиков Бернулли, в 1712 году в Женеве родился Руссо.</a:t>
+            </a:r>
+            <a:endParaRPr lang="en-US" sz="1600" dirty="0"/>
           </a:p>
         </p:txBody>
       </p:sp>
@@ -8651,7 +8651,7 @@
                 <a:ea typeface="Cambria" pitchFamily="34" charset="-122"/>
                 <a:cs typeface="Cambria" pitchFamily="34" charset="-120"/>
               </a:rPr>
-              <a:t>Свобода общин, сильная пехота и честный труд помогли маленькой горной стране отстоять независимость среди великих держав.</a:t>
+              <a:t>Швейцария осталась нейтральной в войнах Европы, но внутри спорила из-за веры и власти. Богатела она ремеслом и наёмной службой.</a:t>
             </a:r>
             <a:endParaRPr lang="en-US" sz="1900" dirty="0"/>
           </a:p>

</xml_diff>

<commit_message>
Add authors: Kirill Lenin and Mikhail Lukonin, 8A
Co-Authored-By: Claude Opus 5.5 <noreply@anthropic.com>
Claude-Session: https://claude.ai/code/session_01ETjVcpBAzS2WJAYjtqxef9
</commit_message>
<xml_diff>
--- a/presentation/Helvetia.pptx
+++ b/presentation/Helvetia.pptx
@@ -507,7 +507,7 @@
           <a:p>
             <a:r>
               <a:rPr lang="en-US" dirty="0"/>
-              <a:t>Здравствуйте! Тема моего проекта — «Швейцария в начале XVIII века». Это время, когда по Европе шли большие войны: за испанское наследство, Северная война. Швейцария была маленьким союзом горных кантонов без короля и общей армии. Я расскажу, как она была устроена, чем жили её люди, какие события произошли в начале века и почему Швейцария смогла остаться в стороне от войн.</a:t>
+              <a:t>Здравствуйте! Тема нашего проекта — «Швейцария в начале XVIII века». Это время, когда по Европе шли большие войны: за испанское наследство, Северная война. Швейцария была маленьким союзом горных кантонов без короля и общей армии. Мы расскажем, как она была устроена, чем жили её люди, какие события произошли в начале века и почему Швейцария смогла остаться в стороне от войн.</a:t>
             </a:r>
             <a:endParaRPr lang="en-US" dirty="0"/>
           </a:p>
@@ -947,7 +947,7 @@
           <a:p>
             <a:r>
               <a:rPr lang="en-US" dirty="0"/>
-              <a:t>Подведём итог. В начале XVIII века Швейцария оставалась нейтральной, хотя вокруг шли большие войны, а её солдаты служили чужим армиям. Внутри страны были споры из-за веры и власти — как Вильмергенская война и восстание Давеля. Богатела Швейцария ремеслом, торговлей и наёмной службой, а её учёные, как Эйлер, прославились на всю Европу. Спасибо за внимание! Готов(а) ответить на ваши вопросы.</a:t>
+              <a:t>Подведём итог. В начале XVIII века Швейцария оставалась нейтральной, хотя вокруг шли большие войны, а её солдаты служили чужим армиям. Внутри страны были споры из-за веры и власти — как Вильмергенская война и восстание Давеля. Богатела Швейцария ремеслом, торговлей и наёмной службой, а её учёные, как Эйлер, прославились на всю Европу. Спасибо за внимание! Готовы ответить на ваши вопросы.</a:t>
             </a:r>
             <a:endParaRPr lang="en-US" dirty="0"/>
           </a:p>
@@ -1885,7 +1885,7 @@
                 <a:ea typeface="Cambria" pitchFamily="34" charset="-122"/>
                 <a:cs typeface="Cambria" pitchFamily="34" charset="-120"/>
               </a:rPr>
-              <a:t>Проект по истории  ·  8 класс  ·  Фамилия Имя</a:t>
+              <a:t>Проект по истории  ·  8 «А» класс  ·  Кирилл Ленин и Михаил Луконин</a:t>
             </a:r>
             <a:endParaRPr lang="en-US" sz="1400" dirty="0"/>
           </a:p>
@@ -2159,7 +2159,7 @@
                 <a:ea typeface="Cambria" pitchFamily="34" charset="-122"/>
                 <a:cs typeface="Cambria" pitchFamily="34" charset="-120"/>
               </a:rPr>
-              <a:t>Проект по истории  ·  8 класс  ·  Фамилия Имя</a:t>
+              <a:t>Проект по истории  ·  8 «А» класс  ·  Кирилл Ленин и Михаил Луконин</a:t>
             </a:r>
             <a:endParaRPr lang="en-US" sz="1400" dirty="0"/>
           </a:p>
@@ -7702,7 +7702,7 @@
                 <a:ea typeface="Cambria" pitchFamily="34" charset="-122"/>
                 <a:cs typeface="Cambria" pitchFamily="34" charset="-120"/>
               </a:rPr>
-              <a:t>Выполнил(а): ученик(ца) 8 «__» класса  ·  Фамилия Имя</a:t>
+              <a:t>Выполнили: ученики 8 «А» класса  ·  Кирилл Ленин и Михаил Луконин</a:t>
             </a:r>
             <a:endParaRPr lang="en-US" sz="1400" dirty="0"/>
           </a:p>
@@ -8690,7 +8690,7 @@
                 <a:ea typeface="Cambria" pitchFamily="34" charset="-122"/>
                 <a:cs typeface="Cambria" pitchFamily="34" charset="-120"/>
               </a:rPr>
-              <a:t>Выполнил(а): ученик(ца) 8 «__» класса  ·  Фамилия Имя</a:t>
+              <a:t>Выполнили: ученики 8 «А» класса  ·  Кирилл Ленин и Михаил Луконин</a:t>
             </a:r>
             <a:endParaRPr lang="en-US" sz="1400" dirty="0"/>
           </a:p>

</xml_diff>